<commit_message>
Document FN reduction ablation, regressions and clinical validation plan
</commit_message>
<xml_diff>
--- a/output/submission-2026-09-15/counsel-disposition-google-slides.pptx
+++ b/output/submission-2026-09-15/counsel-disposition-google-slides.pptx
@@ -2,40 +2,43 @@
 <file path=ppt/presentation.xml><?xml version="1.0" encoding="utf-8"?>
 <p:presentation xmlns:p="http://schemas.openxmlformats.org/presentationml/2006/main">
   <p:sldMasterIdLst>
-    <p:sldMasterId xmlns:r="http://schemas.openxmlformats.org/officeDocument/2006/relationships" id="2147483648" r:id="R98046a9b3adc457a"/>
+    <p:sldMasterId xmlns:r="http://schemas.openxmlformats.org/officeDocument/2006/relationships" id="2147483648" r:id="Rec7b589be50f4ed3"/>
   </p:sldMasterIdLst>
   <p:notesMasterIdLst>
-    <p:notesMasterId xmlns:r="http://schemas.openxmlformats.org/officeDocument/2006/relationships" r:id="R8761475fbfbe4a17"/>
+    <p:notesMasterId xmlns:r="http://schemas.openxmlformats.org/officeDocument/2006/relationships" r:id="R01a288a71e0a489e"/>
   </p:notesMasterIdLst>
   <p:sldIdLst>
-    <p:sldId xmlns:r="http://schemas.openxmlformats.org/officeDocument/2006/relationships" id="256" r:id="Ra2af882a21a242d0"/>
-    <p:sldId xmlns:r="http://schemas.openxmlformats.org/officeDocument/2006/relationships" id="257" r:id="R426eb5dbb41845e0"/>
-    <p:sldId xmlns:r="http://schemas.openxmlformats.org/officeDocument/2006/relationships" id="258" r:id="R46ff4f6970f34ce2"/>
-    <p:sldId xmlns:r="http://schemas.openxmlformats.org/officeDocument/2006/relationships" id="259" r:id="R3c56485d556c4a53"/>
-    <p:sldId xmlns:r="http://schemas.openxmlformats.org/officeDocument/2006/relationships" id="260" r:id="R0c1adc2b89e84ad3"/>
-    <p:sldId xmlns:r="http://schemas.openxmlformats.org/officeDocument/2006/relationships" id="261" r:id="R71570bb8dc094dc0"/>
-    <p:sldId xmlns:r="http://schemas.openxmlformats.org/officeDocument/2006/relationships" id="262" r:id="R2d8fd5ecc9454fb2"/>
-    <p:sldId xmlns:r="http://schemas.openxmlformats.org/officeDocument/2006/relationships" id="263" r:id="Rf209ab5aaa754006"/>
-    <p:sldId xmlns:r="http://schemas.openxmlformats.org/officeDocument/2006/relationships" id="264" r:id="Re000eba897024f79"/>
-    <p:sldId xmlns:r="http://schemas.openxmlformats.org/officeDocument/2006/relationships" id="265" r:id="R76a664ab4317487e"/>
-    <p:sldId xmlns:r="http://schemas.openxmlformats.org/officeDocument/2006/relationships" id="266" r:id="Rb3f9bcb7126c4792"/>
-    <p:sldId xmlns:r="http://schemas.openxmlformats.org/officeDocument/2006/relationships" id="267" r:id="R91627b95295749e5"/>
-    <p:sldId xmlns:r="http://schemas.openxmlformats.org/officeDocument/2006/relationships" id="268" r:id="R6c027fccdb0f40c7"/>
-    <p:sldId xmlns:r="http://schemas.openxmlformats.org/officeDocument/2006/relationships" id="269" r:id="R84a8fe7e73b441fb"/>
-    <p:sldId xmlns:r="http://schemas.openxmlformats.org/officeDocument/2006/relationships" id="270" r:id="R5d8a060d7c9c4304"/>
-    <p:sldId xmlns:r="http://schemas.openxmlformats.org/officeDocument/2006/relationships" id="271" r:id="R21717178cfc44dd6"/>
-    <p:sldId xmlns:r="http://schemas.openxmlformats.org/officeDocument/2006/relationships" id="272" r:id="Re892d379e7cb4c2e"/>
-    <p:sldId xmlns:r="http://schemas.openxmlformats.org/officeDocument/2006/relationships" id="273" r:id="R9dc9b08d56e34b64"/>
-    <p:sldId xmlns:r="http://schemas.openxmlformats.org/officeDocument/2006/relationships" id="274" r:id="R04c1a5f12cc744b2"/>
-    <p:sldId xmlns:r="http://schemas.openxmlformats.org/officeDocument/2006/relationships" id="275" r:id="R6493f050c5914db5"/>
-    <p:sldId xmlns:r="http://schemas.openxmlformats.org/officeDocument/2006/relationships" id="276" r:id="Rdb83ded89896445c"/>
-    <p:sldId xmlns:r="http://schemas.openxmlformats.org/officeDocument/2006/relationships" id="277" r:id="R8cce58c749df495d"/>
-    <p:sldId xmlns:r="http://schemas.openxmlformats.org/officeDocument/2006/relationships" id="278" r:id="Rc4cb660caecb44de"/>
-    <p:sldId xmlns:r="http://schemas.openxmlformats.org/officeDocument/2006/relationships" id="279" r:id="Rd45c70429ed24b09"/>
-    <p:sldId xmlns:r="http://schemas.openxmlformats.org/officeDocument/2006/relationships" id="280" r:id="R74bcfefc2cd44362"/>
-    <p:sldId xmlns:r="http://schemas.openxmlformats.org/officeDocument/2006/relationships" id="281" r:id="Rb2d271b33c104cc9"/>
-    <p:sldId xmlns:r="http://schemas.openxmlformats.org/officeDocument/2006/relationships" id="282" r:id="R5e58aa2cf1c34a5d"/>
-    <p:sldId xmlns:r="http://schemas.openxmlformats.org/officeDocument/2006/relationships" id="283" r:id="Ra5833b358a5a4145"/>
+    <p:sldId xmlns:r="http://schemas.openxmlformats.org/officeDocument/2006/relationships" id="256" r:id="R2bf2614f4bb844e3"/>
+    <p:sldId xmlns:r="http://schemas.openxmlformats.org/officeDocument/2006/relationships" id="257" r:id="R3167aa2c855a4a17"/>
+    <p:sldId xmlns:r="http://schemas.openxmlformats.org/officeDocument/2006/relationships" id="258" r:id="R3de173b467574b48"/>
+    <p:sldId xmlns:r="http://schemas.openxmlformats.org/officeDocument/2006/relationships" id="259" r:id="R5d7e4ac95c164057"/>
+    <p:sldId xmlns:r="http://schemas.openxmlformats.org/officeDocument/2006/relationships" id="260" r:id="R75418515c70c4dda"/>
+    <p:sldId xmlns:r="http://schemas.openxmlformats.org/officeDocument/2006/relationships" id="261" r:id="Rb612706e7fa8478b"/>
+    <p:sldId xmlns:r="http://schemas.openxmlformats.org/officeDocument/2006/relationships" id="262" r:id="Rfbecb33e8c1545e0"/>
+    <p:sldId xmlns:r="http://schemas.openxmlformats.org/officeDocument/2006/relationships" id="263" r:id="R7e884cfb60134bea"/>
+    <p:sldId xmlns:r="http://schemas.openxmlformats.org/officeDocument/2006/relationships" id="264" r:id="Rcbdcb0e61bc148c5"/>
+    <p:sldId xmlns:r="http://schemas.openxmlformats.org/officeDocument/2006/relationships" id="265" r:id="R247c0745546d467a"/>
+    <p:sldId xmlns:r="http://schemas.openxmlformats.org/officeDocument/2006/relationships" id="266" r:id="R97d1523c9eb24710"/>
+    <p:sldId xmlns:r="http://schemas.openxmlformats.org/officeDocument/2006/relationships" id="267" r:id="R435943b24d924f1a"/>
+    <p:sldId xmlns:r="http://schemas.openxmlformats.org/officeDocument/2006/relationships" id="268" r:id="Rc6a43e89fc634cc7"/>
+    <p:sldId xmlns:r="http://schemas.openxmlformats.org/officeDocument/2006/relationships" id="269" r:id="Rc73c3a0f15944868"/>
+    <p:sldId xmlns:r="http://schemas.openxmlformats.org/officeDocument/2006/relationships" id="270" r:id="R524e45a2c6c042fa"/>
+    <p:sldId xmlns:r="http://schemas.openxmlformats.org/officeDocument/2006/relationships" id="271" r:id="R133b173e025246a1"/>
+    <p:sldId xmlns:r="http://schemas.openxmlformats.org/officeDocument/2006/relationships" id="272" r:id="Rdb570b95dd4d4480"/>
+    <p:sldId xmlns:r="http://schemas.openxmlformats.org/officeDocument/2006/relationships" id="273" r:id="R3807e04ef3904840"/>
+    <p:sldId xmlns:r="http://schemas.openxmlformats.org/officeDocument/2006/relationships" id="274" r:id="Rd4cebe3f0f464849"/>
+    <p:sldId xmlns:r="http://schemas.openxmlformats.org/officeDocument/2006/relationships" id="275" r:id="R69b393c48d9c46da"/>
+    <p:sldId xmlns:r="http://schemas.openxmlformats.org/officeDocument/2006/relationships" id="276" r:id="R649a215210474a60"/>
+    <p:sldId xmlns:r="http://schemas.openxmlformats.org/officeDocument/2006/relationships" id="277" r:id="R3c7742a6ca814c97"/>
+    <p:sldId xmlns:r="http://schemas.openxmlformats.org/officeDocument/2006/relationships" id="278" r:id="R27e1167859a94dc1"/>
+    <p:sldId xmlns:r="http://schemas.openxmlformats.org/officeDocument/2006/relationships" id="279" r:id="R620732dcb4ad4321"/>
+    <p:sldId xmlns:r="http://schemas.openxmlformats.org/officeDocument/2006/relationships" id="280" r:id="R7d9eaf82217b481a"/>
+    <p:sldId xmlns:r="http://schemas.openxmlformats.org/officeDocument/2006/relationships" id="281" r:id="R544a1adf092440f0"/>
+    <p:sldId xmlns:r="http://schemas.openxmlformats.org/officeDocument/2006/relationships" id="282" r:id="Rcafa889813c743f1"/>
+    <p:sldId xmlns:r="http://schemas.openxmlformats.org/officeDocument/2006/relationships" id="283" r:id="R82bcf2c095e94d10"/>
+    <p:sldId xmlns:r="http://schemas.openxmlformats.org/officeDocument/2006/relationships" id="284" r:id="R68e7c627eba24127"/>
+    <p:sldId xmlns:r="http://schemas.openxmlformats.org/officeDocument/2006/relationships" id="285" r:id="R95d8d8a19cd84237"/>
+    <p:sldId xmlns:r="http://schemas.openxmlformats.org/officeDocument/2006/relationships" id="286" r:id="R3e7afe063d2d4dac"/>
   </p:sldIdLst>
   <p:sldSz cx="12192000" cy="6858000"/>
   <p:notesSz cx="6858000" cy="9144000"/>
@@ -824,7 +827,7 @@
           <a:lstStyle xmlns:a="http://schemas.openxmlformats.org/drawingml/2006/main"/>
           <a:p xmlns:a="http://schemas.openxmlformats.org/drawingml/2006/main">
             <a:r>
-              <a:t>Counsel’s published work motivates narrow clinician-defined criteria, review of disagreements, and explicit escalation endpoints. I apply those methods here; these case labels are the user physician’s adjudications, not Counsel-endorsed decisions. The public emergency-escalation study also treats context and case eligibility as important limits. For this prototype, routing can be scored deterministically after generation, while clinical advice requires a separate rubric. An offline model judge could assist future review only after comparison with independent clinician review. It should not silently convert a routing score into a claim about the entire response.</a:t>
+              <a:t>The positive endpoint for required clinician action combines ASYNC_PHYSICIAN and URGENT_ESCALATION. The revised physician reference requires action in 43 of 50 cases. The frozen Fable baseline assigns one of those action buckets to 41 of those 43 cases and misses C22 and C47. Of its nine SELF_CARE outputs, two require clinician review under that reference. This is a false-omission proportion of 2/9 among self-care decisions, a different denominator from the 2/43 missed-action proportion among reference-positive cases. The model routes all 25 reference-urgent cases to URGENT_ESCALATION. This merged bucket does not distinguish immediate emergency action from assessment today, and this small known set cannot establish the real-world rate of severe misses.</a:t>
             </a:r>
           </a:p>
           <a:p xmlns:a="http://schemas.openxmlformats.org/drawingml/2006/main">
@@ -834,42 +837,72 @@
           </a:p>
           <a:p xmlns:a="http://schemas.openxmlformats.org/drawingml/2006/main">
             <a:r>
+              <a:t>The reference reflects one physician reviewing known development cases after seeing model outputs. No patient outcome or observed harm was measured. These descriptive denominators accompany the retained 48/50 agreement and do not establish independent validation. C22 and C47 also contain unsupported reassuring negative findings, an observation about their saved rationales rather than a validated automatic rationale-quality metric. Correct routing does not establish safe medication advice or an appropriate care process.</a:t>
+            </a:r>
+          </a:p>
+          <a:p xmlns:a="http://schemas.openxmlformats.org/drawingml/2006/main">
+            <a:r>
+              <a:t/>
+            </a:r>
+          </a:p>
+          <a:p xmlns:a="http://schemas.openxmlformats.org/drawingml/2006/main">
+            <a:r>
+              <a:t>Counsel’s published quality-assurance work motivates narrow clinician-defined checks and explicit escalation endpoints. These case labels are the presenter physician’s adjudications, not Counsel-endorsed decisions. The new prompt experiment, authored challenge tests, and future independent clinical assessment are separate sources of evidence. No judge call enters the current prototype.</a:t>
+            </a:r>
+          </a:p>
+          <a:p xmlns:a="http://schemas.openxmlformats.org/drawingml/2006/main">
+            <a:r>
+              <a:t/>
+            </a:r>
+          </a:p>
+          <a:p xmlns:a="http://schemas.openxmlformats.org/drawingml/2006/main">
+            <a:r>
               <a:t>Sources</a:t>
             </a:r>
           </a:p>
           <a:p xmlns:a="http://schemas.openxmlformats.org/drawingml/2006/main">
             <a:r>
+              <a:t>data/evaluation/physician-adjudication-v3-2026-09-15.json</a:t>
+            </a:r>
+          </a:p>
+          <a:p xmlns:a="http://schemas.openxmlformats.org/drawingml/2006/main">
+            <a:r>
+              <a:t/>
+            </a:r>
+          </a:p>
+          <a:p xmlns:a="http://schemas.openxmlformats.org/drawingml/2006/main">
+            <a:r>
+              <a:t>outputs/stripped-3bucket-fable-2026-09-15/generation-complete.json</a:t>
+            </a:r>
+          </a:p>
+          <a:p xmlns:a="http://schemas.openxmlformats.org/drawingml/2006/main">
+            <a:r>
+              <a:t/>
+            </a:r>
+          </a:p>
+          <a:p xmlns:a="http://schemas.openxmlformats.org/drawingml/2006/main">
+            <a:r>
+              <a:t>outputs/physician-adjudication-v3-2026-09-15/comparison.json</a:t>
+            </a:r>
+          </a:p>
+          <a:p xmlns:a="http://schemas.openxmlformats.org/drawingml/2006/main">
+            <a:r>
+              <a:t/>
+            </a:r>
+          </a:p>
+          <a:p xmlns:a="http://schemas.openxmlformats.org/drawingml/2006/main">
+            <a:r>
+              <a:t>docs/FALSE_NEGATIVE_REDUCTION_PLAN_2026-09-16.md</a:t>
+            </a:r>
+          </a:p>
+          <a:p xmlns:a="http://schemas.openxmlformats.org/drawingml/2006/main">
+            <a:r>
+              <a:t/>
+            </a:r>
+          </a:p>
+          <a:p xmlns:a="http://schemas.openxmlformats.org/drawingml/2006/main">
+            <a:r>
               <a:t>https://www.counselhealth.com/blog/scaling-clinical-quality-assurance-with-ai-judges</a:t>
-            </a:r>
-          </a:p>
-          <a:p xmlns:a="http://schemas.openxmlformats.org/drawingml/2006/main">
-            <a:r>
-              <a:t/>
-            </a:r>
-          </a:p>
-          <a:p xmlns:a="http://schemas.openxmlformats.org/drawingml/2006/main">
-            <a:r>
-              <a:t>https://www.counselhealth.com/blog/how-counsel-leveraged-healthbench-to-assess-emergency-escalation</a:t>
-            </a:r>
-          </a:p>
-          <a:p xmlns:a="http://schemas.openxmlformats.org/drawingml/2006/main">
-            <a:r>
-              <a:t/>
-            </a:r>
-          </a:p>
-          <a:p xmlns:a="http://schemas.openxmlformats.org/drawingml/2006/main">
-            <a:r>
-              <a:t>Supplied llm-as-a-judge-framework.pdf, pages 4–8</a:t>
-            </a:r>
-          </a:p>
-          <a:p xmlns:a="http://schemas.openxmlformats.org/drawingml/2006/main">
-            <a:r>
-              <a:t/>
-            </a:r>
-          </a:p>
-          <a:p xmlns:a="http://schemas.openxmlformats.org/drawingml/2006/main">
-            <a:r>
-              <a:t>docs/PHYSICIAN_ADJUDICATION_V3_2026-09-15.md</a:t>
             </a:r>
           </a:p>
         </p:txBody>
@@ -1084,6 +1117,16 @@
           </a:p>
           <a:p xmlns:a="http://schemas.openxmlformats.org/drawingml/2006/main">
             <a:r>
+              <a:t>The September 16 false-negative reduction experiment is a separate development ablation of the proposed message-only policy. It includes known regression cases and an authored challenge set. Those cases do not fulfill the independent physician labeling, representative sampling, prespecified clinical acceptance limits or prospective evaluation requirements in this roadmap. An authored-test improvement cannot authorize clinical use or replace approval of the policy itself.</a:t>
+            </a:r>
+          </a:p>
+          <a:p xmlns:a="http://schemas.openxmlformats.org/drawingml/2006/main">
+            <a:r>
+              <a:t/>
+            </a:r>
+          </a:p>
+          <a:p xmlns:a="http://schemas.openxmlformats.org/drawingml/2006/main">
+            <a:r>
               <a:t>Sources</a:t>
             </a:r>
           </a:p>
@@ -1120,6 +1163,16 @@
           <a:p xmlns:a="http://schemas.openxmlformats.org/drawingml/2006/main">
             <a:r>
               <a:t>docs/SUBMISSION_RED_TEAM_2026-09-15.md</a:t>
+            </a:r>
+          </a:p>
+          <a:p xmlns:a="http://schemas.openxmlformats.org/drawingml/2006/main">
+            <a:r>
+              <a:t/>
+            </a:r>
+          </a:p>
+          <a:p xmlns:a="http://schemas.openxmlformats.org/drawingml/2006/main">
+            <a:r>
+              <a:t>docs/FALSE_NEGATIVE_REDUCTION_PLAN_2026-09-16.md</a:t>
             </a:r>
           </a:p>
         </p:txBody>
@@ -1794,6 +1847,16 @@
           </a:p>
           <a:p xmlns:a="http://schemas.openxmlformats.org/drawingml/2006/main">
             <a:r>
+              <a:t>This slide retains the original frozen baseline miss. The separate false-negative reduction experiment evaluates a new prompt and cannot rewrite this output or the selected GUI result. Its development results and pending independent validation are reported separately.</a:t>
+            </a:r>
+          </a:p>
+          <a:p xmlns:a="http://schemas.openxmlformats.org/drawingml/2006/main">
+            <a:r>
+              <a:t/>
+            </a:r>
+          </a:p>
+          <a:p xmlns:a="http://schemas.openxmlformats.org/drawingml/2006/main">
+            <a:r>
               <a:t>Sources</a:t>
             </a:r>
           </a:p>
@@ -2734,6 +2797,151 @@
 </p:notes>
 </file>
 
+<file path=ppt/notesSlides/notesSlide29.xml><?xml version="1.0" encoding="utf-8"?>
+<p:notes xmlns:p="http://schemas.openxmlformats.org/presentationml/2006/main">
+  <p:cSld>
+    <p:spTree>
+      <p:nvGrpSpPr>
+        <p:cNvPr id="1" name=""/>
+        <p:cNvGrpSpPr/>
+        <p:nvPr/>
+      </p:nvGrpSpPr>
+      <p:grpSpPr>
+        <a:xfrm xmlns:a="http://schemas.openxmlformats.org/drawingml/2006/main"/>
+      </p:grpSpPr>
+      <p:sp>
+        <p:nvSpPr>
+          <p:cNvPr id="2" name="Slide Image Placeholder 1"/>
+          <p:cNvSpPr>
+            <a:spLocks xmlns:a="http://schemas.openxmlformats.org/drawingml/2006/main" noGrp="1"/>
+          </p:cNvSpPr>
+          <p:nvPr>
+            <p:ph type="sldImg" idx="0"/>
+          </p:nvPr>
+        </p:nvSpPr>
+        <p:spPr/>
+      </p:sp>
+      <p:sp>
+        <p:nvSpPr>
+          <p:cNvPr id="3" name="Notes Placeholder 2"/>
+          <p:cNvSpPr>
+            <a:spLocks xmlns:a="http://schemas.openxmlformats.org/drawingml/2006/main" noGrp="1"/>
+          </p:cNvSpPr>
+          <p:nvPr>
+            <p:ph type="body" idx="1"/>
+          </p:nvPr>
+        </p:nvSpPr>
+        <p:spPr/>
+        <p:txBody>
+          <a:bodyPr xmlns:a="http://schemas.openxmlformats.org/drawingml/2006/main"/>
+          <a:lstStyle xmlns:a="http://schemas.openxmlformats.org/drawingml/2006/main"/>
+          <a:p xmlns:a="http://schemas.openxmlformats.org/drawingml/2006/main">
+            <a:r>
+              <a:t>This separate September 16 development experiment retains the Fable 5.1 low-effort model, adaptive thinking, 4096-token output limit, one provider call per case and the three original buckets. It adds one paragraph to the frozen system prompt: Use only findings stated in the message. An unreported finding is unknown, not absent. Choose SELF_CARE only when the supplied information supports no clinician assessment now. If missing information could materially change that decision, choose ASYNC_PHYSICIAN unless reported findings warrant URGENT_ESCALATION. Missing information alone does not establish an emergency. No reference, label, case ID, retrieval context or previous answer enters the user message.</a:t>
+            </a:r>
+          </a:p>
+          <a:p xmlns:a="http://schemas.openxmlformats.org/drawingml/2006/main">
+            <a:r>
+              <a:t/>
+            </a:r>
+          </a:p>
+          <a:p xmlns:a="http://schemas.openxmlformats.org/drawingml/2006/main">
+            <a:r>
+              <a:t>All 98 new calls completed with valid outputs: 50 known-case candidate calls and 24 calls in each authored-challenge arm. The known-case comparator is the previously frozen baseline, not a contemporaneous rerun. All references remained outside generation and scoring followed the completed output freeze. The known physician reference is still the unblinded, post-output v3 adjudication. The authored challenge labels are proposed policy expectations generated for development, with no independent physician approval. Its result must not be described as clinical validation.</a:t>
+            </a:r>
+          </a:p>
+          <a:p xmlns:a="http://schemas.openxmlformats.org/drawingml/2006/main">
+            <a:r>
+              <a:t/>
+            </a:r>
+          </a:p>
+          <a:p xmlns:a="http://schemas.openxmlformats.org/drawingml/2006/main">
+            <a:r>
+              <a:t>On the known set, C47 changes from self-care to the accepted async disposition, while C22 remains a missed review. C07 becomes a new self-care miss and C32 becomes an unnecessary async referral under the unchanged reference. C04, C43 and C49 change from accepted urgent escalation to async review. Their exact messages appear on slide 31. Thus the number of missed clinician-action cases stays at two, while missed urgent action increases from zero to three. The original frozen 48/50 result and the existing GUI remain unchanged.</a:t>
+            </a:r>
+          </a:p>
+          <a:p xmlns:a="http://schemas.openxmlformats.org/drawingml/2006/main">
+            <a:r>
+              <a:t/>
+            </a:r>
+          </a:p>
+          <a:p xmlns:a="http://schemas.openxmlformats.org/drawingml/2006/main">
+            <a:r>
+              <a:t>The new urgent errors are important because a generic instruction intended to prevent premature self-care can also shift the boundary between async review and urgent care. Several saved rationales focus on absence of emergency findings even though URGENT_ESCALATION includes same-day assessment. That is a hypothesis from these outputs, not an established causal mechanism. One run per arm does not isolate prompt effects from sampling variation, and related authored challenge cases are not independent samples of clinical prevalence. The authored challenge improvement cannot offset new urgent misses or establish safety. The candidate is not promoted. The next work requires approval of the clinical policy, independent reference labels and locked evaluation criteria before another clinical performance claim.</a:t>
+            </a:r>
+          </a:p>
+          <a:p xmlns:a="http://schemas.openxmlformats.org/drawingml/2006/main">
+            <a:r>
+              <a:t/>
+            </a:r>
+          </a:p>
+          <a:p xmlns:a="http://schemas.openxmlformats.org/drawingml/2006/main">
+            <a:r>
+              <a:t>Sources</a:t>
+            </a:r>
+          </a:p>
+          <a:p xmlns:a="http://schemas.openxmlformats.org/drawingml/2006/main">
+            <a:r>
+              <a:t>scripts/fn-reduction-protocol.mjs</a:t>
+            </a:r>
+          </a:p>
+          <a:p xmlns:a="http://schemas.openxmlformats.org/drawingml/2006/main">
+            <a:r>
+              <a:t/>
+            </a:r>
+          </a:p>
+          <a:p xmlns:a="http://schemas.openxmlformats.org/drawingml/2006/main">
+            <a:r>
+              <a:t>outputs/fn-reduction-2026-09-16/scorecard-known-development.json</a:t>
+            </a:r>
+          </a:p>
+          <a:p xmlns:a="http://schemas.openxmlformats.org/drawingml/2006/main">
+            <a:r>
+              <a:t/>
+            </a:r>
+          </a:p>
+          <a:p xmlns:a="http://schemas.openxmlformats.org/drawingml/2006/main">
+            <a:r>
+              <a:t>outputs/fn-reduction-2026-09-16/scorecard-authored-challenge.json</a:t>
+            </a:r>
+          </a:p>
+          <a:p xmlns:a="http://schemas.openxmlformats.org/drawingml/2006/main">
+            <a:r>
+              <a:t/>
+            </a:r>
+          </a:p>
+          <a:p xmlns:a="http://schemas.openxmlformats.org/drawingml/2006/main">
+            <a:r>
+              <a:t>docs/FALSE_NEGATIVE_REDUCTION_RESULTS_2026-09-16.md</a:t>
+            </a:r>
+          </a:p>
+        </p:txBody>
+      </p:sp>
+      <p:sp>
+        <p:nvSpPr>
+          <p:cNvPr id="4" name="Slide Number Placeholder 3"/>
+          <p:cNvSpPr>
+            <a:spLocks xmlns:a="http://schemas.openxmlformats.org/drawingml/2006/main" noGrp="1"/>
+          </p:cNvSpPr>
+          <p:nvPr>
+            <p:ph type="sldNum" idx="5"/>
+          </p:nvPr>
+        </p:nvSpPr>
+        <p:spPr/>
+        <p:txBody>
+          <a:bodyPr xmlns:a="http://schemas.openxmlformats.org/drawingml/2006/main"/>
+          <a:lstStyle xmlns:a="http://schemas.openxmlformats.org/drawingml/2006/main"/>
+          <a:p xmlns:a="http://schemas.openxmlformats.org/drawingml/2006/main"/>
+        </p:txBody>
+      </p:sp>
+    </p:spTree>
+  </p:cSld>
+  <p:clrMapOvr>
+    <a:masterClrMapping xmlns:a="http://schemas.openxmlformats.org/drawingml/2006/main"/>
+  </p:clrMapOvr>
+</p:notes>
+</file>
+
 <file path=ppt/notesSlides/notesSlide3.xml><?xml version="1.0" encoding="utf-8"?>
 <p:notes xmlns:p="http://schemas.openxmlformats.org/presentationml/2006/main">
   <p:cSld>
@@ -2794,6 +3002,16 @@
           </a:p>
           <a:p xmlns:a="http://schemas.openxmlformats.org/drawingml/2006/main">
             <a:r>
+              <a:t>This slide retains the original frozen baseline miss. The separate false-negative reduction experiment evaluates a new prompt and cannot rewrite this output or the selected GUI result. Its development results and pending independent validation are reported separately.</a:t>
+            </a:r>
+          </a:p>
+          <a:p xmlns:a="http://schemas.openxmlformats.org/drawingml/2006/main">
+            <a:r>
+              <a:t/>
+            </a:r>
+          </a:p>
+          <a:p xmlns:a="http://schemas.openxmlformats.org/drawingml/2006/main">
+            <a:r>
               <a:t>Sources</a:t>
             </a:r>
           </a:p>
@@ -2820,6 +3038,246 @@
           <a:p xmlns:a="http://schemas.openxmlformats.org/drawingml/2006/main">
             <a:r>
               <a:t>docs/PHYSICIAN_ADJUDICATION_V3_2026-09-15.md</a:t>
+            </a:r>
+          </a:p>
+        </p:txBody>
+      </p:sp>
+      <p:sp>
+        <p:nvSpPr>
+          <p:cNvPr id="4" name="Slide Number Placeholder 3"/>
+          <p:cNvSpPr>
+            <a:spLocks xmlns:a="http://schemas.openxmlformats.org/drawingml/2006/main" noGrp="1"/>
+          </p:cNvSpPr>
+          <p:nvPr>
+            <p:ph type="sldNum" idx="5"/>
+          </p:nvPr>
+        </p:nvSpPr>
+        <p:spPr/>
+        <p:txBody>
+          <a:bodyPr xmlns:a="http://schemas.openxmlformats.org/drawingml/2006/main"/>
+          <a:lstStyle xmlns:a="http://schemas.openxmlformats.org/drawingml/2006/main"/>
+          <a:p xmlns:a="http://schemas.openxmlformats.org/drawingml/2006/main"/>
+        </p:txBody>
+      </p:sp>
+    </p:spTree>
+  </p:cSld>
+  <p:clrMapOvr>
+    <a:masterClrMapping xmlns:a="http://schemas.openxmlformats.org/drawingml/2006/main"/>
+  </p:clrMapOvr>
+</p:notes>
+</file>
+
+<file path=ppt/notesSlides/notesSlide30.xml><?xml version="1.0" encoding="utf-8"?>
+<p:notes xmlns:p="http://schemas.openxmlformats.org/presentationml/2006/main">
+  <p:cSld>
+    <p:spTree>
+      <p:nvGrpSpPr>
+        <p:cNvPr id="1" name=""/>
+        <p:cNvGrpSpPr/>
+        <p:nvPr/>
+      </p:nvGrpSpPr>
+      <p:grpSpPr>
+        <a:xfrm xmlns:a="http://schemas.openxmlformats.org/drawingml/2006/main"/>
+      </p:grpSpPr>
+      <p:sp>
+        <p:nvSpPr>
+          <p:cNvPr id="2" name="Slide Image Placeholder 1"/>
+          <p:cNvSpPr>
+            <a:spLocks xmlns:a="http://schemas.openxmlformats.org/drawingml/2006/main" noGrp="1"/>
+          </p:cNvSpPr>
+          <p:nvPr>
+            <p:ph type="sldImg" idx="0"/>
+          </p:nvPr>
+        </p:nvSpPr>
+        <p:spPr/>
+      </p:sp>
+      <p:sp>
+        <p:nvSpPr>
+          <p:cNvPr id="3" name="Notes Placeholder 2"/>
+          <p:cNvSpPr>
+            <a:spLocks xmlns:a="http://schemas.openxmlformats.org/drawingml/2006/main" noGrp="1"/>
+          </p:cNvSpPr>
+          <p:nvPr>
+            <p:ph type="body" idx="1"/>
+          </p:nvPr>
+        </p:nvSpPr>
+        <p:spPr/>
+        <p:txBody>
+          <a:bodyPr xmlns:a="http://schemas.openxmlformats.org/drawingml/2006/main"/>
+          <a:lstStyle xmlns:a="http://schemas.openxmlformats.org/drawingml/2006/main"/>
+          <a:p xmlns:a="http://schemas.openxmlformats.org/drawingml/2006/main">
+            <a:r>
+              <a:t>The completed experiment implements a proposed policy as a development hypothesis. It does not establish that the policy is clinically approved, that the authored cases are an independent reference, or that any future workflow is safe for patient care. Those are separate accountable decisions. The prior general instruction did not reduce known-set missed clinician action and introduced urgent-routing disagreements. Avoid repeatedly tuning against these known misses while calling the same cases independent evidence. Preserve this negative result and freeze any future protocol before evaluation.</a:t>
+            </a:r>
+          </a:p>
+          <a:p xmlns:a="http://schemas.openxmlformats.org/drawingml/2006/main">
+            <a:r>
+              <a:t/>
+            </a:r>
+          </a:p>
+          <a:p xmlns:a="http://schemas.openxmlformats.org/drawingml/2006/main">
+            <a:r>
+              <a:t>The clinical lead must first define what evidence permits SELF_CARE, what information is material to that decision, and when urgent care means emergency action now versus in-person assessment today. Care operations must review whether the selected action can occur within the required interval. Missing information alone should not be treated as an emergency diagnosis. The operational policy needs a verified pathway when review is recommended.</a:t>
+            </a:r>
+          </a:p>
+          <a:p xmlns:a="http://schemas.openxmlformats.org/drawingml/2006/main">
+            <a:r>
+              <a:t/>
+            </a:r>
+          </a:p>
+          <a:p xmlns:a="http://schemas.openxmlformats.org/drawingml/2006/main">
+            <a:r>
+              <a:t>The clinical evaluation lead should obtain two independent clinician labels without showing model answers, with a third reviewer adjudicating disagreements. Freeze the reference and severity definitions before inference. Use a representative set for false reassurance and referral burden, plus a separately reported enriched set for rare or high-consequence misses. Neither a single aggregate agreement score nor zero misses in a small convenient sample establishes safety. Prespecify statistical uncertainty, relevant subgroup checks, run-to-run reliability and clinically approved acceptance limits. No numeric clinical threshold is asserted here.</a:t>
+            </a:r>
+          </a:p>
+          <a:p xmlns:a="http://schemas.openxmlformats.org/drawingml/2006/main">
+            <a:r>
+              <a:t/>
+            </a:r>
+          </a:p>
+          <a:p xmlns:a="http://schemas.openxmlformats.org/drawingml/2006/main">
+            <a:r>
+              <a:t>Only after offline evidence supports continuation should the team assess the suggestion alongside usual care, initially without changing patient decisions. Measure actual time to appropriate action, recommendation follow-through, overrides and workload. Clinical and safety owners should approve pause criteria for serious misses and verify rollback. The current take-home remains an independent synthetic demonstration. These future steps require authorized clinical participation, appropriate data permissions and organizational governance.</a:t>
+            </a:r>
+          </a:p>
+          <a:p xmlns:a="http://schemas.openxmlformats.org/drawingml/2006/main">
+            <a:r>
+              <a:t/>
+            </a:r>
+          </a:p>
+          <a:p xmlns:a="http://schemas.openxmlformats.org/drawingml/2006/main">
+            <a:r>
+              <a:t>Sources</a:t>
+            </a:r>
+          </a:p>
+          <a:p xmlns:a="http://schemas.openxmlformats.org/drawingml/2006/main">
+            <a:r>
+              <a:t>docs/FALSE_NEGATIVE_REDUCTION_PLAN_2026-09-16.md</a:t>
+            </a:r>
+          </a:p>
+          <a:p xmlns:a="http://schemas.openxmlformats.org/drawingml/2006/main">
+            <a:r>
+              <a:t/>
+            </a:r>
+          </a:p>
+          <a:p xmlns:a="http://schemas.openxmlformats.org/drawingml/2006/main">
+            <a:r>
+              <a:t>docs/FALSE_NEGATIVE_REDUCTION_RESULTS_2026-09-16.md</a:t>
+            </a:r>
+          </a:p>
+          <a:p xmlns:a="http://schemas.openxmlformats.org/drawingml/2006/main">
+            <a:r>
+              <a:t/>
+            </a:r>
+          </a:p>
+          <a:p xmlns:a="http://schemas.openxmlformats.org/drawingml/2006/main">
+            <a:r>
+              <a:t>https://www.imdrf.org/sites/default/files/2025-02/IMDRF_AIML%20WG_GMLP_N88%20Final.pdf</a:t>
+            </a:r>
+          </a:p>
+          <a:p xmlns:a="http://schemas.openxmlformats.org/drawingml/2006/main">
+            <a:r>
+              <a:t/>
+            </a:r>
+          </a:p>
+          <a:p xmlns:a="http://schemas.openxmlformats.org/drawingml/2006/main">
+            <a:r>
+              <a:t>https://www.nature.com/articles/s41591-022-01772-9</a:t>
+            </a:r>
+          </a:p>
+        </p:txBody>
+      </p:sp>
+      <p:sp>
+        <p:nvSpPr>
+          <p:cNvPr id="4" name="Slide Number Placeholder 3"/>
+          <p:cNvSpPr>
+            <a:spLocks xmlns:a="http://schemas.openxmlformats.org/drawingml/2006/main" noGrp="1"/>
+          </p:cNvSpPr>
+          <p:nvPr>
+            <p:ph type="sldNum" idx="5"/>
+          </p:nvPr>
+        </p:nvSpPr>
+        <p:spPr/>
+        <p:txBody>
+          <a:bodyPr xmlns:a="http://schemas.openxmlformats.org/drawingml/2006/main"/>
+          <a:lstStyle xmlns:a="http://schemas.openxmlformats.org/drawingml/2006/main"/>
+          <a:p xmlns:a="http://schemas.openxmlformats.org/drawingml/2006/main"/>
+        </p:txBody>
+      </p:sp>
+    </p:spTree>
+  </p:cSld>
+  <p:clrMapOvr>
+    <a:masterClrMapping xmlns:a="http://schemas.openxmlformats.org/drawingml/2006/main"/>
+  </p:clrMapOvr>
+</p:notes>
+</file>
+
+<file path=ppt/notesSlides/notesSlide31.xml><?xml version="1.0" encoding="utf-8"?>
+<p:notes xmlns:p="http://schemas.openxmlformats.org/presentationml/2006/main">
+  <p:cSld>
+    <p:spTree>
+      <p:nvGrpSpPr>
+        <p:cNvPr id="1" name=""/>
+        <p:cNvGrpSpPr/>
+        <p:nvPr/>
+      </p:nvGrpSpPr>
+      <p:grpSpPr>
+        <a:xfrm xmlns:a="http://schemas.openxmlformats.org/drawingml/2006/main"/>
+      </p:grpSpPr>
+      <p:sp>
+        <p:nvSpPr>
+          <p:cNvPr id="2" name="Slide Image Placeholder 1"/>
+          <p:cNvSpPr>
+            <a:spLocks xmlns:a="http://schemas.openxmlformats.org/drawingml/2006/main" noGrp="1"/>
+          </p:cNvSpPr>
+          <p:nvPr>
+            <p:ph type="sldImg" idx="0"/>
+          </p:nvPr>
+        </p:nvSpPr>
+        <p:spPr/>
+      </p:sp>
+      <p:sp>
+        <p:nvSpPr>
+          <p:cNvPr id="3" name="Notes Placeholder 2"/>
+          <p:cNvSpPr>
+            <a:spLocks xmlns:a="http://schemas.openxmlformats.org/drawingml/2006/main" noGrp="1"/>
+          </p:cNvSpPr>
+          <p:nvPr>
+            <p:ph type="body" idx="1"/>
+          </p:nvPr>
+        </p:nvSpPr>
+        <p:spPr/>
+        <p:txBody>
+          <a:bodyPr xmlns:a="http://schemas.openxmlformats.org/drawingml/2006/main"/>
+          <a:lstStyle xmlns:a="http://schemas.openxmlformats.org/drawingml/2006/main"/>
+          <a:p xmlns:a="http://schemas.openxmlformats.org/drawingml/2006/main">
+            <a:r>
+              <a:t>These are the exact synthetic assignment messages, reproduced from the labels-free input file verified against the frozen baseline requests. They entered the separate candidate generation without case IDs or reference labels. C04, C43 and C49 are three new urgent-action false negatives under the unchanged physician v3 reference: the candidate still requests clinician review but assigns async instead of urgent care. The table records a routing disagreement, not an observed patient outcome or a confirmed diagnosis. No case-specific runtime rule or label revision follows from this review. All three cases and rationales remain in the frozen development scorecard. No CSV label serves as a clinical target.</a:t>
+            </a:r>
+          </a:p>
+          <a:p xmlns:a="http://schemas.openxmlformats.org/drawingml/2006/main">
+            <a:r>
+              <a:t/>
+            </a:r>
+          </a:p>
+          <a:p xmlns:a="http://schemas.openxmlformats.org/drawingml/2006/main">
+            <a:r>
+              <a:t>Sources</a:t>
+            </a:r>
+          </a:p>
+          <a:p xmlns:a="http://schemas.openxmlformats.org/drawingml/2006/main">
+            <a:r>
+              <a:t>outputs/fn-reduction-2026-09-16/known-messages.json</a:t>
+            </a:r>
+          </a:p>
+          <a:p xmlns:a="http://schemas.openxmlformats.org/drawingml/2006/main">
+            <a:r>
+              <a:t/>
+            </a:r>
+          </a:p>
+          <a:p xmlns:a="http://schemas.openxmlformats.org/drawingml/2006/main">
+            <a:r>
+              <a:t>outputs/fn-reduction-2026-09-16/scorecard-known-development.json</a:t>
             </a:r>
           </a:p>
         </p:txBody>
@@ -3517,7 +3975,7 @@
   </p:cSld>
   <p:clrMap bg1="lt1" tx1="dk1" bg2="lt2" tx2="dk2" accent1="accent1" accent2="accent2" accent3="accent3" accent4="accent4" accent5="accent5" accent6="accent6" hlink="hlink" folHlink="folHlink"/>
   <p:sldLayoutIdLst>
-    <p:sldLayoutId xmlns:r="http://schemas.openxmlformats.org/officeDocument/2006/relationships" id="2147483649" r:id="Rbdfe5d67516b4d09"/>
+    <p:sldLayoutId xmlns:r="http://schemas.openxmlformats.org/officeDocument/2006/relationships" id="2147483649" r:id="Rdeee332b0a2243e9"/>
   </p:sldLayoutIdLst>
   <p:txStyles>
     <p:titleStyle>
@@ -4068,7 +4526,7 @@
           <p:cNvPr id="16" name="">
             <a:extLst>
               <a:ext uri="{FF2B5EF4-FFF2-40B4-BE49-F238E27FC236}">
-                <ns2:creationId id="{0579E67A-063F-4EF2-8DC1-CDD9D61E377D}"/>
+                <ns2:creationId id="{E1AFEE42-206F-4F05-B6E8-29A36C8568DA}"/>
               </a:ext>
             </a:extLst>
           </p:cNvPr>
@@ -4125,7 +4583,7 @@
           <p:cNvPr id="2" name="">
             <a:extLst>
               <a:ext uri="{FF2B5EF4-FFF2-40B4-BE49-F238E27FC236}">
-                <ns2:creationId id="{5CF8C036-D753-4BAE-83E7-61ADEBC99CA2}"/>
+                <ns2:creationId id="{CF2164FB-7344-4DF5-8A87-D97D62C1B85D}"/>
               </a:ext>
             </a:extLst>
           </p:cNvPr>
@@ -4186,7 +4644,7 @@
           <p:nvPr/>
         </p:nvPicPr>
         <p:blipFill>
-          <a:blip r:embed="R2d335d7e7a2f4f5b"/>
+          <a:blip r:embed="Rec8ef0f6b4df4340"/>
           <a:stretch/>
         </p:blipFill>
         <p:spPr>
@@ -4204,7 +4662,7 @@
           <p:cNvPr id="4" name="">
             <a:extLst>
               <a:ext uri="{FF2B5EF4-FFF2-40B4-BE49-F238E27FC236}">
-                <ns2:creationId id="{A787EBAE-CAA7-4C74-BFF4-F4FE7EB63B9C}"/>
+                <ns2:creationId id="{D0DA9419-C4FE-4C02-8E53-B4AA2B53A0D8}"/>
               </a:ext>
             </a:extLst>
           </p:cNvPr>
@@ -4261,7 +4719,7 @@
           <p:cNvPr id="5" name="">
             <a:extLst>
               <a:ext uri="{FF2B5EF4-FFF2-40B4-BE49-F238E27FC236}">
-                <ns2:creationId id="{F883B9C1-CEE5-456D-ABA4-3B2894AED7F1}"/>
+                <ns2:creationId id="{DF238197-91C0-4E28-8414-002843DF5EED}"/>
               </a:ext>
             </a:extLst>
           </p:cNvPr>
@@ -4318,7 +4776,7 @@
           <p:cNvPr id="6" name="">
             <a:extLst>
               <a:ext uri="{FF2B5EF4-FFF2-40B4-BE49-F238E27FC236}">
-                <ns2:creationId id="{5AC12C77-7D19-4955-BB79-5FA58A955C68}"/>
+                <ns2:creationId id="{8ED08D6D-7676-4515-80F3-84EBB7A8F643}"/>
               </a:ext>
             </a:extLst>
           </p:cNvPr>
@@ -4375,7 +4833,7 @@
           <p:cNvPr id="7" name="">
             <a:extLst>
               <a:ext uri="{FF2B5EF4-FFF2-40B4-BE49-F238E27FC236}">
-                <ns2:creationId id="{73924621-C5F4-45A0-80ED-0342D736660A}"/>
+                <ns2:creationId id="{AB234C04-6B4D-4115-9FE0-374323905D22}"/>
               </a:ext>
             </a:extLst>
           </p:cNvPr>
@@ -4432,7 +4890,7 @@
           <p:cNvPr id="8" name="">
             <a:extLst>
               <a:ext uri="{FF2B5EF4-FFF2-40B4-BE49-F238E27FC236}">
-                <ns2:creationId id="{B1F23241-0F58-4498-BECE-9DC8395EBC7F}"/>
+                <ns2:creationId id="{3C55C66A-E3F1-4B60-ABD1-FF3B09733700}"/>
               </a:ext>
             </a:extLst>
           </p:cNvPr>
@@ -4490,7 +4948,7 @@
           <p:cNvPr id="9" name="">
             <a:extLst>
               <a:ext uri="{FF2B5EF4-FFF2-40B4-BE49-F238E27FC236}">
-                <ns2:creationId id="{B72E36E2-B0B0-4F71-86FA-394905246888}"/>
+                <ns2:creationId id="{7D8CE243-B554-46BA-94BC-4541C71B609C}"/>
               </a:ext>
             </a:extLst>
           </p:cNvPr>
@@ -4547,7 +5005,7 @@
           <p:cNvPr id="10" name="">
             <a:extLst>
               <a:ext uri="{FF2B5EF4-FFF2-40B4-BE49-F238E27FC236}">
-                <ns2:creationId id="{63E4CC0E-FB68-4004-A68C-E0E0F748B9F5}"/>
+                <ns2:creationId id="{E5AFD7CC-087B-41B6-AA89-4801F43BBC24}"/>
               </a:ext>
             </a:extLst>
           </p:cNvPr>
@@ -4604,7 +5062,7 @@
           <p:cNvPr id="11" name="">
             <a:extLst>
               <a:ext uri="{FF2B5EF4-FFF2-40B4-BE49-F238E27FC236}">
-                <ns2:creationId id="{4489691D-F784-4BA0-8C22-2BEAD345F505}"/>
+                <ns2:creationId id="{73BECD1B-DD00-4E4E-9F08-966BD7C42BCB}"/>
               </a:ext>
             </a:extLst>
           </p:cNvPr>
@@ -4662,7 +5120,7 @@
           <p:cNvPr id="12" name="">
             <a:extLst>
               <a:ext uri="{FF2B5EF4-FFF2-40B4-BE49-F238E27FC236}">
-                <ns2:creationId id="{BAA1923E-14E3-41BD-856B-0B62DDB147FF}"/>
+                <ns2:creationId id="{206605D2-8598-4C77-B587-448F7B193A1B}"/>
               </a:ext>
             </a:extLst>
           </p:cNvPr>
@@ -4719,7 +5177,7 @@
           <p:cNvPr id="13" name="">
             <a:extLst>
               <a:ext uri="{FF2B5EF4-FFF2-40B4-BE49-F238E27FC236}">
-                <ns2:creationId id="{1577713D-44D8-43C3-9477-4831570DB6B0}"/>
+                <ns2:creationId id="{D5C61D7A-77EB-4AD2-9374-FE827C966B94}"/>
               </a:ext>
             </a:extLst>
           </p:cNvPr>
@@ -4776,7 +5234,7 @@
           <p:cNvPr id="14" name="">
             <a:extLst>
               <a:ext uri="{FF2B5EF4-FFF2-40B4-BE49-F238E27FC236}">
-                <ns2:creationId id="{2743287A-83F0-4812-B4E2-B0551CC27B3D}"/>
+                <ns2:creationId id="{FCC89A28-5B1C-4A37-AC49-9E19CF627601}"/>
               </a:ext>
             </a:extLst>
           </p:cNvPr>
@@ -4833,7 +5291,7 @@
           <p:cNvPr id="15" name="">
             <a:extLst>
               <a:ext uri="{FF2B5EF4-FFF2-40B4-BE49-F238E27FC236}">
-                <ns2:creationId id="{02494F5B-190E-4204-9016-CBB670E2C00B}"/>
+                <ns2:creationId id="{6D31EA88-0FFD-4FD7-BC40-CAEC4E48A97A}"/>
               </a:ext>
             </a:extLst>
           </p:cNvPr>
@@ -4888,7 +5346,7 @@
     </p:spTree>
     <p:extLst>
       <p:ext uri="{BB962C8B-B14F-4D97-AF65-F5344CB8AC3E}">
-        <ns4:creationId val="1039736999"/>
+        <ns4:creationId val="618866186"/>
       </p:ext>
     </p:extLst>
   </p:cSld>
@@ -4919,7 +5377,7 @@
           <p:cNvPr id="7" name="">
             <a:extLst xmlns:a="http://schemas.openxmlformats.org/drawingml/2006/main">
               <a:ext uri="{FF2B5EF4-FFF2-40B4-BE49-F238E27FC236}">
-                <a16:creationId xmlns:a16="http://schemas.microsoft.com/office/drawing/2014/main" id="{98FDA846-45A3-401C-B817-A4FA5DDD65B3}"/>
+                <a16:creationId xmlns:a16="http://schemas.microsoft.com/office/drawing/2014/main" id="{2A23B494-59E0-4EDB-AFE1-B050FAFCC7C5}"/>
               </a:ext>
             </a:extLst>
           </p:cNvPr>
@@ -5588,7 +6046,7 @@
           <p:cNvPr id="3" name="">
             <a:extLst xmlns:a="http://schemas.openxmlformats.org/drawingml/2006/main">
               <a:ext uri="{FF2B5EF4-FFF2-40B4-BE49-F238E27FC236}">
-                <a16:creationId xmlns:a16="http://schemas.microsoft.com/office/drawing/2014/main" id="{215F0F48-CE2B-4FBB-8723-C57D5C93E698}"/>
+                <a16:creationId xmlns:a16="http://schemas.microsoft.com/office/drawing/2014/main" id="{721F2854-8D98-4A80-8834-CC2561C9AEC2}"/>
               </a:ext>
             </a:extLst>
           </p:cNvPr>
@@ -5645,7 +6103,7 @@
           <p:cNvPr id="4" name="">
             <a:extLst xmlns:a="http://schemas.openxmlformats.org/drawingml/2006/main">
               <a:ext uri="{FF2B5EF4-FFF2-40B4-BE49-F238E27FC236}">
-                <a16:creationId xmlns:a16="http://schemas.microsoft.com/office/drawing/2014/main" id="{FDC93105-3D67-4106-9348-319B14E0795E}"/>
+                <a16:creationId xmlns:a16="http://schemas.microsoft.com/office/drawing/2014/main" id="{9FA4F055-8694-4187-9EF2-3CE486EC4F68}"/>
               </a:ext>
             </a:extLst>
           </p:cNvPr>
@@ -5702,7 +6160,7 @@
           <p:cNvPr id="5" name="">
             <a:extLst xmlns:a="http://schemas.openxmlformats.org/drawingml/2006/main">
               <a:ext uri="{FF2B5EF4-FFF2-40B4-BE49-F238E27FC236}">
-                <a16:creationId xmlns:a16="http://schemas.microsoft.com/office/drawing/2014/main" id="{08907DAD-DAD1-4A7D-A488-CCD39D8DC691}"/>
+                <a16:creationId xmlns:a16="http://schemas.microsoft.com/office/drawing/2014/main" id="{9F2AAD90-C80A-44B8-874A-8E35275621B1}"/>
               </a:ext>
             </a:extLst>
           </p:cNvPr>
@@ -5759,7 +6217,7 @@
           <p:cNvPr id="6" name="">
             <a:extLst xmlns:a="http://schemas.openxmlformats.org/drawingml/2006/main">
               <a:ext uri="{FF2B5EF4-FFF2-40B4-BE49-F238E27FC236}">
-                <a16:creationId xmlns:a16="http://schemas.microsoft.com/office/drawing/2014/main" id="{AFD13AAA-C22A-442D-BE2E-084519C6498A}"/>
+                <a16:creationId xmlns:a16="http://schemas.microsoft.com/office/drawing/2014/main" id="{4AB44A41-0C0A-44B6-9C99-A3E2DCE120C4}"/>
               </a:ext>
             </a:extLst>
           </p:cNvPr>
@@ -5814,7 +6272,7 @@
     </p:spTree>
     <p:extLst>
       <p:ext uri="{BB962C8B-B14F-4D97-AF65-F5344CB8AC3E}">
-        <p14:creationId xmlns:p14="http://schemas.microsoft.com/office/powerpoint/2010/main" val="138526618"/>
+        <p14:creationId xmlns:p14="http://schemas.microsoft.com/office/powerpoint/2010/main" val="1300347087"/>
       </p:ext>
     </p:extLst>
   </p:cSld>
@@ -5845,7 +6303,7 @@
           <p:cNvPr id="7" name="">
             <a:extLst xmlns:a="http://schemas.openxmlformats.org/drawingml/2006/main">
               <a:ext uri="{FF2B5EF4-FFF2-40B4-BE49-F238E27FC236}">
-                <a16:creationId xmlns:a16="http://schemas.microsoft.com/office/drawing/2014/main" id="{7360AE7C-04C7-4BA5-96EF-E67F4988D9FB}"/>
+                <a16:creationId xmlns:a16="http://schemas.microsoft.com/office/drawing/2014/main" id="{8363ED18-B1C7-4199-A37B-4373897DE11F}"/>
               </a:ext>
             </a:extLst>
           </p:cNvPr>
@@ -6221,7 +6679,7 @@
           <p:cNvPr id="3" name="">
             <a:extLst xmlns:a="http://schemas.openxmlformats.org/drawingml/2006/main">
               <a:ext uri="{FF2B5EF4-FFF2-40B4-BE49-F238E27FC236}">
-                <a16:creationId xmlns:a16="http://schemas.microsoft.com/office/drawing/2014/main" id="{93E45AE0-F425-48A0-BF56-8BD308DA4888}"/>
+                <a16:creationId xmlns:a16="http://schemas.microsoft.com/office/drawing/2014/main" id="{241F4AE8-D559-4FFA-B9E1-20E1729FA924}"/>
               </a:ext>
             </a:extLst>
           </p:cNvPr>
@@ -6278,7 +6736,7 @@
           <p:cNvPr id="4" name="">
             <a:extLst xmlns:a="http://schemas.openxmlformats.org/drawingml/2006/main">
               <a:ext uri="{FF2B5EF4-FFF2-40B4-BE49-F238E27FC236}">
-                <a16:creationId xmlns:a16="http://schemas.microsoft.com/office/drawing/2014/main" id="{D9560368-433F-4978-8E1E-57522F62F4A9}"/>
+                <a16:creationId xmlns:a16="http://schemas.microsoft.com/office/drawing/2014/main" id="{A5346F80-ABDA-46FF-B67E-217AFC7552FA}"/>
               </a:ext>
             </a:extLst>
           </p:cNvPr>
@@ -6335,7 +6793,7 @@
           <p:cNvPr id="5" name="">
             <a:extLst xmlns:a="http://schemas.openxmlformats.org/drawingml/2006/main">
               <a:ext uri="{FF2B5EF4-FFF2-40B4-BE49-F238E27FC236}">
-                <a16:creationId xmlns:a16="http://schemas.microsoft.com/office/drawing/2014/main" id="{B86D1774-1A07-40E0-AD46-7C628EE0532C}"/>
+                <a16:creationId xmlns:a16="http://schemas.microsoft.com/office/drawing/2014/main" id="{B546DE83-20DF-4091-8B2E-25C9FDB98115}"/>
               </a:ext>
             </a:extLst>
           </p:cNvPr>
@@ -6392,7 +6850,7 @@
           <p:cNvPr id="6" name="">
             <a:extLst xmlns:a="http://schemas.openxmlformats.org/drawingml/2006/main">
               <a:ext uri="{FF2B5EF4-FFF2-40B4-BE49-F238E27FC236}">
-                <a16:creationId xmlns:a16="http://schemas.microsoft.com/office/drawing/2014/main" id="{051D414E-204C-44D4-B4E7-929080986DD5}"/>
+                <a16:creationId xmlns:a16="http://schemas.microsoft.com/office/drawing/2014/main" id="{874F58C9-55C5-412B-8DA7-92FDC3E9F7A6}"/>
               </a:ext>
             </a:extLst>
           </p:cNvPr>
@@ -6447,7 +6905,7 @@
     </p:spTree>
     <p:extLst>
       <p:ext uri="{BB962C8B-B14F-4D97-AF65-F5344CB8AC3E}">
-        <p14:creationId xmlns:p14="http://schemas.microsoft.com/office/powerpoint/2010/main" val="1910218377"/>
+        <p14:creationId xmlns:p14="http://schemas.microsoft.com/office/powerpoint/2010/main" val="261451796"/>
       </p:ext>
     </p:extLst>
   </p:cSld>
@@ -6478,7 +6936,7 @@
           <p:cNvPr id="5" name="">
             <a:extLst xmlns:a="http://schemas.openxmlformats.org/drawingml/2006/main">
               <a:ext uri="{FF2B5EF4-FFF2-40B4-BE49-F238E27FC236}">
-                <a16:creationId xmlns:a16="http://schemas.microsoft.com/office/drawing/2014/main" id="{8881F46F-15DC-4B64-9D2F-3DE62ABA3FF0}"/>
+                <a16:creationId xmlns:a16="http://schemas.microsoft.com/office/drawing/2014/main" id="{CF60605E-4E4C-4047-BDC5-569BEA3D07F2}"/>
               </a:ext>
             </a:extLst>
           </p:cNvPr>
@@ -6490,7 +6948,7 @@
         <p:spPr>
           <a:xfrm xmlns:a="http://schemas.openxmlformats.org/drawingml/2006/main">
             <a:off x="762000" y="485775"/>
-            <a:ext cx="10668000" cy="1096899"/>
+            <a:ext cx="10668000" cy="586550"/>
           </a:xfrm>
           <a:prstGeom xmlns:a="http://schemas.openxmlformats.org/drawingml/2006/main" prst="rect">
             <a:avLst/>
@@ -6525,7 +6983,7 @@
                 <a:ea typeface="Arial"/>
                 <a:cs typeface="Arial"/>
               </a:rPr>
-              <a:t>Clinical quality assurance uses separate endpoints</a:t>
+              <a:t>Safety endpoints for the frozen baseline</a:t>
             </a:r>
           </a:p>
         </p:txBody>
@@ -6537,16 +6995,16 @@
           <p:nvPr/>
         </p:nvGraphicFramePr>
         <p:xfrm>
-          <a:off xmlns:a="http://schemas.openxmlformats.org/drawingml/2006/main" x="762000" y="1839849"/>
-          <a:ext xmlns:a="http://schemas.openxmlformats.org/drawingml/2006/main" cx="10668000" cy="2920746"/>
+          <a:off xmlns:a="http://schemas.openxmlformats.org/drawingml/2006/main" x="762000" y="1619250"/>
+          <a:ext xmlns:a="http://schemas.openxmlformats.org/drawingml/2006/main" cx="10668000" cy="2358390"/>
         </p:xfrm>
         <a:graphic xmlns:a="http://schemas.openxmlformats.org/drawingml/2006/main">
           <a:graphicData uri="http://schemas.openxmlformats.org/drawingml/2006/table">
             <a:tbl>
               <a:tblPr firstRow="1" bandRow="0"/>
               <a:tblGrid>
-                <a:gridCol w="4267200"/>
-                <a:gridCol w="6400800"/>
+                <a:gridCol w="4480560"/>
+                <a:gridCol w="6187440"/>
               </a:tblGrid>
               <a:tr h="471678">
                 <a:tc>
@@ -6563,7 +7021,7 @@
                           <a:ea typeface="Arial"/>
                           <a:cs typeface="Arial"/>
                         </a:rPr>
-                        <a:t>Question</a:t>
+                        <a:t>Endpoint</a:t>
                       </a:r>
                     </a:p>
                   </a:txBody>
@@ -6587,7 +7045,7 @@
                           <a:ea typeface="Arial"/>
                           <a:cs typeface="Arial"/>
                         </a:rPr>
-                        <a:t>How to evaluate it</a:t>
+                        <a:t>Observed result</a:t>
                       </a:r>
                     </a:p>
                   </a:txBody>
@@ -6613,7 +7071,7 @@
                           <a:ea typeface="Arial"/>
                           <a:cs typeface="Arial"/>
                         </a:rPr>
-                        <a:t>Was the care setting appropriate?</a:t>
+                        <a:t>Required clinician action</a:t>
                       </a:r>
                     </a:p>
                   </a:txBody>
@@ -6637,57 +7095,7 @@
                           <a:ea typeface="Arial"/>
                           <a:cs typeface="Arial"/>
                         </a:rPr>
-                        <a:t>Versioned physician reference; deterministic scoring</a:t>
-                      </a:r>
-                    </a:p>
-                  </a:txBody>
-                  <a:tcPr marL="133350" marR="133350" marT="76200" marB="76200" anchor="ctr">
-                    <a:solidFill>
-                      <a:srgbClr val="F6F4ED"/>
-                    </a:solidFill>
-                  </a:tcPr>
-                </a:tc>
-              </a:tr>
-              <a:tr h="752856">
-                <a:tc>
-                  <a:txBody>
-                    <a:bodyPr/>
-                    <a:lstStyle/>
-                    <a:p>
-                      <a:r>
-                        <a:rPr sz="1800" b="0">
-                          <a:solidFill>
-                            <a:srgbClr val="28354A"/>
-                          </a:solidFill>
-                          <a:latin typeface="Arial"/>
-                          <a:ea typeface="Arial"/>
-                          <a:cs typeface="Arial"/>
-                        </a:rPr>
-                        <a:t>Was necessary clinician action missed?</a:t>
-                      </a:r>
-                    </a:p>
-                  </a:txBody>
-                  <a:tcPr marL="133350" marR="133350" marT="76200" marB="76200" anchor="ctr">
-                    <a:solidFill>
-                      <a:srgbClr val="F6F4ED"/>
-                    </a:solidFill>
-                  </a:tcPr>
-                </a:tc>
-                <a:tc>
-                  <a:txBody>
-                    <a:bodyPr/>
-                    <a:lstStyle/>
-                    <a:p>
-                      <a:r>
-                        <a:rPr sz="1800" b="0">
-                          <a:solidFill>
-                            <a:srgbClr val="28354A"/>
-                          </a:solidFill>
-                          <a:latin typeface="Arial"/>
-                          <a:ea typeface="Arial"/>
-                          <a:cs typeface="Arial"/>
-                        </a:rPr>
-                        <a:t>False negatives with a defined positive endpoint</a:t>
+                        <a:t>41/43 received a clinician or urgent disposition</a:t>
                       </a:r>
                     </a:p>
                   </a:txBody>
@@ -6713,7 +7121,7 @@
                           <a:ea typeface="Arial"/>
                           <a:cs typeface="Arial"/>
                         </a:rPr>
-                        <a:t>Was escalation unnecessary?</a:t>
+                        <a:t>Self-care when review was required</a:t>
                       </a:r>
                     </a:p>
                   </a:txBody>
@@ -6737,7 +7145,7 @@
                           <a:ea typeface="Arial"/>
                           <a:cs typeface="Arial"/>
                         </a:rPr>
-                        <a:t>False positives; distinguish urgency from any review</a:t>
+                        <a:t>2/9 self-care outputs: C22 and C47</a:t>
                       </a:r>
                     </a:p>
                   </a:txBody>
@@ -6748,7 +7156,7 @@
                   </a:tcPr>
                 </a:tc>
               </a:tr>
-              <a:tr h="752856">
+              <a:tr h="471678">
                 <a:tc>
                   <a:txBody>
                     <a:bodyPr/>
@@ -6763,7 +7171,7 @@
                           <a:ea typeface="Arial"/>
                           <a:cs typeface="Arial"/>
                         </a:rPr>
-                        <a:t>Was the rationale appropriate?</a:t>
+                        <a:t>Required urgent escalation</a:t>
                       </a:r>
                     </a:p>
                   </a:txBody>
@@ -6787,7 +7195,57 @@
                           <a:ea typeface="Arial"/>
                           <a:cs typeface="Arial"/>
                         </a:rPr>
-                        <a:t>Independent review of assumptions, medication advice, and precautions</a:t>
+                        <a:t>25/25 received an urgent disposition</a:t>
+                      </a:r>
+                    </a:p>
+                  </a:txBody>
+                  <a:tcPr marL="133350" marR="133350" marT="76200" marB="76200" anchor="ctr">
+                    <a:solidFill>
+                      <a:srgbClr val="F6F4ED"/>
+                    </a:solidFill>
+                  </a:tcPr>
+                </a:tc>
+              </a:tr>
+              <a:tr h="471678">
+                <a:tc>
+                  <a:txBody>
+                    <a:bodyPr/>
+                    <a:lstStyle/>
+                    <a:p>
+                      <a:r>
+                        <a:rPr sz="1800" b="0">
+                          <a:solidFill>
+                            <a:srgbClr val="28354A"/>
+                          </a:solidFill>
+                          <a:latin typeface="Arial"/>
+                          <a:ea typeface="Arial"/>
+                          <a:cs typeface="Arial"/>
+                        </a:rPr>
+                        <a:t>Rationale quality</a:t>
+                      </a:r>
+                    </a:p>
+                  </a:txBody>
+                  <a:tcPr marL="133350" marR="133350" marT="76200" marB="76200" anchor="ctr">
+                    <a:solidFill>
+                      <a:srgbClr val="F6F4ED"/>
+                    </a:solidFill>
+                  </a:tcPr>
+                </a:tc>
+                <a:tc>
+                  <a:txBody>
+                    <a:bodyPr/>
+                    <a:lstStyle/>
+                    <a:p>
+                      <a:r>
+                        <a:rPr sz="1800" b="0">
+                          <a:solidFill>
+                            <a:srgbClr val="28354A"/>
+                          </a:solidFill>
+                          <a:latin typeface="Arial"/>
+                          <a:ea typeface="Arial"/>
+                          <a:cs typeface="Arial"/>
+                        </a:rPr>
+                        <a:t>C22/C47 treat unreported findings as absent</a:t>
                       </a:r>
                     </a:p>
                   </a:txBody>
@@ -6807,7 +7265,7 @@
           <p:cNvPr id="3" name="">
             <a:extLst xmlns:a="http://schemas.openxmlformats.org/drawingml/2006/main">
               <a:ext uri="{FF2B5EF4-FFF2-40B4-BE49-F238E27FC236}">
-                <a16:creationId xmlns:a16="http://schemas.microsoft.com/office/drawing/2014/main" id="{36D74147-255D-4604-A46A-6E0A693BA5BE}"/>
+                <a16:creationId xmlns:a16="http://schemas.microsoft.com/office/drawing/2014/main" id="{464B8B2D-081C-4137-96E3-81983AB78F65}"/>
               </a:ext>
             </a:extLst>
           </p:cNvPr>
@@ -6854,7 +7312,7 @@
                 <a:ea typeface="Arial"/>
                 <a:cs typeface="Arial"/>
               </a:rPr>
-              <a:t>The prototype has no judge call. These are evaluation dimensions, not added runtime steps.</a:t>
+              <a:t>Known development cases and post-output physician review. No outcomes measured. Urgent routing does not establish timing.</a:t>
             </a:r>
           </a:p>
         </p:txBody>
@@ -6864,7 +7322,7 @@
           <p:cNvPr id="4" name="">
             <a:extLst xmlns:a="http://schemas.openxmlformats.org/drawingml/2006/main">
               <a:ext uri="{FF2B5EF4-FFF2-40B4-BE49-F238E27FC236}">
-                <a16:creationId xmlns:a16="http://schemas.microsoft.com/office/drawing/2014/main" id="{00020263-A6BE-48DF-8470-AE112CF1B932}"/>
+                <a16:creationId xmlns:a16="http://schemas.microsoft.com/office/drawing/2014/main" id="{F5B7BB06-B8C4-4841-B750-F926208CB509}"/>
               </a:ext>
             </a:extLst>
           </p:cNvPr>
@@ -6919,7 +7377,7 @@
     </p:spTree>
     <p:extLst>
       <p:ext uri="{BB962C8B-B14F-4D97-AF65-F5344CB8AC3E}">
-        <p14:creationId xmlns:p14="http://schemas.microsoft.com/office/powerpoint/2010/main" val="1998527004"/>
+        <p14:creationId xmlns:p14="http://schemas.microsoft.com/office/powerpoint/2010/main" val="809918692"/>
       </p:ext>
     </p:extLst>
   </p:cSld>
@@ -6950,7 +7408,7 @@
           <p:cNvPr id="5" name="">
             <a:extLst xmlns:a="http://schemas.openxmlformats.org/drawingml/2006/main">
               <a:ext uri="{FF2B5EF4-FFF2-40B4-BE49-F238E27FC236}">
-                <a16:creationId xmlns:a16="http://schemas.microsoft.com/office/drawing/2014/main" id="{3EB8AACD-0A06-4BEB-AB49-1ABADABF422C}"/>
+                <a16:creationId xmlns:a16="http://schemas.microsoft.com/office/drawing/2014/main" id="{F779E6DD-A311-42D8-9A85-90E0973133E5}"/>
               </a:ext>
             </a:extLst>
           </p:cNvPr>
@@ -7329,7 +7787,7 @@
           <p:cNvPr id="3" name="">
             <a:extLst xmlns:a="http://schemas.openxmlformats.org/drawingml/2006/main">
               <a:ext uri="{FF2B5EF4-FFF2-40B4-BE49-F238E27FC236}">
-                <a16:creationId xmlns:a16="http://schemas.microsoft.com/office/drawing/2014/main" id="{F049F6EF-C87F-4CE5-B4EC-B6C62046D46D}"/>
+                <a16:creationId xmlns:a16="http://schemas.microsoft.com/office/drawing/2014/main" id="{CB6D5277-48B5-42FC-8322-97356276BE48}"/>
               </a:ext>
             </a:extLst>
           </p:cNvPr>
@@ -7386,7 +7844,7 @@
           <p:cNvPr id="4" name="">
             <a:extLst xmlns:a="http://schemas.openxmlformats.org/drawingml/2006/main">
               <a:ext uri="{FF2B5EF4-FFF2-40B4-BE49-F238E27FC236}">
-                <a16:creationId xmlns:a16="http://schemas.microsoft.com/office/drawing/2014/main" id="{86C45D8F-50DA-401E-BD11-C1A48C6283F6}"/>
+                <a16:creationId xmlns:a16="http://schemas.microsoft.com/office/drawing/2014/main" id="{90EA7474-35A2-4B69-95E8-3E76201B70C9}"/>
               </a:ext>
             </a:extLst>
           </p:cNvPr>
@@ -7441,7 +7899,7 @@
     </p:spTree>
     <p:extLst>
       <p:ext uri="{BB962C8B-B14F-4D97-AF65-F5344CB8AC3E}">
-        <p14:creationId xmlns:p14="http://schemas.microsoft.com/office/powerpoint/2010/main" val="1278315925"/>
+        <p14:creationId xmlns:p14="http://schemas.microsoft.com/office/powerpoint/2010/main" val="778116643"/>
       </p:ext>
     </p:extLst>
   </p:cSld>
@@ -7472,7 +7930,7 @@
           <p:cNvPr id="5" name="">
             <a:extLst xmlns:a="http://schemas.openxmlformats.org/drawingml/2006/main">
               <a:ext uri="{FF2B5EF4-FFF2-40B4-BE49-F238E27FC236}">
-                <a16:creationId xmlns:a16="http://schemas.microsoft.com/office/drawing/2014/main" id="{CD2F7017-C1A2-450F-9526-88EB386EC61E}"/>
+                <a16:creationId xmlns:a16="http://schemas.microsoft.com/office/drawing/2014/main" id="{97688234-269C-4EBD-B37A-562DB441FB25}"/>
               </a:ext>
             </a:extLst>
           </p:cNvPr>
@@ -7974,7 +8432,7 @@
           <p:cNvPr id="3" name="">
             <a:extLst xmlns:a="http://schemas.openxmlformats.org/drawingml/2006/main">
               <a:ext uri="{FF2B5EF4-FFF2-40B4-BE49-F238E27FC236}">
-                <a16:creationId xmlns:a16="http://schemas.microsoft.com/office/drawing/2014/main" id="{F0F6FB56-8976-46DB-A555-DE3D1627195E}"/>
+                <a16:creationId xmlns:a16="http://schemas.microsoft.com/office/drawing/2014/main" id="{03516F15-AAB7-4F3E-9243-54BB73BB83FB}"/>
               </a:ext>
             </a:extLst>
           </p:cNvPr>
@@ -8021,7 +8479,7 @@
                 <a:ea typeface="Arial"/>
                 <a:cs typeface="Arial"/>
               </a:rPr>
-              <a:t>Proposed sequence. Week 4 produces a reviewed change and an evidence-based decision on its use.</a:t>
+              <a:t>The development ablation is complete. Blinded clinical validation remains pending. The selected GUI stays unchanged.</a:t>
             </a:r>
           </a:p>
         </p:txBody>
@@ -8031,7 +8489,7 @@
           <p:cNvPr id="4" name="">
             <a:extLst xmlns:a="http://schemas.openxmlformats.org/drawingml/2006/main">
               <a:ext uri="{FF2B5EF4-FFF2-40B4-BE49-F238E27FC236}">
-                <a16:creationId xmlns:a16="http://schemas.microsoft.com/office/drawing/2014/main" id="{1481778A-D336-421F-B244-B59D7CF7231B}"/>
+                <a16:creationId xmlns:a16="http://schemas.microsoft.com/office/drawing/2014/main" id="{A137E625-FE1A-4A8B-B693-6892E578B2B9}"/>
               </a:ext>
             </a:extLst>
           </p:cNvPr>
@@ -8086,7 +8544,7 @@
     </p:spTree>
     <p:extLst>
       <p:ext uri="{BB962C8B-B14F-4D97-AF65-F5344CB8AC3E}">
-        <p14:creationId xmlns:p14="http://schemas.microsoft.com/office/powerpoint/2010/main" val="563598645"/>
+        <p14:creationId xmlns:p14="http://schemas.microsoft.com/office/powerpoint/2010/main" val="1616477692"/>
       </p:ext>
     </p:extLst>
   </p:cSld>
@@ -8117,7 +8575,7 @@
           <p:cNvPr id="6" name="">
             <a:extLst xmlns:a="http://schemas.openxmlformats.org/drawingml/2006/main">
               <a:ext uri="{FF2B5EF4-FFF2-40B4-BE49-F238E27FC236}">
-                <a16:creationId xmlns:a16="http://schemas.microsoft.com/office/drawing/2014/main" id="{C1644EC4-FAD1-4015-BBCA-3CD721B73B0E}"/>
+                <a16:creationId xmlns:a16="http://schemas.microsoft.com/office/drawing/2014/main" id="{8C1D5EE1-C2B7-49A8-AE6B-221CF9A8F92B}"/>
               </a:ext>
             </a:extLst>
           </p:cNvPr>
@@ -8532,7 +8990,7 @@
           <p:cNvPr id="3" name="">
             <a:extLst xmlns:a="http://schemas.openxmlformats.org/drawingml/2006/main">
               <a:ext uri="{FF2B5EF4-FFF2-40B4-BE49-F238E27FC236}">
-                <a16:creationId xmlns:a16="http://schemas.microsoft.com/office/drawing/2014/main" id="{C5B88CBA-CB32-4332-B7EC-513871560DD9}"/>
+                <a16:creationId xmlns:a16="http://schemas.microsoft.com/office/drawing/2014/main" id="{68B0C354-FAB4-4FA2-9413-0EB59C7B58C9}"/>
               </a:ext>
             </a:extLst>
           </p:cNvPr>
@@ -8589,7 +9047,7 @@
           <p:cNvPr id="4" name="">
             <a:extLst xmlns:a="http://schemas.openxmlformats.org/drawingml/2006/main">
               <a:ext uri="{FF2B5EF4-FFF2-40B4-BE49-F238E27FC236}">
-                <a16:creationId xmlns:a16="http://schemas.microsoft.com/office/drawing/2014/main" id="{06B71CA6-93CD-4837-82AA-E80D77B31B09}"/>
+                <a16:creationId xmlns:a16="http://schemas.microsoft.com/office/drawing/2014/main" id="{BE6400E6-1195-4D5D-9036-BC9A4DF41EDE}"/>
               </a:ext>
             </a:extLst>
           </p:cNvPr>
@@ -8646,7 +9104,7 @@
           <p:cNvPr id="5" name="">
             <a:extLst xmlns:a="http://schemas.openxmlformats.org/drawingml/2006/main">
               <a:ext uri="{FF2B5EF4-FFF2-40B4-BE49-F238E27FC236}">
-                <a16:creationId xmlns:a16="http://schemas.microsoft.com/office/drawing/2014/main" id="{C7D4EA77-21BE-40B7-8126-F5F62ED5CC70}"/>
+                <a16:creationId xmlns:a16="http://schemas.microsoft.com/office/drawing/2014/main" id="{11836D48-11DF-486A-9F8D-4AD6312D372F}"/>
               </a:ext>
             </a:extLst>
           </p:cNvPr>
@@ -8701,7 +9159,7 @@
     </p:spTree>
     <p:extLst>
       <p:ext uri="{BB962C8B-B14F-4D97-AF65-F5344CB8AC3E}">
-        <p14:creationId xmlns:p14="http://schemas.microsoft.com/office/powerpoint/2010/main" val="1480777579"/>
+        <p14:creationId xmlns:p14="http://schemas.microsoft.com/office/powerpoint/2010/main" val="52404378"/>
       </p:ext>
     </p:extLst>
   </p:cSld>
@@ -8732,7 +9190,7 @@
           <p:cNvPr id="6" name="">
             <a:extLst xmlns:a="http://schemas.openxmlformats.org/drawingml/2006/main">
               <a:ext uri="{FF2B5EF4-FFF2-40B4-BE49-F238E27FC236}">
-                <a16:creationId xmlns:a16="http://schemas.microsoft.com/office/drawing/2014/main" id="{A4D213AF-6730-4CC1-A6F7-9185F5EA3B16}"/>
+                <a16:creationId xmlns:a16="http://schemas.microsoft.com/office/drawing/2014/main" id="{F0F5BF94-1DC8-42F8-93D4-DE28022F9A5F}"/>
               </a:ext>
             </a:extLst>
           </p:cNvPr>
@@ -8793,7 +9251,7 @@
           <p:nvPr/>
         </p:nvPicPr>
         <p:blipFill>
-          <a:blip xmlns:r="http://schemas.openxmlformats.org/officeDocument/2006/relationships" xmlns:a="http://schemas.openxmlformats.org/drawingml/2006/main" r:embed="R781e636d4a5a4dc2"/>
+          <a:blip xmlns:r="http://schemas.openxmlformats.org/officeDocument/2006/relationships" xmlns:a="http://schemas.openxmlformats.org/drawingml/2006/main" r:embed="R281d2eb4d7ce4015"/>
           <a:stretch xmlns:a="http://schemas.openxmlformats.org/drawingml/2006/main"/>
         </p:blipFill>
         <p:spPr>
@@ -8811,7 +9269,7 @@
           <p:cNvPr id="3" name="">
             <a:extLst xmlns:a="http://schemas.openxmlformats.org/drawingml/2006/main">
               <a:ext uri="{FF2B5EF4-FFF2-40B4-BE49-F238E27FC236}">
-                <a16:creationId xmlns:a16="http://schemas.microsoft.com/office/drawing/2014/main" id="{5D41656E-5411-42CC-9FB9-D8900A2F9417}"/>
+                <a16:creationId xmlns:a16="http://schemas.microsoft.com/office/drawing/2014/main" id="{D64E7FBB-A0BC-459F-A746-F9DCC75855F1}"/>
               </a:ext>
             </a:extLst>
           </p:cNvPr>
@@ -8868,7 +9326,7 @@
           <p:cNvPr id="4" name="">
             <a:extLst xmlns:a="http://schemas.openxmlformats.org/drawingml/2006/main">
               <a:ext uri="{FF2B5EF4-FFF2-40B4-BE49-F238E27FC236}">
-                <a16:creationId xmlns:a16="http://schemas.microsoft.com/office/drawing/2014/main" id="{167B37FD-F2F0-4B06-BD06-F88C8232FEB8}"/>
+                <a16:creationId xmlns:a16="http://schemas.microsoft.com/office/drawing/2014/main" id="{67BB2306-C7EE-4791-A06A-E220E1FF59C7}"/>
               </a:ext>
             </a:extLst>
           </p:cNvPr>
@@ -8948,7 +9406,7 @@
           <p:cNvPr id="5" name="">
             <a:extLst xmlns:a="http://schemas.openxmlformats.org/drawingml/2006/main">
               <a:ext uri="{FF2B5EF4-FFF2-40B4-BE49-F238E27FC236}">
-                <a16:creationId xmlns:a16="http://schemas.microsoft.com/office/drawing/2014/main" id="{7DC12622-F2DF-4E84-B341-2556AE1427AA}"/>
+                <a16:creationId xmlns:a16="http://schemas.microsoft.com/office/drawing/2014/main" id="{A8F1A77A-EB90-4D54-82A7-AC74347338D6}"/>
               </a:ext>
             </a:extLst>
           </p:cNvPr>
@@ -9003,7 +9461,7 @@
     </p:spTree>
     <p:extLst>
       <p:ext uri="{BB962C8B-B14F-4D97-AF65-F5344CB8AC3E}">
-        <p14:creationId xmlns:p14="http://schemas.microsoft.com/office/powerpoint/2010/main" val="730807956"/>
+        <p14:creationId xmlns:p14="http://schemas.microsoft.com/office/powerpoint/2010/main" val="1442526476"/>
       </p:ext>
     </p:extLst>
   </p:cSld>
@@ -9034,7 +9492,7 @@
           <p:cNvPr id="10" name="">
             <a:extLst xmlns:a="http://schemas.openxmlformats.org/drawingml/2006/main">
               <a:ext uri="{FF2B5EF4-FFF2-40B4-BE49-F238E27FC236}">
-                <a16:creationId xmlns:a16="http://schemas.microsoft.com/office/drawing/2014/main" id="{0BD899A5-AC1F-4A18-830C-6934433D46BD}"/>
+                <a16:creationId xmlns:a16="http://schemas.microsoft.com/office/drawing/2014/main" id="{977FF872-F4A6-423D-8490-1696B7C987F5}"/>
               </a:ext>
             </a:extLst>
           </p:cNvPr>
@@ -9091,7 +9549,7 @@
           <p:cNvPr id="2" name="">
             <a:extLst xmlns:a="http://schemas.openxmlformats.org/drawingml/2006/main">
               <a:ext uri="{FF2B5EF4-FFF2-40B4-BE49-F238E27FC236}">
-                <a16:creationId xmlns:a16="http://schemas.microsoft.com/office/drawing/2014/main" id="{3DF8AD92-9C5C-4D66-8284-4F5C17C95C22}"/>
+                <a16:creationId xmlns:a16="http://schemas.microsoft.com/office/drawing/2014/main" id="{05CFEB77-3403-4F9F-A147-AD7FC67F5759}"/>
               </a:ext>
             </a:extLst>
           </p:cNvPr>
@@ -9148,7 +9606,7 @@
           <p:cNvPr id="3" name="">
             <a:extLst xmlns:a="http://schemas.openxmlformats.org/drawingml/2006/main">
               <a:ext uri="{FF2B5EF4-FFF2-40B4-BE49-F238E27FC236}">
-                <a16:creationId xmlns:a16="http://schemas.microsoft.com/office/drawing/2014/main" id="{4A6CA82C-3CE0-4FA8-817A-02045769432F}"/>
+                <a16:creationId xmlns:a16="http://schemas.microsoft.com/office/drawing/2014/main" id="{6B37A2B9-7143-4386-A12F-1616A91676AA}"/>
               </a:ext>
             </a:extLst>
           </p:cNvPr>
@@ -9205,7 +9663,7 @@
           <p:cNvPr id="4" name="">
             <a:extLst xmlns:a="http://schemas.openxmlformats.org/drawingml/2006/main">
               <a:ext uri="{FF2B5EF4-FFF2-40B4-BE49-F238E27FC236}">
-                <a16:creationId xmlns:a16="http://schemas.microsoft.com/office/drawing/2014/main" id="{D6F77001-8213-431E-BAAC-2BF2BDAB1AEF}"/>
+                <a16:creationId xmlns:a16="http://schemas.microsoft.com/office/drawing/2014/main" id="{14962FD7-8CA4-4EBD-90AA-CB4B656E76AB}"/>
               </a:ext>
             </a:extLst>
           </p:cNvPr>
@@ -9262,7 +9720,7 @@
           <p:cNvPr id="5" name="">
             <a:extLst xmlns:a="http://schemas.openxmlformats.org/drawingml/2006/main">
               <a:ext uri="{FF2B5EF4-FFF2-40B4-BE49-F238E27FC236}">
-                <a16:creationId xmlns:a16="http://schemas.microsoft.com/office/drawing/2014/main" id="{A1C1DF80-478C-451F-8C78-8FD80ED61BB6}"/>
+                <a16:creationId xmlns:a16="http://schemas.microsoft.com/office/drawing/2014/main" id="{DA372AF6-7E71-458B-8330-6A1B00D2A5C6}"/>
               </a:ext>
             </a:extLst>
           </p:cNvPr>
@@ -9319,7 +9777,7 @@
           <p:cNvPr id="6" name="">
             <a:extLst xmlns:a="http://schemas.openxmlformats.org/drawingml/2006/main">
               <a:ext uri="{FF2B5EF4-FFF2-40B4-BE49-F238E27FC236}">
-                <a16:creationId xmlns:a16="http://schemas.microsoft.com/office/drawing/2014/main" id="{8F535F54-DF40-4CF2-AC1B-FB41A20737A2}"/>
+                <a16:creationId xmlns:a16="http://schemas.microsoft.com/office/drawing/2014/main" id="{2069A1A6-5268-434F-9E07-179A6B1262A6}"/>
               </a:ext>
             </a:extLst>
           </p:cNvPr>
@@ -9376,7 +9834,7 @@
           <p:cNvPr id="7" name="">
             <a:extLst xmlns:a="http://schemas.openxmlformats.org/drawingml/2006/main">
               <a:ext uri="{FF2B5EF4-FFF2-40B4-BE49-F238E27FC236}">
-                <a16:creationId xmlns:a16="http://schemas.microsoft.com/office/drawing/2014/main" id="{794E44C8-D98D-47E9-A7B7-BE355CA58AD8}"/>
+                <a16:creationId xmlns:a16="http://schemas.microsoft.com/office/drawing/2014/main" id="{66846337-471F-4E4D-8D75-723AFE65D677}"/>
               </a:ext>
             </a:extLst>
           </p:cNvPr>
@@ -9433,7 +9891,7 @@
           <p:cNvPr id="8" name="">
             <a:extLst xmlns:a="http://schemas.openxmlformats.org/drawingml/2006/main">
               <a:ext uri="{FF2B5EF4-FFF2-40B4-BE49-F238E27FC236}">
-                <a16:creationId xmlns:a16="http://schemas.microsoft.com/office/drawing/2014/main" id="{993ACF50-F29F-40EE-B2A8-5BDD680EFDC9}"/>
+                <a16:creationId xmlns:a16="http://schemas.microsoft.com/office/drawing/2014/main" id="{43CD4721-4D7A-460A-B463-5769451A9346}"/>
               </a:ext>
             </a:extLst>
           </p:cNvPr>
@@ -9490,7 +9948,7 @@
           <p:cNvPr id="9" name="">
             <a:extLst xmlns:a="http://schemas.openxmlformats.org/drawingml/2006/main">
               <a:ext uri="{FF2B5EF4-FFF2-40B4-BE49-F238E27FC236}">
-                <a16:creationId xmlns:a16="http://schemas.microsoft.com/office/drawing/2014/main" id="{F4614A51-FBBA-4340-B8CE-B503AD2D07BB}"/>
+                <a16:creationId xmlns:a16="http://schemas.microsoft.com/office/drawing/2014/main" id="{097FF824-A258-4DB9-B901-5CF3D606CC16}"/>
               </a:ext>
             </a:extLst>
           </p:cNvPr>
@@ -9545,7 +10003,7 @@
     </p:spTree>
     <p:extLst>
       <p:ext uri="{BB962C8B-B14F-4D97-AF65-F5344CB8AC3E}">
-        <p14:creationId xmlns:p14="http://schemas.microsoft.com/office/powerpoint/2010/main" val="44589273"/>
+        <p14:creationId xmlns:p14="http://schemas.microsoft.com/office/powerpoint/2010/main" val="376484738"/>
       </p:ext>
     </p:extLst>
   </p:cSld>
@@ -9576,7 +10034,7 @@
           <p:cNvPr id="5" name="">
             <a:extLst xmlns:a="http://schemas.openxmlformats.org/drawingml/2006/main">
               <a:ext uri="{FF2B5EF4-FFF2-40B4-BE49-F238E27FC236}">
-                <a16:creationId xmlns:a16="http://schemas.microsoft.com/office/drawing/2014/main" id="{339FC85A-C1DE-489E-BDAE-FEB45F6EF9CF}"/>
+                <a16:creationId xmlns:a16="http://schemas.microsoft.com/office/drawing/2014/main" id="{264AA7FC-05A8-4CB2-A207-92F89D4F4A56}"/>
               </a:ext>
             </a:extLst>
           </p:cNvPr>
@@ -9935,7 +10393,7 @@
                           <a:ea typeface="Arial"/>
                           <a:cs typeface="Arial"/>
                         </a:rPr>
-                        <a:t>15 main slides; 7-minute demo; 13 appendix slides</a:t>
+                        <a:t>15 main slides; 7-minute demo; 16 appendix slides</a:t>
                       </a:r>
                     </a:p>
                   </a:txBody>
@@ -9955,7 +10413,7 @@
           <p:cNvPr id="3" name="">
             <a:extLst xmlns:a="http://schemas.openxmlformats.org/drawingml/2006/main">
               <a:ext uri="{FF2B5EF4-FFF2-40B4-BE49-F238E27FC236}">
-                <a16:creationId xmlns:a16="http://schemas.microsoft.com/office/drawing/2014/main" id="{8457F249-957F-4B0F-B6E4-32435545174D}"/>
+                <a16:creationId xmlns:a16="http://schemas.microsoft.com/office/drawing/2014/main" id="{4BBFD0A3-EEB7-4E7A-A653-ACCF3E54E6A8}"/>
               </a:ext>
             </a:extLst>
           </p:cNvPr>
@@ -10012,7 +10470,7 @@
           <p:cNvPr id="4" name="">
             <a:extLst xmlns:a="http://schemas.openxmlformats.org/drawingml/2006/main">
               <a:ext uri="{FF2B5EF4-FFF2-40B4-BE49-F238E27FC236}">
-                <a16:creationId xmlns:a16="http://schemas.microsoft.com/office/drawing/2014/main" id="{77EFDE4D-28F1-49EA-87EF-55725F5C7FBE}"/>
+                <a16:creationId xmlns:a16="http://schemas.microsoft.com/office/drawing/2014/main" id="{AEB91C04-F3D0-47C3-A784-427B713E4937}"/>
               </a:ext>
             </a:extLst>
           </p:cNvPr>
@@ -10067,7 +10525,7 @@
     </p:spTree>
     <p:extLst>
       <p:ext uri="{BB962C8B-B14F-4D97-AF65-F5344CB8AC3E}">
-        <p14:creationId xmlns:p14="http://schemas.microsoft.com/office/powerpoint/2010/main" val="325629300"/>
+        <p14:creationId xmlns:p14="http://schemas.microsoft.com/office/powerpoint/2010/main" val="161128596"/>
       </p:ext>
     </p:extLst>
   </p:cSld>
@@ -10098,7 +10556,7 @@
           <p:cNvPr id="5" name="">
             <a:extLst xmlns:a="http://schemas.openxmlformats.org/drawingml/2006/main">
               <a:ext uri="{FF2B5EF4-FFF2-40B4-BE49-F238E27FC236}">
-                <a16:creationId xmlns:a16="http://schemas.microsoft.com/office/drawing/2014/main" id="{0B5A3CE5-BA4E-40FD-B400-EA0D59CCDBE4}"/>
+                <a16:creationId xmlns:a16="http://schemas.microsoft.com/office/drawing/2014/main" id="{02499DAE-A04E-4DF3-8BF4-480B413082BE}"/>
               </a:ext>
             </a:extLst>
           </p:cNvPr>
@@ -10155,7 +10613,7 @@
           <p:cNvPr id="2" name="">
             <a:extLst xmlns:a="http://schemas.openxmlformats.org/drawingml/2006/main">
               <a:ext uri="{FF2B5EF4-FFF2-40B4-BE49-F238E27FC236}">
-                <a16:creationId xmlns:a16="http://schemas.microsoft.com/office/drawing/2014/main" id="{06D2F0FF-527F-4109-A95B-9AF09A5A1E7D}"/>
+                <a16:creationId xmlns:a16="http://schemas.microsoft.com/office/drawing/2014/main" id="{324EED81-C7F4-4B6F-B301-3093C94AF685}"/>
               </a:ext>
             </a:extLst>
           </p:cNvPr>
@@ -10332,7 +10790,7 @@
           <p:cNvPr id="3" name="">
             <a:extLst xmlns:a="http://schemas.openxmlformats.org/drawingml/2006/main">
               <a:ext uri="{FF2B5EF4-FFF2-40B4-BE49-F238E27FC236}">
-                <a16:creationId xmlns:a16="http://schemas.microsoft.com/office/drawing/2014/main" id="{27805BF6-D000-47BC-A674-D7C06184D1AC}"/>
+                <a16:creationId xmlns:a16="http://schemas.microsoft.com/office/drawing/2014/main" id="{9932A0AB-036A-488D-B57B-37BE5B0BA542}"/>
               </a:ext>
             </a:extLst>
           </p:cNvPr>
@@ -10389,7 +10847,7 @@
           <p:cNvPr id="4" name="">
             <a:extLst xmlns:a="http://schemas.openxmlformats.org/drawingml/2006/main">
               <a:ext uri="{FF2B5EF4-FFF2-40B4-BE49-F238E27FC236}">
-                <a16:creationId xmlns:a16="http://schemas.microsoft.com/office/drawing/2014/main" id="{27F3A894-651F-4B56-AD4C-C86F5BB677C7}"/>
+                <a16:creationId xmlns:a16="http://schemas.microsoft.com/office/drawing/2014/main" id="{22A9B1E7-AF25-4076-A536-824784B5C8A1}"/>
               </a:ext>
             </a:extLst>
           </p:cNvPr>
@@ -10444,7 +10902,7 @@
     </p:spTree>
     <p:extLst>
       <p:ext uri="{BB962C8B-B14F-4D97-AF65-F5344CB8AC3E}">
-        <p14:creationId xmlns:p14="http://schemas.microsoft.com/office/powerpoint/2010/main" val="1665435364"/>
+        <p14:creationId xmlns:p14="http://schemas.microsoft.com/office/powerpoint/2010/main" val="1175507891"/>
       </p:ext>
     </p:extLst>
   </p:cSld>
@@ -10475,7 +10933,7 @@
           <p:cNvPr id="12" name="">
             <a:extLst xmlns:a="http://schemas.openxmlformats.org/drawingml/2006/main">
               <a:ext uri="{FF2B5EF4-FFF2-40B4-BE49-F238E27FC236}">
-                <a16:creationId xmlns:a16="http://schemas.microsoft.com/office/drawing/2014/main" id="{1B416F45-81FB-4E2B-8B62-3EBFF50FEE64}"/>
+                <a16:creationId xmlns:a16="http://schemas.microsoft.com/office/drawing/2014/main" id="{4F0B6593-5B1F-4719-B87F-B1A42DECB87B}"/>
               </a:ext>
             </a:extLst>
           </p:cNvPr>
@@ -10536,7 +10994,7 @@
           <p:nvPr/>
         </p:nvPicPr>
         <p:blipFill>
-          <a:blip xmlns:r="http://schemas.openxmlformats.org/officeDocument/2006/relationships" xmlns:a="http://schemas.openxmlformats.org/drawingml/2006/main" r:embed="R9690b309758d451c"/>
+          <a:blip xmlns:r="http://schemas.openxmlformats.org/officeDocument/2006/relationships" xmlns:a="http://schemas.openxmlformats.org/drawingml/2006/main" r:embed="R349941e9a6984b49"/>
           <a:stretch xmlns:a="http://schemas.openxmlformats.org/drawingml/2006/main"/>
         </p:blipFill>
         <p:spPr>
@@ -10558,7 +11016,7 @@
           <p:nvPr/>
         </p:nvPicPr>
         <p:blipFill>
-          <a:blip xmlns:r="http://schemas.openxmlformats.org/officeDocument/2006/relationships" xmlns:a="http://schemas.openxmlformats.org/drawingml/2006/main" r:embed="R12ba7cb33f34491d"/>
+          <a:blip xmlns:r="http://schemas.openxmlformats.org/officeDocument/2006/relationships" xmlns:a="http://schemas.openxmlformats.org/drawingml/2006/main" r:embed="Re76e0315948e493f"/>
           <a:stretch xmlns:a="http://schemas.openxmlformats.org/drawingml/2006/main"/>
         </p:blipFill>
         <p:spPr>
@@ -10576,7 +11034,7 @@
           <p:cNvPr id="4" name="">
             <a:extLst xmlns:a="http://schemas.openxmlformats.org/drawingml/2006/main">
               <a:ext uri="{FF2B5EF4-FFF2-40B4-BE49-F238E27FC236}">
-                <a16:creationId xmlns:a16="http://schemas.microsoft.com/office/drawing/2014/main" id="{19A01A73-824D-4A4C-B97B-1A24DD92CE7C}"/>
+                <a16:creationId xmlns:a16="http://schemas.microsoft.com/office/drawing/2014/main" id="{A421A570-BE8A-4DA1-9477-1D10B9BCB57A}"/>
               </a:ext>
             </a:extLst>
           </p:cNvPr>
@@ -10633,7 +11091,7 @@
           <p:cNvPr id="5" name="">
             <a:extLst xmlns:a="http://schemas.openxmlformats.org/drawingml/2006/main">
               <a:ext uri="{FF2B5EF4-FFF2-40B4-BE49-F238E27FC236}">
-                <a16:creationId xmlns:a16="http://schemas.microsoft.com/office/drawing/2014/main" id="{9FF0FC5F-BAF8-4C2A-8CE8-434A1F562F44}"/>
+                <a16:creationId xmlns:a16="http://schemas.microsoft.com/office/drawing/2014/main" id="{311158E8-F978-4525-A276-B9A5BE87FDF2}"/>
               </a:ext>
             </a:extLst>
           </p:cNvPr>
@@ -10690,7 +11148,7 @@
           <p:cNvPr id="6" name="">
             <a:extLst xmlns:a="http://schemas.openxmlformats.org/drawingml/2006/main">
               <a:ext uri="{FF2B5EF4-FFF2-40B4-BE49-F238E27FC236}">
-                <a16:creationId xmlns:a16="http://schemas.microsoft.com/office/drawing/2014/main" id="{6D156039-F76A-4716-A0BE-E3551E42A49F}"/>
+                <a16:creationId xmlns:a16="http://schemas.microsoft.com/office/drawing/2014/main" id="{A772E0EC-C02F-49C6-AD23-3AB8D8B76EA6}"/>
               </a:ext>
             </a:extLst>
           </p:cNvPr>
@@ -10737,7 +11195,7 @@
                 <a:ea typeface="Arial"/>
                 <a:cs typeface="Arial"/>
               </a:rPr>
-              <a:t>Fable: SELF_CARE</a:t>
+              <a:t>Frozen Fable: SELF_CARE</a:t>
             </a:r>
           </a:p>
           <a:p xmlns:a="http://schemas.openxmlformats.org/drawingml/2006/main">
@@ -10770,7 +11228,7 @@
           <p:cNvPr id="7" name="">
             <a:extLst xmlns:a="http://schemas.openxmlformats.org/drawingml/2006/main">
               <a:ext uri="{FF2B5EF4-FFF2-40B4-BE49-F238E27FC236}">
-                <a16:creationId xmlns:a16="http://schemas.microsoft.com/office/drawing/2014/main" id="{CE4E536E-67F6-43B0-93FE-F02DF5725A48}"/>
+                <a16:creationId xmlns:a16="http://schemas.microsoft.com/office/drawing/2014/main" id="{49ECF6E7-962A-450E-B24B-131BF55C9B04}"/>
               </a:ext>
             </a:extLst>
           </p:cNvPr>
@@ -10827,7 +11285,7 @@
           <p:cNvPr id="8" name="">
             <a:extLst xmlns:a="http://schemas.openxmlformats.org/drawingml/2006/main">
               <a:ext uri="{FF2B5EF4-FFF2-40B4-BE49-F238E27FC236}">
-                <a16:creationId xmlns:a16="http://schemas.microsoft.com/office/drawing/2014/main" id="{3293B890-E0D9-4B7E-89A4-CEF7824A29DD}"/>
+                <a16:creationId xmlns:a16="http://schemas.microsoft.com/office/drawing/2014/main" id="{5B3DD810-CC1D-4E82-BBA9-72C696C2BA01}"/>
               </a:ext>
             </a:extLst>
           </p:cNvPr>
@@ -10884,7 +11342,7 @@
           <p:cNvPr id="9" name="">
             <a:extLst xmlns:a="http://schemas.openxmlformats.org/drawingml/2006/main">
               <a:ext uri="{FF2B5EF4-FFF2-40B4-BE49-F238E27FC236}">
-                <a16:creationId xmlns:a16="http://schemas.microsoft.com/office/drawing/2014/main" id="{AA95A50E-B3D3-498C-B191-4D17D0202E3F}"/>
+                <a16:creationId xmlns:a16="http://schemas.microsoft.com/office/drawing/2014/main" id="{2E4C442A-318C-4673-A742-C1A429BDA927}"/>
               </a:ext>
             </a:extLst>
           </p:cNvPr>
@@ -10941,7 +11399,7 @@
           <p:cNvPr id="10" name="">
             <a:extLst xmlns:a="http://schemas.openxmlformats.org/drawingml/2006/main">
               <a:ext uri="{FF2B5EF4-FFF2-40B4-BE49-F238E27FC236}">
-                <a16:creationId xmlns:a16="http://schemas.microsoft.com/office/drawing/2014/main" id="{80BD05EC-CAD0-4F1B-A8F4-82881206731F}"/>
+                <a16:creationId xmlns:a16="http://schemas.microsoft.com/office/drawing/2014/main" id="{46AB35AA-A63F-4547-8DFB-469F612E13EC}"/>
               </a:ext>
             </a:extLst>
           </p:cNvPr>
@@ -10998,7 +11456,7 @@
           <p:cNvPr id="11" name="">
             <a:extLst xmlns:a="http://schemas.openxmlformats.org/drawingml/2006/main">
               <a:ext uri="{FF2B5EF4-FFF2-40B4-BE49-F238E27FC236}">
-                <a16:creationId xmlns:a16="http://schemas.microsoft.com/office/drawing/2014/main" id="{F6F47FD6-379E-423F-9C80-D3F0B659B969}"/>
+                <a16:creationId xmlns:a16="http://schemas.microsoft.com/office/drawing/2014/main" id="{9ED1A5B6-8069-452F-A92B-EB7A9DE04736}"/>
               </a:ext>
             </a:extLst>
           </p:cNvPr>
@@ -11053,7 +11511,7 @@
     </p:spTree>
     <p:extLst>
       <p:ext uri="{BB962C8B-B14F-4D97-AF65-F5344CB8AC3E}">
-        <p14:creationId xmlns:p14="http://schemas.microsoft.com/office/powerpoint/2010/main" val="570133429"/>
+        <p14:creationId xmlns:p14="http://schemas.microsoft.com/office/powerpoint/2010/main" val="250057367"/>
       </p:ext>
     </p:extLst>
   </p:cSld>
@@ -11084,7 +11542,7 @@
           <p:cNvPr id="9" name="">
             <a:extLst xmlns:a="http://schemas.openxmlformats.org/drawingml/2006/main">
               <a:ext uri="{FF2B5EF4-FFF2-40B4-BE49-F238E27FC236}">
-                <a16:creationId xmlns:a16="http://schemas.microsoft.com/office/drawing/2014/main" id="{1E539B6E-3129-4EAE-83FF-57286B0EB072}"/>
+                <a16:creationId xmlns:a16="http://schemas.microsoft.com/office/drawing/2014/main" id="{ACF3F247-DDDB-4A63-9639-EDDEEC4D3AB7}"/>
               </a:ext>
             </a:extLst>
           </p:cNvPr>
@@ -11141,7 +11599,7 @@
           <p:cNvPr id="2" name="">
             <a:extLst xmlns:a="http://schemas.openxmlformats.org/drawingml/2006/main">
               <a:ext uri="{FF2B5EF4-FFF2-40B4-BE49-F238E27FC236}">
-                <a16:creationId xmlns:a16="http://schemas.microsoft.com/office/drawing/2014/main" id="{E3C49024-7648-45F3-9A7A-8527EE5775C1}"/>
+                <a16:creationId xmlns:a16="http://schemas.microsoft.com/office/drawing/2014/main" id="{1EAF55BF-7EA6-4047-B472-C6A1DADA6B5F}"/>
               </a:ext>
             </a:extLst>
           </p:cNvPr>
@@ -11198,7 +11656,7 @@
           <p:cNvPr id="3" name="">
             <a:extLst xmlns:a="http://schemas.openxmlformats.org/drawingml/2006/main">
               <a:ext uri="{FF2B5EF4-FFF2-40B4-BE49-F238E27FC236}">
-                <a16:creationId xmlns:a16="http://schemas.microsoft.com/office/drawing/2014/main" id="{B9C38D8D-D8D3-4C2D-B36D-7017F56060F1}"/>
+                <a16:creationId xmlns:a16="http://schemas.microsoft.com/office/drawing/2014/main" id="{B1FBEE24-FA83-4BA1-964C-0AE25197FF2C}"/>
               </a:ext>
             </a:extLst>
           </p:cNvPr>
@@ -11255,7 +11713,7 @@
           <p:cNvPr id="4" name="">
             <a:extLst xmlns:a="http://schemas.openxmlformats.org/drawingml/2006/main">
               <a:ext uri="{FF2B5EF4-FFF2-40B4-BE49-F238E27FC236}">
-                <a16:creationId xmlns:a16="http://schemas.microsoft.com/office/drawing/2014/main" id="{078FFB3C-E90A-4282-A7F2-91B2AC5DFDBD}"/>
+                <a16:creationId xmlns:a16="http://schemas.microsoft.com/office/drawing/2014/main" id="{8D332FF1-32EA-4908-9EE2-A070D8F53849}"/>
               </a:ext>
             </a:extLst>
           </p:cNvPr>
@@ -11312,7 +11770,7 @@
           <p:cNvPr id="5" name="">
             <a:extLst xmlns:a="http://schemas.openxmlformats.org/drawingml/2006/main">
               <a:ext uri="{FF2B5EF4-FFF2-40B4-BE49-F238E27FC236}">
-                <a16:creationId xmlns:a16="http://schemas.microsoft.com/office/drawing/2014/main" id="{1E0174C3-8F60-40A5-8B15-51808564B3E0}"/>
+                <a16:creationId xmlns:a16="http://schemas.microsoft.com/office/drawing/2014/main" id="{2275920B-539E-4C50-A5BA-84CA37604AD0}"/>
               </a:ext>
             </a:extLst>
           </p:cNvPr>
@@ -11369,7 +11827,7 @@
           <p:cNvPr id="6" name="">
             <a:extLst xmlns:a="http://schemas.openxmlformats.org/drawingml/2006/main">
               <a:ext uri="{FF2B5EF4-FFF2-40B4-BE49-F238E27FC236}">
-                <a16:creationId xmlns:a16="http://schemas.microsoft.com/office/drawing/2014/main" id="{AB354895-2F2C-404C-A61E-9BC0178D7D04}"/>
+                <a16:creationId xmlns:a16="http://schemas.microsoft.com/office/drawing/2014/main" id="{8824434F-31E0-409F-9896-9DA68549A478}"/>
               </a:ext>
             </a:extLst>
           </p:cNvPr>
@@ -11426,7 +11884,7 @@
           <p:cNvPr id="7" name="">
             <a:extLst xmlns:a="http://schemas.openxmlformats.org/drawingml/2006/main">
               <a:ext uri="{FF2B5EF4-FFF2-40B4-BE49-F238E27FC236}">
-                <a16:creationId xmlns:a16="http://schemas.microsoft.com/office/drawing/2014/main" id="{34580FA0-DF26-4545-81C2-3E5FB22A4E90}"/>
+                <a16:creationId xmlns:a16="http://schemas.microsoft.com/office/drawing/2014/main" id="{72290381-9BE1-46B2-A1DD-25DB05E74F2B}"/>
               </a:ext>
             </a:extLst>
           </p:cNvPr>
@@ -11483,7 +11941,7 @@
           <p:cNvPr id="8" name="">
             <a:extLst xmlns:a="http://schemas.openxmlformats.org/drawingml/2006/main">
               <a:ext uri="{FF2B5EF4-FFF2-40B4-BE49-F238E27FC236}">
-                <a16:creationId xmlns:a16="http://schemas.microsoft.com/office/drawing/2014/main" id="{4622F44C-65B2-4D1E-AED5-98B087B2AD3F}"/>
+                <a16:creationId xmlns:a16="http://schemas.microsoft.com/office/drawing/2014/main" id="{C118132B-ED12-4E9B-A1CE-CFBC0DDE204A}"/>
               </a:ext>
             </a:extLst>
           </p:cNvPr>
@@ -11538,7 +11996,7 @@
     </p:spTree>
     <p:extLst>
       <p:ext uri="{BB962C8B-B14F-4D97-AF65-F5344CB8AC3E}">
-        <p14:creationId xmlns:p14="http://schemas.microsoft.com/office/powerpoint/2010/main" val="986126485"/>
+        <p14:creationId xmlns:p14="http://schemas.microsoft.com/office/powerpoint/2010/main" val="651066066"/>
       </p:ext>
     </p:extLst>
   </p:cSld>
@@ -11569,7 +12027,7 @@
           <p:cNvPr id="7" name="">
             <a:extLst xmlns:a="http://schemas.openxmlformats.org/drawingml/2006/main">
               <a:ext uri="{FF2B5EF4-FFF2-40B4-BE49-F238E27FC236}">
-                <a16:creationId xmlns:a16="http://schemas.microsoft.com/office/drawing/2014/main" id="{989DE348-8D6B-46E0-9641-6F54A4B570CD}"/>
+                <a16:creationId xmlns:a16="http://schemas.microsoft.com/office/drawing/2014/main" id="{9DFA0845-B9AB-466F-A60C-C3ECF0BC1E7A}"/>
               </a:ext>
             </a:extLst>
           </p:cNvPr>
@@ -11897,7 +12355,7 @@
           <p:cNvPr id="3" name="">
             <a:extLst xmlns:a="http://schemas.openxmlformats.org/drawingml/2006/main">
               <a:ext uri="{FF2B5EF4-FFF2-40B4-BE49-F238E27FC236}">
-                <a16:creationId xmlns:a16="http://schemas.microsoft.com/office/drawing/2014/main" id="{38DBDC12-DD3F-4A39-895A-DA26E9A12013}"/>
+                <a16:creationId xmlns:a16="http://schemas.microsoft.com/office/drawing/2014/main" id="{8DA8AF90-2122-4581-81A2-1B1EFB4DA4F4}"/>
               </a:ext>
             </a:extLst>
           </p:cNvPr>
@@ -11954,7 +12412,7 @@
           <p:cNvPr id="4" name="">
             <a:extLst xmlns:a="http://schemas.openxmlformats.org/drawingml/2006/main">
               <a:ext uri="{FF2B5EF4-FFF2-40B4-BE49-F238E27FC236}">
-                <a16:creationId xmlns:a16="http://schemas.microsoft.com/office/drawing/2014/main" id="{8379265D-C478-437E-A37D-0695F6B61B47}"/>
+                <a16:creationId xmlns:a16="http://schemas.microsoft.com/office/drawing/2014/main" id="{E8FF203B-5B16-4444-A5AF-1A3DBCEB075F}"/>
               </a:ext>
             </a:extLst>
           </p:cNvPr>
@@ -12011,7 +12469,7 @@
           <p:cNvPr id="5" name="">
             <a:extLst xmlns:a="http://schemas.openxmlformats.org/drawingml/2006/main">
               <a:ext uri="{FF2B5EF4-FFF2-40B4-BE49-F238E27FC236}">
-                <a16:creationId xmlns:a16="http://schemas.microsoft.com/office/drawing/2014/main" id="{831DE7F6-6174-4532-B63B-0B15F1B13CA6}"/>
+                <a16:creationId xmlns:a16="http://schemas.microsoft.com/office/drawing/2014/main" id="{FD993375-1DEE-406C-9101-38C1C146BC32}"/>
               </a:ext>
             </a:extLst>
           </p:cNvPr>
@@ -12068,7 +12526,7 @@
           <p:cNvPr id="6" name="">
             <a:extLst xmlns:a="http://schemas.openxmlformats.org/drawingml/2006/main">
               <a:ext uri="{FF2B5EF4-FFF2-40B4-BE49-F238E27FC236}">
-                <a16:creationId xmlns:a16="http://schemas.microsoft.com/office/drawing/2014/main" id="{CEB9E574-BDB3-41A8-91B4-F8708246D95B}"/>
+                <a16:creationId xmlns:a16="http://schemas.microsoft.com/office/drawing/2014/main" id="{DCDD88E9-CA57-4D1D-A44E-1D8E55F3D04C}"/>
               </a:ext>
             </a:extLst>
           </p:cNvPr>
@@ -12123,7 +12581,7 @@
     </p:spTree>
     <p:extLst>
       <p:ext uri="{BB962C8B-B14F-4D97-AF65-F5344CB8AC3E}">
-        <p14:creationId xmlns:p14="http://schemas.microsoft.com/office/powerpoint/2010/main" val="719271654"/>
+        <p14:creationId xmlns:p14="http://schemas.microsoft.com/office/powerpoint/2010/main" val="133682894"/>
       </p:ext>
     </p:extLst>
   </p:cSld>
@@ -12154,7 +12612,7 @@
           <p:cNvPr id="7" name="">
             <a:extLst xmlns:a="http://schemas.openxmlformats.org/drawingml/2006/main">
               <a:ext uri="{FF2B5EF4-FFF2-40B4-BE49-F238E27FC236}">
-                <a16:creationId xmlns:a16="http://schemas.microsoft.com/office/drawing/2014/main" id="{46DBE203-39DA-4FA2-A4AC-1E72193210FF}"/>
+                <a16:creationId xmlns:a16="http://schemas.microsoft.com/office/drawing/2014/main" id="{E9C867C3-CAE9-44F3-A7AD-449818DF619C}"/>
               </a:ext>
             </a:extLst>
           </p:cNvPr>
@@ -12530,7 +12988,7 @@
           <p:cNvPr id="3" name="">
             <a:extLst xmlns:a="http://schemas.openxmlformats.org/drawingml/2006/main">
               <a:ext uri="{FF2B5EF4-FFF2-40B4-BE49-F238E27FC236}">
-                <a16:creationId xmlns:a16="http://schemas.microsoft.com/office/drawing/2014/main" id="{D75EDB5C-BD5F-4AD7-8BB7-097308019B2C}"/>
+                <a16:creationId xmlns:a16="http://schemas.microsoft.com/office/drawing/2014/main" id="{D66B9DFF-812C-4441-BD02-8A27C3642193}"/>
               </a:ext>
             </a:extLst>
           </p:cNvPr>
@@ -12587,7 +13045,7 @@
           <p:cNvPr id="4" name="">
             <a:extLst xmlns:a="http://schemas.openxmlformats.org/drawingml/2006/main">
               <a:ext uri="{FF2B5EF4-FFF2-40B4-BE49-F238E27FC236}">
-                <a16:creationId xmlns:a16="http://schemas.microsoft.com/office/drawing/2014/main" id="{D829FFC6-E47B-4A4C-BB5A-E98429C999D2}"/>
+                <a16:creationId xmlns:a16="http://schemas.microsoft.com/office/drawing/2014/main" id="{72381DAA-3FC1-4243-A690-7185363BC4C1}"/>
               </a:ext>
             </a:extLst>
           </p:cNvPr>
@@ -12644,7 +13102,7 @@
           <p:cNvPr id="5" name="">
             <a:extLst xmlns:a="http://schemas.openxmlformats.org/drawingml/2006/main">
               <a:ext uri="{FF2B5EF4-FFF2-40B4-BE49-F238E27FC236}">
-                <a16:creationId xmlns:a16="http://schemas.microsoft.com/office/drawing/2014/main" id="{E4CF5CE8-F314-4FB6-AB8E-5BE4D0E73AAF}"/>
+                <a16:creationId xmlns:a16="http://schemas.microsoft.com/office/drawing/2014/main" id="{21E3159F-18EC-47FD-A81D-D9DE950C450C}"/>
               </a:ext>
             </a:extLst>
           </p:cNvPr>
@@ -12701,7 +13159,7 @@
           <p:cNvPr id="6" name="">
             <a:extLst xmlns:a="http://schemas.openxmlformats.org/drawingml/2006/main">
               <a:ext uri="{FF2B5EF4-FFF2-40B4-BE49-F238E27FC236}">
-                <a16:creationId xmlns:a16="http://schemas.microsoft.com/office/drawing/2014/main" id="{9038885F-6B3A-4F72-A646-73B943175C5C}"/>
+                <a16:creationId xmlns:a16="http://schemas.microsoft.com/office/drawing/2014/main" id="{B2A0F17C-6C97-415C-86FF-494C26651D5C}"/>
               </a:ext>
             </a:extLst>
           </p:cNvPr>
@@ -12756,7 +13214,7 @@
     </p:spTree>
     <p:extLst>
       <p:ext uri="{BB962C8B-B14F-4D97-AF65-F5344CB8AC3E}">
-        <p14:creationId xmlns:p14="http://schemas.microsoft.com/office/powerpoint/2010/main" val="1411394183"/>
+        <p14:creationId xmlns:p14="http://schemas.microsoft.com/office/powerpoint/2010/main" val="1176373197"/>
       </p:ext>
     </p:extLst>
   </p:cSld>
@@ -12787,7 +13245,7 @@
           <p:cNvPr id="5" name="">
             <a:extLst xmlns:a="http://schemas.openxmlformats.org/drawingml/2006/main">
               <a:ext uri="{FF2B5EF4-FFF2-40B4-BE49-F238E27FC236}">
-                <a16:creationId xmlns:a16="http://schemas.microsoft.com/office/drawing/2014/main" id="{F2E547BD-2F39-4298-8597-74E8FBB01059}"/>
+                <a16:creationId xmlns:a16="http://schemas.microsoft.com/office/drawing/2014/main" id="{70147C84-E8BE-4F90-ABA3-3E615B9F43BD}"/>
               </a:ext>
             </a:extLst>
           </p:cNvPr>
@@ -13066,7 +13524,7 @@
           <p:cNvPr id="3" name="">
             <a:extLst xmlns:a="http://schemas.openxmlformats.org/drawingml/2006/main">
               <a:ext uri="{FF2B5EF4-FFF2-40B4-BE49-F238E27FC236}">
-                <a16:creationId xmlns:a16="http://schemas.microsoft.com/office/drawing/2014/main" id="{67E889BD-281D-4C07-8ACE-FA4CEADC5A1F}"/>
+                <a16:creationId xmlns:a16="http://schemas.microsoft.com/office/drawing/2014/main" id="{ED35CB17-183A-44CB-8C4F-0916418654CB}"/>
               </a:ext>
             </a:extLst>
           </p:cNvPr>
@@ -13123,7 +13581,7 @@
           <p:cNvPr id="4" name="">
             <a:extLst xmlns:a="http://schemas.openxmlformats.org/drawingml/2006/main">
               <a:ext uri="{FF2B5EF4-FFF2-40B4-BE49-F238E27FC236}">
-                <a16:creationId xmlns:a16="http://schemas.microsoft.com/office/drawing/2014/main" id="{58EFDCAD-3621-4DFF-B49A-A8D0FCCC9699}"/>
+                <a16:creationId xmlns:a16="http://schemas.microsoft.com/office/drawing/2014/main" id="{4C0288AB-7B5D-4341-A476-5C43621F413F}"/>
               </a:ext>
             </a:extLst>
           </p:cNvPr>
@@ -13178,7 +13636,7 @@
     </p:spTree>
     <p:extLst>
       <p:ext uri="{BB962C8B-B14F-4D97-AF65-F5344CB8AC3E}">
-        <p14:creationId xmlns:p14="http://schemas.microsoft.com/office/powerpoint/2010/main" val="202977253"/>
+        <p14:creationId xmlns:p14="http://schemas.microsoft.com/office/powerpoint/2010/main" val="551304386"/>
       </p:ext>
     </p:extLst>
   </p:cSld>
@@ -13209,7 +13667,7 @@
           <p:cNvPr id="5" name="">
             <a:extLst xmlns:a="http://schemas.openxmlformats.org/drawingml/2006/main">
               <a:ext uri="{FF2B5EF4-FFF2-40B4-BE49-F238E27FC236}">
-                <a16:creationId xmlns:a16="http://schemas.microsoft.com/office/drawing/2014/main" id="{4C5B79F5-8A9F-4830-B631-24C2321E7716}"/>
+                <a16:creationId xmlns:a16="http://schemas.microsoft.com/office/drawing/2014/main" id="{78602848-A596-4E11-8F04-4131E733DD00}"/>
               </a:ext>
             </a:extLst>
           </p:cNvPr>
@@ -13488,7 +13946,7 @@
           <p:cNvPr id="3" name="">
             <a:extLst xmlns:a="http://schemas.openxmlformats.org/drawingml/2006/main">
               <a:ext uri="{FF2B5EF4-FFF2-40B4-BE49-F238E27FC236}">
-                <a16:creationId xmlns:a16="http://schemas.microsoft.com/office/drawing/2014/main" id="{032F95EE-1EF7-4B5C-8B96-4E0D20C08ECC}"/>
+                <a16:creationId xmlns:a16="http://schemas.microsoft.com/office/drawing/2014/main" id="{3FC928F5-4CAD-4168-B8AA-8C6335C106F3}"/>
               </a:ext>
             </a:extLst>
           </p:cNvPr>
@@ -13545,7 +14003,7 @@
           <p:cNvPr id="4" name="">
             <a:extLst xmlns:a="http://schemas.openxmlformats.org/drawingml/2006/main">
               <a:ext uri="{FF2B5EF4-FFF2-40B4-BE49-F238E27FC236}">
-                <a16:creationId xmlns:a16="http://schemas.microsoft.com/office/drawing/2014/main" id="{C6C0A930-2749-48A0-BC59-059BCB63258E}"/>
+                <a16:creationId xmlns:a16="http://schemas.microsoft.com/office/drawing/2014/main" id="{E030C0DB-3174-4373-8640-0B6F370150B9}"/>
               </a:ext>
             </a:extLst>
           </p:cNvPr>
@@ -13600,7 +14058,7 @@
     </p:spTree>
     <p:extLst>
       <p:ext uri="{BB962C8B-B14F-4D97-AF65-F5344CB8AC3E}">
-        <p14:creationId xmlns:p14="http://schemas.microsoft.com/office/powerpoint/2010/main" val="1421832216"/>
+        <p14:creationId xmlns:p14="http://schemas.microsoft.com/office/powerpoint/2010/main" val="248176847"/>
       </p:ext>
     </p:extLst>
   </p:cSld>
@@ -13631,7 +14089,7 @@
           <p:cNvPr id="5" name="">
             <a:extLst xmlns:a="http://schemas.openxmlformats.org/drawingml/2006/main">
               <a:ext uri="{FF2B5EF4-FFF2-40B4-BE49-F238E27FC236}">
-                <a16:creationId xmlns:a16="http://schemas.microsoft.com/office/drawing/2014/main" id="{7A8BCBB9-65B7-46BA-99DC-936DB79FB7FE}"/>
+                <a16:creationId xmlns:a16="http://schemas.microsoft.com/office/drawing/2014/main" id="{10D3A628-046F-41A7-8C94-C93C69D555B9}"/>
               </a:ext>
             </a:extLst>
           </p:cNvPr>
@@ -13910,7 +14368,7 @@
           <p:cNvPr id="3" name="">
             <a:extLst xmlns:a="http://schemas.openxmlformats.org/drawingml/2006/main">
               <a:ext uri="{FF2B5EF4-FFF2-40B4-BE49-F238E27FC236}">
-                <a16:creationId xmlns:a16="http://schemas.microsoft.com/office/drawing/2014/main" id="{882A6C53-4452-4CD2-BE28-174F562542F9}"/>
+                <a16:creationId xmlns:a16="http://schemas.microsoft.com/office/drawing/2014/main" id="{BF7F8B3F-33ED-4774-84FD-0A6FB4E851E5}"/>
               </a:ext>
             </a:extLst>
           </p:cNvPr>
@@ -13967,7 +14425,7 @@
           <p:cNvPr id="4" name="">
             <a:extLst xmlns:a="http://schemas.openxmlformats.org/drawingml/2006/main">
               <a:ext uri="{FF2B5EF4-FFF2-40B4-BE49-F238E27FC236}">
-                <a16:creationId xmlns:a16="http://schemas.microsoft.com/office/drawing/2014/main" id="{7BC9CF91-51B0-4E41-B610-D8A779A35012}"/>
+                <a16:creationId xmlns:a16="http://schemas.microsoft.com/office/drawing/2014/main" id="{3AD134AD-E22F-45FB-A1CC-48D6FAE6BC8A}"/>
               </a:ext>
             </a:extLst>
           </p:cNvPr>
@@ -14022,7 +14480,7 @@
     </p:spTree>
     <p:extLst>
       <p:ext uri="{BB962C8B-B14F-4D97-AF65-F5344CB8AC3E}">
-        <p14:creationId xmlns:p14="http://schemas.microsoft.com/office/powerpoint/2010/main" val="467125894"/>
+        <p14:creationId xmlns:p14="http://schemas.microsoft.com/office/powerpoint/2010/main" val="854144057"/>
       </p:ext>
     </p:extLst>
   </p:cSld>
@@ -14053,7 +14511,7 @@
           <p:cNvPr id="5" name="">
             <a:extLst xmlns:a="http://schemas.openxmlformats.org/drawingml/2006/main">
               <a:ext uri="{FF2B5EF4-FFF2-40B4-BE49-F238E27FC236}">
-                <a16:creationId xmlns:a16="http://schemas.microsoft.com/office/drawing/2014/main" id="{1728B78B-9342-4E84-AD5B-BF7C1E95FF0A}"/>
+                <a16:creationId xmlns:a16="http://schemas.microsoft.com/office/drawing/2014/main" id="{6163760C-136E-4625-B8E9-AAB844049AD1}"/>
               </a:ext>
             </a:extLst>
           </p:cNvPr>
@@ -14332,7 +14790,7 @@
           <p:cNvPr id="3" name="">
             <a:extLst xmlns:a="http://schemas.openxmlformats.org/drawingml/2006/main">
               <a:ext uri="{FF2B5EF4-FFF2-40B4-BE49-F238E27FC236}">
-                <a16:creationId xmlns:a16="http://schemas.microsoft.com/office/drawing/2014/main" id="{C106782C-307A-4D2B-BDCA-BE0596244746}"/>
+                <a16:creationId xmlns:a16="http://schemas.microsoft.com/office/drawing/2014/main" id="{FFBD9758-D453-42C4-BCE5-9814F1418365}"/>
               </a:ext>
             </a:extLst>
           </p:cNvPr>
@@ -14389,7 +14847,7 @@
           <p:cNvPr id="4" name="">
             <a:extLst xmlns:a="http://schemas.openxmlformats.org/drawingml/2006/main">
               <a:ext uri="{FF2B5EF4-FFF2-40B4-BE49-F238E27FC236}">
-                <a16:creationId xmlns:a16="http://schemas.microsoft.com/office/drawing/2014/main" id="{8853DCD2-C4EB-4FB0-B5D0-052373A3378F}"/>
+                <a16:creationId xmlns:a16="http://schemas.microsoft.com/office/drawing/2014/main" id="{997A0FCF-7BA7-4E3C-8E6F-CA6D601AD477}"/>
               </a:ext>
             </a:extLst>
           </p:cNvPr>
@@ -14444,7 +14902,7 @@
     </p:spTree>
     <p:extLst>
       <p:ext uri="{BB962C8B-B14F-4D97-AF65-F5344CB8AC3E}">
-        <p14:creationId xmlns:p14="http://schemas.microsoft.com/office/powerpoint/2010/main" val="812895997"/>
+        <p14:creationId xmlns:p14="http://schemas.microsoft.com/office/powerpoint/2010/main" val="1491986120"/>
       </p:ext>
     </p:extLst>
   </p:cSld>
@@ -14475,7 +14933,7 @@
           <p:cNvPr id="5" name="">
             <a:extLst xmlns:a="http://schemas.openxmlformats.org/drawingml/2006/main">
               <a:ext uri="{FF2B5EF4-FFF2-40B4-BE49-F238E27FC236}">
-                <a16:creationId xmlns:a16="http://schemas.microsoft.com/office/drawing/2014/main" id="{DB0BCA22-A74E-4A80-9A80-BDE97234DB22}"/>
+                <a16:creationId xmlns:a16="http://schemas.microsoft.com/office/drawing/2014/main" id="{DB18AF3B-E4F6-4DB0-813E-24F758FD0DAE}"/>
               </a:ext>
             </a:extLst>
           </p:cNvPr>
@@ -14754,7 +15212,7 @@
           <p:cNvPr id="3" name="">
             <a:extLst xmlns:a="http://schemas.openxmlformats.org/drawingml/2006/main">
               <a:ext uri="{FF2B5EF4-FFF2-40B4-BE49-F238E27FC236}">
-                <a16:creationId xmlns:a16="http://schemas.microsoft.com/office/drawing/2014/main" id="{C4AF41F5-398E-4887-ACAE-B9315AE55E51}"/>
+                <a16:creationId xmlns:a16="http://schemas.microsoft.com/office/drawing/2014/main" id="{B0A10C20-DEF1-4752-B2CB-68BB443D6EF2}"/>
               </a:ext>
             </a:extLst>
           </p:cNvPr>
@@ -14811,7 +15269,7 @@
           <p:cNvPr id="4" name="">
             <a:extLst xmlns:a="http://schemas.openxmlformats.org/drawingml/2006/main">
               <a:ext uri="{FF2B5EF4-FFF2-40B4-BE49-F238E27FC236}">
-                <a16:creationId xmlns:a16="http://schemas.microsoft.com/office/drawing/2014/main" id="{AA64AEEE-AC9A-47DB-A78D-BF428399E577}"/>
+                <a16:creationId xmlns:a16="http://schemas.microsoft.com/office/drawing/2014/main" id="{A0ABB6F2-1ECC-460D-A9C7-11892A563B7F}"/>
               </a:ext>
             </a:extLst>
           </p:cNvPr>
@@ -14866,7 +15324,7 @@
     </p:spTree>
     <p:extLst>
       <p:ext uri="{BB962C8B-B14F-4D97-AF65-F5344CB8AC3E}">
-        <p14:creationId xmlns:p14="http://schemas.microsoft.com/office/powerpoint/2010/main" val="947046183"/>
+        <p14:creationId xmlns:p14="http://schemas.microsoft.com/office/powerpoint/2010/main" val="2127753512"/>
       </p:ext>
     </p:extLst>
   </p:cSld>
@@ -14897,7 +15355,7 @@
           <p:cNvPr id="5" name="">
             <a:extLst xmlns:a="http://schemas.openxmlformats.org/drawingml/2006/main">
               <a:ext uri="{FF2B5EF4-FFF2-40B4-BE49-F238E27FC236}">
-                <a16:creationId xmlns:a16="http://schemas.microsoft.com/office/drawing/2014/main" id="{98C68FEA-584B-45E3-969A-2AC7EAF1AB06}"/>
+                <a16:creationId xmlns:a16="http://schemas.microsoft.com/office/drawing/2014/main" id="{800066AB-D29D-4FBE-B5A4-1E507D26BD40}"/>
               </a:ext>
             </a:extLst>
           </p:cNvPr>
@@ -15126,7 +15584,7 @@
           <p:cNvPr id="3" name="">
             <a:extLst xmlns:a="http://schemas.openxmlformats.org/drawingml/2006/main">
               <a:ext uri="{FF2B5EF4-FFF2-40B4-BE49-F238E27FC236}">
-                <a16:creationId xmlns:a16="http://schemas.microsoft.com/office/drawing/2014/main" id="{78F96641-825C-4F53-B002-0181E78E2A0A}"/>
+                <a16:creationId xmlns:a16="http://schemas.microsoft.com/office/drawing/2014/main" id="{046D95A8-137B-411C-9218-5ADAA3D37404}"/>
               </a:ext>
             </a:extLst>
           </p:cNvPr>
@@ -15183,7 +15641,7 @@
           <p:cNvPr id="4" name="">
             <a:extLst xmlns:a="http://schemas.openxmlformats.org/drawingml/2006/main">
               <a:ext uri="{FF2B5EF4-FFF2-40B4-BE49-F238E27FC236}">
-                <a16:creationId xmlns:a16="http://schemas.microsoft.com/office/drawing/2014/main" id="{282CDD22-8E1B-469C-8231-D90372F19667}"/>
+                <a16:creationId xmlns:a16="http://schemas.microsoft.com/office/drawing/2014/main" id="{2FAF6FEA-F1F6-434D-9592-71E8CACC4949}"/>
               </a:ext>
             </a:extLst>
           </p:cNvPr>
@@ -15238,7 +15696,879 @@
     </p:spTree>
     <p:extLst>
       <p:ext uri="{BB962C8B-B14F-4D97-AF65-F5344CB8AC3E}">
-        <p14:creationId xmlns:p14="http://schemas.microsoft.com/office/powerpoint/2010/main" val="1490437536"/>
+        <p14:creationId xmlns:p14="http://schemas.microsoft.com/office/powerpoint/2010/main" val="1009031219"/>
+      </p:ext>
+    </p:extLst>
+  </p:cSld>
+</p:sld>
+</file>
+
+<file path=ppt/slides/slide29.xml><?xml version="1.0" encoding="utf-8"?>
+<p:sld xmlns:p="http://schemas.openxmlformats.org/presentationml/2006/main">
+  <p:cSld>
+    <p:bg>
+      <p:bgPr>
+        <a:solidFill xmlns:a="http://schemas.openxmlformats.org/drawingml/2006/main">
+          <a:srgbClr val="F6F4ED"/>
+        </a:solidFill>
+      </p:bgPr>
+    </p:bg>
+    <p:spTree>
+      <p:nvGrpSpPr>
+        <p:cNvPr id="1" name=""/>
+        <p:cNvGrpSpPr/>
+        <p:nvPr/>
+      </p:nvGrpSpPr>
+      <p:grpSpPr>
+        <a:xfrm xmlns:a="http://schemas.openxmlformats.org/drawingml/2006/main"/>
+      </p:grpSpPr>
+      <p:sp>
+        <p:nvSpPr>
+          <p:cNvPr id="6" name="">
+            <a:extLst xmlns:a="http://schemas.openxmlformats.org/drawingml/2006/main">
+              <a:ext uri="{FF2B5EF4-FFF2-40B4-BE49-F238E27FC236}">
+                <a16:creationId xmlns:a16="http://schemas.microsoft.com/office/drawing/2014/main" id="{073B2E49-2464-45BA-8317-ACCAAE499BFE}"/>
+              </a:ext>
+            </a:extLst>
+          </p:cNvPr>
+          <p:cNvSpPr>
+            <a:spLocks xmlns:a="http://schemas.openxmlformats.org/drawingml/2006/main" noGrp="1"/>
+          </p:cNvSpPr>
+          <p:nvPr/>
+        </p:nvSpPr>
+        <p:spPr>
+          <a:xfrm xmlns:a="http://schemas.openxmlformats.org/drawingml/2006/main">
+            <a:off x="762000" y="485775"/>
+            <a:ext cx="10668000" cy="586550"/>
+          </a:xfrm>
+          <a:prstGeom xmlns:a="http://schemas.openxmlformats.org/drawingml/2006/main" prst="rect">
+            <a:avLst/>
+          </a:prstGeom>
+          <a:noFill xmlns:a="http://schemas.openxmlformats.org/drawingml/2006/main"/>
+          <a:ln xmlns:a="http://schemas.openxmlformats.org/drawingml/2006/main" w="0">
+            <a:noFill/>
+          </a:ln>
+        </p:spPr>
+        <p:txBody>
+          <a:bodyPr xmlns:a="http://schemas.openxmlformats.org/drawingml/2006/main" wrap="square" lIns="0" tIns="0" rIns="0" bIns="0" anchor="t">
+            <a:noAutofit/>
+          </a:bodyPr>
+          <a:lstStyle xmlns:a="http://schemas.openxmlformats.org/drawingml/2006/main"/>
+          <a:p xmlns:a="http://schemas.openxmlformats.org/drawingml/2006/main">
+            <a:pPr>
+              <a:defRPr sz="3525" b="1">
+                <a:solidFill>
+                  <a:srgbClr val="243866"/>
+                </a:solidFill>
+                <a:latin typeface="Arial"/>
+                <a:ea typeface="Arial"/>
+                <a:cs typeface="Arial"/>
+              </a:defRPr>
+            </a:pPr>
+            <a:r>
+              <a:rPr sz="3525" b="1">
+                <a:solidFill>
+                  <a:srgbClr val="243866"/>
+                </a:solidFill>
+                <a:latin typeface="Arial"/>
+                <a:ea typeface="Arial"/>
+                <a:cs typeface="Arial"/>
+              </a:rPr>
+              <a:t>Development experiment: new urgent misses</a:t>
+            </a:r>
+          </a:p>
+        </p:txBody>
+      </p:sp>
+      <p:graphicFrame>
+        <p:nvGraphicFramePr>
+          <p:cNvPr id="7" name=""/>
+          <p:cNvGraphicFramePr/>
+          <p:nvPr/>
+        </p:nvGraphicFramePr>
+        <p:xfrm>
+          <a:off xmlns:a="http://schemas.openxmlformats.org/drawingml/2006/main" x="762000" y="1619250"/>
+          <a:ext xmlns:a="http://schemas.openxmlformats.org/drawingml/2006/main" cx="10668000" cy="3679698"/>
+        </p:xfrm>
+        <a:graphic xmlns:a="http://schemas.openxmlformats.org/drawingml/2006/main">
+          <a:graphicData uri="http://schemas.openxmlformats.org/drawingml/2006/table">
+            <a:tbl>
+              <a:tblPr firstRow="1" bandRow="0"/>
+              <a:tblGrid>
+                <a:gridCol w="6400800"/>
+                <a:gridCol w="2133600"/>
+                <a:gridCol w="2133600"/>
+              </a:tblGrid>
+              <a:tr h="459962">
+                <a:tc>
+                  <a:txBody>
+                    <a:bodyPr/>
+                    <a:lstStyle/>
+                    <a:p>
+                      <a:r>
+                        <a:rPr sz="1725" b="1">
+                          <a:solidFill>
+                            <a:srgbClr val="FFFFFF"/>
+                          </a:solidFill>
+                          <a:latin typeface="Arial"/>
+                          <a:ea typeface="Arial"/>
+                          <a:cs typeface="Arial"/>
+                        </a:rPr>
+                        <a:t>Case set and endpoint</a:t>
+                      </a:r>
+                    </a:p>
+                  </a:txBody>
+                  <a:tcPr marL="133350" marR="133350" marT="76200" marB="76200" anchor="ctr">
+                    <a:solidFill>
+                      <a:srgbClr val="243866"/>
+                    </a:solidFill>
+                  </a:tcPr>
+                </a:tc>
+                <a:tc>
+                  <a:txBody>
+                    <a:bodyPr/>
+                    <a:lstStyle/>
+                    <a:p>
+                      <a:r>
+                        <a:rPr sz="1725" b="1">
+                          <a:solidFill>
+                            <a:srgbClr val="FFFFFF"/>
+                          </a:solidFill>
+                          <a:latin typeface="Arial"/>
+                          <a:ea typeface="Arial"/>
+                          <a:cs typeface="Arial"/>
+                        </a:rPr>
+                        <a:t>Baseline</a:t>
+                      </a:r>
+                    </a:p>
+                  </a:txBody>
+                  <a:tcPr marL="133350" marR="133350" marT="76200" marB="76200" anchor="ctr">
+                    <a:solidFill>
+                      <a:srgbClr val="243866"/>
+                    </a:solidFill>
+                  </a:tcPr>
+                </a:tc>
+                <a:tc>
+                  <a:txBody>
+                    <a:bodyPr/>
+                    <a:lstStyle/>
+                    <a:p>
+                      <a:r>
+                        <a:rPr sz="1725" b="1">
+                          <a:solidFill>
+                            <a:srgbClr val="FFFFFF"/>
+                          </a:solidFill>
+                          <a:latin typeface="Arial"/>
+                          <a:ea typeface="Arial"/>
+                          <a:cs typeface="Arial"/>
+                        </a:rPr>
+                        <a:t>New prompt</a:t>
+                      </a:r>
+                    </a:p>
+                  </a:txBody>
+                  <a:tcPr marL="133350" marR="133350" marT="76200" marB="76200" anchor="ctr">
+                    <a:solidFill>
+                      <a:srgbClr val="243866"/>
+                    </a:solidFill>
+                  </a:tcPr>
+                </a:tc>
+              </a:tr>
+              <a:tr h="459962">
+                <a:tc>
+                  <a:txBody>
+                    <a:bodyPr/>
+                    <a:lstStyle/>
+                    <a:p>
+                      <a:r>
+                        <a:rPr sz="1725" b="0">
+                          <a:solidFill>
+                            <a:srgbClr val="28354A"/>
+                          </a:solidFill>
+                          <a:latin typeface="Arial"/>
+                          <a:ea typeface="Arial"/>
+                          <a:cs typeface="Arial"/>
+                        </a:rPr>
+                        <a:t>Known physician reference: agreement</a:t>
+                      </a:r>
+                    </a:p>
+                  </a:txBody>
+                  <a:tcPr marL="133350" marR="133350" marT="76200" marB="76200" anchor="ctr">
+                    <a:solidFill>
+                      <a:srgbClr val="F6F4ED"/>
+                    </a:solidFill>
+                  </a:tcPr>
+                </a:tc>
+                <a:tc>
+                  <a:txBody>
+                    <a:bodyPr/>
+                    <a:lstStyle/>
+                    <a:p>
+                      <a:r>
+                        <a:rPr sz="1725" b="0">
+                          <a:solidFill>
+                            <a:srgbClr val="28354A"/>
+                          </a:solidFill>
+                          <a:latin typeface="Arial"/>
+                          <a:ea typeface="Arial"/>
+                          <a:cs typeface="Arial"/>
+                        </a:rPr>
+                        <a:t>48/50</a:t>
+                      </a:r>
+                    </a:p>
+                  </a:txBody>
+                  <a:tcPr marL="133350" marR="133350" marT="76200" marB="76200" anchor="ctr">
+                    <a:solidFill>
+                      <a:srgbClr val="F6F4ED"/>
+                    </a:solidFill>
+                  </a:tcPr>
+                </a:tc>
+                <a:tc>
+                  <a:txBody>
+                    <a:bodyPr/>
+                    <a:lstStyle/>
+                    <a:p>
+                      <a:r>
+                        <a:rPr sz="1725" b="0">
+                          <a:solidFill>
+                            <a:srgbClr val="28354A"/>
+                          </a:solidFill>
+                          <a:latin typeface="Arial"/>
+                          <a:ea typeface="Arial"/>
+                          <a:cs typeface="Arial"/>
+                        </a:rPr>
+                        <a:t>44/50</a:t>
+                      </a:r>
+                    </a:p>
+                  </a:txBody>
+                  <a:tcPr marL="133350" marR="133350" marT="76200" marB="76200" anchor="ctr">
+                    <a:solidFill>
+                      <a:srgbClr val="F6F4ED"/>
+                    </a:solidFill>
+                  </a:tcPr>
+                </a:tc>
+              </a:tr>
+              <a:tr h="459962">
+                <a:tc>
+                  <a:txBody>
+                    <a:bodyPr/>
+                    <a:lstStyle/>
+                    <a:p>
+                      <a:r>
+                        <a:rPr sz="1725" b="0">
+                          <a:solidFill>
+                            <a:srgbClr val="28354A"/>
+                          </a:solidFill>
+                          <a:latin typeface="Arial"/>
+                          <a:ea typeface="Arial"/>
+                          <a:cs typeface="Arial"/>
+                        </a:rPr>
+                        <a:t>Known: required clinician action missed</a:t>
+                      </a:r>
+                    </a:p>
+                  </a:txBody>
+                  <a:tcPr marL="133350" marR="133350" marT="76200" marB="76200" anchor="ctr">
+                    <a:solidFill>
+                      <a:srgbClr val="F6F4ED"/>
+                    </a:solidFill>
+                  </a:tcPr>
+                </a:tc>
+                <a:tc>
+                  <a:txBody>
+                    <a:bodyPr/>
+                    <a:lstStyle/>
+                    <a:p>
+                      <a:r>
+                        <a:rPr sz="1725" b="0">
+                          <a:solidFill>
+                            <a:srgbClr val="28354A"/>
+                          </a:solidFill>
+                          <a:latin typeface="Arial"/>
+                          <a:ea typeface="Arial"/>
+                          <a:cs typeface="Arial"/>
+                        </a:rPr>
+                        <a:t>2/43</a:t>
+                      </a:r>
+                    </a:p>
+                  </a:txBody>
+                  <a:tcPr marL="133350" marR="133350" marT="76200" marB="76200" anchor="ctr">
+                    <a:solidFill>
+                      <a:srgbClr val="F6F4ED"/>
+                    </a:solidFill>
+                  </a:tcPr>
+                </a:tc>
+                <a:tc>
+                  <a:txBody>
+                    <a:bodyPr/>
+                    <a:lstStyle/>
+                    <a:p>
+                      <a:r>
+                        <a:rPr sz="1725" b="0">
+                          <a:solidFill>
+                            <a:srgbClr val="28354A"/>
+                          </a:solidFill>
+                          <a:latin typeface="Arial"/>
+                          <a:ea typeface="Arial"/>
+                          <a:cs typeface="Arial"/>
+                        </a:rPr>
+                        <a:t>2/43</a:t>
+                      </a:r>
+                    </a:p>
+                  </a:txBody>
+                  <a:tcPr marL="133350" marR="133350" marT="76200" marB="76200" anchor="ctr">
+                    <a:solidFill>
+                      <a:srgbClr val="F6F4ED"/>
+                    </a:solidFill>
+                  </a:tcPr>
+                </a:tc>
+              </a:tr>
+              <a:tr h="459962">
+                <a:tc>
+                  <a:txBody>
+                    <a:bodyPr/>
+                    <a:lstStyle/>
+                    <a:p>
+                      <a:r>
+                        <a:rPr sz="1725" b="0">
+                          <a:solidFill>
+                            <a:srgbClr val="28354A"/>
+                          </a:solidFill>
+                          <a:latin typeface="Arial"/>
+                          <a:ea typeface="Arial"/>
+                          <a:cs typeface="Arial"/>
+                        </a:rPr>
+                        <a:t>Known: required urgent action missed</a:t>
+                      </a:r>
+                    </a:p>
+                  </a:txBody>
+                  <a:tcPr marL="133350" marR="133350" marT="76200" marB="76200" anchor="ctr">
+                    <a:solidFill>
+                      <a:srgbClr val="F6F4ED"/>
+                    </a:solidFill>
+                  </a:tcPr>
+                </a:tc>
+                <a:tc>
+                  <a:txBody>
+                    <a:bodyPr/>
+                    <a:lstStyle/>
+                    <a:p>
+                      <a:r>
+                        <a:rPr sz="1725" b="0">
+                          <a:solidFill>
+                            <a:srgbClr val="28354A"/>
+                          </a:solidFill>
+                          <a:latin typeface="Arial"/>
+                          <a:ea typeface="Arial"/>
+                          <a:cs typeface="Arial"/>
+                        </a:rPr>
+                        <a:t>0/25</a:t>
+                      </a:r>
+                    </a:p>
+                  </a:txBody>
+                  <a:tcPr marL="133350" marR="133350" marT="76200" marB="76200" anchor="ctr">
+                    <a:solidFill>
+                      <a:srgbClr val="F6F4ED"/>
+                    </a:solidFill>
+                  </a:tcPr>
+                </a:tc>
+                <a:tc>
+                  <a:txBody>
+                    <a:bodyPr/>
+                    <a:lstStyle/>
+                    <a:p>
+                      <a:r>
+                        <a:rPr sz="1725" b="0">
+                          <a:solidFill>
+                            <a:srgbClr val="28354A"/>
+                          </a:solidFill>
+                          <a:latin typeface="Arial"/>
+                          <a:ea typeface="Arial"/>
+                          <a:cs typeface="Arial"/>
+                        </a:rPr>
+                        <a:t>3/25</a:t>
+                      </a:r>
+                    </a:p>
+                  </a:txBody>
+                  <a:tcPr marL="133350" marR="133350" marT="76200" marB="76200" anchor="ctr">
+                    <a:solidFill>
+                      <a:srgbClr val="F6F4ED"/>
+                    </a:solidFill>
+                  </a:tcPr>
+                </a:tc>
+              </a:tr>
+              <a:tr h="459962">
+                <a:tc>
+                  <a:txBody>
+                    <a:bodyPr/>
+                    <a:lstStyle/>
+                    <a:p>
+                      <a:r>
+                        <a:rPr sz="1725" b="0">
+                          <a:solidFill>
+                            <a:srgbClr val="28354A"/>
+                          </a:solidFill>
+                          <a:latin typeface="Arial"/>
+                          <a:ea typeface="Arial"/>
+                          <a:cs typeface="Arial"/>
+                        </a:rPr>
+                        <a:t>Known: unnecessary clinician review</a:t>
+                      </a:r>
+                    </a:p>
+                  </a:txBody>
+                  <a:tcPr marL="133350" marR="133350" marT="76200" marB="76200" anchor="ctr">
+                    <a:solidFill>
+                      <a:srgbClr val="F6F4ED"/>
+                    </a:solidFill>
+                  </a:tcPr>
+                </a:tc>
+                <a:tc>
+                  <a:txBody>
+                    <a:bodyPr/>
+                    <a:lstStyle/>
+                    <a:p>
+                      <a:r>
+                        <a:rPr sz="1725" b="0">
+                          <a:solidFill>
+                            <a:srgbClr val="28354A"/>
+                          </a:solidFill>
+                          <a:latin typeface="Arial"/>
+                          <a:ea typeface="Arial"/>
+                          <a:cs typeface="Arial"/>
+                        </a:rPr>
+                        <a:t>0/7</a:t>
+                      </a:r>
+                    </a:p>
+                  </a:txBody>
+                  <a:tcPr marL="133350" marR="133350" marT="76200" marB="76200" anchor="ctr">
+                    <a:solidFill>
+                      <a:srgbClr val="F6F4ED"/>
+                    </a:solidFill>
+                  </a:tcPr>
+                </a:tc>
+                <a:tc>
+                  <a:txBody>
+                    <a:bodyPr/>
+                    <a:lstStyle/>
+                    <a:p>
+                      <a:r>
+                        <a:rPr sz="1725" b="0">
+                          <a:solidFill>
+                            <a:srgbClr val="28354A"/>
+                          </a:solidFill>
+                          <a:latin typeface="Arial"/>
+                          <a:ea typeface="Arial"/>
+                          <a:cs typeface="Arial"/>
+                        </a:rPr>
+                        <a:t>1/7</a:t>
+                      </a:r>
+                    </a:p>
+                  </a:txBody>
+                  <a:tcPr marL="133350" marR="133350" marT="76200" marB="76200" anchor="ctr">
+                    <a:solidFill>
+                      <a:srgbClr val="F6F4ED"/>
+                    </a:solidFill>
+                  </a:tcPr>
+                </a:tc>
+              </a:tr>
+              <a:tr h="459962">
+                <a:tc>
+                  <a:txBody>
+                    <a:bodyPr/>
+                    <a:lstStyle/>
+                    <a:p>
+                      <a:r>
+                        <a:rPr sz="1725" b="0">
+                          <a:solidFill>
+                            <a:srgbClr val="28354A"/>
+                          </a:solidFill>
+                          <a:latin typeface="Arial"/>
+                          <a:ea typeface="Arial"/>
+                          <a:cs typeface="Arial"/>
+                        </a:rPr>
+                        <a:t>Authored challenge: agreement</a:t>
+                      </a:r>
+                    </a:p>
+                  </a:txBody>
+                  <a:tcPr marL="133350" marR="133350" marT="76200" marB="76200" anchor="ctr">
+                    <a:solidFill>
+                      <a:srgbClr val="F6F4ED"/>
+                    </a:solidFill>
+                  </a:tcPr>
+                </a:tc>
+                <a:tc>
+                  <a:txBody>
+                    <a:bodyPr/>
+                    <a:lstStyle/>
+                    <a:p>
+                      <a:r>
+                        <a:rPr sz="1725" b="0">
+                          <a:solidFill>
+                            <a:srgbClr val="28354A"/>
+                          </a:solidFill>
+                          <a:latin typeface="Arial"/>
+                          <a:ea typeface="Arial"/>
+                          <a:cs typeface="Arial"/>
+                        </a:rPr>
+                        <a:t>22/24</a:t>
+                      </a:r>
+                    </a:p>
+                  </a:txBody>
+                  <a:tcPr marL="133350" marR="133350" marT="76200" marB="76200" anchor="ctr">
+                    <a:solidFill>
+                      <a:srgbClr val="F6F4ED"/>
+                    </a:solidFill>
+                  </a:tcPr>
+                </a:tc>
+                <a:tc>
+                  <a:txBody>
+                    <a:bodyPr/>
+                    <a:lstStyle/>
+                    <a:p>
+                      <a:r>
+                        <a:rPr sz="1725" b="0">
+                          <a:solidFill>
+                            <a:srgbClr val="28354A"/>
+                          </a:solidFill>
+                          <a:latin typeface="Arial"/>
+                          <a:ea typeface="Arial"/>
+                          <a:cs typeface="Arial"/>
+                        </a:rPr>
+                        <a:t>23/24</a:t>
+                      </a:r>
+                    </a:p>
+                  </a:txBody>
+                  <a:tcPr marL="133350" marR="133350" marT="76200" marB="76200" anchor="ctr">
+                    <a:solidFill>
+                      <a:srgbClr val="F6F4ED"/>
+                    </a:solidFill>
+                  </a:tcPr>
+                </a:tc>
+              </a:tr>
+              <a:tr h="459962">
+                <a:tc>
+                  <a:txBody>
+                    <a:bodyPr/>
+                    <a:lstStyle/>
+                    <a:p>
+                      <a:r>
+                        <a:rPr sz="1725" b="0">
+                          <a:solidFill>
+                            <a:srgbClr val="28354A"/>
+                          </a:solidFill>
+                          <a:latin typeface="Arial"/>
+                          <a:ea typeface="Arial"/>
+                          <a:cs typeface="Arial"/>
+                        </a:rPr>
+                        <a:t>Authored challenge: clinician action missed</a:t>
+                      </a:r>
+                    </a:p>
+                  </a:txBody>
+                  <a:tcPr marL="133350" marR="133350" marT="76200" marB="76200" anchor="ctr">
+                    <a:solidFill>
+                      <a:srgbClr val="F6F4ED"/>
+                    </a:solidFill>
+                  </a:tcPr>
+                </a:tc>
+                <a:tc>
+                  <a:txBody>
+                    <a:bodyPr/>
+                    <a:lstStyle/>
+                    <a:p>
+                      <a:r>
+                        <a:rPr sz="1725" b="0">
+                          <a:solidFill>
+                            <a:srgbClr val="28354A"/>
+                          </a:solidFill>
+                          <a:latin typeface="Arial"/>
+                          <a:ea typeface="Arial"/>
+                          <a:cs typeface="Arial"/>
+                        </a:rPr>
+                        <a:t>1/18</a:t>
+                      </a:r>
+                    </a:p>
+                  </a:txBody>
+                  <a:tcPr marL="133350" marR="133350" marT="76200" marB="76200" anchor="ctr">
+                    <a:solidFill>
+                      <a:srgbClr val="F6F4ED"/>
+                    </a:solidFill>
+                  </a:tcPr>
+                </a:tc>
+                <a:tc>
+                  <a:txBody>
+                    <a:bodyPr/>
+                    <a:lstStyle/>
+                    <a:p>
+                      <a:r>
+                        <a:rPr sz="1725" b="0">
+                          <a:solidFill>
+                            <a:srgbClr val="28354A"/>
+                          </a:solidFill>
+                          <a:latin typeface="Arial"/>
+                          <a:ea typeface="Arial"/>
+                          <a:cs typeface="Arial"/>
+                        </a:rPr>
+                        <a:t>0/18</a:t>
+                      </a:r>
+                    </a:p>
+                  </a:txBody>
+                  <a:tcPr marL="133350" marR="133350" marT="76200" marB="76200" anchor="ctr">
+                    <a:solidFill>
+                      <a:srgbClr val="F6F4ED"/>
+                    </a:solidFill>
+                  </a:tcPr>
+                </a:tc>
+              </a:tr>
+              <a:tr h="459962">
+                <a:tc>
+                  <a:txBody>
+                    <a:bodyPr/>
+                    <a:lstStyle/>
+                    <a:p>
+                      <a:r>
+                        <a:rPr sz="1725" b="0">
+                          <a:solidFill>
+                            <a:srgbClr val="28354A"/>
+                          </a:solidFill>
+                          <a:latin typeface="Arial"/>
+                          <a:ea typeface="Arial"/>
+                          <a:cs typeface="Arial"/>
+                        </a:rPr>
+                        <a:t>Authored challenge: urgent action missed</a:t>
+                      </a:r>
+                    </a:p>
+                  </a:txBody>
+                  <a:tcPr marL="133350" marR="133350" marT="76200" marB="76200" anchor="ctr">
+                    <a:solidFill>
+                      <a:srgbClr val="F6F4ED"/>
+                    </a:solidFill>
+                  </a:tcPr>
+                </a:tc>
+                <a:tc>
+                  <a:txBody>
+                    <a:bodyPr/>
+                    <a:lstStyle/>
+                    <a:p>
+                      <a:r>
+                        <a:rPr sz="1725" b="0">
+                          <a:solidFill>
+                            <a:srgbClr val="28354A"/>
+                          </a:solidFill>
+                          <a:latin typeface="Arial"/>
+                          <a:ea typeface="Arial"/>
+                          <a:cs typeface="Arial"/>
+                        </a:rPr>
+                        <a:t>1/10</a:t>
+                      </a:r>
+                    </a:p>
+                  </a:txBody>
+                  <a:tcPr marL="133350" marR="133350" marT="76200" marB="76200" anchor="ctr">
+                    <a:solidFill>
+                      <a:srgbClr val="F6F4ED"/>
+                    </a:solidFill>
+                  </a:tcPr>
+                </a:tc>
+                <a:tc>
+                  <a:txBody>
+                    <a:bodyPr/>
+                    <a:lstStyle/>
+                    <a:p>
+                      <a:r>
+                        <a:rPr sz="1725" b="0">
+                          <a:solidFill>
+                            <a:srgbClr val="28354A"/>
+                          </a:solidFill>
+                          <a:latin typeface="Arial"/>
+                          <a:ea typeface="Arial"/>
+                          <a:cs typeface="Arial"/>
+                        </a:rPr>
+                        <a:t>1/10</a:t>
+                      </a:r>
+                    </a:p>
+                  </a:txBody>
+                  <a:tcPr marL="133350" marR="133350" marT="76200" marB="76200" anchor="ctr">
+                    <a:solidFill>
+                      <a:srgbClr val="F6F4ED"/>
+                    </a:solidFill>
+                  </a:tcPr>
+                </a:tc>
+              </a:tr>
+            </a:tbl>
+          </a:graphicData>
+        </a:graphic>
+      </p:graphicFrame>
+      <p:sp>
+        <p:nvSpPr>
+          <p:cNvPr id="3" name="">
+            <a:extLst xmlns:a="http://schemas.openxmlformats.org/drawingml/2006/main">
+              <a:ext uri="{FF2B5EF4-FFF2-40B4-BE49-F238E27FC236}">
+                <a16:creationId xmlns:a16="http://schemas.microsoft.com/office/drawing/2014/main" id="{6639EC88-DFA0-459A-A673-D526DB5581A4}"/>
+              </a:ext>
+            </a:extLst>
+          </p:cNvPr>
+          <p:cNvSpPr>
+            <a:spLocks xmlns:a="http://schemas.openxmlformats.org/drawingml/2006/main" noGrp="1"/>
+          </p:cNvSpPr>
+          <p:nvPr/>
+        </p:nvSpPr>
+        <p:spPr>
+          <a:xfrm xmlns:a="http://schemas.openxmlformats.org/drawingml/2006/main">
+            <a:off x="762000" y="5562600"/>
+            <a:ext cx="10382250" cy="590550"/>
+          </a:xfrm>
+          <a:prstGeom xmlns:a="http://schemas.openxmlformats.org/drawingml/2006/main" prst="rect">
+            <a:avLst/>
+          </a:prstGeom>
+          <a:noFill xmlns:a="http://schemas.openxmlformats.org/drawingml/2006/main"/>
+          <a:ln xmlns:a="http://schemas.openxmlformats.org/drawingml/2006/main" w="0">
+            <a:noFill/>
+          </a:ln>
+        </p:spPr>
+        <p:txBody>
+          <a:bodyPr xmlns:a="http://schemas.openxmlformats.org/drawingml/2006/main" wrap="square" lIns="0" tIns="0" rIns="0" bIns="0" anchor="t">
+            <a:noAutofit/>
+          </a:bodyPr>
+          <a:lstStyle xmlns:a="http://schemas.openxmlformats.org/drawingml/2006/main"/>
+          <a:p xmlns:a="http://schemas.openxmlformats.org/drawingml/2006/main">
+            <a:pPr>
+              <a:defRPr sz="1875" b="1">
+                <a:solidFill>
+                  <a:srgbClr val="286B68"/>
+                </a:solidFill>
+                <a:latin typeface="Arial"/>
+                <a:ea typeface="Arial"/>
+                <a:cs typeface="Arial"/>
+              </a:defRPr>
+            </a:pPr>
+            <a:r>
+              <a:rPr sz="1875" b="1">
+                <a:solidFill>
+                  <a:srgbClr val="286B68"/>
+                </a:solidFill>
+                <a:latin typeface="Arial"/>
+                <a:ea typeface="Arial"/>
+                <a:cs typeface="Arial"/>
+              </a:rPr>
+              <a:t>Candidate not promoted. Three new urgent routing misses require review.</a:t>
+            </a:r>
+          </a:p>
+        </p:txBody>
+      </p:sp>
+      <p:sp>
+        <p:nvSpPr>
+          <p:cNvPr id="4" name="">
+            <a:extLst xmlns:a="http://schemas.openxmlformats.org/drawingml/2006/main">
+              <a:ext uri="{FF2B5EF4-FFF2-40B4-BE49-F238E27FC236}">
+                <a16:creationId xmlns:a16="http://schemas.microsoft.com/office/drawing/2014/main" id="{891CB177-EADF-4F64-ACC3-443F553A8D7A}"/>
+              </a:ext>
+            </a:extLst>
+          </p:cNvPr>
+          <p:cNvSpPr>
+            <a:spLocks xmlns:a="http://schemas.openxmlformats.org/drawingml/2006/main" noGrp="1"/>
+          </p:cNvSpPr>
+          <p:nvPr/>
+        </p:nvSpPr>
+        <p:spPr>
+          <a:xfrm xmlns:a="http://schemas.openxmlformats.org/drawingml/2006/main">
+            <a:off x="762000" y="6229350"/>
+            <a:ext cx="10096500" cy="466725"/>
+          </a:xfrm>
+          <a:prstGeom xmlns:a="http://schemas.openxmlformats.org/drawingml/2006/main" prst="rect">
+            <a:avLst/>
+          </a:prstGeom>
+          <a:noFill xmlns:a="http://schemas.openxmlformats.org/drawingml/2006/main"/>
+          <a:ln xmlns:a="http://schemas.openxmlformats.org/drawingml/2006/main" w="0">
+            <a:noFill/>
+          </a:ln>
+        </p:spPr>
+        <p:txBody>
+          <a:bodyPr xmlns:a="http://schemas.openxmlformats.org/drawingml/2006/main" wrap="square" lIns="0" tIns="0" rIns="0" bIns="0" anchor="t">
+            <a:noAutofit/>
+          </a:bodyPr>
+          <a:lstStyle xmlns:a="http://schemas.openxmlformats.org/drawingml/2006/main"/>
+          <a:p xmlns:a="http://schemas.openxmlformats.org/drawingml/2006/main">
+            <a:pPr>
+              <a:defRPr sz="1275">
+                <a:solidFill>
+                  <a:srgbClr val="667084"/>
+                </a:solidFill>
+                <a:latin typeface="Arial"/>
+                <a:ea typeface="Arial"/>
+                <a:cs typeface="Arial"/>
+              </a:defRPr>
+            </a:pPr>
+            <a:r>
+              <a:rPr sz="1275">
+                <a:solidFill>
+                  <a:srgbClr val="667084"/>
+                </a:solidFill>
+                <a:latin typeface="Arial"/>
+                <a:ea typeface="Arial"/>
+                <a:cs typeface="Arial"/>
+              </a:rPr>
+              <a:t>Known set: post-output physician reference. Challenge: AI-authored policy checks, no physician approval. GUI unchanged.</a:t>
+            </a:r>
+          </a:p>
+        </p:txBody>
+      </p:sp>
+      <p:sp>
+        <p:nvSpPr>
+          <p:cNvPr id="5" name="">
+            <a:extLst xmlns:a="http://schemas.openxmlformats.org/drawingml/2006/main">
+              <a:ext uri="{FF2B5EF4-FFF2-40B4-BE49-F238E27FC236}">
+                <a16:creationId xmlns:a16="http://schemas.microsoft.com/office/drawing/2014/main" id="{B35010EE-7355-4BE3-8A40-8ADA42631472}"/>
+              </a:ext>
+            </a:extLst>
+          </p:cNvPr>
+          <p:cNvSpPr>
+            <a:spLocks xmlns:a="http://schemas.openxmlformats.org/drawingml/2006/main" noGrp="1"/>
+          </p:cNvSpPr>
+          <p:nvPr/>
+        </p:nvSpPr>
+        <p:spPr>
+          <a:xfrm xmlns:a="http://schemas.openxmlformats.org/drawingml/2006/main">
+            <a:off x="11296650" y="6400800"/>
+            <a:ext cx="361950" cy="228600"/>
+          </a:xfrm>
+          <a:prstGeom xmlns:a="http://schemas.openxmlformats.org/drawingml/2006/main" prst="rect">
+            <a:avLst/>
+          </a:prstGeom>
+          <a:noFill xmlns:a="http://schemas.openxmlformats.org/drawingml/2006/main"/>
+          <a:ln xmlns:a="http://schemas.openxmlformats.org/drawingml/2006/main" w="0">
+            <a:noFill/>
+          </a:ln>
+        </p:spPr>
+        <p:txBody>
+          <a:bodyPr xmlns:a="http://schemas.openxmlformats.org/drawingml/2006/main" wrap="square" lIns="0" tIns="0" rIns="0" bIns="0" anchor="t">
+            <a:noAutofit/>
+          </a:bodyPr>
+          <a:lstStyle xmlns:a="http://schemas.openxmlformats.org/drawingml/2006/main"/>
+          <a:p xmlns:a="http://schemas.openxmlformats.org/drawingml/2006/main">
+            <a:pPr algn="r">
+              <a:defRPr sz="1275">
+                <a:solidFill>
+                  <a:srgbClr val="667084"/>
+                </a:solidFill>
+                <a:latin typeface="Arial"/>
+                <a:ea typeface="Arial"/>
+                <a:cs typeface="Arial"/>
+              </a:defRPr>
+            </a:pPr>
+            <a:r>
+              <a:rPr sz="1275">
+                <a:solidFill>
+                  <a:srgbClr val="667084"/>
+                </a:solidFill>
+                <a:latin typeface="Arial"/>
+                <a:ea typeface="Arial"/>
+                <a:cs typeface="Arial"/>
+              </a:rPr>
+              <a:t>29</a:t>
+            </a:r>
+          </a:p>
+        </p:txBody>
+      </p:sp>
+    </p:spTree>
+    <p:extLst>
+      <p:ext uri="{BB962C8B-B14F-4D97-AF65-F5344CB8AC3E}">
+        <p14:creationId xmlns:p14="http://schemas.microsoft.com/office/powerpoint/2010/main" val="1333111578"/>
       </p:ext>
     </p:extLst>
   </p:cSld>
@@ -15269,7 +16599,7 @@
           <p:cNvPr id="10" name="">
             <a:extLst xmlns:a="http://schemas.openxmlformats.org/drawingml/2006/main">
               <a:ext uri="{FF2B5EF4-FFF2-40B4-BE49-F238E27FC236}">
-                <a16:creationId xmlns:a16="http://schemas.microsoft.com/office/drawing/2014/main" id="{D6384096-12F4-4707-9975-93BDC363C910}"/>
+                <a16:creationId xmlns:a16="http://schemas.microsoft.com/office/drawing/2014/main" id="{6684928C-032B-425F-8334-CBA8FD3CCD0F}"/>
               </a:ext>
             </a:extLst>
           </p:cNvPr>
@@ -15326,7 +16656,7 @@
           <p:cNvPr id="2" name="">
             <a:extLst xmlns:a="http://schemas.openxmlformats.org/drawingml/2006/main">
               <a:ext uri="{FF2B5EF4-FFF2-40B4-BE49-F238E27FC236}">
-                <a16:creationId xmlns:a16="http://schemas.microsoft.com/office/drawing/2014/main" id="{3263E1E0-B960-4048-82ED-D06DEDF51302}"/>
+                <a16:creationId xmlns:a16="http://schemas.microsoft.com/office/drawing/2014/main" id="{A2F83472-C267-4091-9E3E-9957683AD764}"/>
               </a:ext>
             </a:extLst>
           </p:cNvPr>
@@ -15373,7 +16703,7 @@
                 <a:ea typeface="Arial"/>
                 <a:cs typeface="Arial"/>
               </a:rPr>
-              <a:t>Fable SELF_CARE → physician ASYNC_PHYSICIAN</a:t>
+              <a:t>Frozen Fable SELF_CARE → physician ASYNC_PHYSICIAN</a:t>
             </a:r>
           </a:p>
         </p:txBody>
@@ -15383,7 +16713,7 @@
           <p:cNvPr id="3" name="">
             <a:extLst xmlns:a="http://schemas.openxmlformats.org/drawingml/2006/main">
               <a:ext uri="{FF2B5EF4-FFF2-40B4-BE49-F238E27FC236}">
-                <a16:creationId xmlns:a16="http://schemas.microsoft.com/office/drawing/2014/main" id="{92817178-6FD8-4423-9AD0-2433AC8E4C33}"/>
+                <a16:creationId xmlns:a16="http://schemas.microsoft.com/office/drawing/2014/main" id="{EAB90AA2-CD7A-41AD-A619-A399C5647D8B}"/>
               </a:ext>
             </a:extLst>
           </p:cNvPr>
@@ -15440,7 +16770,7 @@
           <p:cNvPr id="4" name="">
             <a:extLst xmlns:a="http://schemas.openxmlformats.org/drawingml/2006/main">
               <a:ext uri="{FF2B5EF4-FFF2-40B4-BE49-F238E27FC236}">
-                <a16:creationId xmlns:a16="http://schemas.microsoft.com/office/drawing/2014/main" id="{4135CA28-0EB8-4795-B1E7-888063ACE426}"/>
+                <a16:creationId xmlns:a16="http://schemas.microsoft.com/office/drawing/2014/main" id="{F93D5451-2B78-4B36-ACA6-3C4C4E2DFE8D}"/>
               </a:ext>
             </a:extLst>
           </p:cNvPr>
@@ -15497,7 +16827,7 @@
           <p:cNvPr id="5" name="">
             <a:extLst xmlns:a="http://schemas.openxmlformats.org/drawingml/2006/main">
               <a:ext uri="{FF2B5EF4-FFF2-40B4-BE49-F238E27FC236}">
-                <a16:creationId xmlns:a16="http://schemas.microsoft.com/office/drawing/2014/main" id="{EC256323-D62A-4006-A39A-6F929A1F8BEF}"/>
+                <a16:creationId xmlns:a16="http://schemas.microsoft.com/office/drawing/2014/main" id="{27AFB6CC-0CB3-4DB3-8618-F9DB18B023B4}"/>
               </a:ext>
             </a:extLst>
           </p:cNvPr>
@@ -15554,7 +16884,7 @@
           <p:cNvPr id="6" name="">
             <a:extLst xmlns:a="http://schemas.openxmlformats.org/drawingml/2006/main">
               <a:ext uri="{FF2B5EF4-FFF2-40B4-BE49-F238E27FC236}">
-                <a16:creationId xmlns:a16="http://schemas.microsoft.com/office/drawing/2014/main" id="{D1ABB657-FEB1-4A61-BAC2-28CD86576492}"/>
+                <a16:creationId xmlns:a16="http://schemas.microsoft.com/office/drawing/2014/main" id="{854293D3-8AA4-4FFA-88F8-B19954106153}"/>
               </a:ext>
             </a:extLst>
           </p:cNvPr>
@@ -15611,7 +16941,7 @@
           <p:cNvPr id="7" name="">
             <a:extLst xmlns:a="http://schemas.openxmlformats.org/drawingml/2006/main">
               <a:ext uri="{FF2B5EF4-FFF2-40B4-BE49-F238E27FC236}">
-                <a16:creationId xmlns:a16="http://schemas.microsoft.com/office/drawing/2014/main" id="{424534AE-5038-47F4-B9EE-EC3A68C8EDDC}"/>
+                <a16:creationId xmlns:a16="http://schemas.microsoft.com/office/drawing/2014/main" id="{0181DCCE-80C6-40F5-9450-31DA6D80BB9B}"/>
               </a:ext>
             </a:extLst>
           </p:cNvPr>
@@ -15668,7 +16998,7 @@
           <p:cNvPr id="8" name="">
             <a:extLst xmlns:a="http://schemas.openxmlformats.org/drawingml/2006/main">
               <a:ext uri="{FF2B5EF4-FFF2-40B4-BE49-F238E27FC236}">
-                <a16:creationId xmlns:a16="http://schemas.microsoft.com/office/drawing/2014/main" id="{B3DF7DEA-D009-4A03-AAC2-B539A1116B9F}"/>
+                <a16:creationId xmlns:a16="http://schemas.microsoft.com/office/drawing/2014/main" id="{22E14226-6FC7-4CBF-80D5-DC5490E274AF}"/>
               </a:ext>
             </a:extLst>
           </p:cNvPr>
@@ -15725,7 +17055,7 @@
           <p:cNvPr id="9" name="">
             <a:extLst xmlns:a="http://schemas.openxmlformats.org/drawingml/2006/main">
               <a:ext uri="{FF2B5EF4-FFF2-40B4-BE49-F238E27FC236}">
-                <a16:creationId xmlns:a16="http://schemas.microsoft.com/office/drawing/2014/main" id="{7D26B055-0FF1-4916-AC63-857D533D02C2}"/>
+                <a16:creationId xmlns:a16="http://schemas.microsoft.com/office/drawing/2014/main" id="{9D1CAE06-D8B9-4F46-8608-9D5E5F942607}"/>
               </a:ext>
             </a:extLst>
           </p:cNvPr>
@@ -15780,7 +17110,953 @@
     </p:spTree>
     <p:extLst>
       <p:ext uri="{BB962C8B-B14F-4D97-AF65-F5344CB8AC3E}">
-        <p14:creationId xmlns:p14="http://schemas.microsoft.com/office/powerpoint/2010/main" val="859143774"/>
+        <p14:creationId xmlns:p14="http://schemas.microsoft.com/office/powerpoint/2010/main" val="1267219906"/>
+      </p:ext>
+    </p:extLst>
+  </p:cSld>
+</p:sld>
+</file>
+
+<file path=ppt/slides/slide30.xml><?xml version="1.0" encoding="utf-8"?>
+<p:sld xmlns:p="http://schemas.openxmlformats.org/presentationml/2006/main">
+  <p:cSld>
+    <p:bg>
+      <p:bgPr>
+        <a:solidFill xmlns:a="http://schemas.openxmlformats.org/drawingml/2006/main">
+          <a:srgbClr val="F6F4ED"/>
+        </a:solidFill>
+      </p:bgPr>
+    </p:bg>
+    <p:spTree>
+      <p:nvGrpSpPr>
+        <p:cNvPr id="1" name=""/>
+        <p:cNvGrpSpPr/>
+        <p:nvPr/>
+      </p:nvGrpSpPr>
+      <p:grpSpPr>
+        <a:xfrm xmlns:a="http://schemas.openxmlformats.org/drawingml/2006/main"/>
+      </p:grpSpPr>
+      <p:sp>
+        <p:nvSpPr>
+          <p:cNvPr id="5" name="">
+            <a:extLst xmlns:a="http://schemas.openxmlformats.org/drawingml/2006/main">
+              <a:ext uri="{FF2B5EF4-FFF2-40B4-BE49-F238E27FC236}">
+                <a16:creationId xmlns:a16="http://schemas.microsoft.com/office/drawing/2014/main" id="{ABFD1881-AD6C-4D73-B6F4-48F640A06A62}"/>
+              </a:ext>
+            </a:extLst>
+          </p:cNvPr>
+          <p:cNvSpPr>
+            <a:spLocks xmlns:a="http://schemas.openxmlformats.org/drawingml/2006/main" noGrp="1"/>
+          </p:cNvSpPr>
+          <p:nvPr/>
+        </p:nvSpPr>
+        <p:spPr>
+          <a:xfrm xmlns:a="http://schemas.openxmlformats.org/drawingml/2006/main">
+            <a:off x="762000" y="485775"/>
+            <a:ext cx="10668000" cy="586550"/>
+          </a:xfrm>
+          <a:prstGeom xmlns:a="http://schemas.openxmlformats.org/drawingml/2006/main" prst="rect">
+            <a:avLst/>
+          </a:prstGeom>
+          <a:noFill xmlns:a="http://schemas.openxmlformats.org/drawingml/2006/main"/>
+          <a:ln xmlns:a="http://schemas.openxmlformats.org/drawingml/2006/main" w="0">
+            <a:noFill/>
+          </a:ln>
+        </p:spPr>
+        <p:txBody>
+          <a:bodyPr xmlns:a="http://schemas.openxmlformats.org/drawingml/2006/main" wrap="square" lIns="0" tIns="0" rIns="0" bIns="0" anchor="t">
+            <a:noAutofit/>
+          </a:bodyPr>
+          <a:lstStyle xmlns:a="http://schemas.openxmlformats.org/drawingml/2006/main"/>
+          <a:p xmlns:a="http://schemas.openxmlformats.org/drawingml/2006/main">
+            <a:pPr>
+              <a:defRPr sz="3525" b="1">
+                <a:solidFill>
+                  <a:srgbClr val="243866"/>
+                </a:solidFill>
+                <a:latin typeface="Arial"/>
+                <a:ea typeface="Arial"/>
+                <a:cs typeface="Arial"/>
+              </a:defRPr>
+            </a:pPr>
+            <a:r>
+              <a:rPr sz="3525" b="1">
+                <a:solidFill>
+                  <a:srgbClr val="243866"/>
+                </a:solidFill>
+                <a:latin typeface="Arial"/>
+                <a:ea typeface="Arial"/>
+                <a:cs typeface="Arial"/>
+              </a:rPr>
+              <a:t>Independent validation remains pending</a:t>
+            </a:r>
+          </a:p>
+        </p:txBody>
+      </p:sp>
+      <p:graphicFrame>
+        <p:nvGraphicFramePr>
+          <p:cNvPr id="6" name=""/>
+          <p:cNvGraphicFramePr/>
+          <p:nvPr/>
+        </p:nvGraphicFramePr>
+        <p:xfrm>
+          <a:off xmlns:a="http://schemas.openxmlformats.org/drawingml/2006/main" x="762000" y="1619250"/>
+          <a:ext xmlns:a="http://schemas.openxmlformats.org/drawingml/2006/main" cx="10668000" cy="3377660"/>
+        </p:xfrm>
+        <a:graphic xmlns:a="http://schemas.openxmlformats.org/drawingml/2006/main">
+          <a:graphicData uri="http://schemas.openxmlformats.org/drawingml/2006/table">
+            <a:tbl>
+              <a:tblPr firstRow="1" bandRow="0"/>
+              <a:tblGrid>
+                <a:gridCol w="3413760"/>
+                <a:gridCol w="7254240"/>
+              </a:tblGrid>
+              <a:tr h="459962">
+                <a:tc>
+                  <a:txBody>
+                    <a:bodyPr/>
+                    <a:lstStyle/>
+                    <a:p>
+                      <a:r>
+                        <a:rPr sz="1725" b="1">
+                          <a:solidFill>
+                            <a:srgbClr val="FFFFFF"/>
+                          </a:solidFill>
+                          <a:latin typeface="Arial"/>
+                          <a:ea typeface="Arial"/>
+                          <a:cs typeface="Arial"/>
+                        </a:rPr>
+                        <a:t>Owner and work</a:t>
+                      </a:r>
+                    </a:p>
+                  </a:txBody>
+                  <a:tcPr marL="133350" marR="133350" marT="76200" marB="76200" anchor="ctr">
+                    <a:solidFill>
+                      <a:srgbClr val="243866"/>
+                    </a:solidFill>
+                  </a:tcPr>
+                </a:tc>
+                <a:tc>
+                  <a:txBody>
+                    <a:bodyPr/>
+                    <a:lstStyle/>
+                    <a:p>
+                      <a:r>
+                        <a:rPr sz="1725" b="1">
+                          <a:solidFill>
+                            <a:srgbClr val="FFFFFF"/>
+                          </a:solidFill>
+                          <a:latin typeface="Arial"/>
+                          <a:ea typeface="Arial"/>
+                          <a:cs typeface="Arial"/>
+                        </a:rPr>
+                        <a:t>Evidence required</a:t>
+                      </a:r>
+                    </a:p>
+                  </a:txBody>
+                  <a:tcPr marL="133350" marR="133350" marT="76200" marB="76200" anchor="ctr">
+                    <a:solidFill>
+                      <a:srgbClr val="243866"/>
+                    </a:solidFill>
+                  </a:tcPr>
+                </a:tc>
+              </a:tr>
+              <a:tr h="729425">
+                <a:tc>
+                  <a:txBody>
+                    <a:bodyPr/>
+                    <a:lstStyle/>
+                    <a:p>
+                      <a:r>
+                        <a:rPr sz="1725" b="0">
+                          <a:solidFill>
+                            <a:srgbClr val="28354A"/>
+                          </a:solidFill>
+                          <a:latin typeface="Arial"/>
+                          <a:ea typeface="Arial"/>
+                          <a:cs typeface="Arial"/>
+                        </a:rPr>
+                        <a:t>Clinical policy</a:t>
+                      </a:r>
+                    </a:p>
+                    <a:p>
+                      <a:r>
+                        <a:rPr sz="1725" b="0">
+                          <a:solidFill>
+                            <a:srgbClr val="28354A"/>
+                          </a:solidFill>
+                          <a:latin typeface="Arial"/>
+                          <a:ea typeface="Arial"/>
+                          <a:cs typeface="Arial"/>
+                        </a:rPr>
+                        <a:t>Clinical lead</a:t>
+                      </a:r>
+                    </a:p>
+                  </a:txBody>
+                  <a:tcPr marL="133350" marR="133350" marT="76200" marB="76200" anchor="ctr">
+                    <a:solidFill>
+                      <a:srgbClr val="F6F4ED"/>
+                    </a:solidFill>
+                  </a:tcPr>
+                </a:tc>
+                <a:tc>
+                  <a:txBody>
+                    <a:bodyPr/>
+                    <a:lstStyle/>
+                    <a:p>
+                      <a:r>
+                        <a:rPr sz="1725" b="0">
+                          <a:solidFill>
+                            <a:srgbClr val="28354A"/>
+                          </a:solidFill>
+                          <a:latin typeface="Arial"/>
+                          <a:ea typeface="Arial"/>
+                          <a:cs typeface="Arial"/>
+                        </a:rPr>
+                        <a:t>Approve self-care eligibility, care timing and handling of clinically material unknowns.</a:t>
+                      </a:r>
+                    </a:p>
+                  </a:txBody>
+                  <a:tcPr marL="133350" marR="133350" marT="76200" marB="76200" anchor="ctr">
+                    <a:solidFill>
+                      <a:srgbClr val="F6F4ED"/>
+                    </a:solidFill>
+                  </a:tcPr>
+                </a:tc>
+              </a:tr>
+              <a:tr h="729425">
+                <a:tc>
+                  <a:txBody>
+                    <a:bodyPr/>
+                    <a:lstStyle/>
+                    <a:p>
+                      <a:r>
+                        <a:rPr sz="1725" b="0">
+                          <a:solidFill>
+                            <a:srgbClr val="28354A"/>
+                          </a:solidFill>
+                          <a:latin typeface="Arial"/>
+                          <a:ea typeface="Arial"/>
+                          <a:cs typeface="Arial"/>
+                        </a:rPr>
+                        <a:t>Independent reference</a:t>
+                      </a:r>
+                    </a:p>
+                    <a:p>
+                      <a:r>
+                        <a:rPr sz="1725" b="0">
+                          <a:solidFill>
+                            <a:srgbClr val="28354A"/>
+                          </a:solidFill>
+                          <a:latin typeface="Arial"/>
+                          <a:ea typeface="Arial"/>
+                          <a:cs typeface="Arial"/>
+                        </a:rPr>
+                        <a:t>Clinical evaluation lead</a:t>
+                      </a:r>
+                    </a:p>
+                  </a:txBody>
+                  <a:tcPr marL="133350" marR="133350" marT="76200" marB="76200" anchor="ctr">
+                    <a:solidFill>
+                      <a:srgbClr val="F6F4ED"/>
+                    </a:solidFill>
+                  </a:tcPr>
+                </a:tc>
+                <a:tc>
+                  <a:txBody>
+                    <a:bodyPr/>
+                    <a:lstStyle/>
+                    <a:p>
+                      <a:r>
+                        <a:rPr sz="1725" b="0">
+                          <a:solidFill>
+                            <a:srgbClr val="28354A"/>
+                          </a:solidFill>
+                          <a:latin typeface="Arial"/>
+                          <a:ea typeface="Arial"/>
+                          <a:cs typeface="Arial"/>
+                        </a:rPr>
+                        <a:t>Two clinicians label new cases without model outputs. A third adjudicates disagreements.</a:t>
+                      </a:r>
+                    </a:p>
+                  </a:txBody>
+                  <a:tcPr marL="133350" marR="133350" marT="76200" marB="76200" anchor="ctr">
+                    <a:solidFill>
+                      <a:srgbClr val="F6F4ED"/>
+                    </a:solidFill>
+                  </a:tcPr>
+                </a:tc>
+              </a:tr>
+              <a:tr h="729425">
+                <a:tc>
+                  <a:txBody>
+                    <a:bodyPr/>
+                    <a:lstStyle/>
+                    <a:p>
+                      <a:r>
+                        <a:rPr sz="1725" b="0">
+                          <a:solidFill>
+                            <a:srgbClr val="28354A"/>
+                          </a:solidFill>
+                          <a:latin typeface="Arial"/>
+                          <a:ea typeface="Arial"/>
+                          <a:cs typeface="Arial"/>
+                        </a:rPr>
+                        <a:t>Locked evaluation</a:t>
+                      </a:r>
+                    </a:p>
+                    <a:p>
+                      <a:r>
+                        <a:rPr sz="1725" b="0">
+                          <a:solidFill>
+                            <a:srgbClr val="28354A"/>
+                          </a:solidFill>
+                          <a:latin typeface="Arial"/>
+                          <a:ea typeface="Arial"/>
+                          <a:cs typeface="Arial"/>
+                        </a:rPr>
+                        <a:t>Evaluation + safety</a:t>
+                      </a:r>
+                    </a:p>
+                  </a:txBody>
+                  <a:tcPr marL="133350" marR="133350" marT="76200" marB="76200" anchor="ctr">
+                    <a:solidFill>
+                      <a:srgbClr val="F6F4ED"/>
+                    </a:solidFill>
+                  </a:tcPr>
+                </a:tc>
+                <a:tc>
+                  <a:txBody>
+                    <a:bodyPr/>
+                    <a:lstStyle/>
+                    <a:p>
+                      <a:r>
+                        <a:rPr sz="1725" b="0">
+                          <a:solidFill>
+                            <a:srgbClr val="28354A"/>
+                          </a:solidFill>
+                          <a:latin typeface="Arial"/>
+                          <a:ea typeface="Arial"/>
+                          <a:cs typeface="Arial"/>
+                        </a:rPr>
+                        <a:t>Freeze new case sets, endpoints and limits. Report severe misses, uncertainty and referral burden.</a:t>
+                      </a:r>
+                    </a:p>
+                  </a:txBody>
+                  <a:tcPr marL="133350" marR="133350" marT="76200" marB="76200" anchor="ctr">
+                    <a:solidFill>
+                      <a:srgbClr val="F6F4ED"/>
+                    </a:solidFill>
+                  </a:tcPr>
+                </a:tc>
+              </a:tr>
+              <a:tr h="729425">
+                <a:tc>
+                  <a:txBody>
+                    <a:bodyPr/>
+                    <a:lstStyle/>
+                    <a:p>
+                      <a:r>
+                        <a:rPr sz="1725" b="0">
+                          <a:solidFill>
+                            <a:srgbClr val="28354A"/>
+                          </a:solidFill>
+                          <a:latin typeface="Arial"/>
+                          <a:ea typeface="Arial"/>
+                          <a:cs typeface="Arial"/>
+                        </a:rPr>
+                        <a:t>Prospective review</a:t>
+                      </a:r>
+                    </a:p>
+                    <a:p>
+                      <a:r>
+                        <a:rPr sz="1725" b="0">
+                          <a:solidFill>
+                            <a:srgbClr val="28354A"/>
+                          </a:solidFill>
+                          <a:latin typeface="Arial"/>
+                          <a:ea typeface="Arial"/>
+                          <a:cs typeface="Arial"/>
+                        </a:rPr>
+                        <a:t>Care operations</a:t>
+                      </a:r>
+                    </a:p>
+                  </a:txBody>
+                  <a:tcPr marL="133350" marR="133350" marT="76200" marB="76200" anchor="ctr">
+                    <a:solidFill>
+                      <a:srgbClr val="F6F4ED"/>
+                    </a:solidFill>
+                  </a:tcPr>
+                </a:tc>
+                <a:tc>
+                  <a:txBody>
+                    <a:bodyPr/>
+                    <a:lstStyle/>
+                    <a:p>
+                      <a:r>
+                        <a:rPr sz="1725" b="0">
+                          <a:solidFill>
+                            <a:srgbClr val="28354A"/>
+                          </a:solidFill>
+                          <a:latin typeface="Arial"/>
+                          <a:ea typeface="Arial"/>
+                          <a:cs typeface="Arial"/>
+                        </a:rPr>
+                        <a:t>After offline criteria pass, evaluate alongside usual care. Verify follow-through, workload and pause rules.</a:t>
+                      </a:r>
+                    </a:p>
+                  </a:txBody>
+                  <a:tcPr marL="133350" marR="133350" marT="76200" marB="76200" anchor="ctr">
+                    <a:solidFill>
+                      <a:srgbClr val="F6F4ED"/>
+                    </a:solidFill>
+                  </a:tcPr>
+                </a:tc>
+              </a:tr>
+            </a:tbl>
+          </a:graphicData>
+        </a:graphic>
+      </p:graphicFrame>
+      <p:sp>
+        <p:nvSpPr>
+          <p:cNvPr id="3" name="">
+            <a:extLst xmlns:a="http://schemas.openxmlformats.org/drawingml/2006/main">
+              <a:ext uri="{FF2B5EF4-FFF2-40B4-BE49-F238E27FC236}">
+                <a16:creationId xmlns:a16="http://schemas.microsoft.com/office/drawing/2014/main" id="{F32B60F4-5AC2-462B-8D8C-16C5820E6443}"/>
+              </a:ext>
+            </a:extLst>
+          </p:cNvPr>
+          <p:cNvSpPr>
+            <a:spLocks xmlns:a="http://schemas.openxmlformats.org/drawingml/2006/main" noGrp="1"/>
+          </p:cNvSpPr>
+          <p:nvPr/>
+        </p:nvSpPr>
+        <p:spPr>
+          <a:xfrm xmlns:a="http://schemas.openxmlformats.org/drawingml/2006/main">
+            <a:off x="762000" y="5886450"/>
+            <a:ext cx="10096500" cy="514350"/>
+          </a:xfrm>
+          <a:prstGeom xmlns:a="http://schemas.openxmlformats.org/drawingml/2006/main" prst="rect">
+            <a:avLst/>
+          </a:prstGeom>
+          <a:noFill xmlns:a="http://schemas.openxmlformats.org/drawingml/2006/main"/>
+          <a:ln xmlns:a="http://schemas.openxmlformats.org/drawingml/2006/main" w="0">
+            <a:noFill/>
+          </a:ln>
+        </p:spPr>
+        <p:txBody>
+          <a:bodyPr xmlns:a="http://schemas.openxmlformats.org/drawingml/2006/main" wrap="square" lIns="0" tIns="0" rIns="0" bIns="0" anchor="t">
+            <a:noAutofit/>
+          </a:bodyPr>
+          <a:lstStyle xmlns:a="http://schemas.openxmlformats.org/drawingml/2006/main"/>
+          <a:p xmlns:a="http://schemas.openxmlformats.org/drawingml/2006/main">
+            <a:pPr>
+              <a:defRPr sz="1350">
+                <a:solidFill>
+                  <a:srgbClr val="667084"/>
+                </a:solidFill>
+                <a:latin typeface="Arial"/>
+                <a:ea typeface="Arial"/>
+                <a:cs typeface="Arial"/>
+              </a:defRPr>
+            </a:pPr>
+            <a:r>
+              <a:rPr sz="1350">
+                <a:solidFill>
+                  <a:srgbClr val="667084"/>
+                </a:solidFill>
+                <a:latin typeface="Arial"/>
+                <a:ea typeface="Arial"/>
+                <a:cs typeface="Arial"/>
+              </a:rPr>
+              <a:t>Physician approval, independent clinical labels and prospective testing have not occurred. No autonomous clinical use.</a:t>
+            </a:r>
+          </a:p>
+        </p:txBody>
+      </p:sp>
+      <p:sp>
+        <p:nvSpPr>
+          <p:cNvPr id="4" name="">
+            <a:extLst xmlns:a="http://schemas.openxmlformats.org/drawingml/2006/main">
+              <a:ext uri="{FF2B5EF4-FFF2-40B4-BE49-F238E27FC236}">
+                <a16:creationId xmlns:a16="http://schemas.microsoft.com/office/drawing/2014/main" id="{30AABD4A-3F38-4583-9095-76231BF412D3}"/>
+              </a:ext>
+            </a:extLst>
+          </p:cNvPr>
+          <p:cNvSpPr>
+            <a:spLocks xmlns:a="http://schemas.openxmlformats.org/drawingml/2006/main" noGrp="1"/>
+          </p:cNvSpPr>
+          <p:nvPr/>
+        </p:nvSpPr>
+        <p:spPr>
+          <a:xfrm xmlns:a="http://schemas.openxmlformats.org/drawingml/2006/main">
+            <a:off x="11296650" y="6400800"/>
+            <a:ext cx="361950" cy="228600"/>
+          </a:xfrm>
+          <a:prstGeom xmlns:a="http://schemas.openxmlformats.org/drawingml/2006/main" prst="rect">
+            <a:avLst/>
+          </a:prstGeom>
+          <a:noFill xmlns:a="http://schemas.openxmlformats.org/drawingml/2006/main"/>
+          <a:ln xmlns:a="http://schemas.openxmlformats.org/drawingml/2006/main" w="0">
+            <a:noFill/>
+          </a:ln>
+        </p:spPr>
+        <p:txBody>
+          <a:bodyPr xmlns:a="http://schemas.openxmlformats.org/drawingml/2006/main" wrap="square" lIns="0" tIns="0" rIns="0" bIns="0" anchor="t">
+            <a:noAutofit/>
+          </a:bodyPr>
+          <a:lstStyle xmlns:a="http://schemas.openxmlformats.org/drawingml/2006/main"/>
+          <a:p xmlns:a="http://schemas.openxmlformats.org/drawingml/2006/main">
+            <a:pPr algn="r">
+              <a:defRPr sz="1275">
+                <a:solidFill>
+                  <a:srgbClr val="667084"/>
+                </a:solidFill>
+                <a:latin typeface="Arial"/>
+                <a:ea typeface="Arial"/>
+                <a:cs typeface="Arial"/>
+              </a:defRPr>
+            </a:pPr>
+            <a:r>
+              <a:rPr sz="1275">
+                <a:solidFill>
+                  <a:srgbClr val="667084"/>
+                </a:solidFill>
+                <a:latin typeface="Arial"/>
+                <a:ea typeface="Arial"/>
+                <a:cs typeface="Arial"/>
+              </a:rPr>
+              <a:t>30</a:t>
+            </a:r>
+          </a:p>
+        </p:txBody>
+      </p:sp>
+    </p:spTree>
+    <p:extLst>
+      <p:ext uri="{BB962C8B-B14F-4D97-AF65-F5344CB8AC3E}">
+        <p14:creationId xmlns:p14="http://schemas.microsoft.com/office/powerpoint/2010/main" val="1452197195"/>
+      </p:ext>
+    </p:extLst>
+  </p:cSld>
+</p:sld>
+</file>
+
+<file path=ppt/slides/slide31.xml><?xml version="1.0" encoding="utf-8"?>
+<p:sld xmlns:p="http://schemas.openxmlformats.org/presentationml/2006/main">
+  <p:cSld>
+    <p:bg>
+      <p:bgPr>
+        <a:solidFill xmlns:a="http://schemas.openxmlformats.org/drawingml/2006/main">
+          <a:srgbClr val="F6F4ED"/>
+        </a:solidFill>
+      </p:bgPr>
+    </p:bg>
+    <p:spTree>
+      <p:nvGrpSpPr>
+        <p:cNvPr id="1" name=""/>
+        <p:cNvGrpSpPr/>
+        <p:nvPr/>
+      </p:nvGrpSpPr>
+      <p:grpSpPr>
+        <a:xfrm xmlns:a="http://schemas.openxmlformats.org/drawingml/2006/main"/>
+      </p:grpSpPr>
+      <p:sp>
+        <p:nvSpPr>
+          <p:cNvPr id="5" name="">
+            <a:extLst xmlns:a="http://schemas.openxmlformats.org/drawingml/2006/main">
+              <a:ext uri="{FF2B5EF4-FFF2-40B4-BE49-F238E27FC236}">
+                <a16:creationId xmlns:a16="http://schemas.microsoft.com/office/drawing/2014/main" id="{82CB2349-799A-4C55-AEE6-A07FA7A5A36C}"/>
+              </a:ext>
+            </a:extLst>
+          </p:cNvPr>
+          <p:cNvSpPr>
+            <a:spLocks xmlns:a="http://schemas.openxmlformats.org/drawingml/2006/main" noGrp="1"/>
+          </p:cNvSpPr>
+          <p:nvPr/>
+        </p:nvSpPr>
+        <p:spPr>
+          <a:xfrm xmlns:a="http://schemas.openxmlformats.org/drawingml/2006/main">
+            <a:off x="762000" y="485775"/>
+            <a:ext cx="10668000" cy="586550"/>
+          </a:xfrm>
+          <a:prstGeom xmlns:a="http://schemas.openxmlformats.org/drawingml/2006/main" prst="rect">
+            <a:avLst/>
+          </a:prstGeom>
+          <a:noFill xmlns:a="http://schemas.openxmlformats.org/drawingml/2006/main"/>
+          <a:ln xmlns:a="http://schemas.openxmlformats.org/drawingml/2006/main" w="0">
+            <a:noFill/>
+          </a:ln>
+        </p:spPr>
+        <p:txBody>
+          <a:bodyPr xmlns:a="http://schemas.openxmlformats.org/drawingml/2006/main" wrap="square" lIns="0" tIns="0" rIns="0" bIns="0" anchor="t">
+            <a:noAutofit/>
+          </a:bodyPr>
+          <a:lstStyle xmlns:a="http://schemas.openxmlformats.org/drawingml/2006/main"/>
+          <a:p xmlns:a="http://schemas.openxmlformats.org/drawingml/2006/main">
+            <a:pPr>
+              <a:defRPr sz="3525" b="1">
+                <a:solidFill>
+                  <a:srgbClr val="243866"/>
+                </a:solidFill>
+                <a:latin typeface="Arial"/>
+                <a:ea typeface="Arial"/>
+                <a:cs typeface="Arial"/>
+              </a:defRPr>
+            </a:pPr>
+            <a:r>
+              <a:rPr sz="3525" b="1">
+                <a:solidFill>
+                  <a:srgbClr val="243866"/>
+                </a:solidFill>
+                <a:latin typeface="Arial"/>
+                <a:ea typeface="Arial"/>
+                <a:cs typeface="Arial"/>
+              </a:rPr>
+              <a:t>Case text: new urgent-routing misses</a:t>
+            </a:r>
+          </a:p>
+        </p:txBody>
+      </p:sp>
+      <p:graphicFrame>
+        <p:nvGraphicFramePr>
+          <p:cNvPr id="6" name=""/>
+          <p:cNvGraphicFramePr/>
+          <p:nvPr/>
+        </p:nvGraphicFramePr>
+        <p:xfrm>
+          <a:off xmlns:a="http://schemas.openxmlformats.org/drawingml/2006/main" x="762000" y="1619250"/>
+          <a:ext xmlns:a="http://schemas.openxmlformats.org/drawingml/2006/main" cx="10668000" cy="3011424"/>
+        </p:xfrm>
+        <a:graphic xmlns:a="http://schemas.openxmlformats.org/drawingml/2006/main">
+          <a:graphicData uri="http://schemas.openxmlformats.org/drawingml/2006/table">
+            <a:tbl>
+              <a:tblPr firstRow="1" bandRow="0"/>
+              <a:tblGrid>
+                <a:gridCol w="1066800"/>
+                <a:gridCol w="9601200"/>
+              </a:tblGrid>
+              <a:tr h="471678">
+                <a:tc>
+                  <a:txBody>
+                    <a:bodyPr/>
+                    <a:lstStyle/>
+                    <a:p>
+                      <a:r>
+                        <a:rPr sz="1800" b="1">
+                          <a:solidFill>
+                            <a:srgbClr val="FFFFFF"/>
+                          </a:solidFill>
+                          <a:latin typeface="Arial"/>
+                          <a:ea typeface="Arial"/>
+                          <a:cs typeface="Arial"/>
+                        </a:rPr>
+                        <a:t>Case</a:t>
+                      </a:r>
+                    </a:p>
+                  </a:txBody>
+                  <a:tcPr marL="133350" marR="133350" marT="76200" marB="76200" anchor="ctr">
+                    <a:solidFill>
+                      <a:srgbClr val="243866"/>
+                    </a:solidFill>
+                  </a:tcPr>
+                </a:tc>
+                <a:tc>
+                  <a:txBody>
+                    <a:bodyPr/>
+                    <a:lstStyle/>
+                    <a:p>
+                      <a:r>
+                        <a:rPr sz="1800" b="1">
+                          <a:solidFill>
+                            <a:srgbClr val="FFFFFF"/>
+                          </a:solidFill>
+                          <a:latin typeface="Arial"/>
+                          <a:ea typeface="Arial"/>
+                          <a:cs typeface="Arial"/>
+                        </a:rPr>
+                        <a:t>Exact patient message</a:t>
+                      </a:r>
+                    </a:p>
+                  </a:txBody>
+                  <a:tcPr marL="133350" marR="133350" marT="76200" marB="76200" anchor="ctr">
+                    <a:solidFill>
+                      <a:srgbClr val="243866"/>
+                    </a:solidFill>
+                  </a:tcPr>
+                </a:tc>
+              </a:tr>
+              <a:tr h="752856">
+                <a:tc>
+                  <a:txBody>
+                    <a:bodyPr/>
+                    <a:lstStyle/>
+                    <a:p>
+                      <a:r>
+                        <a:rPr sz="1800" b="0">
+                          <a:solidFill>
+                            <a:srgbClr val="28354A"/>
+                          </a:solidFill>
+                          <a:latin typeface="Arial"/>
+                          <a:ea typeface="Arial"/>
+                          <a:cs typeface="Arial"/>
+                        </a:rPr>
+                        <a:t>C04</a:t>
+                      </a:r>
+                    </a:p>
+                  </a:txBody>
+                  <a:tcPr marL="133350" marR="133350" marT="76200" marB="76200" anchor="ctr">
+                    <a:solidFill>
+                      <a:srgbClr val="F6F4ED"/>
+                    </a:solidFill>
+                  </a:tcPr>
+                </a:tc>
+                <a:tc>
+                  <a:txBody>
+                    <a:bodyPr/>
+                    <a:lstStyle/>
+                    <a:p>
+                      <a:r>
+                        <a:rPr sz="1800" b="0">
+                          <a:solidFill>
+                            <a:srgbClr val="28354A"/>
+                          </a:solidFill>
+                          <a:latin typeface="Arial"/>
+                          <a:ea typeface="Arial"/>
+                          <a:cs typeface="Arial"/>
+                        </a:rPr>
+                        <a:t>62F, I'm diabetic. I got a small cut on the bottom of my foot about 4 days ago and now the skin around it is red and a little swollen. No fever. It's tender when I press on it.</a:t>
+                      </a:r>
+                    </a:p>
+                  </a:txBody>
+                  <a:tcPr marL="133350" marR="133350" marT="76200" marB="76200" anchor="ctr">
+                    <a:solidFill>
+                      <a:srgbClr val="F6F4ED"/>
+                    </a:solidFill>
+                  </a:tcPr>
+                </a:tc>
+              </a:tr>
+              <a:tr h="752856">
+                <a:tc>
+                  <a:txBody>
+                    <a:bodyPr/>
+                    <a:lstStyle/>
+                    <a:p>
+                      <a:r>
+                        <a:rPr sz="1800" b="0">
+                          <a:solidFill>
+                            <a:srgbClr val="28354A"/>
+                          </a:solidFill>
+                          <a:latin typeface="Arial"/>
+                          <a:ea typeface="Arial"/>
+                          <a:cs typeface="Arial"/>
+                        </a:rPr>
+                        <a:t>C43</a:t>
+                      </a:r>
+                    </a:p>
+                  </a:txBody>
+                  <a:tcPr marL="133350" marR="133350" marT="76200" marB="76200" anchor="ctr">
+                    <a:solidFill>
+                      <a:srgbClr val="F6F4ED"/>
+                    </a:solidFill>
+                  </a:tcPr>
+                </a:tc>
+                <a:tc>
+                  <a:txBody>
+                    <a:bodyPr/>
+                    <a:lstStyle/>
+                    <a:p>
+                      <a:r>
+                        <a:rPr sz="1800" b="0">
+                          <a:solidFill>
+                            <a:srgbClr val="28354A"/>
+                          </a:solidFill>
+                          <a:latin typeface="Arial"/>
+                          <a:ea typeface="Arial"/>
+                          <a:cs typeface="Arial"/>
+                        </a:rPr>
+                        <a:t>34M. I've had a cough for about three weeks now with night sweats and I've lost maybe 10 pounds without trying. I moved here from a country where TB is common.</a:t>
+                      </a:r>
+                    </a:p>
+                  </a:txBody>
+                  <a:tcPr marL="133350" marR="133350" marT="76200" marB="76200" anchor="ctr">
+                    <a:solidFill>
+                      <a:srgbClr val="F6F4ED"/>
+                    </a:solidFill>
+                  </a:tcPr>
+                </a:tc>
+              </a:tr>
+              <a:tr h="1034034">
+                <a:tc>
+                  <a:txBody>
+                    <a:bodyPr/>
+                    <a:lstStyle/>
+                    <a:p>
+                      <a:r>
+                        <a:rPr sz="1800" b="0">
+                          <a:solidFill>
+                            <a:srgbClr val="28354A"/>
+                          </a:solidFill>
+                          <a:latin typeface="Arial"/>
+                          <a:ea typeface="Arial"/>
+                          <a:cs typeface="Arial"/>
+                        </a:rPr>
+                        <a:t>C49</a:t>
+                      </a:r>
+                    </a:p>
+                  </a:txBody>
+                  <a:tcPr marL="133350" marR="133350" marT="76200" marB="76200" anchor="ctr">
+                    <a:solidFill>
+                      <a:srgbClr val="F6F4ED"/>
+                    </a:solidFill>
+                  </a:tcPr>
+                </a:tc>
+                <a:tc>
+                  <a:txBody>
+                    <a:bodyPr/>
+                    <a:lstStyle/>
+                    <a:p>
+                      <a:r>
+                        <a:rPr sz="1800" b="0">
+                          <a:solidFill>
+                            <a:srgbClr val="28354A"/>
+                          </a:solidFill>
+                          <a:latin typeface="Arial"/>
+                          <a:ea typeface="Arial"/>
+                          <a:cs typeface="Arial"/>
+                        </a:rPr>
+                        <a:t>28M. Sharp pain on the left side of my chest since yesterday, worse when I take a deep breath. I did a heavy chest workout two days ago. No shortness of breath, no leg swelling, I don't smoke.</a:t>
+                      </a:r>
+                    </a:p>
+                  </a:txBody>
+                  <a:tcPr marL="133350" marR="133350" marT="76200" marB="76200" anchor="ctr">
+                    <a:solidFill>
+                      <a:srgbClr val="F6F4ED"/>
+                    </a:solidFill>
+                  </a:tcPr>
+                </a:tc>
+              </a:tr>
+            </a:tbl>
+          </a:graphicData>
+        </a:graphic>
+      </p:graphicFrame>
+      <p:sp>
+        <p:nvSpPr>
+          <p:cNvPr id="3" name="">
+            <a:extLst xmlns:a="http://schemas.openxmlformats.org/drawingml/2006/main">
+              <a:ext uri="{FF2B5EF4-FFF2-40B4-BE49-F238E27FC236}">
+                <a16:creationId xmlns:a16="http://schemas.microsoft.com/office/drawing/2014/main" id="{B2620C7B-BC83-4F3D-A2BE-4E58878130B5}"/>
+              </a:ext>
+            </a:extLst>
+          </p:cNvPr>
+          <p:cNvSpPr>
+            <a:spLocks xmlns:a="http://schemas.openxmlformats.org/drawingml/2006/main" noGrp="1"/>
+          </p:cNvSpPr>
+          <p:nvPr/>
+        </p:nvSpPr>
+        <p:spPr>
+          <a:xfrm xmlns:a="http://schemas.openxmlformats.org/drawingml/2006/main">
+            <a:off x="762000" y="5886450"/>
+            <a:ext cx="10096500" cy="514350"/>
+          </a:xfrm>
+          <a:prstGeom xmlns:a="http://schemas.openxmlformats.org/drawingml/2006/main" prst="rect">
+            <a:avLst/>
+          </a:prstGeom>
+          <a:noFill xmlns:a="http://schemas.openxmlformats.org/drawingml/2006/main"/>
+          <a:ln xmlns:a="http://schemas.openxmlformats.org/drawingml/2006/main" w="0">
+            <a:noFill/>
+          </a:ln>
+        </p:spPr>
+        <p:txBody>
+          <a:bodyPr xmlns:a="http://schemas.openxmlformats.org/drawingml/2006/main" wrap="square" lIns="0" tIns="0" rIns="0" bIns="0" anchor="t">
+            <a:noAutofit/>
+          </a:bodyPr>
+          <a:lstStyle xmlns:a="http://schemas.openxmlformats.org/drawingml/2006/main"/>
+          <a:p xmlns:a="http://schemas.openxmlformats.org/drawingml/2006/main">
+            <a:pPr>
+              <a:defRPr sz="1350">
+                <a:solidFill>
+                  <a:srgbClr val="667084"/>
+                </a:solidFill>
+                <a:latin typeface="Arial"/>
+                <a:ea typeface="Arial"/>
+                <a:cs typeface="Arial"/>
+              </a:defRPr>
+            </a:pPr>
+            <a:r>
+              <a:rPr sz="1350">
+                <a:solidFill>
+                  <a:srgbClr val="667084"/>
+                </a:solidFill>
+                <a:latin typeface="Arial"/>
+                <a:ea typeface="Arial"/>
+                <a:cs typeface="Arial"/>
+              </a:rPr>
+              <a:t>The new prompt assigns ASYNC_PHYSICIAN to all three. Frozen baseline and unchanged physician reference assign URGENT_ESCALATION.</a:t>
+            </a:r>
+          </a:p>
+        </p:txBody>
+      </p:sp>
+      <p:sp>
+        <p:nvSpPr>
+          <p:cNvPr id="4" name="">
+            <a:extLst xmlns:a="http://schemas.openxmlformats.org/drawingml/2006/main">
+              <a:ext uri="{FF2B5EF4-FFF2-40B4-BE49-F238E27FC236}">
+                <a16:creationId xmlns:a16="http://schemas.microsoft.com/office/drawing/2014/main" id="{C6F97261-6BAF-4486-A0B8-B5B28CDC45AB}"/>
+              </a:ext>
+            </a:extLst>
+          </p:cNvPr>
+          <p:cNvSpPr>
+            <a:spLocks xmlns:a="http://schemas.openxmlformats.org/drawingml/2006/main" noGrp="1"/>
+          </p:cNvSpPr>
+          <p:nvPr/>
+        </p:nvSpPr>
+        <p:spPr>
+          <a:xfrm xmlns:a="http://schemas.openxmlformats.org/drawingml/2006/main">
+            <a:off x="11296650" y="6400800"/>
+            <a:ext cx="361950" cy="228600"/>
+          </a:xfrm>
+          <a:prstGeom xmlns:a="http://schemas.openxmlformats.org/drawingml/2006/main" prst="rect">
+            <a:avLst/>
+          </a:prstGeom>
+          <a:noFill xmlns:a="http://schemas.openxmlformats.org/drawingml/2006/main"/>
+          <a:ln xmlns:a="http://schemas.openxmlformats.org/drawingml/2006/main" w="0">
+            <a:noFill/>
+          </a:ln>
+        </p:spPr>
+        <p:txBody>
+          <a:bodyPr xmlns:a="http://schemas.openxmlformats.org/drawingml/2006/main" wrap="square" lIns="0" tIns="0" rIns="0" bIns="0" anchor="t">
+            <a:noAutofit/>
+          </a:bodyPr>
+          <a:lstStyle xmlns:a="http://schemas.openxmlformats.org/drawingml/2006/main"/>
+          <a:p xmlns:a="http://schemas.openxmlformats.org/drawingml/2006/main">
+            <a:pPr algn="r">
+              <a:defRPr sz="1275">
+                <a:solidFill>
+                  <a:srgbClr val="667084"/>
+                </a:solidFill>
+                <a:latin typeface="Arial"/>
+                <a:ea typeface="Arial"/>
+                <a:cs typeface="Arial"/>
+              </a:defRPr>
+            </a:pPr>
+            <a:r>
+              <a:rPr sz="1275">
+                <a:solidFill>
+                  <a:srgbClr val="667084"/>
+                </a:solidFill>
+                <a:latin typeface="Arial"/>
+                <a:ea typeface="Arial"/>
+                <a:cs typeface="Arial"/>
+              </a:rPr>
+              <a:t>31</a:t>
+            </a:r>
+          </a:p>
+        </p:txBody>
+      </p:sp>
+    </p:spTree>
+    <p:extLst>
+      <p:ext uri="{BB962C8B-B14F-4D97-AF65-F5344CB8AC3E}">
+        <p14:creationId xmlns:p14="http://schemas.microsoft.com/office/powerpoint/2010/main" val="1391466645"/>
       </p:ext>
     </p:extLst>
   </p:cSld>
@@ -15811,7 +18087,7 @@
           <p:cNvPr id="7" name="">
             <a:extLst xmlns:a="http://schemas.openxmlformats.org/drawingml/2006/main">
               <a:ext uri="{FF2B5EF4-FFF2-40B4-BE49-F238E27FC236}">
-                <a16:creationId xmlns:a16="http://schemas.microsoft.com/office/drawing/2014/main" id="{8A93A1EE-90A5-4104-81F0-2F5DB45FD583}"/>
+                <a16:creationId xmlns:a16="http://schemas.microsoft.com/office/drawing/2014/main" id="{55A09439-ADB4-4D0D-9722-A107596696B4}"/>
               </a:ext>
             </a:extLst>
           </p:cNvPr>
@@ -15872,7 +18148,7 @@
           <p:nvPr/>
         </p:nvPicPr>
         <p:blipFill>
-          <a:blip xmlns:r="http://schemas.openxmlformats.org/officeDocument/2006/relationships" xmlns:a="http://schemas.openxmlformats.org/drawingml/2006/main" r:embed="R7a9705c66d3641e5"/>
+          <a:blip xmlns:r="http://schemas.openxmlformats.org/officeDocument/2006/relationships" xmlns:a="http://schemas.openxmlformats.org/drawingml/2006/main" r:embed="Rb6957c25684e4695"/>
           <a:stretch xmlns:a="http://schemas.openxmlformats.org/drawingml/2006/main"/>
         </p:blipFill>
         <p:spPr>
@@ -15890,7 +18166,7 @@
           <p:cNvPr id="3" name="">
             <a:extLst xmlns:a="http://schemas.openxmlformats.org/drawingml/2006/main">
               <a:ext uri="{FF2B5EF4-FFF2-40B4-BE49-F238E27FC236}">
-                <a16:creationId xmlns:a16="http://schemas.microsoft.com/office/drawing/2014/main" id="{BC2B5A7E-FF39-4A20-A139-31E2BC5571A1}"/>
+                <a16:creationId xmlns:a16="http://schemas.microsoft.com/office/drawing/2014/main" id="{A2F48E6A-22DE-4097-9451-1980029FD95D}"/>
               </a:ext>
             </a:extLst>
           </p:cNvPr>
@@ -15947,7 +18223,7 @@
           <p:cNvPr id="4" name="">
             <a:extLst xmlns:a="http://schemas.openxmlformats.org/drawingml/2006/main">
               <a:ext uri="{FF2B5EF4-FFF2-40B4-BE49-F238E27FC236}">
-                <a16:creationId xmlns:a16="http://schemas.microsoft.com/office/drawing/2014/main" id="{D4BC6971-7EC5-423C-82E1-E17803269D60}"/>
+                <a16:creationId xmlns:a16="http://schemas.microsoft.com/office/drawing/2014/main" id="{72BB7D1A-7876-4B7B-AE8D-E7E06C5A686C}"/>
               </a:ext>
             </a:extLst>
           </p:cNvPr>
@@ -16004,7 +18280,7 @@
           <p:cNvPr id="5" name="">
             <a:extLst xmlns:a="http://schemas.openxmlformats.org/drawingml/2006/main">
               <a:ext uri="{FF2B5EF4-FFF2-40B4-BE49-F238E27FC236}">
-                <a16:creationId xmlns:a16="http://schemas.microsoft.com/office/drawing/2014/main" id="{745C448C-3445-46C2-BC3F-1875FE4620E8}"/>
+                <a16:creationId xmlns:a16="http://schemas.microsoft.com/office/drawing/2014/main" id="{C5DF6373-AC07-422E-B561-BB724AE4F1E1}"/>
               </a:ext>
             </a:extLst>
           </p:cNvPr>
@@ -16061,7 +18337,7 @@
           <p:cNvPr id="6" name="">
             <a:extLst xmlns:a="http://schemas.openxmlformats.org/drawingml/2006/main">
               <a:ext uri="{FF2B5EF4-FFF2-40B4-BE49-F238E27FC236}">
-                <a16:creationId xmlns:a16="http://schemas.microsoft.com/office/drawing/2014/main" id="{B2BC0C4B-40D7-4FED-A682-9D6784AC6857}"/>
+                <a16:creationId xmlns:a16="http://schemas.microsoft.com/office/drawing/2014/main" id="{39E97F15-CD12-48A2-BD30-60059C147368}"/>
               </a:ext>
             </a:extLst>
           </p:cNvPr>
@@ -16116,7 +18392,7 @@
     </p:spTree>
     <p:extLst>
       <p:ext uri="{BB962C8B-B14F-4D97-AF65-F5344CB8AC3E}">
-        <p14:creationId xmlns:p14="http://schemas.microsoft.com/office/powerpoint/2010/main" val="1865803515"/>
+        <p14:creationId xmlns:p14="http://schemas.microsoft.com/office/powerpoint/2010/main" val="1014604273"/>
       </p:ext>
     </p:extLst>
   </p:cSld>
@@ -16147,7 +18423,7 @@
           <p:cNvPr id="5" name="">
             <a:extLst xmlns:a="http://schemas.openxmlformats.org/drawingml/2006/main">
               <a:ext uri="{FF2B5EF4-FFF2-40B4-BE49-F238E27FC236}">
-                <a16:creationId xmlns:a16="http://schemas.microsoft.com/office/drawing/2014/main" id="{B3E235E6-D1D7-4CE8-8A49-316DD0CF7073}"/>
+                <a16:creationId xmlns:a16="http://schemas.microsoft.com/office/drawing/2014/main" id="{06DD2180-651B-4353-88E3-20265A4837D2}"/>
               </a:ext>
             </a:extLst>
           </p:cNvPr>
@@ -16476,7 +18752,7 @@
           <p:cNvPr id="3" name="">
             <a:extLst xmlns:a="http://schemas.openxmlformats.org/drawingml/2006/main">
               <a:ext uri="{FF2B5EF4-FFF2-40B4-BE49-F238E27FC236}">
-                <a16:creationId xmlns:a16="http://schemas.microsoft.com/office/drawing/2014/main" id="{91DDB88E-7200-45CA-85AF-085FAFAEFCAC}"/>
+                <a16:creationId xmlns:a16="http://schemas.microsoft.com/office/drawing/2014/main" id="{496F08C5-8791-4D1C-A2EF-C36353984622}"/>
               </a:ext>
             </a:extLst>
           </p:cNvPr>
@@ -16533,7 +18809,7 @@
           <p:cNvPr id="4" name="">
             <a:extLst xmlns:a="http://schemas.openxmlformats.org/drawingml/2006/main">
               <a:ext uri="{FF2B5EF4-FFF2-40B4-BE49-F238E27FC236}">
-                <a16:creationId xmlns:a16="http://schemas.microsoft.com/office/drawing/2014/main" id="{9918C403-7107-4FB4-81E8-6C36F53285BD}"/>
+                <a16:creationId xmlns:a16="http://schemas.microsoft.com/office/drawing/2014/main" id="{F1B638A8-FE3C-4EB0-920F-0D1459B6EA4C}"/>
               </a:ext>
             </a:extLst>
           </p:cNvPr>
@@ -16588,7 +18864,7 @@
     </p:spTree>
     <p:extLst>
       <p:ext uri="{BB962C8B-B14F-4D97-AF65-F5344CB8AC3E}">
-        <p14:creationId xmlns:p14="http://schemas.microsoft.com/office/powerpoint/2010/main" val="902431955"/>
+        <p14:creationId xmlns:p14="http://schemas.microsoft.com/office/powerpoint/2010/main" val="2056065562"/>
       </p:ext>
     </p:extLst>
   </p:cSld>
@@ -16619,7 +18895,7 @@
           <p:cNvPr id="7" name="">
             <a:extLst xmlns:a="http://schemas.openxmlformats.org/drawingml/2006/main">
               <a:ext uri="{FF2B5EF4-FFF2-40B4-BE49-F238E27FC236}">
-                <a16:creationId xmlns:a16="http://schemas.microsoft.com/office/drawing/2014/main" id="{5DDB404B-3C0A-4BAE-A5F9-C14165BEF45A}"/>
+                <a16:creationId xmlns:a16="http://schemas.microsoft.com/office/drawing/2014/main" id="{A6AD5BF8-1899-494B-8F05-35F05831220A}"/>
               </a:ext>
             </a:extLst>
           </p:cNvPr>
@@ -16898,7 +19174,7 @@
           <p:cNvPr id="3" name="">
             <a:extLst xmlns:a="http://schemas.openxmlformats.org/drawingml/2006/main">
               <a:ext uri="{FF2B5EF4-FFF2-40B4-BE49-F238E27FC236}">
-                <a16:creationId xmlns:a16="http://schemas.microsoft.com/office/drawing/2014/main" id="{86533E6D-FDE0-42FA-A169-23BE65EF2F85}"/>
+                <a16:creationId xmlns:a16="http://schemas.microsoft.com/office/drawing/2014/main" id="{722C9D5B-7592-4D3B-BEFF-197305BFCBA2}"/>
               </a:ext>
             </a:extLst>
           </p:cNvPr>
@@ -16955,7 +19231,7 @@
           <p:cNvPr id="4" name="">
             <a:extLst xmlns:a="http://schemas.openxmlformats.org/drawingml/2006/main">
               <a:ext uri="{FF2B5EF4-FFF2-40B4-BE49-F238E27FC236}">
-                <a16:creationId xmlns:a16="http://schemas.microsoft.com/office/drawing/2014/main" id="{E7B33E69-10A7-4A75-B1F7-92EC1E4C3596}"/>
+                <a16:creationId xmlns:a16="http://schemas.microsoft.com/office/drawing/2014/main" id="{62EC42B3-E43A-4397-B38B-EE2CFB0CB938}"/>
               </a:ext>
             </a:extLst>
           </p:cNvPr>
@@ -17012,7 +19288,7 @@
           <p:cNvPr id="5" name="">
             <a:extLst xmlns:a="http://schemas.openxmlformats.org/drawingml/2006/main">
               <a:ext uri="{FF2B5EF4-FFF2-40B4-BE49-F238E27FC236}">
-                <a16:creationId xmlns:a16="http://schemas.microsoft.com/office/drawing/2014/main" id="{8AE77AAE-84D9-4125-B37D-D207A0AAA9EC}"/>
+                <a16:creationId xmlns:a16="http://schemas.microsoft.com/office/drawing/2014/main" id="{1B5FE35A-1E3D-4D0B-AE16-41FF7ADD2450}"/>
               </a:ext>
             </a:extLst>
           </p:cNvPr>
@@ -17069,7 +19345,7 @@
           <p:cNvPr id="6" name="">
             <a:extLst xmlns:a="http://schemas.openxmlformats.org/drawingml/2006/main">
               <a:ext uri="{FF2B5EF4-FFF2-40B4-BE49-F238E27FC236}">
-                <a16:creationId xmlns:a16="http://schemas.microsoft.com/office/drawing/2014/main" id="{B78B0A2E-5DA6-446B-8E7F-26BF977E8D4E}"/>
+                <a16:creationId xmlns:a16="http://schemas.microsoft.com/office/drawing/2014/main" id="{2FAAC6EC-10D9-457D-B73F-DC57CA38BC7C}"/>
               </a:ext>
             </a:extLst>
           </p:cNvPr>
@@ -17124,7 +19400,7 @@
     </p:spTree>
     <p:extLst>
       <p:ext uri="{BB962C8B-B14F-4D97-AF65-F5344CB8AC3E}">
-        <p14:creationId xmlns:p14="http://schemas.microsoft.com/office/powerpoint/2010/main" val="1869934954"/>
+        <p14:creationId xmlns:p14="http://schemas.microsoft.com/office/powerpoint/2010/main" val="1228187678"/>
       </p:ext>
     </p:extLst>
   </p:cSld>
@@ -17155,7 +19431,7 @@
           <p:cNvPr id="9" name="">
             <a:extLst xmlns:a="http://schemas.openxmlformats.org/drawingml/2006/main">
               <a:ext uri="{FF2B5EF4-FFF2-40B4-BE49-F238E27FC236}">
-                <a16:creationId xmlns:a16="http://schemas.microsoft.com/office/drawing/2014/main" id="{6B51E344-0A71-4028-B5A4-297FFA717284}"/>
+                <a16:creationId xmlns:a16="http://schemas.microsoft.com/office/drawing/2014/main" id="{6038C41A-C883-492D-9D86-A81D92468DD5}"/>
               </a:ext>
             </a:extLst>
           </p:cNvPr>
@@ -17212,7 +19488,7 @@
           <p:cNvPr id="2" name="">
             <a:extLst xmlns:a="http://schemas.openxmlformats.org/drawingml/2006/main">
               <a:ext uri="{FF2B5EF4-FFF2-40B4-BE49-F238E27FC236}">
-                <a16:creationId xmlns:a16="http://schemas.microsoft.com/office/drawing/2014/main" id="{6121D79C-237D-4EEC-89E8-6D82219EA171}"/>
+                <a16:creationId xmlns:a16="http://schemas.microsoft.com/office/drawing/2014/main" id="{597193A7-0BE4-4B22-AE72-116563CF446A}"/>
               </a:ext>
             </a:extLst>
           </p:cNvPr>
@@ -17269,7 +19545,7 @@
           <p:cNvPr id="3" name="">
             <a:extLst xmlns:a="http://schemas.openxmlformats.org/drawingml/2006/main">
               <a:ext uri="{FF2B5EF4-FFF2-40B4-BE49-F238E27FC236}">
-                <a16:creationId xmlns:a16="http://schemas.microsoft.com/office/drawing/2014/main" id="{076E50C2-8DD2-49D6-AD6D-C46CF9ABDF51}"/>
+                <a16:creationId xmlns:a16="http://schemas.microsoft.com/office/drawing/2014/main" id="{D610E7BF-2848-48CA-BA4C-F3F3CEB427F9}"/>
               </a:ext>
             </a:extLst>
           </p:cNvPr>
@@ -17326,7 +19602,7 @@
           <p:cNvPr id="4" name="">
             <a:extLst xmlns:a="http://schemas.openxmlformats.org/drawingml/2006/main">
               <a:ext uri="{FF2B5EF4-FFF2-40B4-BE49-F238E27FC236}">
-                <a16:creationId xmlns:a16="http://schemas.microsoft.com/office/drawing/2014/main" id="{0A486E39-E5C4-498B-88F8-DE5C15138E72}"/>
+                <a16:creationId xmlns:a16="http://schemas.microsoft.com/office/drawing/2014/main" id="{6434A3BC-00DB-4517-889C-BD3C550D1DB5}"/>
               </a:ext>
             </a:extLst>
           </p:cNvPr>
@@ -17383,7 +19659,7 @@
           <p:cNvPr id="5" name="">
             <a:extLst xmlns:a="http://schemas.openxmlformats.org/drawingml/2006/main">
               <a:ext uri="{FF2B5EF4-FFF2-40B4-BE49-F238E27FC236}">
-                <a16:creationId xmlns:a16="http://schemas.microsoft.com/office/drawing/2014/main" id="{E66F0527-E889-432B-A898-874DDD0BA788}"/>
+                <a16:creationId xmlns:a16="http://schemas.microsoft.com/office/drawing/2014/main" id="{16D43A30-D7B3-4B81-B3BC-D2983E8BFDA1}"/>
               </a:ext>
             </a:extLst>
           </p:cNvPr>
@@ -17440,7 +19716,7 @@
           <p:cNvPr id="6" name="">
             <a:extLst xmlns:a="http://schemas.openxmlformats.org/drawingml/2006/main">
               <a:ext uri="{FF2B5EF4-FFF2-40B4-BE49-F238E27FC236}">
-                <a16:creationId xmlns:a16="http://schemas.microsoft.com/office/drawing/2014/main" id="{8F5DF719-7870-4DEA-98C6-EB8BF58CF6CE}"/>
+                <a16:creationId xmlns:a16="http://schemas.microsoft.com/office/drawing/2014/main" id="{58F9B781-883A-4DC9-AB24-1320272F2DC2}"/>
               </a:ext>
             </a:extLst>
           </p:cNvPr>
@@ -17497,7 +19773,7 @@
           <p:cNvPr id="7" name="">
             <a:extLst xmlns:a="http://schemas.openxmlformats.org/drawingml/2006/main">
               <a:ext uri="{FF2B5EF4-FFF2-40B4-BE49-F238E27FC236}">
-                <a16:creationId xmlns:a16="http://schemas.microsoft.com/office/drawing/2014/main" id="{561A7972-9B50-4854-B401-A584F8E1E2D2}"/>
+                <a16:creationId xmlns:a16="http://schemas.microsoft.com/office/drawing/2014/main" id="{9022BA3A-4DE6-4A8D-BB3F-FB8408F7F530}"/>
               </a:ext>
             </a:extLst>
           </p:cNvPr>
@@ -17554,7 +19830,7 @@
           <p:cNvPr id="8" name="">
             <a:extLst xmlns:a="http://schemas.openxmlformats.org/drawingml/2006/main">
               <a:ext uri="{FF2B5EF4-FFF2-40B4-BE49-F238E27FC236}">
-                <a16:creationId xmlns:a16="http://schemas.microsoft.com/office/drawing/2014/main" id="{40A85468-9C38-4860-8A0B-29A88F1537F1}"/>
+                <a16:creationId xmlns:a16="http://schemas.microsoft.com/office/drawing/2014/main" id="{87105B3F-2888-4742-89AB-2B449EB4EE37}"/>
               </a:ext>
             </a:extLst>
           </p:cNvPr>
@@ -17609,7 +19885,7 @@
     </p:spTree>
     <p:extLst>
       <p:ext uri="{BB962C8B-B14F-4D97-AF65-F5344CB8AC3E}">
-        <p14:creationId xmlns:p14="http://schemas.microsoft.com/office/powerpoint/2010/main" val="442545537"/>
+        <p14:creationId xmlns:p14="http://schemas.microsoft.com/office/powerpoint/2010/main" val="215353726"/>
       </p:ext>
     </p:extLst>
   </p:cSld>
@@ -17640,7 +19916,7 @@
           <p:cNvPr id="15" name="">
             <a:extLst xmlns:a="http://schemas.openxmlformats.org/drawingml/2006/main">
               <a:ext uri="{FF2B5EF4-FFF2-40B4-BE49-F238E27FC236}">
-                <a16:creationId xmlns:a16="http://schemas.microsoft.com/office/drawing/2014/main" id="{1794FA62-B5C5-47C3-95E7-F2F512886ADC}"/>
+                <a16:creationId xmlns:a16="http://schemas.microsoft.com/office/drawing/2014/main" id="{2C6C4EEA-CFEB-45C4-A74A-555675604643}"/>
               </a:ext>
             </a:extLst>
           </p:cNvPr>
@@ -17697,7 +19973,7 @@
           <p:cNvPr id="2" name="">
             <a:extLst xmlns:a="http://schemas.openxmlformats.org/drawingml/2006/main">
               <a:ext uri="{FF2B5EF4-FFF2-40B4-BE49-F238E27FC236}">
-                <a16:creationId xmlns:a16="http://schemas.microsoft.com/office/drawing/2014/main" id="{4A883E48-EB6E-4E11-AC1B-569E0AD2471B}"/>
+                <a16:creationId xmlns:a16="http://schemas.microsoft.com/office/drawing/2014/main" id="{D49F6FFB-A150-4CBC-874D-49907B2D2A78}"/>
               </a:ext>
             </a:extLst>
           </p:cNvPr>
@@ -17754,7 +20030,7 @@
           <p:cNvPr id="3" name="">
             <a:extLst xmlns:a="http://schemas.openxmlformats.org/drawingml/2006/main">
               <a:ext uri="{FF2B5EF4-FFF2-40B4-BE49-F238E27FC236}">
-                <a16:creationId xmlns:a16="http://schemas.microsoft.com/office/drawing/2014/main" id="{78256DD7-5D86-4310-BB12-598CFFDC1EAB}"/>
+                <a16:creationId xmlns:a16="http://schemas.microsoft.com/office/drawing/2014/main" id="{9E8F55FE-53CE-484E-971B-7A795627206E}"/>
               </a:ext>
             </a:extLst>
           </p:cNvPr>
@@ -17811,7 +20087,7 @@
           <p:cNvPr id="4" name="">
             <a:extLst xmlns:a="http://schemas.openxmlformats.org/drawingml/2006/main">
               <a:ext uri="{FF2B5EF4-FFF2-40B4-BE49-F238E27FC236}">
-                <a16:creationId xmlns:a16="http://schemas.microsoft.com/office/drawing/2014/main" id="{E24D56D1-81C3-4CB6-9982-226878F44C3C}"/>
+                <a16:creationId xmlns:a16="http://schemas.microsoft.com/office/drawing/2014/main" id="{A384828C-E6AA-4F14-BB4F-1F8514D107D0}"/>
               </a:ext>
             </a:extLst>
           </p:cNvPr>
@@ -17868,7 +20144,7 @@
           <p:cNvPr id="5" name="">
             <a:extLst xmlns:a="http://schemas.openxmlformats.org/drawingml/2006/main">
               <a:ext uri="{FF2B5EF4-FFF2-40B4-BE49-F238E27FC236}">
-                <a16:creationId xmlns:a16="http://schemas.microsoft.com/office/drawing/2014/main" id="{5AD84A1A-D134-4A43-9A96-B1B419437646}"/>
+                <a16:creationId xmlns:a16="http://schemas.microsoft.com/office/drawing/2014/main" id="{D02A4861-6C9A-42E6-8F74-F461AFA54C93}"/>
               </a:ext>
             </a:extLst>
           </p:cNvPr>
@@ -17925,7 +20201,7 @@
           <p:cNvPr id="6" name="">
             <a:extLst xmlns:a="http://schemas.openxmlformats.org/drawingml/2006/main">
               <a:ext uri="{FF2B5EF4-FFF2-40B4-BE49-F238E27FC236}">
-                <a16:creationId xmlns:a16="http://schemas.microsoft.com/office/drawing/2014/main" id="{8FAA3287-EC41-40DF-AFEC-3FC292490F9F}"/>
+                <a16:creationId xmlns:a16="http://schemas.microsoft.com/office/drawing/2014/main" id="{AF92DD21-C041-45D0-A545-126A9D450172}"/>
               </a:ext>
             </a:extLst>
           </p:cNvPr>
@@ -17982,7 +20258,7 @@
           <p:cNvPr id="7" name="">
             <a:extLst xmlns:a="http://schemas.openxmlformats.org/drawingml/2006/main">
               <a:ext uri="{FF2B5EF4-FFF2-40B4-BE49-F238E27FC236}">
-                <a16:creationId xmlns:a16="http://schemas.microsoft.com/office/drawing/2014/main" id="{7A0D7D42-807A-45FD-ADA1-14AF0C319823}"/>
+                <a16:creationId xmlns:a16="http://schemas.microsoft.com/office/drawing/2014/main" id="{908653EC-F317-40B1-83CD-28A89B461E13}"/>
               </a:ext>
             </a:extLst>
           </p:cNvPr>
@@ -18039,7 +20315,7 @@
           <p:cNvPr id="8" name="">
             <a:extLst xmlns:a="http://schemas.openxmlformats.org/drawingml/2006/main">
               <a:ext uri="{FF2B5EF4-FFF2-40B4-BE49-F238E27FC236}">
-                <a16:creationId xmlns:a16="http://schemas.microsoft.com/office/drawing/2014/main" id="{A717FA71-9C7E-4CF4-9253-315EA8D56469}"/>
+                <a16:creationId xmlns:a16="http://schemas.microsoft.com/office/drawing/2014/main" id="{0214948B-9882-4603-BB3C-A05EC3F619E9}"/>
               </a:ext>
             </a:extLst>
           </p:cNvPr>
@@ -18096,7 +20372,7 @@
           <p:cNvPr id="9" name="">
             <a:extLst xmlns:a="http://schemas.openxmlformats.org/drawingml/2006/main">
               <a:ext uri="{FF2B5EF4-FFF2-40B4-BE49-F238E27FC236}">
-                <a16:creationId xmlns:a16="http://schemas.microsoft.com/office/drawing/2014/main" id="{C508CBF5-41B8-41D9-B4BD-654B3BD04FF6}"/>
+                <a16:creationId xmlns:a16="http://schemas.microsoft.com/office/drawing/2014/main" id="{4406A7AA-E94E-4E7C-835F-BAE3B45C55AB}"/>
               </a:ext>
             </a:extLst>
           </p:cNvPr>
@@ -18153,7 +20429,7 @@
           <p:cNvPr id="10" name="">
             <a:extLst xmlns:a="http://schemas.openxmlformats.org/drawingml/2006/main">
               <a:ext uri="{FF2B5EF4-FFF2-40B4-BE49-F238E27FC236}">
-                <a16:creationId xmlns:a16="http://schemas.microsoft.com/office/drawing/2014/main" id="{A1CF2031-AB36-4B2B-9662-DB6964515E60}"/>
+                <a16:creationId xmlns:a16="http://schemas.microsoft.com/office/drawing/2014/main" id="{7F83E4E9-C6FB-444D-8012-1F6225E85219}"/>
               </a:ext>
             </a:extLst>
           </p:cNvPr>
@@ -18210,7 +20486,7 @@
           <p:cNvPr id="11" name="">
             <a:extLst xmlns:a="http://schemas.openxmlformats.org/drawingml/2006/main">
               <a:ext uri="{FF2B5EF4-FFF2-40B4-BE49-F238E27FC236}">
-                <a16:creationId xmlns:a16="http://schemas.microsoft.com/office/drawing/2014/main" id="{00CF203B-F6C8-457B-9517-B3D622000E92}"/>
+                <a16:creationId xmlns:a16="http://schemas.microsoft.com/office/drawing/2014/main" id="{F95FD072-B461-4476-AE52-BCF8D459B82A}"/>
               </a:ext>
             </a:extLst>
           </p:cNvPr>
@@ -18267,7 +20543,7 @@
           <p:cNvPr id="12" name="">
             <a:extLst xmlns:a="http://schemas.openxmlformats.org/drawingml/2006/main">
               <a:ext uri="{FF2B5EF4-FFF2-40B4-BE49-F238E27FC236}">
-                <a16:creationId xmlns:a16="http://schemas.microsoft.com/office/drawing/2014/main" id="{65DEF4BC-1229-4D2B-89BD-1521EF779114}"/>
+                <a16:creationId xmlns:a16="http://schemas.microsoft.com/office/drawing/2014/main" id="{7F106BE8-4AE9-4E17-B17C-ED756DB5982B}"/>
               </a:ext>
             </a:extLst>
           </p:cNvPr>
@@ -18324,7 +20600,7 @@
           <p:cNvPr id="13" name="">
             <a:extLst xmlns:a="http://schemas.openxmlformats.org/drawingml/2006/main">
               <a:ext uri="{FF2B5EF4-FFF2-40B4-BE49-F238E27FC236}">
-                <a16:creationId xmlns:a16="http://schemas.microsoft.com/office/drawing/2014/main" id="{EEDABD6A-7566-4176-9A50-BD1F6B6013DA}"/>
+                <a16:creationId xmlns:a16="http://schemas.microsoft.com/office/drawing/2014/main" id="{7A4D1A11-C1C3-4223-B345-6AA5F09A440D}"/>
               </a:ext>
             </a:extLst>
           </p:cNvPr>
@@ -18381,7 +20657,7 @@
           <p:cNvPr id="14" name="">
             <a:extLst xmlns:a="http://schemas.openxmlformats.org/drawingml/2006/main">
               <a:ext uri="{FF2B5EF4-FFF2-40B4-BE49-F238E27FC236}">
-                <a16:creationId xmlns:a16="http://schemas.microsoft.com/office/drawing/2014/main" id="{6C91E373-19BF-4E3B-9E7D-1C228DDD1293}"/>
+                <a16:creationId xmlns:a16="http://schemas.microsoft.com/office/drawing/2014/main" id="{E6220D46-205C-4229-A862-A5D59FA19FDB}"/>
               </a:ext>
             </a:extLst>
           </p:cNvPr>
@@ -18436,7 +20712,7 @@
     </p:spTree>
     <p:extLst>
       <p:ext uri="{BB962C8B-B14F-4D97-AF65-F5344CB8AC3E}">
-        <p14:creationId xmlns:p14="http://schemas.microsoft.com/office/powerpoint/2010/main" val="2039030296"/>
+        <p14:creationId xmlns:p14="http://schemas.microsoft.com/office/powerpoint/2010/main" val="1840600143"/>
       </p:ext>
     </p:extLst>
   </p:cSld>
@@ -18467,7 +20743,7 @@
           <p:cNvPr id="7" name="">
             <a:extLst xmlns:a="http://schemas.openxmlformats.org/drawingml/2006/main">
               <a:ext uri="{FF2B5EF4-FFF2-40B4-BE49-F238E27FC236}">
-                <a16:creationId xmlns:a16="http://schemas.microsoft.com/office/drawing/2014/main" id="{B9070B66-414E-43D4-AC0F-3530ABC4F333}"/>
+                <a16:creationId xmlns:a16="http://schemas.microsoft.com/office/drawing/2014/main" id="{3D55299D-5739-49E2-A275-4F489354FC5A}"/>
               </a:ext>
             </a:extLst>
           </p:cNvPr>
@@ -18843,7 +21119,7 @@
           <p:cNvPr id="3" name="">
             <a:extLst xmlns:a="http://schemas.openxmlformats.org/drawingml/2006/main">
               <a:ext uri="{FF2B5EF4-FFF2-40B4-BE49-F238E27FC236}">
-                <a16:creationId xmlns:a16="http://schemas.microsoft.com/office/drawing/2014/main" id="{1DED4F9C-28D3-4BF1-8C33-3BC68A095A17}"/>
+                <a16:creationId xmlns:a16="http://schemas.microsoft.com/office/drawing/2014/main" id="{80E5AD51-B7BC-478E-B9CA-DB3E922519D9}"/>
               </a:ext>
             </a:extLst>
           </p:cNvPr>
@@ -18900,7 +21176,7 @@
           <p:cNvPr id="4" name="">
             <a:extLst xmlns:a="http://schemas.openxmlformats.org/drawingml/2006/main">
               <a:ext uri="{FF2B5EF4-FFF2-40B4-BE49-F238E27FC236}">
-                <a16:creationId xmlns:a16="http://schemas.microsoft.com/office/drawing/2014/main" id="{FDADC113-5299-4352-8C00-C317C940DE9F}"/>
+                <a16:creationId xmlns:a16="http://schemas.microsoft.com/office/drawing/2014/main" id="{3A541AEA-BD76-44CE-B273-28CB8DCC5E73}"/>
               </a:ext>
             </a:extLst>
           </p:cNvPr>
@@ -18957,7 +21233,7 @@
           <p:cNvPr id="5" name="">
             <a:extLst xmlns:a="http://schemas.openxmlformats.org/drawingml/2006/main">
               <a:ext uri="{FF2B5EF4-FFF2-40B4-BE49-F238E27FC236}">
-                <a16:creationId xmlns:a16="http://schemas.microsoft.com/office/drawing/2014/main" id="{D2EA1E7D-5332-4FB0-BE05-3BA8C606E0D8}"/>
+                <a16:creationId xmlns:a16="http://schemas.microsoft.com/office/drawing/2014/main" id="{C114959A-E9AC-42C5-89EF-3162E33B1C04}"/>
               </a:ext>
             </a:extLst>
           </p:cNvPr>
@@ -19014,7 +21290,7 @@
           <p:cNvPr id="6" name="">
             <a:extLst xmlns:a="http://schemas.openxmlformats.org/drawingml/2006/main">
               <a:ext uri="{FF2B5EF4-FFF2-40B4-BE49-F238E27FC236}">
-                <a16:creationId xmlns:a16="http://schemas.microsoft.com/office/drawing/2014/main" id="{2EFB773A-42FF-4EBC-AAE2-65C671B71DFA}"/>
+                <a16:creationId xmlns:a16="http://schemas.microsoft.com/office/drawing/2014/main" id="{4F402B8C-F96B-4180-AC85-6C57F18EEB4B}"/>
               </a:ext>
             </a:extLst>
           </p:cNvPr>
@@ -19069,7 +21345,7 @@
     </p:spTree>
     <p:extLst>
       <p:ext uri="{BB962C8B-B14F-4D97-AF65-F5344CB8AC3E}">
-        <p14:creationId xmlns:p14="http://schemas.microsoft.com/office/powerpoint/2010/main" val="1021259709"/>
+        <p14:creationId xmlns:p14="http://schemas.microsoft.com/office/powerpoint/2010/main" val="1208925010"/>
       </p:ext>
     </p:extLst>
   </p:cSld>

</xml_diff>

<commit_message>
Clarify async care timing and reference-based disagreements
</commit_message>
<xml_diff>
--- a/output/submission-2026-09-15/counsel-disposition-google-slides.pptx
+++ b/output/submission-2026-09-15/counsel-disposition-google-slides.pptx
@@ -2,43 +2,44 @@
 <file path=ppt/presentation.xml><?xml version="1.0" encoding="utf-8"?>
 <p:presentation xmlns:p="http://schemas.openxmlformats.org/presentationml/2006/main">
   <p:sldMasterIdLst>
-    <p:sldMasterId xmlns:r="http://schemas.openxmlformats.org/officeDocument/2006/relationships" id="2147483648" r:id="Rec7b589be50f4ed3"/>
+    <p:sldMasterId xmlns:r="http://schemas.openxmlformats.org/officeDocument/2006/relationships" id="2147483648" r:id="R9359f40ee7cf47da"/>
   </p:sldMasterIdLst>
   <p:notesMasterIdLst>
-    <p:notesMasterId xmlns:r="http://schemas.openxmlformats.org/officeDocument/2006/relationships" r:id="R01a288a71e0a489e"/>
+    <p:notesMasterId xmlns:r="http://schemas.openxmlformats.org/officeDocument/2006/relationships" r:id="Re18c0cdf1f194b49"/>
   </p:notesMasterIdLst>
   <p:sldIdLst>
-    <p:sldId xmlns:r="http://schemas.openxmlformats.org/officeDocument/2006/relationships" id="256" r:id="R2bf2614f4bb844e3"/>
-    <p:sldId xmlns:r="http://schemas.openxmlformats.org/officeDocument/2006/relationships" id="257" r:id="R3167aa2c855a4a17"/>
-    <p:sldId xmlns:r="http://schemas.openxmlformats.org/officeDocument/2006/relationships" id="258" r:id="R3de173b467574b48"/>
-    <p:sldId xmlns:r="http://schemas.openxmlformats.org/officeDocument/2006/relationships" id="259" r:id="R5d7e4ac95c164057"/>
-    <p:sldId xmlns:r="http://schemas.openxmlformats.org/officeDocument/2006/relationships" id="260" r:id="R75418515c70c4dda"/>
-    <p:sldId xmlns:r="http://schemas.openxmlformats.org/officeDocument/2006/relationships" id="261" r:id="Rb612706e7fa8478b"/>
-    <p:sldId xmlns:r="http://schemas.openxmlformats.org/officeDocument/2006/relationships" id="262" r:id="Rfbecb33e8c1545e0"/>
-    <p:sldId xmlns:r="http://schemas.openxmlformats.org/officeDocument/2006/relationships" id="263" r:id="R7e884cfb60134bea"/>
-    <p:sldId xmlns:r="http://schemas.openxmlformats.org/officeDocument/2006/relationships" id="264" r:id="Rcbdcb0e61bc148c5"/>
-    <p:sldId xmlns:r="http://schemas.openxmlformats.org/officeDocument/2006/relationships" id="265" r:id="R247c0745546d467a"/>
-    <p:sldId xmlns:r="http://schemas.openxmlformats.org/officeDocument/2006/relationships" id="266" r:id="R97d1523c9eb24710"/>
-    <p:sldId xmlns:r="http://schemas.openxmlformats.org/officeDocument/2006/relationships" id="267" r:id="R435943b24d924f1a"/>
-    <p:sldId xmlns:r="http://schemas.openxmlformats.org/officeDocument/2006/relationships" id="268" r:id="Rc6a43e89fc634cc7"/>
-    <p:sldId xmlns:r="http://schemas.openxmlformats.org/officeDocument/2006/relationships" id="269" r:id="Rc73c3a0f15944868"/>
-    <p:sldId xmlns:r="http://schemas.openxmlformats.org/officeDocument/2006/relationships" id="270" r:id="R524e45a2c6c042fa"/>
-    <p:sldId xmlns:r="http://schemas.openxmlformats.org/officeDocument/2006/relationships" id="271" r:id="R133b173e025246a1"/>
-    <p:sldId xmlns:r="http://schemas.openxmlformats.org/officeDocument/2006/relationships" id="272" r:id="Rdb570b95dd4d4480"/>
-    <p:sldId xmlns:r="http://schemas.openxmlformats.org/officeDocument/2006/relationships" id="273" r:id="R3807e04ef3904840"/>
-    <p:sldId xmlns:r="http://schemas.openxmlformats.org/officeDocument/2006/relationships" id="274" r:id="Rd4cebe3f0f464849"/>
-    <p:sldId xmlns:r="http://schemas.openxmlformats.org/officeDocument/2006/relationships" id="275" r:id="R69b393c48d9c46da"/>
-    <p:sldId xmlns:r="http://schemas.openxmlformats.org/officeDocument/2006/relationships" id="276" r:id="R649a215210474a60"/>
-    <p:sldId xmlns:r="http://schemas.openxmlformats.org/officeDocument/2006/relationships" id="277" r:id="R3c7742a6ca814c97"/>
-    <p:sldId xmlns:r="http://schemas.openxmlformats.org/officeDocument/2006/relationships" id="278" r:id="R27e1167859a94dc1"/>
-    <p:sldId xmlns:r="http://schemas.openxmlformats.org/officeDocument/2006/relationships" id="279" r:id="R620732dcb4ad4321"/>
-    <p:sldId xmlns:r="http://schemas.openxmlformats.org/officeDocument/2006/relationships" id="280" r:id="R7d9eaf82217b481a"/>
-    <p:sldId xmlns:r="http://schemas.openxmlformats.org/officeDocument/2006/relationships" id="281" r:id="R544a1adf092440f0"/>
-    <p:sldId xmlns:r="http://schemas.openxmlformats.org/officeDocument/2006/relationships" id="282" r:id="Rcafa889813c743f1"/>
-    <p:sldId xmlns:r="http://schemas.openxmlformats.org/officeDocument/2006/relationships" id="283" r:id="R82bcf2c095e94d10"/>
-    <p:sldId xmlns:r="http://schemas.openxmlformats.org/officeDocument/2006/relationships" id="284" r:id="R68e7c627eba24127"/>
-    <p:sldId xmlns:r="http://schemas.openxmlformats.org/officeDocument/2006/relationships" id="285" r:id="R95d8d8a19cd84237"/>
-    <p:sldId xmlns:r="http://schemas.openxmlformats.org/officeDocument/2006/relationships" id="286" r:id="R3e7afe063d2d4dac"/>
+    <p:sldId xmlns:r="http://schemas.openxmlformats.org/officeDocument/2006/relationships" id="256" r:id="Rc3130ffb9e984a53"/>
+    <p:sldId xmlns:r="http://schemas.openxmlformats.org/officeDocument/2006/relationships" id="257" r:id="R59f5a015b866425e"/>
+    <p:sldId xmlns:r="http://schemas.openxmlformats.org/officeDocument/2006/relationships" id="258" r:id="R5a242369c5da4b2a"/>
+    <p:sldId xmlns:r="http://schemas.openxmlformats.org/officeDocument/2006/relationships" id="259" r:id="R547953d6b0294a54"/>
+    <p:sldId xmlns:r="http://schemas.openxmlformats.org/officeDocument/2006/relationships" id="260" r:id="R2655d4732aed42e1"/>
+    <p:sldId xmlns:r="http://schemas.openxmlformats.org/officeDocument/2006/relationships" id="261" r:id="R23084b1aa8844a83"/>
+    <p:sldId xmlns:r="http://schemas.openxmlformats.org/officeDocument/2006/relationships" id="262" r:id="Rad0c1328b6ea4a92"/>
+    <p:sldId xmlns:r="http://schemas.openxmlformats.org/officeDocument/2006/relationships" id="263" r:id="Ra81a4a6e5d6c460a"/>
+    <p:sldId xmlns:r="http://schemas.openxmlformats.org/officeDocument/2006/relationships" id="264" r:id="R76f603d91cb04a1f"/>
+    <p:sldId xmlns:r="http://schemas.openxmlformats.org/officeDocument/2006/relationships" id="265" r:id="R3242ac11ce594484"/>
+    <p:sldId xmlns:r="http://schemas.openxmlformats.org/officeDocument/2006/relationships" id="266" r:id="Rd10cab4e4a7548ac"/>
+    <p:sldId xmlns:r="http://schemas.openxmlformats.org/officeDocument/2006/relationships" id="267" r:id="R7725b28df30e4536"/>
+    <p:sldId xmlns:r="http://schemas.openxmlformats.org/officeDocument/2006/relationships" id="268" r:id="R319df0568bca4495"/>
+    <p:sldId xmlns:r="http://schemas.openxmlformats.org/officeDocument/2006/relationships" id="269" r:id="R4f64257c22594c85"/>
+    <p:sldId xmlns:r="http://schemas.openxmlformats.org/officeDocument/2006/relationships" id="270" r:id="Rc2b8ff6843ce4031"/>
+    <p:sldId xmlns:r="http://schemas.openxmlformats.org/officeDocument/2006/relationships" id="271" r:id="R1afdbf7b7a0848ad"/>
+    <p:sldId xmlns:r="http://schemas.openxmlformats.org/officeDocument/2006/relationships" id="272" r:id="Rac10f98a93ff47c5"/>
+    <p:sldId xmlns:r="http://schemas.openxmlformats.org/officeDocument/2006/relationships" id="273" r:id="R92abc22fea5541c9"/>
+    <p:sldId xmlns:r="http://schemas.openxmlformats.org/officeDocument/2006/relationships" id="274" r:id="Rfa39ab125a5b45f3"/>
+    <p:sldId xmlns:r="http://schemas.openxmlformats.org/officeDocument/2006/relationships" id="275" r:id="Rdebe305d7f2c4e48"/>
+    <p:sldId xmlns:r="http://schemas.openxmlformats.org/officeDocument/2006/relationships" id="276" r:id="R5b623e0320eb43fa"/>
+    <p:sldId xmlns:r="http://schemas.openxmlformats.org/officeDocument/2006/relationships" id="277" r:id="R0c2dd4136ffb419a"/>
+    <p:sldId xmlns:r="http://schemas.openxmlformats.org/officeDocument/2006/relationships" id="278" r:id="R215f600e85f245cf"/>
+    <p:sldId xmlns:r="http://schemas.openxmlformats.org/officeDocument/2006/relationships" id="279" r:id="Rbbd4617f3d9a4dd8"/>
+    <p:sldId xmlns:r="http://schemas.openxmlformats.org/officeDocument/2006/relationships" id="280" r:id="R08d2504001d14e5b"/>
+    <p:sldId xmlns:r="http://schemas.openxmlformats.org/officeDocument/2006/relationships" id="281" r:id="R90dd3b36ca934adc"/>
+    <p:sldId xmlns:r="http://schemas.openxmlformats.org/officeDocument/2006/relationships" id="282" r:id="Ra9595c24d1004653"/>
+    <p:sldId xmlns:r="http://schemas.openxmlformats.org/officeDocument/2006/relationships" id="283" r:id="R2b237fe279fd4d56"/>
+    <p:sldId xmlns:r="http://schemas.openxmlformats.org/officeDocument/2006/relationships" id="284" r:id="Rece619dcf2474b45"/>
+    <p:sldId xmlns:r="http://schemas.openxmlformats.org/officeDocument/2006/relationships" id="285" r:id="R6879ba4d493540ff"/>
+    <p:sldId xmlns:r="http://schemas.openxmlformats.org/officeDocument/2006/relationships" id="286" r:id="R95f4b7b1659f486a"/>
+    <p:sldId xmlns:r="http://schemas.openxmlformats.org/officeDocument/2006/relationships" id="287" r:id="R24f1903240b040cd"/>
   </p:sldIdLst>
   <p:sldSz cx="12192000" cy="6858000"/>
   <p:notesSz cx="6858000" cy="9144000"/>
@@ -2857,7 +2858,7 @@
           </a:p>
           <a:p xmlns:a="http://schemas.openxmlformats.org/drawingml/2006/main">
             <a:r>
-              <a:t>On the known set, C47 changes from self-care to the accepted async disposition, while C22 remains a missed review. C07 becomes a new self-care miss and C32 becomes an unnecessary async referral under the unchanged reference. C04, C43 and C49 change from accepted urgent escalation to async review. Their exact messages appear on slide 31. Thus the number of missed clinician-action cases stays at two, while missed urgent action increases from zero to three. The original frozen 48/50 result and the existing GUI remain unchanged.</a:t>
+              <a:t>On the known set, C47 changes from self-care to the accepted async disposition, while C22 remains a missed review. C07 becomes a new self-care miss and C32 becomes an unnecessary async referral under the unchanged reference. C04, C43 and C49 change from the accepted urgent bucket to async review. Their exact messages appear on slide 31. The missed-clinician-action count stays at two. The frozen scorer counts the three urgent-to-async changes as false negatives against its urgent-reference endpoint. That remains the correct description of the scorer and its unchanged labels. It does not establish that a physician response, examination, investigation or treatment actually occurred late. No such outcomes were measured. The original 48/50 result and selected GUI remain unchanged.</a:t>
             </a:r>
           </a:p>
           <a:p xmlns:a="http://schemas.openxmlformats.org/drawingml/2006/main">
@@ -2867,7 +2868,7 @@
           </a:p>
           <a:p xmlns:a="http://schemas.openxmlformats.org/drawingml/2006/main">
             <a:r>
-              <a:t>The new urgent errors are important because a generic instruction intended to prevent premature self-care can also shift the boundary between async review and urgent care. Several saved rationales focus on absence of emergency findings even though URGENT_ESCALATION includes same-day assessment. That is a hypothesis from these outputs, not an established causal mechanism. One run per arm does not isolate prompt effects from sampling variation, and related authored challenge cases are not independent samples of clinical prevalence. The authored challenge improvement cannot offset new urgent misses or establish safety. The candidate is not promoted. The next work requires approval of the clinical policy, independent reference labels and locked evaluation criteria before another clinical performance claim.</a:t>
+              <a:t>ASYNC_PHYSICIAN describes a communication channel and can potentially provide rapid physician assessment and coordinate same-day care. The required time and care capability need separate definitions. These three model/reference disagreements therefore require a clinical and operational contract review before interpreting them as demonstrated undertriage in the actual service. Several saved rationales focus on emergency thresholds even though the frozen urgent bucket includes same-day assessment. That is a hypothesis about the disagreement, not an established causal mechanism or proof that async is inappropriate in every case.</a:t>
             </a:r>
           </a:p>
           <a:p xmlns:a="http://schemas.openxmlformats.org/drawingml/2006/main">
@@ -2877,6 +2878,16 @@
           </a:p>
           <a:p xmlns:a="http://schemas.openxmlformats.org/drawingml/2006/main">
             <a:r>
+              <a:t>One run per arm does not isolate prompt effects from sampling variation. Related authored challenge cases do not independently sample clinical prevalence. Known-reference agreement falls from 48/50 to 44/50 and the two clinician-action false negatives remain, so this experiment establishes no improvement in the primary known-set missed-action endpoint. Authored checks cannot establish clinical safety. The candidate is not promoted. The next work requires approval of the routing contract, independent reference labels and prospectively defined evaluation criteria.</a:t>
+            </a:r>
+          </a:p>
+          <a:p xmlns:a="http://schemas.openxmlformats.org/drawingml/2006/main">
+            <a:r>
+              <a:t/>
+            </a:r>
+          </a:p>
+          <a:p xmlns:a="http://schemas.openxmlformats.org/drawingml/2006/main">
+            <a:r>
               <a:t>Sources</a:t>
             </a:r>
           </a:p>
@@ -2913,6 +2924,16 @@
           <a:p xmlns:a="http://schemas.openxmlformats.org/drawingml/2006/main">
             <a:r>
               <a:t>docs/FALSE_NEGATIVE_REDUCTION_RESULTS_2026-09-16.md</a:t>
+            </a:r>
+          </a:p>
+          <a:p xmlns:a="http://schemas.openxmlformats.org/drawingml/2006/main">
+            <a:r>
+              <a:t/>
+            </a:r>
+          </a:p>
+          <a:p xmlns:a="http://schemas.openxmlformats.org/drawingml/2006/main">
+            <a:r>
+              <a:t>docs/COUNSEL_ASYNC_CARE_CONTEXT_2026-09-16.md</a:t>
             </a:r>
           </a:p>
         </p:txBody>
@@ -3107,7 +3128,7 @@
           <a:lstStyle xmlns:a="http://schemas.openxmlformats.org/drawingml/2006/main"/>
           <a:p xmlns:a="http://schemas.openxmlformats.org/drawingml/2006/main">
             <a:r>
-              <a:t>The completed experiment implements a proposed policy as a development hypothesis. It does not establish that the policy is clinically approved, that the authored cases are an independent reference, or that any future workflow is safe for patient care. Those are separate accountable decisions. The prior general instruction did not reduce known-set missed clinician action and introduced urgent-routing disagreements. Avoid repeatedly tuning against these known misses while calling the same cases independent evidence. Preserve this negative result and freeze any future protocol before evaluation.</a:t>
+              <a:t>The completed experiment implements a proposed policy as a development hypothesis. It does not establish that the policy is clinically approved, that the authored cases are an independent reference, or that any future workflow is safe for patient care. Those are separate accountable decisions. The prior general instruction did not reduce known-set missed clinician action and introduced urgent-routing disagreements. Avoid repeatedly tuning against these known misses while calling the same cases independent evidence. Preserve this result and freeze any future protocol before evaluation.</a:t>
             </a:r>
           </a:p>
           <a:p xmlns:a="http://schemas.openxmlformats.org/drawingml/2006/main">
@@ -3117,7 +3138,7 @@
           </a:p>
           <a:p xmlns:a="http://schemas.openxmlformats.org/drawingml/2006/main">
             <a:r>
-              <a:t>The clinical lead must first define what evidence permits SELF_CARE, what information is material to that decision, and when urgent care means emergency action now versus in-person assessment today. Care operations must review whether the selected action can occur within the required interval. Missing information alone should not be treated as an emergency diagnosis. The operational policy needs a verified pathway when review is recommended.</a:t>
+              <a:t>The clinical lead must first define what evidence permits SELF_CARE and what information is material to that decision. The routing contract must distinguish the next contact from the setting in which care must be completed, the required clinical deadline, and the capability of the available pathway. Async physician contact can be compatible with same-day care. It does not establish whether an examination, testing or treatment can actually occur within the needed interval. Care operations must verify that capability and the process for completing a recommended transfer or assessment. Missing information alone should not be treated as an emergency diagnosis. A response-time average cannot substitute for the required case-specific deadline.</a:t>
             </a:r>
           </a:p>
           <a:p xmlns:a="http://schemas.openxmlformats.org/drawingml/2006/main">
@@ -3183,6 +3204,16 @@
           <a:p xmlns:a="http://schemas.openxmlformats.org/drawingml/2006/main">
             <a:r>
               <a:t>https://www.nature.com/articles/s41591-022-01772-9</a:t>
+            </a:r>
+          </a:p>
+          <a:p xmlns:a="http://schemas.openxmlformats.org/drawingml/2006/main">
+            <a:r>
+              <a:t/>
+            </a:r>
+          </a:p>
+          <a:p xmlns:a="http://schemas.openxmlformats.org/drawingml/2006/main">
+            <a:r>
+              <a:t>docs/COUNSEL_ASYNC_CARE_CONTEXT_2026-09-16.md</a:t>
             </a:r>
           </a:p>
         </p:txBody>
@@ -3252,7 +3283,7 @@
           <a:lstStyle xmlns:a="http://schemas.openxmlformats.org/drawingml/2006/main"/>
           <a:p xmlns:a="http://schemas.openxmlformats.org/drawingml/2006/main">
             <a:r>
-              <a:t>These are the exact synthetic assignment messages, reproduced from the labels-free input file verified against the frozen baseline requests. They entered the separate candidate generation without case IDs or reference labels. C04, C43 and C49 are three new urgent-action false negatives under the unchanged physician v3 reference: the candidate still requests clinician review but assigns async instead of urgent care. The table records a routing disagreement, not an observed patient outcome or a confirmed diagnosis. No case-specific runtime rule or label revision follows from this review. All three cases and rationales remain in the frozen development scorecard. No CSV label serves as a clinical target.</a:t>
+              <a:t>These are the exact synthetic assignment messages, reproduced from the labels-free input file verified against the frozen baseline requests. They entered the separate candidate generation without case IDs or reference labels. For C04, C43 and C49, the candidate still requests clinician review but assigns async rather than the urgent bucket required by physician reference v3. The frozen scorer therefore counts all three as urgent-reference false negatives. This records a label disagreement. It does not show whether the next physician contact or necessary care would have been delayed.</a:t>
             </a:r>
           </a:p>
           <a:p xmlns:a="http://schemas.openxmlformats.org/drawingml/2006/main">
@@ -3262,12 +3293,177 @@
           </a:p>
           <a:p xmlns:a="http://schemas.openxmlformats.org/drawingml/2006/main">
             <a:r>
+              <a:t>A rapid async pathway could potentially assess the presentation and coordinate same-day care when the required capabilities and deadline are confirmed. That conditional possibility requires clinical and operational validation. It does not make every async route acceptable and does not change the saved labels or this experiment’s 44/50 agreement. No observed patient outcome or confirmed diagnosis is established here. No case-specific runtime rule or label revision follows from this review. All three cases and rationales remain in the frozen development scorecard. No CSV label serves as a clinical target.</a:t>
+            </a:r>
+          </a:p>
+          <a:p xmlns:a="http://schemas.openxmlformats.org/drawingml/2006/main">
+            <a:r>
+              <a:t/>
+            </a:r>
+          </a:p>
+          <a:p xmlns:a="http://schemas.openxmlformats.org/drawingml/2006/main">
+            <a:r>
               <a:t>Sources</a:t>
             </a:r>
           </a:p>
           <a:p xmlns:a="http://schemas.openxmlformats.org/drawingml/2006/main">
             <a:r>
               <a:t>outputs/fn-reduction-2026-09-16/known-messages.json</a:t>
+            </a:r>
+          </a:p>
+          <a:p xmlns:a="http://schemas.openxmlformats.org/drawingml/2006/main">
+            <a:r>
+              <a:t/>
+            </a:r>
+          </a:p>
+          <a:p xmlns:a="http://schemas.openxmlformats.org/drawingml/2006/main">
+            <a:r>
+              <a:t>outputs/fn-reduction-2026-09-16/scorecard-known-development.json</a:t>
+            </a:r>
+          </a:p>
+          <a:p xmlns:a="http://schemas.openxmlformats.org/drawingml/2006/main">
+            <a:r>
+              <a:t/>
+            </a:r>
+          </a:p>
+          <a:p xmlns:a="http://schemas.openxmlformats.org/drawingml/2006/main">
+            <a:r>
+              <a:t>docs/COUNSEL_ASYNC_CARE_CONTEXT_2026-09-16.md</a:t>
+            </a:r>
+          </a:p>
+        </p:txBody>
+      </p:sp>
+      <p:sp>
+        <p:nvSpPr>
+          <p:cNvPr id="4" name="Slide Number Placeholder 3"/>
+          <p:cNvSpPr>
+            <a:spLocks xmlns:a="http://schemas.openxmlformats.org/drawingml/2006/main" noGrp="1"/>
+          </p:cNvSpPr>
+          <p:nvPr>
+            <p:ph type="sldNum" idx="5"/>
+          </p:nvPr>
+        </p:nvSpPr>
+        <p:spPr/>
+        <p:txBody>
+          <a:bodyPr xmlns:a="http://schemas.openxmlformats.org/drawingml/2006/main"/>
+          <a:lstStyle xmlns:a="http://schemas.openxmlformats.org/drawingml/2006/main"/>
+          <a:p xmlns:a="http://schemas.openxmlformats.org/drawingml/2006/main"/>
+        </p:txBody>
+      </p:sp>
+    </p:spTree>
+  </p:cSld>
+  <p:clrMapOvr>
+    <a:masterClrMapping xmlns:a="http://schemas.openxmlformats.org/drawingml/2006/main"/>
+  </p:clrMapOvr>
+</p:notes>
+</file>
+
+<file path=ppt/notesSlides/notesSlide32.xml><?xml version="1.0" encoding="utf-8"?>
+<p:notes xmlns:p="http://schemas.openxmlformats.org/presentationml/2006/main">
+  <p:cSld>
+    <p:spTree>
+      <p:nvGrpSpPr>
+        <p:cNvPr id="1" name=""/>
+        <p:cNvGrpSpPr/>
+        <p:nvPr/>
+      </p:nvGrpSpPr>
+      <p:grpSpPr>
+        <a:xfrm xmlns:a="http://schemas.openxmlformats.org/drawingml/2006/main"/>
+      </p:grpSpPr>
+      <p:sp>
+        <p:nvSpPr>
+          <p:cNvPr id="2" name="Slide Image Placeholder 1"/>
+          <p:cNvSpPr>
+            <a:spLocks xmlns:a="http://schemas.openxmlformats.org/drawingml/2006/main" noGrp="1"/>
+          </p:cNvSpPr>
+          <p:nvPr>
+            <p:ph type="sldImg" idx="0"/>
+          </p:nvPr>
+        </p:nvSpPr>
+        <p:spPr/>
+      </p:sp>
+      <p:sp>
+        <p:nvSpPr>
+          <p:cNvPr id="3" name="Notes Placeholder 2"/>
+          <p:cNvSpPr>
+            <a:spLocks xmlns:a="http://schemas.openxmlformats.org/drawingml/2006/main" noGrp="1"/>
+          </p:cNvSpPr>
+          <p:nvPr>
+            <p:ph type="body" idx="1"/>
+          </p:nvPr>
+        </p:nvSpPr>
+        <p:spPr/>
+        <p:txBody>
+          <a:bodyPr xmlns:a="http://schemas.openxmlformats.org/drawingml/2006/main"/>
+          <a:lstStyle xmlns:a="http://schemas.openxmlformats.org/drawingml/2006/main"/>
+          <a:p xmlns:a="http://schemas.openxmlformats.org/drawingml/2006/main">
+            <a:r>
+              <a:t>The FAQ qualifies access by clinical hours, 8am–9pm daily. Informed consent describes primarily asynchronous care, with in-person limits and emergency instructions. Sources accessed 16 September 2026.</a:t>
+            </a:r>
+          </a:p>
+          <a:p xmlns:a="http://schemas.openxmlformats.org/drawingml/2006/main">
+            <a:r>
+              <a:t/>
+            </a:r>
+          </a:p>
+          <a:p xmlns:a="http://schemas.openxmlformats.org/drawingml/2006/main">
+            <a:r>
+              <a:t>This public service description provides context for interpreting a communication channel. It does not establish a guaranteed response for a particular case, an end-to-end clinical deadline, or verified availability of an examination, testing, treatment or transfer. The prototype measured provider inference latency, not those clinical events.</a:t>
+            </a:r>
+          </a:p>
+          <a:p xmlns:a="http://schemas.openxmlformats.org/drawingml/2006/main">
+            <a:r>
+              <a:t/>
+            </a:r>
+          </a:p>
+          <a:p xmlns:a="http://schemas.openxmlformats.org/drawingml/2006/main">
+            <a:r>
+              <a:t>For a future approved policy, rapid async physician assessment could be an appropriate first contact when the pathway can complete or arrange the clinically required next action within its deadline. This is a proposed conditional routing contract for evaluation, not a statement of Counsel’s internal clinical policy or a treatment recommendation for these synthetic cases. Emergency presentations still require a separately defined immediate-action policy. No queue, service-availability logic, new physician label or runtime promotion is implemented by this presentation.</a:t>
+            </a:r>
+          </a:p>
+          <a:p xmlns:a="http://schemas.openxmlformats.org/drawingml/2006/main">
+            <a:r>
+              <a:t/>
+            </a:r>
+          </a:p>
+          <a:p xmlns:a="http://schemas.openxmlformats.org/drawingml/2006/main">
+            <a:r>
+              <a:t>The next review should determine whether the bucket represents the first contact or the required final care setting. Future labels and measurement should then follow that definition. Frozen baseline and candidate predictions and reference scores remain intact, with the development disagreements reported transparently.</a:t>
+            </a:r>
+          </a:p>
+          <a:p xmlns:a="http://schemas.openxmlformats.org/drawingml/2006/main">
+            <a:r>
+              <a:t/>
+            </a:r>
+          </a:p>
+          <a:p xmlns:a="http://schemas.openxmlformats.org/drawingml/2006/main">
+            <a:r>
+              <a:t>Sources</a:t>
+            </a:r>
+          </a:p>
+          <a:p xmlns:a="http://schemas.openxmlformats.org/drawingml/2006/main">
+            <a:r>
+              <a:t>https://www.counselhealth.com/</a:t>
+            </a:r>
+          </a:p>
+          <a:p xmlns:a="http://schemas.openxmlformats.org/drawingml/2006/main">
+            <a:r>
+              <a:t/>
+            </a:r>
+          </a:p>
+          <a:p xmlns:a="http://schemas.openxmlformats.org/drawingml/2006/main">
+            <a:r>
+              <a:t>https://www.counselhealth.com/informed-consent</a:t>
+            </a:r>
+          </a:p>
+          <a:p xmlns:a="http://schemas.openxmlformats.org/drawingml/2006/main">
+            <a:r>
+              <a:t/>
+            </a:r>
+          </a:p>
+          <a:p xmlns:a="http://schemas.openxmlformats.org/drawingml/2006/main">
+            <a:r>
+              <a:t>docs/COUNSEL_ASYNC_CARE_CONTEXT_2026-09-16.md</a:t>
             </a:r>
           </a:p>
           <a:p xmlns:a="http://schemas.openxmlformats.org/drawingml/2006/main">
@@ -3462,6 +3658,16 @@
           </a:p>
           <a:p xmlns:a="http://schemas.openxmlformats.org/drawingml/2006/main">
             <a:r>
+              <a:t>The labels are the frozen research interface. They do not fully specify the receiving service or distinguish first physician contact from the location and deadline of definitive assessment. The later service-context review explains why async contact can still support same-day care. No saved label or output changes.</a:t>
+            </a:r>
+          </a:p>
+          <a:p xmlns:a="http://schemas.openxmlformats.org/drawingml/2006/main">
+            <a:r>
+              <a:t/>
+            </a:r>
+          </a:p>
+          <a:p xmlns:a="http://schemas.openxmlformats.org/drawingml/2006/main">
+            <a:r>
               <a:t>Sources</a:t>
             </a:r>
           </a:p>
@@ -3488,6 +3694,16 @@
           <a:p xmlns:a="http://schemas.openxmlformats.org/drawingml/2006/main">
             <a:r>
               <a:t>docs/PHYSICIAN_ADJUDICATION_V3_2026-09-15.md</a:t>
+            </a:r>
+          </a:p>
+          <a:p xmlns:a="http://schemas.openxmlformats.org/drawingml/2006/main">
+            <a:r>
+              <a:t/>
+            </a:r>
+          </a:p>
+          <a:p xmlns:a="http://schemas.openxmlformats.org/drawingml/2006/main">
+            <a:r>
+              <a:t>docs/COUNSEL_ASYNC_CARE_CONTEXT_2026-09-16.md</a:t>
             </a:r>
           </a:p>
         </p:txBody>
@@ -3567,6 +3783,16 @@
           </a:p>
           <a:p xmlns:a="http://schemas.openxmlformats.org/drawingml/2006/main">
             <a:r>
+              <a:t>ASYNC_PHYSICIAN describes a communication channel, not an assumption of delayed care. Rapid async physician review can be compatible with same-day care, subject to the available clinical capabilities and the required deadline. The urgent bucket in this frozen evaluation still combines same-day in-person care and emergency action. Its saved labels and deterministic scores remain unchanged. The service-context correction does not make all async alternatives clinically interchangeable. A future clinical and operational contract must specify the next contact, necessary care setting, clinical deadline and who confirms completion. None of those service events was measured or implemented in the current prototype.</a:t>
+            </a:r>
+          </a:p>
+          <a:p xmlns:a="http://schemas.openxmlformats.org/drawingml/2006/main">
+            <a:r>
+              <a:t/>
+            </a:r>
+          </a:p>
+          <a:p xmlns:a="http://schemas.openxmlformats.org/drawingml/2006/main">
+            <a:r>
               <a:t>Sources</a:t>
             </a:r>
           </a:p>
@@ -3583,6 +3809,16 @@
           <a:p xmlns:a="http://schemas.openxmlformats.org/drawingml/2006/main">
             <a:r>
               <a:t>data/evaluation/physician-adjudication-v3-2026-09-15.json</a:t>
+            </a:r>
+          </a:p>
+          <a:p xmlns:a="http://schemas.openxmlformats.org/drawingml/2006/main">
+            <a:r>
+              <a:t/>
+            </a:r>
+          </a:p>
+          <a:p xmlns:a="http://schemas.openxmlformats.org/drawingml/2006/main">
+            <a:r>
+              <a:t>docs/COUNSEL_ASYNC_CARE_CONTEXT_2026-09-16.md</a:t>
             </a:r>
           </a:p>
         </p:txBody>
@@ -3975,7 +4211,7 @@
   </p:cSld>
   <p:clrMap bg1="lt1" tx1="dk1" bg2="lt2" tx2="dk2" accent1="accent1" accent2="accent2" accent3="accent3" accent4="accent4" accent5="accent5" accent6="accent6" hlink="hlink" folHlink="folHlink"/>
   <p:sldLayoutIdLst>
-    <p:sldLayoutId xmlns:r="http://schemas.openxmlformats.org/officeDocument/2006/relationships" id="2147483649" r:id="Rdeee332b0a2243e9"/>
+    <p:sldLayoutId xmlns:r="http://schemas.openxmlformats.org/officeDocument/2006/relationships" id="2147483649" r:id="R944de6c12ef54002"/>
   </p:sldLayoutIdLst>
   <p:txStyles>
     <p:titleStyle>
@@ -4526,7 +4762,7 @@
           <p:cNvPr id="16" name="">
             <a:extLst>
               <a:ext uri="{FF2B5EF4-FFF2-40B4-BE49-F238E27FC236}">
-                <ns2:creationId id="{E1AFEE42-206F-4F05-B6E8-29A36C8568DA}"/>
+                <ns2:creationId id="{E2006363-5ED7-4E19-9A8F-1A5DF2382B5F}"/>
               </a:ext>
             </a:extLst>
           </p:cNvPr>
@@ -4583,7 +4819,7 @@
           <p:cNvPr id="2" name="">
             <a:extLst>
               <a:ext uri="{FF2B5EF4-FFF2-40B4-BE49-F238E27FC236}">
-                <ns2:creationId id="{CF2164FB-7344-4DF5-8A87-D97D62C1B85D}"/>
+                <ns2:creationId id="{6E3495E1-E1C6-4BBF-98DD-16C27821CE30}"/>
               </a:ext>
             </a:extLst>
           </p:cNvPr>
@@ -4644,7 +4880,7 @@
           <p:nvPr/>
         </p:nvPicPr>
         <p:blipFill>
-          <a:blip r:embed="Rec8ef0f6b4df4340"/>
+          <a:blip r:embed="Rbc77e40048254d92"/>
           <a:stretch/>
         </p:blipFill>
         <p:spPr>
@@ -4662,7 +4898,7 @@
           <p:cNvPr id="4" name="">
             <a:extLst>
               <a:ext uri="{FF2B5EF4-FFF2-40B4-BE49-F238E27FC236}">
-                <ns2:creationId id="{D0DA9419-C4FE-4C02-8E53-B4AA2B53A0D8}"/>
+                <ns2:creationId id="{AAFB440B-FCE4-4D06-9F25-14BE25EE8E2F}"/>
               </a:ext>
             </a:extLst>
           </p:cNvPr>
@@ -4719,7 +4955,7 @@
           <p:cNvPr id="5" name="">
             <a:extLst>
               <a:ext uri="{FF2B5EF4-FFF2-40B4-BE49-F238E27FC236}">
-                <ns2:creationId id="{DF238197-91C0-4E28-8414-002843DF5EED}"/>
+                <ns2:creationId id="{6CB5875B-39FB-4C54-A775-7D7F2B012FE9}"/>
               </a:ext>
             </a:extLst>
           </p:cNvPr>
@@ -4776,7 +5012,7 @@
           <p:cNvPr id="6" name="">
             <a:extLst>
               <a:ext uri="{FF2B5EF4-FFF2-40B4-BE49-F238E27FC236}">
-                <ns2:creationId id="{8ED08D6D-7676-4515-80F3-84EBB7A8F643}"/>
+                <ns2:creationId id="{143EC994-B347-47BE-81BE-7624456E2377}"/>
               </a:ext>
             </a:extLst>
           </p:cNvPr>
@@ -4833,7 +5069,7 @@
           <p:cNvPr id="7" name="">
             <a:extLst>
               <a:ext uri="{FF2B5EF4-FFF2-40B4-BE49-F238E27FC236}">
-                <ns2:creationId id="{AB234C04-6B4D-4115-9FE0-374323905D22}"/>
+                <ns2:creationId id="{B90B43DC-D5D0-4D13-9642-A42753BF68A8}"/>
               </a:ext>
             </a:extLst>
           </p:cNvPr>
@@ -4890,7 +5126,7 @@
           <p:cNvPr id="8" name="">
             <a:extLst>
               <a:ext uri="{FF2B5EF4-FFF2-40B4-BE49-F238E27FC236}">
-                <ns2:creationId id="{3C55C66A-E3F1-4B60-ABD1-FF3B09733700}"/>
+                <ns2:creationId id="{CBCA569A-3727-43A7-A567-58B59F11AEE6}"/>
               </a:ext>
             </a:extLst>
           </p:cNvPr>
@@ -4948,7 +5184,7 @@
           <p:cNvPr id="9" name="">
             <a:extLst>
               <a:ext uri="{FF2B5EF4-FFF2-40B4-BE49-F238E27FC236}">
-                <ns2:creationId id="{7D8CE243-B554-46BA-94BC-4541C71B609C}"/>
+                <ns2:creationId id="{E715EAB3-7AA5-4237-9C98-EA1C48C77D39}"/>
               </a:ext>
             </a:extLst>
           </p:cNvPr>
@@ -5005,7 +5241,7 @@
           <p:cNvPr id="10" name="">
             <a:extLst>
               <a:ext uri="{FF2B5EF4-FFF2-40B4-BE49-F238E27FC236}">
-                <ns2:creationId id="{E5AFD7CC-087B-41B6-AA89-4801F43BBC24}"/>
+                <ns2:creationId id="{C2FC0D9E-FB52-4F46-9F3C-02D12D651BA9}"/>
               </a:ext>
             </a:extLst>
           </p:cNvPr>
@@ -5062,7 +5298,7 @@
           <p:cNvPr id="11" name="">
             <a:extLst>
               <a:ext uri="{FF2B5EF4-FFF2-40B4-BE49-F238E27FC236}">
-                <ns2:creationId id="{73BECD1B-DD00-4E4E-9F08-966BD7C42BCB}"/>
+                <ns2:creationId id="{E2F8A6C0-FDAB-4D26-B88D-F5FD6A0EADC2}"/>
               </a:ext>
             </a:extLst>
           </p:cNvPr>
@@ -5120,7 +5356,7 @@
           <p:cNvPr id="12" name="">
             <a:extLst>
               <a:ext uri="{FF2B5EF4-FFF2-40B4-BE49-F238E27FC236}">
-                <ns2:creationId id="{206605D2-8598-4C77-B587-448F7B193A1B}"/>
+                <ns2:creationId id="{90B05C36-8580-48F7-A244-C30E230AB171}"/>
               </a:ext>
             </a:extLst>
           </p:cNvPr>
@@ -5177,7 +5413,7 @@
           <p:cNvPr id="13" name="">
             <a:extLst>
               <a:ext uri="{FF2B5EF4-FFF2-40B4-BE49-F238E27FC236}">
-                <ns2:creationId id="{D5C61D7A-77EB-4AD2-9374-FE827C966B94}"/>
+                <ns2:creationId id="{50774CC7-F850-468C-992F-B71F5A6D64B2}"/>
               </a:ext>
             </a:extLst>
           </p:cNvPr>
@@ -5234,7 +5470,7 @@
           <p:cNvPr id="14" name="">
             <a:extLst>
               <a:ext uri="{FF2B5EF4-FFF2-40B4-BE49-F238E27FC236}">
-                <ns2:creationId id="{FCC89A28-5B1C-4A37-AC49-9E19CF627601}"/>
+                <ns2:creationId id="{1A56EA99-303D-41D0-A898-212C168D1FD2}"/>
               </a:ext>
             </a:extLst>
           </p:cNvPr>
@@ -5291,7 +5527,7 @@
           <p:cNvPr id="15" name="">
             <a:extLst>
               <a:ext uri="{FF2B5EF4-FFF2-40B4-BE49-F238E27FC236}">
-                <ns2:creationId id="{6D31EA88-0FFD-4FD7-BC40-CAEC4E48A97A}"/>
+                <ns2:creationId id="{BE3A2BDF-08F4-4BE5-B2AB-77DA505E9CF1}"/>
               </a:ext>
             </a:extLst>
           </p:cNvPr>
@@ -5346,7 +5582,7 @@
     </p:spTree>
     <p:extLst>
       <p:ext uri="{BB962C8B-B14F-4D97-AF65-F5344CB8AC3E}">
-        <ns4:creationId val="618866186"/>
+        <ns4:creationId val="734977239"/>
       </p:ext>
     </p:extLst>
   </p:cSld>
@@ -5377,7 +5613,7 @@
           <p:cNvPr id="7" name="">
             <a:extLst xmlns:a="http://schemas.openxmlformats.org/drawingml/2006/main">
               <a:ext uri="{FF2B5EF4-FFF2-40B4-BE49-F238E27FC236}">
-                <a16:creationId xmlns:a16="http://schemas.microsoft.com/office/drawing/2014/main" id="{2A23B494-59E0-4EDB-AFE1-B050FAFCC7C5}"/>
+                <a16:creationId xmlns:a16="http://schemas.microsoft.com/office/drawing/2014/main" id="{09E1DA10-A2DE-4368-A8DD-2A4AEED3FAF5}"/>
               </a:ext>
             </a:extLst>
           </p:cNvPr>
@@ -6046,7 +6282,7 @@
           <p:cNvPr id="3" name="">
             <a:extLst xmlns:a="http://schemas.openxmlformats.org/drawingml/2006/main">
               <a:ext uri="{FF2B5EF4-FFF2-40B4-BE49-F238E27FC236}">
-                <a16:creationId xmlns:a16="http://schemas.microsoft.com/office/drawing/2014/main" id="{721F2854-8D98-4A80-8834-CC2561C9AEC2}"/>
+                <a16:creationId xmlns:a16="http://schemas.microsoft.com/office/drawing/2014/main" id="{7D6842EE-DEED-4E7E-9BF0-CBC31B5DC463}"/>
               </a:ext>
             </a:extLst>
           </p:cNvPr>
@@ -6103,7 +6339,7 @@
           <p:cNvPr id="4" name="">
             <a:extLst xmlns:a="http://schemas.openxmlformats.org/drawingml/2006/main">
               <a:ext uri="{FF2B5EF4-FFF2-40B4-BE49-F238E27FC236}">
-                <a16:creationId xmlns:a16="http://schemas.microsoft.com/office/drawing/2014/main" id="{9FA4F055-8694-4187-9EF2-3CE486EC4F68}"/>
+                <a16:creationId xmlns:a16="http://schemas.microsoft.com/office/drawing/2014/main" id="{AECE8DE3-4F30-4CF7-A826-60181E41A10B}"/>
               </a:ext>
             </a:extLst>
           </p:cNvPr>
@@ -6160,7 +6396,7 @@
           <p:cNvPr id="5" name="">
             <a:extLst xmlns:a="http://schemas.openxmlformats.org/drawingml/2006/main">
               <a:ext uri="{FF2B5EF4-FFF2-40B4-BE49-F238E27FC236}">
-                <a16:creationId xmlns:a16="http://schemas.microsoft.com/office/drawing/2014/main" id="{9F2AAD90-C80A-44B8-874A-8E35275621B1}"/>
+                <a16:creationId xmlns:a16="http://schemas.microsoft.com/office/drawing/2014/main" id="{CB5463CE-3FA4-4494-A1CE-FEADC19E3A2C}"/>
               </a:ext>
             </a:extLst>
           </p:cNvPr>
@@ -6217,7 +6453,7 @@
           <p:cNvPr id="6" name="">
             <a:extLst xmlns:a="http://schemas.openxmlformats.org/drawingml/2006/main">
               <a:ext uri="{FF2B5EF4-FFF2-40B4-BE49-F238E27FC236}">
-                <a16:creationId xmlns:a16="http://schemas.microsoft.com/office/drawing/2014/main" id="{4AB44A41-0C0A-44B6-9C99-A3E2DCE120C4}"/>
+                <a16:creationId xmlns:a16="http://schemas.microsoft.com/office/drawing/2014/main" id="{753070FE-2E0C-49EF-A5F9-DAAAD4CC67C2}"/>
               </a:ext>
             </a:extLst>
           </p:cNvPr>
@@ -6272,7 +6508,7 @@
     </p:spTree>
     <p:extLst>
       <p:ext uri="{BB962C8B-B14F-4D97-AF65-F5344CB8AC3E}">
-        <p14:creationId xmlns:p14="http://schemas.microsoft.com/office/powerpoint/2010/main" val="1300347087"/>
+        <p14:creationId xmlns:p14="http://schemas.microsoft.com/office/powerpoint/2010/main" val="1023995832"/>
       </p:ext>
     </p:extLst>
   </p:cSld>
@@ -6303,7 +6539,7 @@
           <p:cNvPr id="7" name="">
             <a:extLst xmlns:a="http://schemas.openxmlformats.org/drawingml/2006/main">
               <a:ext uri="{FF2B5EF4-FFF2-40B4-BE49-F238E27FC236}">
-                <a16:creationId xmlns:a16="http://schemas.microsoft.com/office/drawing/2014/main" id="{8363ED18-B1C7-4199-A37B-4373897DE11F}"/>
+                <a16:creationId xmlns:a16="http://schemas.microsoft.com/office/drawing/2014/main" id="{3590ED64-A532-49E8-A8DD-24A472D48019}"/>
               </a:ext>
             </a:extLst>
           </p:cNvPr>
@@ -6679,7 +6915,7 @@
           <p:cNvPr id="3" name="">
             <a:extLst xmlns:a="http://schemas.openxmlformats.org/drawingml/2006/main">
               <a:ext uri="{FF2B5EF4-FFF2-40B4-BE49-F238E27FC236}">
-                <a16:creationId xmlns:a16="http://schemas.microsoft.com/office/drawing/2014/main" id="{241F4AE8-D559-4FFA-B9E1-20E1729FA924}"/>
+                <a16:creationId xmlns:a16="http://schemas.microsoft.com/office/drawing/2014/main" id="{293597CF-C260-4C00-9C5A-BF9F7F9B7E61}"/>
               </a:ext>
             </a:extLst>
           </p:cNvPr>
@@ -6736,7 +6972,7 @@
           <p:cNvPr id="4" name="">
             <a:extLst xmlns:a="http://schemas.openxmlformats.org/drawingml/2006/main">
               <a:ext uri="{FF2B5EF4-FFF2-40B4-BE49-F238E27FC236}">
-                <a16:creationId xmlns:a16="http://schemas.microsoft.com/office/drawing/2014/main" id="{A5346F80-ABDA-46FF-B67E-217AFC7552FA}"/>
+                <a16:creationId xmlns:a16="http://schemas.microsoft.com/office/drawing/2014/main" id="{96648007-6F56-449E-AA7A-6E458E6655A8}"/>
               </a:ext>
             </a:extLst>
           </p:cNvPr>
@@ -6793,7 +7029,7 @@
           <p:cNvPr id="5" name="">
             <a:extLst xmlns:a="http://schemas.openxmlformats.org/drawingml/2006/main">
               <a:ext uri="{FF2B5EF4-FFF2-40B4-BE49-F238E27FC236}">
-                <a16:creationId xmlns:a16="http://schemas.microsoft.com/office/drawing/2014/main" id="{B546DE83-20DF-4091-8B2E-25C9FDB98115}"/>
+                <a16:creationId xmlns:a16="http://schemas.microsoft.com/office/drawing/2014/main" id="{9C0304C3-CEEF-4787-A0A5-9D4626ADA0EB}"/>
               </a:ext>
             </a:extLst>
           </p:cNvPr>
@@ -6850,7 +7086,7 @@
           <p:cNvPr id="6" name="">
             <a:extLst xmlns:a="http://schemas.openxmlformats.org/drawingml/2006/main">
               <a:ext uri="{FF2B5EF4-FFF2-40B4-BE49-F238E27FC236}">
-                <a16:creationId xmlns:a16="http://schemas.microsoft.com/office/drawing/2014/main" id="{874F58C9-55C5-412B-8DA7-92FDC3E9F7A6}"/>
+                <a16:creationId xmlns:a16="http://schemas.microsoft.com/office/drawing/2014/main" id="{73E3E1E1-8CCB-48C2-BE13-6B453FAC1A30}"/>
               </a:ext>
             </a:extLst>
           </p:cNvPr>
@@ -6905,7 +7141,7 @@
     </p:spTree>
     <p:extLst>
       <p:ext uri="{BB962C8B-B14F-4D97-AF65-F5344CB8AC3E}">
-        <p14:creationId xmlns:p14="http://schemas.microsoft.com/office/powerpoint/2010/main" val="261451796"/>
+        <p14:creationId xmlns:p14="http://schemas.microsoft.com/office/powerpoint/2010/main" val="1245908843"/>
       </p:ext>
     </p:extLst>
   </p:cSld>
@@ -6936,7 +7172,7 @@
           <p:cNvPr id="5" name="">
             <a:extLst xmlns:a="http://schemas.openxmlformats.org/drawingml/2006/main">
               <a:ext uri="{FF2B5EF4-FFF2-40B4-BE49-F238E27FC236}">
-                <a16:creationId xmlns:a16="http://schemas.microsoft.com/office/drawing/2014/main" id="{CF60605E-4E4C-4047-BDC5-569BEA3D07F2}"/>
+                <a16:creationId xmlns:a16="http://schemas.microsoft.com/office/drawing/2014/main" id="{31FC4C9A-CA13-4CA6-A2CF-4AFF4FCFF65B}"/>
               </a:ext>
             </a:extLst>
           </p:cNvPr>
@@ -7265,7 +7501,7 @@
           <p:cNvPr id="3" name="">
             <a:extLst xmlns:a="http://schemas.openxmlformats.org/drawingml/2006/main">
               <a:ext uri="{FF2B5EF4-FFF2-40B4-BE49-F238E27FC236}">
-                <a16:creationId xmlns:a16="http://schemas.microsoft.com/office/drawing/2014/main" id="{464B8B2D-081C-4137-96E3-81983AB78F65}"/>
+                <a16:creationId xmlns:a16="http://schemas.microsoft.com/office/drawing/2014/main" id="{EC734C13-252D-4826-A08C-D628BFABEA1B}"/>
               </a:ext>
             </a:extLst>
           </p:cNvPr>
@@ -7322,7 +7558,7 @@
           <p:cNvPr id="4" name="">
             <a:extLst xmlns:a="http://schemas.openxmlformats.org/drawingml/2006/main">
               <a:ext uri="{FF2B5EF4-FFF2-40B4-BE49-F238E27FC236}">
-                <a16:creationId xmlns:a16="http://schemas.microsoft.com/office/drawing/2014/main" id="{F5B7BB06-B8C4-4841-B750-F926208CB509}"/>
+                <a16:creationId xmlns:a16="http://schemas.microsoft.com/office/drawing/2014/main" id="{70EADC33-E7A2-4B9C-878E-D846BAD4BABC}"/>
               </a:ext>
             </a:extLst>
           </p:cNvPr>
@@ -7377,7 +7613,7 @@
     </p:spTree>
     <p:extLst>
       <p:ext uri="{BB962C8B-B14F-4D97-AF65-F5344CB8AC3E}">
-        <p14:creationId xmlns:p14="http://schemas.microsoft.com/office/powerpoint/2010/main" val="809918692"/>
+        <p14:creationId xmlns:p14="http://schemas.microsoft.com/office/powerpoint/2010/main" val="394132160"/>
       </p:ext>
     </p:extLst>
   </p:cSld>
@@ -7408,7 +7644,7 @@
           <p:cNvPr id="5" name="">
             <a:extLst xmlns:a="http://schemas.openxmlformats.org/drawingml/2006/main">
               <a:ext uri="{FF2B5EF4-FFF2-40B4-BE49-F238E27FC236}">
-                <a16:creationId xmlns:a16="http://schemas.microsoft.com/office/drawing/2014/main" id="{F779E6DD-A311-42D8-9A85-90E0973133E5}"/>
+                <a16:creationId xmlns:a16="http://schemas.microsoft.com/office/drawing/2014/main" id="{2F4C7D29-A626-415B-9767-24307AE70411}"/>
               </a:ext>
             </a:extLst>
           </p:cNvPr>
@@ -7787,7 +8023,7 @@
           <p:cNvPr id="3" name="">
             <a:extLst xmlns:a="http://schemas.openxmlformats.org/drawingml/2006/main">
               <a:ext uri="{FF2B5EF4-FFF2-40B4-BE49-F238E27FC236}">
-                <a16:creationId xmlns:a16="http://schemas.microsoft.com/office/drawing/2014/main" id="{CB6D5277-48B5-42FC-8322-97356276BE48}"/>
+                <a16:creationId xmlns:a16="http://schemas.microsoft.com/office/drawing/2014/main" id="{5508CF0C-63F5-4040-A15D-BE25E923AEBD}"/>
               </a:ext>
             </a:extLst>
           </p:cNvPr>
@@ -7844,7 +8080,7 @@
           <p:cNvPr id="4" name="">
             <a:extLst xmlns:a="http://schemas.openxmlformats.org/drawingml/2006/main">
               <a:ext uri="{FF2B5EF4-FFF2-40B4-BE49-F238E27FC236}">
-                <a16:creationId xmlns:a16="http://schemas.microsoft.com/office/drawing/2014/main" id="{90EA7474-35A2-4B69-95E8-3E76201B70C9}"/>
+                <a16:creationId xmlns:a16="http://schemas.microsoft.com/office/drawing/2014/main" id="{CD492481-89B4-4C27-A1A9-C0B009563DC0}"/>
               </a:ext>
             </a:extLst>
           </p:cNvPr>
@@ -7899,7 +8135,7 @@
     </p:spTree>
     <p:extLst>
       <p:ext uri="{BB962C8B-B14F-4D97-AF65-F5344CB8AC3E}">
-        <p14:creationId xmlns:p14="http://schemas.microsoft.com/office/powerpoint/2010/main" val="778116643"/>
+        <p14:creationId xmlns:p14="http://schemas.microsoft.com/office/powerpoint/2010/main" val="1717278837"/>
       </p:ext>
     </p:extLst>
   </p:cSld>
@@ -7930,7 +8166,7 @@
           <p:cNvPr id="5" name="">
             <a:extLst xmlns:a="http://schemas.openxmlformats.org/drawingml/2006/main">
               <a:ext uri="{FF2B5EF4-FFF2-40B4-BE49-F238E27FC236}">
-                <a16:creationId xmlns:a16="http://schemas.microsoft.com/office/drawing/2014/main" id="{97688234-269C-4EBD-B37A-562DB441FB25}"/>
+                <a16:creationId xmlns:a16="http://schemas.microsoft.com/office/drawing/2014/main" id="{AA8D5BC8-D936-41AE-9E07-205FE191EAC6}"/>
               </a:ext>
             </a:extLst>
           </p:cNvPr>
@@ -8432,7 +8668,7 @@
           <p:cNvPr id="3" name="">
             <a:extLst xmlns:a="http://schemas.openxmlformats.org/drawingml/2006/main">
               <a:ext uri="{FF2B5EF4-FFF2-40B4-BE49-F238E27FC236}">
-                <a16:creationId xmlns:a16="http://schemas.microsoft.com/office/drawing/2014/main" id="{03516F15-AAB7-4F3E-9243-54BB73BB83FB}"/>
+                <a16:creationId xmlns:a16="http://schemas.microsoft.com/office/drawing/2014/main" id="{0C121F5C-AB20-493E-B73E-535ADEA51A83}"/>
               </a:ext>
             </a:extLst>
           </p:cNvPr>
@@ -8489,7 +8725,7 @@
           <p:cNvPr id="4" name="">
             <a:extLst xmlns:a="http://schemas.openxmlformats.org/drawingml/2006/main">
               <a:ext uri="{FF2B5EF4-FFF2-40B4-BE49-F238E27FC236}">
-                <a16:creationId xmlns:a16="http://schemas.microsoft.com/office/drawing/2014/main" id="{A137E625-FE1A-4A8B-B693-6892E578B2B9}"/>
+                <a16:creationId xmlns:a16="http://schemas.microsoft.com/office/drawing/2014/main" id="{D8DE4763-CA39-49CE-BB59-8F49048BD6A3}"/>
               </a:ext>
             </a:extLst>
           </p:cNvPr>
@@ -8544,7 +8780,7 @@
     </p:spTree>
     <p:extLst>
       <p:ext uri="{BB962C8B-B14F-4D97-AF65-F5344CB8AC3E}">
-        <p14:creationId xmlns:p14="http://schemas.microsoft.com/office/powerpoint/2010/main" val="1616477692"/>
+        <p14:creationId xmlns:p14="http://schemas.microsoft.com/office/powerpoint/2010/main" val="452969687"/>
       </p:ext>
     </p:extLst>
   </p:cSld>
@@ -8575,7 +8811,7 @@
           <p:cNvPr id="6" name="">
             <a:extLst xmlns:a="http://schemas.openxmlformats.org/drawingml/2006/main">
               <a:ext uri="{FF2B5EF4-FFF2-40B4-BE49-F238E27FC236}">
-                <a16:creationId xmlns:a16="http://schemas.microsoft.com/office/drawing/2014/main" id="{8C1D5EE1-C2B7-49A8-AE6B-221CF9A8F92B}"/>
+                <a16:creationId xmlns:a16="http://schemas.microsoft.com/office/drawing/2014/main" id="{BE438A29-58AF-4FEA-88F9-E2AF985C6E9C}"/>
               </a:ext>
             </a:extLst>
           </p:cNvPr>
@@ -8990,7 +9226,7 @@
           <p:cNvPr id="3" name="">
             <a:extLst xmlns:a="http://schemas.openxmlformats.org/drawingml/2006/main">
               <a:ext uri="{FF2B5EF4-FFF2-40B4-BE49-F238E27FC236}">
-                <a16:creationId xmlns:a16="http://schemas.microsoft.com/office/drawing/2014/main" id="{68B0C354-FAB4-4FA2-9413-0EB59C7B58C9}"/>
+                <a16:creationId xmlns:a16="http://schemas.microsoft.com/office/drawing/2014/main" id="{371586DB-0BF2-4DDF-A157-5F5AE539206A}"/>
               </a:ext>
             </a:extLst>
           </p:cNvPr>
@@ -9047,7 +9283,7 @@
           <p:cNvPr id="4" name="">
             <a:extLst xmlns:a="http://schemas.openxmlformats.org/drawingml/2006/main">
               <a:ext uri="{FF2B5EF4-FFF2-40B4-BE49-F238E27FC236}">
-                <a16:creationId xmlns:a16="http://schemas.microsoft.com/office/drawing/2014/main" id="{BE6400E6-1195-4D5D-9036-BC9A4DF41EDE}"/>
+                <a16:creationId xmlns:a16="http://schemas.microsoft.com/office/drawing/2014/main" id="{3305FE7D-83BA-4A0C-82F2-818EAAF7BB63}"/>
               </a:ext>
             </a:extLst>
           </p:cNvPr>
@@ -9104,7 +9340,7 @@
           <p:cNvPr id="5" name="">
             <a:extLst xmlns:a="http://schemas.openxmlformats.org/drawingml/2006/main">
               <a:ext uri="{FF2B5EF4-FFF2-40B4-BE49-F238E27FC236}">
-                <a16:creationId xmlns:a16="http://schemas.microsoft.com/office/drawing/2014/main" id="{11836D48-11DF-486A-9F8D-4AD6312D372F}"/>
+                <a16:creationId xmlns:a16="http://schemas.microsoft.com/office/drawing/2014/main" id="{7CC1A7FD-CC96-4799-9E58-514FC4A1A55C}"/>
               </a:ext>
             </a:extLst>
           </p:cNvPr>
@@ -9159,7 +9395,7 @@
     </p:spTree>
     <p:extLst>
       <p:ext uri="{BB962C8B-B14F-4D97-AF65-F5344CB8AC3E}">
-        <p14:creationId xmlns:p14="http://schemas.microsoft.com/office/powerpoint/2010/main" val="52404378"/>
+        <p14:creationId xmlns:p14="http://schemas.microsoft.com/office/powerpoint/2010/main" val="600988350"/>
       </p:ext>
     </p:extLst>
   </p:cSld>
@@ -9190,7 +9426,7 @@
           <p:cNvPr id="6" name="">
             <a:extLst xmlns:a="http://schemas.openxmlformats.org/drawingml/2006/main">
               <a:ext uri="{FF2B5EF4-FFF2-40B4-BE49-F238E27FC236}">
-                <a16:creationId xmlns:a16="http://schemas.microsoft.com/office/drawing/2014/main" id="{F0F5BF94-1DC8-42F8-93D4-DE28022F9A5F}"/>
+                <a16:creationId xmlns:a16="http://schemas.microsoft.com/office/drawing/2014/main" id="{F06C09FC-723C-4551-8E8D-28D815B123D5}"/>
               </a:ext>
             </a:extLst>
           </p:cNvPr>
@@ -9251,7 +9487,7 @@
           <p:nvPr/>
         </p:nvPicPr>
         <p:blipFill>
-          <a:blip xmlns:r="http://schemas.openxmlformats.org/officeDocument/2006/relationships" xmlns:a="http://schemas.openxmlformats.org/drawingml/2006/main" r:embed="R281d2eb4d7ce4015"/>
+          <a:blip xmlns:r="http://schemas.openxmlformats.org/officeDocument/2006/relationships" xmlns:a="http://schemas.openxmlformats.org/drawingml/2006/main" r:embed="R6b64817263044ecf"/>
           <a:stretch xmlns:a="http://schemas.openxmlformats.org/drawingml/2006/main"/>
         </p:blipFill>
         <p:spPr>
@@ -9269,7 +9505,7 @@
           <p:cNvPr id="3" name="">
             <a:extLst xmlns:a="http://schemas.openxmlformats.org/drawingml/2006/main">
               <a:ext uri="{FF2B5EF4-FFF2-40B4-BE49-F238E27FC236}">
-                <a16:creationId xmlns:a16="http://schemas.microsoft.com/office/drawing/2014/main" id="{D64E7FBB-A0BC-459F-A746-F9DCC75855F1}"/>
+                <a16:creationId xmlns:a16="http://schemas.microsoft.com/office/drawing/2014/main" id="{5387B5D5-60EF-40D8-BCEE-F37DB3551AAE}"/>
               </a:ext>
             </a:extLst>
           </p:cNvPr>
@@ -9326,7 +9562,7 @@
           <p:cNvPr id="4" name="">
             <a:extLst xmlns:a="http://schemas.openxmlformats.org/drawingml/2006/main">
               <a:ext uri="{FF2B5EF4-FFF2-40B4-BE49-F238E27FC236}">
-                <a16:creationId xmlns:a16="http://schemas.microsoft.com/office/drawing/2014/main" id="{67BB2306-C7EE-4791-A06A-E220E1FF59C7}"/>
+                <a16:creationId xmlns:a16="http://schemas.microsoft.com/office/drawing/2014/main" id="{DA673AA1-032A-4B60-AE47-0496C70F9129}"/>
               </a:ext>
             </a:extLst>
           </p:cNvPr>
@@ -9406,7 +9642,7 @@
           <p:cNvPr id="5" name="">
             <a:extLst xmlns:a="http://schemas.openxmlformats.org/drawingml/2006/main">
               <a:ext uri="{FF2B5EF4-FFF2-40B4-BE49-F238E27FC236}">
-                <a16:creationId xmlns:a16="http://schemas.microsoft.com/office/drawing/2014/main" id="{A8F1A77A-EB90-4D54-82A7-AC74347338D6}"/>
+                <a16:creationId xmlns:a16="http://schemas.microsoft.com/office/drawing/2014/main" id="{57A669B9-E759-48CB-B761-79A7F584D126}"/>
               </a:ext>
             </a:extLst>
           </p:cNvPr>
@@ -9461,7 +9697,7 @@
     </p:spTree>
     <p:extLst>
       <p:ext uri="{BB962C8B-B14F-4D97-AF65-F5344CB8AC3E}">
-        <p14:creationId xmlns:p14="http://schemas.microsoft.com/office/powerpoint/2010/main" val="1442526476"/>
+        <p14:creationId xmlns:p14="http://schemas.microsoft.com/office/powerpoint/2010/main" val="428767448"/>
       </p:ext>
     </p:extLst>
   </p:cSld>
@@ -9492,7 +9728,7 @@
           <p:cNvPr id="10" name="">
             <a:extLst xmlns:a="http://schemas.openxmlformats.org/drawingml/2006/main">
               <a:ext uri="{FF2B5EF4-FFF2-40B4-BE49-F238E27FC236}">
-                <a16:creationId xmlns:a16="http://schemas.microsoft.com/office/drawing/2014/main" id="{977FF872-F4A6-423D-8490-1696B7C987F5}"/>
+                <a16:creationId xmlns:a16="http://schemas.microsoft.com/office/drawing/2014/main" id="{76218BB4-D7D9-40A3-8725-B83A7D0082ED}"/>
               </a:ext>
             </a:extLst>
           </p:cNvPr>
@@ -9549,7 +9785,7 @@
           <p:cNvPr id="2" name="">
             <a:extLst xmlns:a="http://schemas.openxmlformats.org/drawingml/2006/main">
               <a:ext uri="{FF2B5EF4-FFF2-40B4-BE49-F238E27FC236}">
-                <a16:creationId xmlns:a16="http://schemas.microsoft.com/office/drawing/2014/main" id="{05CFEB77-3403-4F9F-A147-AD7FC67F5759}"/>
+                <a16:creationId xmlns:a16="http://schemas.microsoft.com/office/drawing/2014/main" id="{AB6E71D0-498C-4F6D-964C-E22218AEB57A}"/>
               </a:ext>
             </a:extLst>
           </p:cNvPr>
@@ -9606,7 +9842,7 @@
           <p:cNvPr id="3" name="">
             <a:extLst xmlns:a="http://schemas.openxmlformats.org/drawingml/2006/main">
               <a:ext uri="{FF2B5EF4-FFF2-40B4-BE49-F238E27FC236}">
-                <a16:creationId xmlns:a16="http://schemas.microsoft.com/office/drawing/2014/main" id="{6B37A2B9-7143-4386-A12F-1616A91676AA}"/>
+                <a16:creationId xmlns:a16="http://schemas.microsoft.com/office/drawing/2014/main" id="{843B60B1-A108-4751-A1FC-73F76360F495}"/>
               </a:ext>
             </a:extLst>
           </p:cNvPr>
@@ -9663,7 +9899,7 @@
           <p:cNvPr id="4" name="">
             <a:extLst xmlns:a="http://schemas.openxmlformats.org/drawingml/2006/main">
               <a:ext uri="{FF2B5EF4-FFF2-40B4-BE49-F238E27FC236}">
-                <a16:creationId xmlns:a16="http://schemas.microsoft.com/office/drawing/2014/main" id="{14962FD7-8CA4-4EBD-90AA-CB4B656E76AB}"/>
+                <a16:creationId xmlns:a16="http://schemas.microsoft.com/office/drawing/2014/main" id="{0A47DE9E-FAFA-4F23-A298-EF755FEE48D3}"/>
               </a:ext>
             </a:extLst>
           </p:cNvPr>
@@ -9720,7 +9956,7 @@
           <p:cNvPr id="5" name="">
             <a:extLst xmlns:a="http://schemas.openxmlformats.org/drawingml/2006/main">
               <a:ext uri="{FF2B5EF4-FFF2-40B4-BE49-F238E27FC236}">
-                <a16:creationId xmlns:a16="http://schemas.microsoft.com/office/drawing/2014/main" id="{DA372AF6-7E71-458B-8330-6A1B00D2A5C6}"/>
+                <a16:creationId xmlns:a16="http://schemas.microsoft.com/office/drawing/2014/main" id="{39C05C85-3316-48EE-ACE4-4A8864E8DE4A}"/>
               </a:ext>
             </a:extLst>
           </p:cNvPr>
@@ -9777,7 +10013,7 @@
           <p:cNvPr id="6" name="">
             <a:extLst xmlns:a="http://schemas.openxmlformats.org/drawingml/2006/main">
               <a:ext uri="{FF2B5EF4-FFF2-40B4-BE49-F238E27FC236}">
-                <a16:creationId xmlns:a16="http://schemas.microsoft.com/office/drawing/2014/main" id="{2069A1A6-5268-434F-9E07-179A6B1262A6}"/>
+                <a16:creationId xmlns:a16="http://schemas.microsoft.com/office/drawing/2014/main" id="{B6AF6124-DD38-4D23-A1E3-9CB3A1853801}"/>
               </a:ext>
             </a:extLst>
           </p:cNvPr>
@@ -9834,7 +10070,7 @@
           <p:cNvPr id="7" name="">
             <a:extLst xmlns:a="http://schemas.openxmlformats.org/drawingml/2006/main">
               <a:ext uri="{FF2B5EF4-FFF2-40B4-BE49-F238E27FC236}">
-                <a16:creationId xmlns:a16="http://schemas.microsoft.com/office/drawing/2014/main" id="{66846337-471F-4E4D-8D75-723AFE65D677}"/>
+                <a16:creationId xmlns:a16="http://schemas.microsoft.com/office/drawing/2014/main" id="{FEC0CEDD-48B4-4859-A120-8C2DD7E4EAD5}"/>
               </a:ext>
             </a:extLst>
           </p:cNvPr>
@@ -9891,7 +10127,7 @@
           <p:cNvPr id="8" name="">
             <a:extLst xmlns:a="http://schemas.openxmlformats.org/drawingml/2006/main">
               <a:ext uri="{FF2B5EF4-FFF2-40B4-BE49-F238E27FC236}">
-                <a16:creationId xmlns:a16="http://schemas.microsoft.com/office/drawing/2014/main" id="{43CD4721-4D7A-460A-B463-5769451A9346}"/>
+                <a16:creationId xmlns:a16="http://schemas.microsoft.com/office/drawing/2014/main" id="{5A912B70-B2A7-4CD1-8A86-AB9AD079C5AF}"/>
               </a:ext>
             </a:extLst>
           </p:cNvPr>
@@ -9948,7 +10184,7 @@
           <p:cNvPr id="9" name="">
             <a:extLst xmlns:a="http://schemas.openxmlformats.org/drawingml/2006/main">
               <a:ext uri="{FF2B5EF4-FFF2-40B4-BE49-F238E27FC236}">
-                <a16:creationId xmlns:a16="http://schemas.microsoft.com/office/drawing/2014/main" id="{097FF824-A258-4DB9-B901-5CF3D606CC16}"/>
+                <a16:creationId xmlns:a16="http://schemas.microsoft.com/office/drawing/2014/main" id="{FE3FF3B6-A8CD-43F7-847A-EE71FBBC9782}"/>
               </a:ext>
             </a:extLst>
           </p:cNvPr>
@@ -10003,7 +10239,7 @@
     </p:spTree>
     <p:extLst>
       <p:ext uri="{BB962C8B-B14F-4D97-AF65-F5344CB8AC3E}">
-        <p14:creationId xmlns:p14="http://schemas.microsoft.com/office/powerpoint/2010/main" val="376484738"/>
+        <p14:creationId xmlns:p14="http://schemas.microsoft.com/office/powerpoint/2010/main" val="507489511"/>
       </p:ext>
     </p:extLst>
   </p:cSld>
@@ -10034,7 +10270,7 @@
           <p:cNvPr id="5" name="">
             <a:extLst xmlns:a="http://schemas.openxmlformats.org/drawingml/2006/main">
               <a:ext uri="{FF2B5EF4-FFF2-40B4-BE49-F238E27FC236}">
-                <a16:creationId xmlns:a16="http://schemas.microsoft.com/office/drawing/2014/main" id="{264AA7FC-05A8-4CB2-A207-92F89D4F4A56}"/>
+                <a16:creationId xmlns:a16="http://schemas.microsoft.com/office/drawing/2014/main" id="{2A17B06D-503B-4512-B32B-3A9A542FB96A}"/>
               </a:ext>
             </a:extLst>
           </p:cNvPr>
@@ -10393,7 +10629,7 @@
                           <a:ea typeface="Arial"/>
                           <a:cs typeface="Arial"/>
                         </a:rPr>
-                        <a:t>15 main slides; 7-minute demo; 16 appendix slides</a:t>
+                        <a:t>15 main slides; 7-minute demo; 17 appendix slides</a:t>
                       </a:r>
                     </a:p>
                   </a:txBody>
@@ -10413,7 +10649,7 @@
           <p:cNvPr id="3" name="">
             <a:extLst xmlns:a="http://schemas.openxmlformats.org/drawingml/2006/main">
               <a:ext uri="{FF2B5EF4-FFF2-40B4-BE49-F238E27FC236}">
-                <a16:creationId xmlns:a16="http://schemas.microsoft.com/office/drawing/2014/main" id="{4BBFD0A3-EEB7-4E7A-A653-ACCF3E54E6A8}"/>
+                <a16:creationId xmlns:a16="http://schemas.microsoft.com/office/drawing/2014/main" id="{2062D805-D68D-4E65-B4B0-B5D5646360FB}"/>
               </a:ext>
             </a:extLst>
           </p:cNvPr>
@@ -10470,7 +10706,7 @@
           <p:cNvPr id="4" name="">
             <a:extLst xmlns:a="http://schemas.openxmlformats.org/drawingml/2006/main">
               <a:ext uri="{FF2B5EF4-FFF2-40B4-BE49-F238E27FC236}">
-                <a16:creationId xmlns:a16="http://schemas.microsoft.com/office/drawing/2014/main" id="{AEB91C04-F3D0-47C3-A784-427B713E4937}"/>
+                <a16:creationId xmlns:a16="http://schemas.microsoft.com/office/drawing/2014/main" id="{C346D22B-63A4-4762-AFF9-A84A3A8CCCC9}"/>
               </a:ext>
             </a:extLst>
           </p:cNvPr>
@@ -10525,7 +10761,7 @@
     </p:spTree>
     <p:extLst>
       <p:ext uri="{BB962C8B-B14F-4D97-AF65-F5344CB8AC3E}">
-        <p14:creationId xmlns:p14="http://schemas.microsoft.com/office/powerpoint/2010/main" val="161128596"/>
+        <p14:creationId xmlns:p14="http://schemas.microsoft.com/office/powerpoint/2010/main" val="652484674"/>
       </p:ext>
     </p:extLst>
   </p:cSld>
@@ -10556,7 +10792,7 @@
           <p:cNvPr id="5" name="">
             <a:extLst xmlns:a="http://schemas.openxmlformats.org/drawingml/2006/main">
               <a:ext uri="{FF2B5EF4-FFF2-40B4-BE49-F238E27FC236}">
-                <a16:creationId xmlns:a16="http://schemas.microsoft.com/office/drawing/2014/main" id="{02499DAE-A04E-4DF3-8BF4-480B413082BE}"/>
+                <a16:creationId xmlns:a16="http://schemas.microsoft.com/office/drawing/2014/main" id="{3CA7FA0D-AB95-440B-A07F-093E795BA477}"/>
               </a:ext>
             </a:extLst>
           </p:cNvPr>
@@ -10613,7 +10849,7 @@
           <p:cNvPr id="2" name="">
             <a:extLst xmlns:a="http://schemas.openxmlformats.org/drawingml/2006/main">
               <a:ext uri="{FF2B5EF4-FFF2-40B4-BE49-F238E27FC236}">
-                <a16:creationId xmlns:a16="http://schemas.microsoft.com/office/drawing/2014/main" id="{324EED81-C7F4-4B6F-B301-3093C94AF685}"/>
+                <a16:creationId xmlns:a16="http://schemas.microsoft.com/office/drawing/2014/main" id="{E827F966-D792-4580-93CE-87C91AAADFFA}"/>
               </a:ext>
             </a:extLst>
           </p:cNvPr>
@@ -10790,7 +11026,7 @@
           <p:cNvPr id="3" name="">
             <a:extLst xmlns:a="http://schemas.openxmlformats.org/drawingml/2006/main">
               <a:ext uri="{FF2B5EF4-FFF2-40B4-BE49-F238E27FC236}">
-                <a16:creationId xmlns:a16="http://schemas.microsoft.com/office/drawing/2014/main" id="{9932A0AB-036A-488D-B57B-37BE5B0BA542}"/>
+                <a16:creationId xmlns:a16="http://schemas.microsoft.com/office/drawing/2014/main" id="{3DE4DA3C-36D1-4FCC-8B93-E33AC12E44FD}"/>
               </a:ext>
             </a:extLst>
           </p:cNvPr>
@@ -10847,7 +11083,7 @@
           <p:cNvPr id="4" name="">
             <a:extLst xmlns:a="http://schemas.openxmlformats.org/drawingml/2006/main">
               <a:ext uri="{FF2B5EF4-FFF2-40B4-BE49-F238E27FC236}">
-                <a16:creationId xmlns:a16="http://schemas.microsoft.com/office/drawing/2014/main" id="{22A9B1E7-AF25-4076-A536-824784B5C8A1}"/>
+                <a16:creationId xmlns:a16="http://schemas.microsoft.com/office/drawing/2014/main" id="{0A0085EC-D200-4B65-ADE9-71CC133A46C7}"/>
               </a:ext>
             </a:extLst>
           </p:cNvPr>
@@ -10902,7 +11138,7 @@
     </p:spTree>
     <p:extLst>
       <p:ext uri="{BB962C8B-B14F-4D97-AF65-F5344CB8AC3E}">
-        <p14:creationId xmlns:p14="http://schemas.microsoft.com/office/powerpoint/2010/main" val="1175507891"/>
+        <p14:creationId xmlns:p14="http://schemas.microsoft.com/office/powerpoint/2010/main" val="1167939322"/>
       </p:ext>
     </p:extLst>
   </p:cSld>
@@ -10933,7 +11169,7 @@
           <p:cNvPr id="12" name="">
             <a:extLst xmlns:a="http://schemas.openxmlformats.org/drawingml/2006/main">
               <a:ext uri="{FF2B5EF4-FFF2-40B4-BE49-F238E27FC236}">
-                <a16:creationId xmlns:a16="http://schemas.microsoft.com/office/drawing/2014/main" id="{4F0B6593-5B1F-4719-B87F-B1A42DECB87B}"/>
+                <a16:creationId xmlns:a16="http://schemas.microsoft.com/office/drawing/2014/main" id="{9CD7A1BB-8FE5-40F8-BDB6-D98E620D3F9C}"/>
               </a:ext>
             </a:extLst>
           </p:cNvPr>
@@ -10994,7 +11230,7 @@
           <p:nvPr/>
         </p:nvPicPr>
         <p:blipFill>
-          <a:blip xmlns:r="http://schemas.openxmlformats.org/officeDocument/2006/relationships" xmlns:a="http://schemas.openxmlformats.org/drawingml/2006/main" r:embed="R349941e9a6984b49"/>
+          <a:blip xmlns:r="http://schemas.openxmlformats.org/officeDocument/2006/relationships" xmlns:a="http://schemas.openxmlformats.org/drawingml/2006/main" r:embed="R53aa9368849c4215"/>
           <a:stretch xmlns:a="http://schemas.openxmlformats.org/drawingml/2006/main"/>
         </p:blipFill>
         <p:spPr>
@@ -11016,7 +11252,7 @@
           <p:nvPr/>
         </p:nvPicPr>
         <p:blipFill>
-          <a:blip xmlns:r="http://schemas.openxmlformats.org/officeDocument/2006/relationships" xmlns:a="http://schemas.openxmlformats.org/drawingml/2006/main" r:embed="Re76e0315948e493f"/>
+          <a:blip xmlns:r="http://schemas.openxmlformats.org/officeDocument/2006/relationships" xmlns:a="http://schemas.openxmlformats.org/drawingml/2006/main" r:embed="Ra8349924904c44a2"/>
           <a:stretch xmlns:a="http://schemas.openxmlformats.org/drawingml/2006/main"/>
         </p:blipFill>
         <p:spPr>
@@ -11034,7 +11270,7 @@
           <p:cNvPr id="4" name="">
             <a:extLst xmlns:a="http://schemas.openxmlformats.org/drawingml/2006/main">
               <a:ext uri="{FF2B5EF4-FFF2-40B4-BE49-F238E27FC236}">
-                <a16:creationId xmlns:a16="http://schemas.microsoft.com/office/drawing/2014/main" id="{A421A570-BE8A-4DA1-9477-1D10B9BCB57A}"/>
+                <a16:creationId xmlns:a16="http://schemas.microsoft.com/office/drawing/2014/main" id="{BB37C659-B8D8-4E96-889E-CFDD31D837D8}"/>
               </a:ext>
             </a:extLst>
           </p:cNvPr>
@@ -11091,7 +11327,7 @@
           <p:cNvPr id="5" name="">
             <a:extLst xmlns:a="http://schemas.openxmlformats.org/drawingml/2006/main">
               <a:ext uri="{FF2B5EF4-FFF2-40B4-BE49-F238E27FC236}">
-                <a16:creationId xmlns:a16="http://schemas.microsoft.com/office/drawing/2014/main" id="{311158E8-F978-4525-A276-B9A5BE87FDF2}"/>
+                <a16:creationId xmlns:a16="http://schemas.microsoft.com/office/drawing/2014/main" id="{107D74B2-7D02-4C9C-A404-223EBCD3DE17}"/>
               </a:ext>
             </a:extLst>
           </p:cNvPr>
@@ -11148,7 +11384,7 @@
           <p:cNvPr id="6" name="">
             <a:extLst xmlns:a="http://schemas.openxmlformats.org/drawingml/2006/main">
               <a:ext uri="{FF2B5EF4-FFF2-40B4-BE49-F238E27FC236}">
-                <a16:creationId xmlns:a16="http://schemas.microsoft.com/office/drawing/2014/main" id="{A772E0EC-C02F-49C6-AD23-3AB8D8B76EA6}"/>
+                <a16:creationId xmlns:a16="http://schemas.microsoft.com/office/drawing/2014/main" id="{DA59ACE5-27AC-440B-AC48-FD3EFE120F36}"/>
               </a:ext>
             </a:extLst>
           </p:cNvPr>
@@ -11228,7 +11464,7 @@
           <p:cNvPr id="7" name="">
             <a:extLst xmlns:a="http://schemas.openxmlformats.org/drawingml/2006/main">
               <a:ext uri="{FF2B5EF4-FFF2-40B4-BE49-F238E27FC236}">
-                <a16:creationId xmlns:a16="http://schemas.microsoft.com/office/drawing/2014/main" id="{49ECF6E7-962A-450E-B24B-131BF55C9B04}"/>
+                <a16:creationId xmlns:a16="http://schemas.microsoft.com/office/drawing/2014/main" id="{BA3F602D-74A6-47B7-B022-C5AFCE20391C}"/>
               </a:ext>
             </a:extLst>
           </p:cNvPr>
@@ -11285,7 +11521,7 @@
           <p:cNvPr id="8" name="">
             <a:extLst xmlns:a="http://schemas.openxmlformats.org/drawingml/2006/main">
               <a:ext uri="{FF2B5EF4-FFF2-40B4-BE49-F238E27FC236}">
-                <a16:creationId xmlns:a16="http://schemas.microsoft.com/office/drawing/2014/main" id="{5B3DD810-CC1D-4E82-BBA9-72C696C2BA01}"/>
+                <a16:creationId xmlns:a16="http://schemas.microsoft.com/office/drawing/2014/main" id="{30307286-6750-417F-AEAD-55937059ED2A}"/>
               </a:ext>
             </a:extLst>
           </p:cNvPr>
@@ -11342,7 +11578,7 @@
           <p:cNvPr id="9" name="">
             <a:extLst xmlns:a="http://schemas.openxmlformats.org/drawingml/2006/main">
               <a:ext uri="{FF2B5EF4-FFF2-40B4-BE49-F238E27FC236}">
-                <a16:creationId xmlns:a16="http://schemas.microsoft.com/office/drawing/2014/main" id="{2E4C442A-318C-4673-A742-C1A429BDA927}"/>
+                <a16:creationId xmlns:a16="http://schemas.microsoft.com/office/drawing/2014/main" id="{467180A2-393C-4943-93B5-3D69A6B5C7F9}"/>
               </a:ext>
             </a:extLst>
           </p:cNvPr>
@@ -11399,7 +11635,7 @@
           <p:cNvPr id="10" name="">
             <a:extLst xmlns:a="http://schemas.openxmlformats.org/drawingml/2006/main">
               <a:ext uri="{FF2B5EF4-FFF2-40B4-BE49-F238E27FC236}">
-                <a16:creationId xmlns:a16="http://schemas.microsoft.com/office/drawing/2014/main" id="{46AB35AA-A63F-4547-8DFB-469F612E13EC}"/>
+                <a16:creationId xmlns:a16="http://schemas.microsoft.com/office/drawing/2014/main" id="{D3347670-7349-403E-86ED-2821AB871264}"/>
               </a:ext>
             </a:extLst>
           </p:cNvPr>
@@ -11456,7 +11692,7 @@
           <p:cNvPr id="11" name="">
             <a:extLst xmlns:a="http://schemas.openxmlformats.org/drawingml/2006/main">
               <a:ext uri="{FF2B5EF4-FFF2-40B4-BE49-F238E27FC236}">
-                <a16:creationId xmlns:a16="http://schemas.microsoft.com/office/drawing/2014/main" id="{9ED1A5B6-8069-452F-A92B-EB7A9DE04736}"/>
+                <a16:creationId xmlns:a16="http://schemas.microsoft.com/office/drawing/2014/main" id="{6F969228-7BF8-4C24-9978-E690C8FCF8F3}"/>
               </a:ext>
             </a:extLst>
           </p:cNvPr>
@@ -11511,7 +11747,7 @@
     </p:spTree>
     <p:extLst>
       <p:ext uri="{BB962C8B-B14F-4D97-AF65-F5344CB8AC3E}">
-        <p14:creationId xmlns:p14="http://schemas.microsoft.com/office/powerpoint/2010/main" val="250057367"/>
+        <p14:creationId xmlns:p14="http://schemas.microsoft.com/office/powerpoint/2010/main" val="220408299"/>
       </p:ext>
     </p:extLst>
   </p:cSld>
@@ -11542,7 +11778,7 @@
           <p:cNvPr id="9" name="">
             <a:extLst xmlns:a="http://schemas.openxmlformats.org/drawingml/2006/main">
               <a:ext uri="{FF2B5EF4-FFF2-40B4-BE49-F238E27FC236}">
-                <a16:creationId xmlns:a16="http://schemas.microsoft.com/office/drawing/2014/main" id="{ACF3F247-DDDB-4A63-9639-EDDEEC4D3AB7}"/>
+                <a16:creationId xmlns:a16="http://schemas.microsoft.com/office/drawing/2014/main" id="{EA07B244-ECC2-4742-8FD2-E9544EC87BA8}"/>
               </a:ext>
             </a:extLst>
           </p:cNvPr>
@@ -11599,7 +11835,7 @@
           <p:cNvPr id="2" name="">
             <a:extLst xmlns:a="http://schemas.openxmlformats.org/drawingml/2006/main">
               <a:ext uri="{FF2B5EF4-FFF2-40B4-BE49-F238E27FC236}">
-                <a16:creationId xmlns:a16="http://schemas.microsoft.com/office/drawing/2014/main" id="{1EAF55BF-7EA6-4047-B472-C6A1DADA6B5F}"/>
+                <a16:creationId xmlns:a16="http://schemas.microsoft.com/office/drawing/2014/main" id="{39D09F26-87CE-4838-B831-4B67AD413174}"/>
               </a:ext>
             </a:extLst>
           </p:cNvPr>
@@ -11656,7 +11892,7 @@
           <p:cNvPr id="3" name="">
             <a:extLst xmlns:a="http://schemas.openxmlformats.org/drawingml/2006/main">
               <a:ext uri="{FF2B5EF4-FFF2-40B4-BE49-F238E27FC236}">
-                <a16:creationId xmlns:a16="http://schemas.microsoft.com/office/drawing/2014/main" id="{B1FBEE24-FA83-4BA1-964C-0AE25197FF2C}"/>
+                <a16:creationId xmlns:a16="http://schemas.microsoft.com/office/drawing/2014/main" id="{E469B88D-C505-4C3B-9739-99CDF1894C9F}"/>
               </a:ext>
             </a:extLst>
           </p:cNvPr>
@@ -11713,7 +11949,7 @@
           <p:cNvPr id="4" name="">
             <a:extLst xmlns:a="http://schemas.openxmlformats.org/drawingml/2006/main">
               <a:ext uri="{FF2B5EF4-FFF2-40B4-BE49-F238E27FC236}">
-                <a16:creationId xmlns:a16="http://schemas.microsoft.com/office/drawing/2014/main" id="{8D332FF1-32EA-4908-9EE2-A070D8F53849}"/>
+                <a16:creationId xmlns:a16="http://schemas.microsoft.com/office/drawing/2014/main" id="{9EB2AD8C-7C4A-4FFC-A24F-8AAD59DD0096}"/>
               </a:ext>
             </a:extLst>
           </p:cNvPr>
@@ -11770,7 +12006,7 @@
           <p:cNvPr id="5" name="">
             <a:extLst xmlns:a="http://schemas.openxmlformats.org/drawingml/2006/main">
               <a:ext uri="{FF2B5EF4-FFF2-40B4-BE49-F238E27FC236}">
-                <a16:creationId xmlns:a16="http://schemas.microsoft.com/office/drawing/2014/main" id="{2275920B-539E-4C50-A5BA-84CA37604AD0}"/>
+                <a16:creationId xmlns:a16="http://schemas.microsoft.com/office/drawing/2014/main" id="{740BCD41-6E04-449A-895B-F758FE10C72E}"/>
               </a:ext>
             </a:extLst>
           </p:cNvPr>
@@ -11827,7 +12063,7 @@
           <p:cNvPr id="6" name="">
             <a:extLst xmlns:a="http://schemas.openxmlformats.org/drawingml/2006/main">
               <a:ext uri="{FF2B5EF4-FFF2-40B4-BE49-F238E27FC236}">
-                <a16:creationId xmlns:a16="http://schemas.microsoft.com/office/drawing/2014/main" id="{8824434F-31E0-409F-9896-9DA68549A478}"/>
+                <a16:creationId xmlns:a16="http://schemas.microsoft.com/office/drawing/2014/main" id="{F53A4421-11AD-46D2-BEB2-3B67E863076B}"/>
               </a:ext>
             </a:extLst>
           </p:cNvPr>
@@ -11884,7 +12120,7 @@
           <p:cNvPr id="7" name="">
             <a:extLst xmlns:a="http://schemas.openxmlformats.org/drawingml/2006/main">
               <a:ext uri="{FF2B5EF4-FFF2-40B4-BE49-F238E27FC236}">
-                <a16:creationId xmlns:a16="http://schemas.microsoft.com/office/drawing/2014/main" id="{72290381-9BE1-46B2-A1DD-25DB05E74F2B}"/>
+                <a16:creationId xmlns:a16="http://schemas.microsoft.com/office/drawing/2014/main" id="{52834EE7-7F42-4B1F-AA62-02B16836D51C}"/>
               </a:ext>
             </a:extLst>
           </p:cNvPr>
@@ -11941,7 +12177,7 @@
           <p:cNvPr id="8" name="">
             <a:extLst xmlns:a="http://schemas.openxmlformats.org/drawingml/2006/main">
               <a:ext uri="{FF2B5EF4-FFF2-40B4-BE49-F238E27FC236}">
-                <a16:creationId xmlns:a16="http://schemas.microsoft.com/office/drawing/2014/main" id="{C118132B-ED12-4E9B-A1CE-CFBC0DDE204A}"/>
+                <a16:creationId xmlns:a16="http://schemas.microsoft.com/office/drawing/2014/main" id="{160A957A-362A-4DB2-AD58-CE8E8E90BD93}"/>
               </a:ext>
             </a:extLst>
           </p:cNvPr>
@@ -11996,7 +12232,7 @@
     </p:spTree>
     <p:extLst>
       <p:ext uri="{BB962C8B-B14F-4D97-AF65-F5344CB8AC3E}">
-        <p14:creationId xmlns:p14="http://schemas.microsoft.com/office/powerpoint/2010/main" val="651066066"/>
+        <p14:creationId xmlns:p14="http://schemas.microsoft.com/office/powerpoint/2010/main" val="1995028778"/>
       </p:ext>
     </p:extLst>
   </p:cSld>
@@ -12027,7 +12263,7 @@
           <p:cNvPr id="7" name="">
             <a:extLst xmlns:a="http://schemas.openxmlformats.org/drawingml/2006/main">
               <a:ext uri="{FF2B5EF4-FFF2-40B4-BE49-F238E27FC236}">
-                <a16:creationId xmlns:a16="http://schemas.microsoft.com/office/drawing/2014/main" id="{9DFA0845-B9AB-466F-A60C-C3ECF0BC1E7A}"/>
+                <a16:creationId xmlns:a16="http://schemas.microsoft.com/office/drawing/2014/main" id="{4B17F7A7-96BE-486E-B487-E1FF3AF118FA}"/>
               </a:ext>
             </a:extLst>
           </p:cNvPr>
@@ -12355,7 +12591,7 @@
           <p:cNvPr id="3" name="">
             <a:extLst xmlns:a="http://schemas.openxmlformats.org/drawingml/2006/main">
               <a:ext uri="{FF2B5EF4-FFF2-40B4-BE49-F238E27FC236}">
-                <a16:creationId xmlns:a16="http://schemas.microsoft.com/office/drawing/2014/main" id="{8DA8AF90-2122-4581-81A2-1B1EFB4DA4F4}"/>
+                <a16:creationId xmlns:a16="http://schemas.microsoft.com/office/drawing/2014/main" id="{1F9E5C77-138A-4C81-8EA9-82D53CDA03E9}"/>
               </a:ext>
             </a:extLst>
           </p:cNvPr>
@@ -12412,7 +12648,7 @@
           <p:cNvPr id="4" name="">
             <a:extLst xmlns:a="http://schemas.openxmlformats.org/drawingml/2006/main">
               <a:ext uri="{FF2B5EF4-FFF2-40B4-BE49-F238E27FC236}">
-                <a16:creationId xmlns:a16="http://schemas.microsoft.com/office/drawing/2014/main" id="{E8FF203B-5B16-4444-A5AF-1A3DBCEB075F}"/>
+                <a16:creationId xmlns:a16="http://schemas.microsoft.com/office/drawing/2014/main" id="{8ECF002B-C1D3-4686-83F8-FC6FE11CFED4}"/>
               </a:ext>
             </a:extLst>
           </p:cNvPr>
@@ -12469,7 +12705,7 @@
           <p:cNvPr id="5" name="">
             <a:extLst xmlns:a="http://schemas.openxmlformats.org/drawingml/2006/main">
               <a:ext uri="{FF2B5EF4-FFF2-40B4-BE49-F238E27FC236}">
-                <a16:creationId xmlns:a16="http://schemas.microsoft.com/office/drawing/2014/main" id="{FD993375-1DEE-406C-9101-38C1C146BC32}"/>
+                <a16:creationId xmlns:a16="http://schemas.microsoft.com/office/drawing/2014/main" id="{FD840BD7-11B6-48F1-A5E1-AAA106BBE647}"/>
               </a:ext>
             </a:extLst>
           </p:cNvPr>
@@ -12526,7 +12762,7 @@
           <p:cNvPr id="6" name="">
             <a:extLst xmlns:a="http://schemas.openxmlformats.org/drawingml/2006/main">
               <a:ext uri="{FF2B5EF4-FFF2-40B4-BE49-F238E27FC236}">
-                <a16:creationId xmlns:a16="http://schemas.microsoft.com/office/drawing/2014/main" id="{DCDD88E9-CA57-4D1D-A44E-1D8E55F3D04C}"/>
+                <a16:creationId xmlns:a16="http://schemas.microsoft.com/office/drawing/2014/main" id="{1FD39FF5-7A01-4089-AC7E-3E7A5B02F90A}"/>
               </a:ext>
             </a:extLst>
           </p:cNvPr>
@@ -12581,7 +12817,7 @@
     </p:spTree>
     <p:extLst>
       <p:ext uri="{BB962C8B-B14F-4D97-AF65-F5344CB8AC3E}">
-        <p14:creationId xmlns:p14="http://schemas.microsoft.com/office/powerpoint/2010/main" val="133682894"/>
+        <p14:creationId xmlns:p14="http://schemas.microsoft.com/office/powerpoint/2010/main" val="1436861644"/>
       </p:ext>
     </p:extLst>
   </p:cSld>
@@ -12612,7 +12848,7 @@
           <p:cNvPr id="7" name="">
             <a:extLst xmlns:a="http://schemas.openxmlformats.org/drawingml/2006/main">
               <a:ext uri="{FF2B5EF4-FFF2-40B4-BE49-F238E27FC236}">
-                <a16:creationId xmlns:a16="http://schemas.microsoft.com/office/drawing/2014/main" id="{E9C867C3-CAE9-44F3-A7AD-449818DF619C}"/>
+                <a16:creationId xmlns:a16="http://schemas.microsoft.com/office/drawing/2014/main" id="{4BAC56D0-85AF-4605-B151-8BFE9C6A7CB5}"/>
               </a:ext>
             </a:extLst>
           </p:cNvPr>
@@ -12988,7 +13224,7 @@
           <p:cNvPr id="3" name="">
             <a:extLst xmlns:a="http://schemas.openxmlformats.org/drawingml/2006/main">
               <a:ext uri="{FF2B5EF4-FFF2-40B4-BE49-F238E27FC236}">
-                <a16:creationId xmlns:a16="http://schemas.microsoft.com/office/drawing/2014/main" id="{D66B9DFF-812C-4441-BD02-8A27C3642193}"/>
+                <a16:creationId xmlns:a16="http://schemas.microsoft.com/office/drawing/2014/main" id="{62F46BED-4057-49C6-A22E-33FAF3C3C844}"/>
               </a:ext>
             </a:extLst>
           </p:cNvPr>
@@ -13045,7 +13281,7 @@
           <p:cNvPr id="4" name="">
             <a:extLst xmlns:a="http://schemas.openxmlformats.org/drawingml/2006/main">
               <a:ext uri="{FF2B5EF4-FFF2-40B4-BE49-F238E27FC236}">
-                <a16:creationId xmlns:a16="http://schemas.microsoft.com/office/drawing/2014/main" id="{72381DAA-3FC1-4243-A690-7185363BC4C1}"/>
+                <a16:creationId xmlns:a16="http://schemas.microsoft.com/office/drawing/2014/main" id="{800E3F99-D052-46FD-B83A-2951350D35A6}"/>
               </a:ext>
             </a:extLst>
           </p:cNvPr>
@@ -13102,7 +13338,7 @@
           <p:cNvPr id="5" name="">
             <a:extLst xmlns:a="http://schemas.openxmlformats.org/drawingml/2006/main">
               <a:ext uri="{FF2B5EF4-FFF2-40B4-BE49-F238E27FC236}">
-                <a16:creationId xmlns:a16="http://schemas.microsoft.com/office/drawing/2014/main" id="{21E3159F-18EC-47FD-A81D-D9DE950C450C}"/>
+                <a16:creationId xmlns:a16="http://schemas.microsoft.com/office/drawing/2014/main" id="{6F6E02DA-1E6E-4451-B447-4634705E7998}"/>
               </a:ext>
             </a:extLst>
           </p:cNvPr>
@@ -13159,7 +13395,7 @@
           <p:cNvPr id="6" name="">
             <a:extLst xmlns:a="http://schemas.openxmlformats.org/drawingml/2006/main">
               <a:ext uri="{FF2B5EF4-FFF2-40B4-BE49-F238E27FC236}">
-                <a16:creationId xmlns:a16="http://schemas.microsoft.com/office/drawing/2014/main" id="{B2A0F17C-6C97-415C-86FF-494C26651D5C}"/>
+                <a16:creationId xmlns:a16="http://schemas.microsoft.com/office/drawing/2014/main" id="{336CF50D-C13C-414E-BFA2-65A67CEC824A}"/>
               </a:ext>
             </a:extLst>
           </p:cNvPr>
@@ -13214,7 +13450,7 @@
     </p:spTree>
     <p:extLst>
       <p:ext uri="{BB962C8B-B14F-4D97-AF65-F5344CB8AC3E}">
-        <p14:creationId xmlns:p14="http://schemas.microsoft.com/office/powerpoint/2010/main" val="1176373197"/>
+        <p14:creationId xmlns:p14="http://schemas.microsoft.com/office/powerpoint/2010/main" val="745499933"/>
       </p:ext>
     </p:extLst>
   </p:cSld>
@@ -13245,7 +13481,7 @@
           <p:cNvPr id="5" name="">
             <a:extLst xmlns:a="http://schemas.openxmlformats.org/drawingml/2006/main">
               <a:ext uri="{FF2B5EF4-FFF2-40B4-BE49-F238E27FC236}">
-                <a16:creationId xmlns:a16="http://schemas.microsoft.com/office/drawing/2014/main" id="{70147C84-E8BE-4F90-ABA3-3E615B9F43BD}"/>
+                <a16:creationId xmlns:a16="http://schemas.microsoft.com/office/drawing/2014/main" id="{D56FC8CC-4DC3-4F00-8D59-CC422B511833}"/>
               </a:ext>
             </a:extLst>
           </p:cNvPr>
@@ -13524,7 +13760,7 @@
           <p:cNvPr id="3" name="">
             <a:extLst xmlns:a="http://schemas.openxmlformats.org/drawingml/2006/main">
               <a:ext uri="{FF2B5EF4-FFF2-40B4-BE49-F238E27FC236}">
-                <a16:creationId xmlns:a16="http://schemas.microsoft.com/office/drawing/2014/main" id="{ED35CB17-183A-44CB-8C4F-0916418654CB}"/>
+                <a16:creationId xmlns:a16="http://schemas.microsoft.com/office/drawing/2014/main" id="{EBEE81B8-427A-47CE-A8F1-4E749D9C9939}"/>
               </a:ext>
             </a:extLst>
           </p:cNvPr>
@@ -13581,7 +13817,7 @@
           <p:cNvPr id="4" name="">
             <a:extLst xmlns:a="http://schemas.openxmlformats.org/drawingml/2006/main">
               <a:ext uri="{FF2B5EF4-FFF2-40B4-BE49-F238E27FC236}">
-                <a16:creationId xmlns:a16="http://schemas.microsoft.com/office/drawing/2014/main" id="{4C0288AB-7B5D-4341-A476-5C43621F413F}"/>
+                <a16:creationId xmlns:a16="http://schemas.microsoft.com/office/drawing/2014/main" id="{56F4AAD6-E5FA-416F-8899-0939D65A4B8B}"/>
               </a:ext>
             </a:extLst>
           </p:cNvPr>
@@ -13636,7 +13872,7 @@
     </p:spTree>
     <p:extLst>
       <p:ext uri="{BB962C8B-B14F-4D97-AF65-F5344CB8AC3E}">
-        <p14:creationId xmlns:p14="http://schemas.microsoft.com/office/powerpoint/2010/main" val="551304386"/>
+        <p14:creationId xmlns:p14="http://schemas.microsoft.com/office/powerpoint/2010/main" val="1752884258"/>
       </p:ext>
     </p:extLst>
   </p:cSld>
@@ -13667,7 +13903,7 @@
           <p:cNvPr id="5" name="">
             <a:extLst xmlns:a="http://schemas.openxmlformats.org/drawingml/2006/main">
               <a:ext uri="{FF2B5EF4-FFF2-40B4-BE49-F238E27FC236}">
-                <a16:creationId xmlns:a16="http://schemas.microsoft.com/office/drawing/2014/main" id="{78602848-A596-4E11-8F04-4131E733DD00}"/>
+                <a16:creationId xmlns:a16="http://schemas.microsoft.com/office/drawing/2014/main" id="{76C68A8D-17EE-47C0-8C79-3FC2819037D1}"/>
               </a:ext>
             </a:extLst>
           </p:cNvPr>
@@ -13946,7 +14182,7 @@
           <p:cNvPr id="3" name="">
             <a:extLst xmlns:a="http://schemas.openxmlformats.org/drawingml/2006/main">
               <a:ext uri="{FF2B5EF4-FFF2-40B4-BE49-F238E27FC236}">
-                <a16:creationId xmlns:a16="http://schemas.microsoft.com/office/drawing/2014/main" id="{3FC928F5-4CAD-4168-B8AA-8C6335C106F3}"/>
+                <a16:creationId xmlns:a16="http://schemas.microsoft.com/office/drawing/2014/main" id="{6C86F1FD-B867-4CA9-AE3F-FB52273F41BE}"/>
               </a:ext>
             </a:extLst>
           </p:cNvPr>
@@ -14003,7 +14239,7 @@
           <p:cNvPr id="4" name="">
             <a:extLst xmlns:a="http://schemas.openxmlformats.org/drawingml/2006/main">
               <a:ext uri="{FF2B5EF4-FFF2-40B4-BE49-F238E27FC236}">
-                <a16:creationId xmlns:a16="http://schemas.microsoft.com/office/drawing/2014/main" id="{E030C0DB-3174-4373-8640-0B6F370150B9}"/>
+                <a16:creationId xmlns:a16="http://schemas.microsoft.com/office/drawing/2014/main" id="{2CF59B1D-780F-4E78-BEB0-7AC134A91CFA}"/>
               </a:ext>
             </a:extLst>
           </p:cNvPr>
@@ -14058,7 +14294,7 @@
     </p:spTree>
     <p:extLst>
       <p:ext uri="{BB962C8B-B14F-4D97-AF65-F5344CB8AC3E}">
-        <p14:creationId xmlns:p14="http://schemas.microsoft.com/office/powerpoint/2010/main" val="248176847"/>
+        <p14:creationId xmlns:p14="http://schemas.microsoft.com/office/powerpoint/2010/main" val="130690183"/>
       </p:ext>
     </p:extLst>
   </p:cSld>
@@ -14089,7 +14325,7 @@
           <p:cNvPr id="5" name="">
             <a:extLst xmlns:a="http://schemas.openxmlformats.org/drawingml/2006/main">
               <a:ext uri="{FF2B5EF4-FFF2-40B4-BE49-F238E27FC236}">
-                <a16:creationId xmlns:a16="http://schemas.microsoft.com/office/drawing/2014/main" id="{10D3A628-046F-41A7-8C94-C93C69D555B9}"/>
+                <a16:creationId xmlns:a16="http://schemas.microsoft.com/office/drawing/2014/main" id="{535DA540-EAAF-45B3-BD31-F5BACDD6CCF6}"/>
               </a:ext>
             </a:extLst>
           </p:cNvPr>
@@ -14368,7 +14604,7 @@
           <p:cNvPr id="3" name="">
             <a:extLst xmlns:a="http://schemas.openxmlformats.org/drawingml/2006/main">
               <a:ext uri="{FF2B5EF4-FFF2-40B4-BE49-F238E27FC236}">
-                <a16:creationId xmlns:a16="http://schemas.microsoft.com/office/drawing/2014/main" id="{BF7F8B3F-33ED-4774-84FD-0A6FB4E851E5}"/>
+                <a16:creationId xmlns:a16="http://schemas.microsoft.com/office/drawing/2014/main" id="{FACFFA5C-F5F4-44EA-A02E-E493AF4A7624}"/>
               </a:ext>
             </a:extLst>
           </p:cNvPr>
@@ -14425,7 +14661,7 @@
           <p:cNvPr id="4" name="">
             <a:extLst xmlns:a="http://schemas.openxmlformats.org/drawingml/2006/main">
               <a:ext uri="{FF2B5EF4-FFF2-40B4-BE49-F238E27FC236}">
-                <a16:creationId xmlns:a16="http://schemas.microsoft.com/office/drawing/2014/main" id="{3AD134AD-E22F-45FB-A1CC-48D6FAE6BC8A}"/>
+                <a16:creationId xmlns:a16="http://schemas.microsoft.com/office/drawing/2014/main" id="{0ACC60CE-9F92-4CAD-B365-2DF98E95EDC6}"/>
               </a:ext>
             </a:extLst>
           </p:cNvPr>
@@ -14480,7 +14716,7 @@
     </p:spTree>
     <p:extLst>
       <p:ext uri="{BB962C8B-B14F-4D97-AF65-F5344CB8AC3E}">
-        <p14:creationId xmlns:p14="http://schemas.microsoft.com/office/powerpoint/2010/main" val="854144057"/>
+        <p14:creationId xmlns:p14="http://schemas.microsoft.com/office/powerpoint/2010/main" val="1769665292"/>
       </p:ext>
     </p:extLst>
   </p:cSld>
@@ -14511,7 +14747,7 @@
           <p:cNvPr id="5" name="">
             <a:extLst xmlns:a="http://schemas.openxmlformats.org/drawingml/2006/main">
               <a:ext uri="{FF2B5EF4-FFF2-40B4-BE49-F238E27FC236}">
-                <a16:creationId xmlns:a16="http://schemas.microsoft.com/office/drawing/2014/main" id="{6163760C-136E-4625-B8E9-AAB844049AD1}"/>
+                <a16:creationId xmlns:a16="http://schemas.microsoft.com/office/drawing/2014/main" id="{41DA46E6-1054-4F8C-B131-690FDD70447F}"/>
               </a:ext>
             </a:extLst>
           </p:cNvPr>
@@ -14790,7 +15026,7 @@
           <p:cNvPr id="3" name="">
             <a:extLst xmlns:a="http://schemas.openxmlformats.org/drawingml/2006/main">
               <a:ext uri="{FF2B5EF4-FFF2-40B4-BE49-F238E27FC236}">
-                <a16:creationId xmlns:a16="http://schemas.microsoft.com/office/drawing/2014/main" id="{FFBD9758-D453-42C4-BCE5-9814F1418365}"/>
+                <a16:creationId xmlns:a16="http://schemas.microsoft.com/office/drawing/2014/main" id="{9F1D2AFC-154E-4692-AC27-090ED6A5CB2E}"/>
               </a:ext>
             </a:extLst>
           </p:cNvPr>
@@ -14847,7 +15083,7 @@
           <p:cNvPr id="4" name="">
             <a:extLst xmlns:a="http://schemas.openxmlformats.org/drawingml/2006/main">
               <a:ext uri="{FF2B5EF4-FFF2-40B4-BE49-F238E27FC236}">
-                <a16:creationId xmlns:a16="http://schemas.microsoft.com/office/drawing/2014/main" id="{997A0FCF-7BA7-4E3C-8E6F-CA6D601AD477}"/>
+                <a16:creationId xmlns:a16="http://schemas.microsoft.com/office/drawing/2014/main" id="{3293837F-D9C7-406F-9BBC-7B4C3145D833}"/>
               </a:ext>
             </a:extLst>
           </p:cNvPr>
@@ -14902,7 +15138,7 @@
     </p:spTree>
     <p:extLst>
       <p:ext uri="{BB962C8B-B14F-4D97-AF65-F5344CB8AC3E}">
-        <p14:creationId xmlns:p14="http://schemas.microsoft.com/office/powerpoint/2010/main" val="1491986120"/>
+        <p14:creationId xmlns:p14="http://schemas.microsoft.com/office/powerpoint/2010/main" val="1461432178"/>
       </p:ext>
     </p:extLst>
   </p:cSld>
@@ -14933,7 +15169,7 @@
           <p:cNvPr id="5" name="">
             <a:extLst xmlns:a="http://schemas.openxmlformats.org/drawingml/2006/main">
               <a:ext uri="{FF2B5EF4-FFF2-40B4-BE49-F238E27FC236}">
-                <a16:creationId xmlns:a16="http://schemas.microsoft.com/office/drawing/2014/main" id="{DB18AF3B-E4F6-4DB0-813E-24F758FD0DAE}"/>
+                <a16:creationId xmlns:a16="http://schemas.microsoft.com/office/drawing/2014/main" id="{551C15A7-6BB4-4A91-A9C7-EF2EE2699B9F}"/>
               </a:ext>
             </a:extLst>
           </p:cNvPr>
@@ -15212,7 +15448,7 @@
           <p:cNvPr id="3" name="">
             <a:extLst xmlns:a="http://schemas.openxmlformats.org/drawingml/2006/main">
               <a:ext uri="{FF2B5EF4-FFF2-40B4-BE49-F238E27FC236}">
-                <a16:creationId xmlns:a16="http://schemas.microsoft.com/office/drawing/2014/main" id="{B0A10C20-DEF1-4752-B2CB-68BB443D6EF2}"/>
+                <a16:creationId xmlns:a16="http://schemas.microsoft.com/office/drawing/2014/main" id="{428C2DE4-64FA-4F02-8A9B-31E569658425}"/>
               </a:ext>
             </a:extLst>
           </p:cNvPr>
@@ -15269,7 +15505,7 @@
           <p:cNvPr id="4" name="">
             <a:extLst xmlns:a="http://schemas.openxmlformats.org/drawingml/2006/main">
               <a:ext uri="{FF2B5EF4-FFF2-40B4-BE49-F238E27FC236}">
-                <a16:creationId xmlns:a16="http://schemas.microsoft.com/office/drawing/2014/main" id="{A0ABB6F2-1ECC-460D-A9C7-11892A563B7F}"/>
+                <a16:creationId xmlns:a16="http://schemas.microsoft.com/office/drawing/2014/main" id="{E57853C5-EF00-4095-BF09-1AD90CA4BA70}"/>
               </a:ext>
             </a:extLst>
           </p:cNvPr>
@@ -15324,7 +15560,7 @@
     </p:spTree>
     <p:extLst>
       <p:ext uri="{BB962C8B-B14F-4D97-AF65-F5344CB8AC3E}">
-        <p14:creationId xmlns:p14="http://schemas.microsoft.com/office/powerpoint/2010/main" val="2127753512"/>
+        <p14:creationId xmlns:p14="http://schemas.microsoft.com/office/powerpoint/2010/main" val="1979001750"/>
       </p:ext>
     </p:extLst>
   </p:cSld>
@@ -15355,7 +15591,7 @@
           <p:cNvPr id="5" name="">
             <a:extLst xmlns:a="http://schemas.openxmlformats.org/drawingml/2006/main">
               <a:ext uri="{FF2B5EF4-FFF2-40B4-BE49-F238E27FC236}">
-                <a16:creationId xmlns:a16="http://schemas.microsoft.com/office/drawing/2014/main" id="{800066AB-D29D-4FBE-B5A4-1E507D26BD40}"/>
+                <a16:creationId xmlns:a16="http://schemas.microsoft.com/office/drawing/2014/main" id="{EBCA172C-BCB6-46CA-A21B-75C3E3567844}"/>
               </a:ext>
             </a:extLst>
           </p:cNvPr>
@@ -15584,7 +15820,7 @@
           <p:cNvPr id="3" name="">
             <a:extLst xmlns:a="http://schemas.openxmlformats.org/drawingml/2006/main">
               <a:ext uri="{FF2B5EF4-FFF2-40B4-BE49-F238E27FC236}">
-                <a16:creationId xmlns:a16="http://schemas.microsoft.com/office/drawing/2014/main" id="{046D95A8-137B-411C-9218-5ADAA3D37404}"/>
+                <a16:creationId xmlns:a16="http://schemas.microsoft.com/office/drawing/2014/main" id="{3FE24925-C62D-42A6-89E5-4B1A1D412DBE}"/>
               </a:ext>
             </a:extLst>
           </p:cNvPr>
@@ -15641,7 +15877,7 @@
           <p:cNvPr id="4" name="">
             <a:extLst xmlns:a="http://schemas.openxmlformats.org/drawingml/2006/main">
               <a:ext uri="{FF2B5EF4-FFF2-40B4-BE49-F238E27FC236}">
-                <a16:creationId xmlns:a16="http://schemas.microsoft.com/office/drawing/2014/main" id="{2FAF6FEA-F1F6-434D-9592-71E8CACC4949}"/>
+                <a16:creationId xmlns:a16="http://schemas.microsoft.com/office/drawing/2014/main" id="{F8F36E5B-EFEF-4AC2-B359-B54814C80515}"/>
               </a:ext>
             </a:extLst>
           </p:cNvPr>
@@ -15696,7 +15932,7 @@
     </p:spTree>
     <p:extLst>
       <p:ext uri="{BB962C8B-B14F-4D97-AF65-F5344CB8AC3E}">
-        <p14:creationId xmlns:p14="http://schemas.microsoft.com/office/powerpoint/2010/main" val="1009031219"/>
+        <p14:creationId xmlns:p14="http://schemas.microsoft.com/office/powerpoint/2010/main" val="779074584"/>
       </p:ext>
     </p:extLst>
   </p:cSld>
@@ -15727,7 +15963,7 @@
           <p:cNvPr id="6" name="">
             <a:extLst xmlns:a="http://schemas.openxmlformats.org/drawingml/2006/main">
               <a:ext uri="{FF2B5EF4-FFF2-40B4-BE49-F238E27FC236}">
-                <a16:creationId xmlns:a16="http://schemas.microsoft.com/office/drawing/2014/main" id="{073B2E49-2464-45BA-8317-ACCAAE499BFE}"/>
+                <a16:creationId xmlns:a16="http://schemas.microsoft.com/office/drawing/2014/main" id="{1502D6DE-CC98-428C-80A9-B5CF17285844}"/>
               </a:ext>
             </a:extLst>
           </p:cNvPr>
@@ -15774,7 +16010,7 @@
                 <a:ea typeface="Arial"/>
                 <a:cs typeface="Arial"/>
               </a:rPr>
-              <a:t>Development experiment: new urgent misses</a:t>
+              <a:t>Development: urgent-reference disagreements</a:t>
             </a:r>
           </a:p>
         </p:txBody>
@@ -16035,7 +16271,7 @@
                           <a:ea typeface="Arial"/>
                           <a:cs typeface="Arial"/>
                         </a:rPr>
-                        <a:t>Known: required urgent action missed</a:t>
+                        <a:t>Known: urgent-reference cases assigned async</a:t>
                       </a:r>
                     </a:p>
                   </a:txBody>
@@ -16331,7 +16567,7 @@
                           <a:ea typeface="Arial"/>
                           <a:cs typeface="Arial"/>
                         </a:rPr>
-                        <a:t>Authored challenge: urgent action missed</a:t>
+                        <a:t>Challenge: urgent-reference cases not urgent</a:t>
                       </a:r>
                     </a:p>
                   </a:txBody>
@@ -16399,7 +16635,7 @@
           <p:cNvPr id="3" name="">
             <a:extLst xmlns:a="http://schemas.openxmlformats.org/drawingml/2006/main">
               <a:ext uri="{FF2B5EF4-FFF2-40B4-BE49-F238E27FC236}">
-                <a16:creationId xmlns:a16="http://schemas.microsoft.com/office/drawing/2014/main" id="{6639EC88-DFA0-459A-A673-D526DB5581A4}"/>
+                <a16:creationId xmlns:a16="http://schemas.microsoft.com/office/drawing/2014/main" id="{7201CF68-F8EF-40CF-A0C7-BEBBCB7C56C9}"/>
               </a:ext>
             </a:extLst>
           </p:cNvPr>
@@ -16446,7 +16682,7 @@
                 <a:ea typeface="Arial"/>
                 <a:cs typeface="Arial"/>
               </a:rPr>
-              <a:t>Candidate not promoted. Three new urgent routing misses require review.</a:t>
+              <a:t>Async does not imply delayed care. Clinical timing was not measured.</a:t>
             </a:r>
           </a:p>
         </p:txBody>
@@ -16456,7 +16692,7 @@
           <p:cNvPr id="4" name="">
             <a:extLst xmlns:a="http://schemas.openxmlformats.org/drawingml/2006/main">
               <a:ext uri="{FF2B5EF4-FFF2-40B4-BE49-F238E27FC236}">
-                <a16:creationId xmlns:a16="http://schemas.microsoft.com/office/drawing/2014/main" id="{891CB177-EADF-4F64-ACC3-443F553A8D7A}"/>
+                <a16:creationId xmlns:a16="http://schemas.microsoft.com/office/drawing/2014/main" id="{4ADABC3D-BDBB-41C0-9F82-B9E5042EF32E}"/>
               </a:ext>
             </a:extLst>
           </p:cNvPr>
@@ -16503,7 +16739,7 @@
                 <a:ea typeface="Arial"/>
                 <a:cs typeface="Arial"/>
               </a:rPr>
-              <a:t>Known set: post-output physician reference. Challenge: AI-authored policy checks, no physician approval. GUI unchanged.</a:t>
+              <a:t>Known set: unchanged physician reference. Challenge: AI-authored checks without physician approval. Candidate not promoted.</a:t>
             </a:r>
           </a:p>
         </p:txBody>
@@ -16513,7 +16749,7 @@
           <p:cNvPr id="5" name="">
             <a:extLst xmlns:a="http://schemas.openxmlformats.org/drawingml/2006/main">
               <a:ext uri="{FF2B5EF4-FFF2-40B4-BE49-F238E27FC236}">
-                <a16:creationId xmlns:a16="http://schemas.microsoft.com/office/drawing/2014/main" id="{B35010EE-7355-4BE3-8A40-8ADA42631472}"/>
+                <a16:creationId xmlns:a16="http://schemas.microsoft.com/office/drawing/2014/main" id="{4798A26A-7EF8-44C9-BF70-81188D925F9B}"/>
               </a:ext>
             </a:extLst>
           </p:cNvPr>
@@ -16568,7 +16804,7 @@
     </p:spTree>
     <p:extLst>
       <p:ext uri="{BB962C8B-B14F-4D97-AF65-F5344CB8AC3E}">
-        <p14:creationId xmlns:p14="http://schemas.microsoft.com/office/powerpoint/2010/main" val="1333111578"/>
+        <p14:creationId xmlns:p14="http://schemas.microsoft.com/office/powerpoint/2010/main" val="236379818"/>
       </p:ext>
     </p:extLst>
   </p:cSld>
@@ -16599,7 +16835,7 @@
           <p:cNvPr id="10" name="">
             <a:extLst xmlns:a="http://schemas.openxmlformats.org/drawingml/2006/main">
               <a:ext uri="{FF2B5EF4-FFF2-40B4-BE49-F238E27FC236}">
-                <a16:creationId xmlns:a16="http://schemas.microsoft.com/office/drawing/2014/main" id="{6684928C-032B-425F-8334-CBA8FD3CCD0F}"/>
+                <a16:creationId xmlns:a16="http://schemas.microsoft.com/office/drawing/2014/main" id="{168A7245-EF6B-4775-9521-EAF2F2068C29}"/>
               </a:ext>
             </a:extLst>
           </p:cNvPr>
@@ -16656,7 +16892,7 @@
           <p:cNvPr id="2" name="">
             <a:extLst xmlns:a="http://schemas.openxmlformats.org/drawingml/2006/main">
               <a:ext uri="{FF2B5EF4-FFF2-40B4-BE49-F238E27FC236}">
-                <a16:creationId xmlns:a16="http://schemas.microsoft.com/office/drawing/2014/main" id="{A2F83472-C267-4091-9E3E-9957683AD764}"/>
+                <a16:creationId xmlns:a16="http://schemas.microsoft.com/office/drawing/2014/main" id="{CBE95E4C-CD59-4C3C-9896-75A10474EC1D}"/>
               </a:ext>
             </a:extLst>
           </p:cNvPr>
@@ -16713,7 +16949,7 @@
           <p:cNvPr id="3" name="">
             <a:extLst xmlns:a="http://schemas.openxmlformats.org/drawingml/2006/main">
               <a:ext uri="{FF2B5EF4-FFF2-40B4-BE49-F238E27FC236}">
-                <a16:creationId xmlns:a16="http://schemas.microsoft.com/office/drawing/2014/main" id="{EAB90AA2-CD7A-41AD-A619-A399C5647D8B}"/>
+                <a16:creationId xmlns:a16="http://schemas.microsoft.com/office/drawing/2014/main" id="{061A2D2F-E8F5-4441-9BCA-72D221C27366}"/>
               </a:ext>
             </a:extLst>
           </p:cNvPr>
@@ -16770,7 +17006,7 @@
           <p:cNvPr id="4" name="">
             <a:extLst xmlns:a="http://schemas.openxmlformats.org/drawingml/2006/main">
               <a:ext uri="{FF2B5EF4-FFF2-40B4-BE49-F238E27FC236}">
-                <a16:creationId xmlns:a16="http://schemas.microsoft.com/office/drawing/2014/main" id="{F93D5451-2B78-4B36-ACA6-3C4C4E2DFE8D}"/>
+                <a16:creationId xmlns:a16="http://schemas.microsoft.com/office/drawing/2014/main" id="{986A513A-4F56-497B-8928-99AB9A743BDE}"/>
               </a:ext>
             </a:extLst>
           </p:cNvPr>
@@ -16827,7 +17063,7 @@
           <p:cNvPr id="5" name="">
             <a:extLst xmlns:a="http://schemas.openxmlformats.org/drawingml/2006/main">
               <a:ext uri="{FF2B5EF4-FFF2-40B4-BE49-F238E27FC236}">
-                <a16:creationId xmlns:a16="http://schemas.microsoft.com/office/drawing/2014/main" id="{27AFB6CC-0CB3-4DB3-8618-F9DB18B023B4}"/>
+                <a16:creationId xmlns:a16="http://schemas.microsoft.com/office/drawing/2014/main" id="{ECEDC388-200C-45FF-8CBA-5ADE0D41D04E}"/>
               </a:ext>
             </a:extLst>
           </p:cNvPr>
@@ -16884,7 +17120,7 @@
           <p:cNvPr id="6" name="">
             <a:extLst xmlns:a="http://schemas.openxmlformats.org/drawingml/2006/main">
               <a:ext uri="{FF2B5EF4-FFF2-40B4-BE49-F238E27FC236}">
-                <a16:creationId xmlns:a16="http://schemas.microsoft.com/office/drawing/2014/main" id="{854293D3-8AA4-4FFA-88F8-B19954106153}"/>
+                <a16:creationId xmlns:a16="http://schemas.microsoft.com/office/drawing/2014/main" id="{1BF92A20-71C6-44C0-9C3F-427F51486CFD}"/>
               </a:ext>
             </a:extLst>
           </p:cNvPr>
@@ -16941,7 +17177,7 @@
           <p:cNvPr id="7" name="">
             <a:extLst xmlns:a="http://schemas.openxmlformats.org/drawingml/2006/main">
               <a:ext uri="{FF2B5EF4-FFF2-40B4-BE49-F238E27FC236}">
-                <a16:creationId xmlns:a16="http://schemas.microsoft.com/office/drawing/2014/main" id="{0181DCCE-80C6-40F5-9450-31DA6D80BB9B}"/>
+                <a16:creationId xmlns:a16="http://schemas.microsoft.com/office/drawing/2014/main" id="{CBE50E17-AA84-4292-8D14-845209FF02C7}"/>
               </a:ext>
             </a:extLst>
           </p:cNvPr>
@@ -16998,7 +17234,7 @@
           <p:cNvPr id="8" name="">
             <a:extLst xmlns:a="http://schemas.openxmlformats.org/drawingml/2006/main">
               <a:ext uri="{FF2B5EF4-FFF2-40B4-BE49-F238E27FC236}">
-                <a16:creationId xmlns:a16="http://schemas.microsoft.com/office/drawing/2014/main" id="{22E14226-6FC7-4CBF-80D5-DC5490E274AF}"/>
+                <a16:creationId xmlns:a16="http://schemas.microsoft.com/office/drawing/2014/main" id="{C0D9183F-66CF-4E36-A5F1-A381273A178C}"/>
               </a:ext>
             </a:extLst>
           </p:cNvPr>
@@ -17055,7 +17291,7 @@
           <p:cNvPr id="9" name="">
             <a:extLst xmlns:a="http://schemas.openxmlformats.org/drawingml/2006/main">
               <a:ext uri="{FF2B5EF4-FFF2-40B4-BE49-F238E27FC236}">
-                <a16:creationId xmlns:a16="http://schemas.microsoft.com/office/drawing/2014/main" id="{9D1CAE06-D8B9-4F46-8608-9D5E5F942607}"/>
+                <a16:creationId xmlns:a16="http://schemas.microsoft.com/office/drawing/2014/main" id="{07F6EA3E-1135-4B41-AE4C-197182511762}"/>
               </a:ext>
             </a:extLst>
           </p:cNvPr>
@@ -17110,7 +17346,7 @@
     </p:spTree>
     <p:extLst>
       <p:ext uri="{BB962C8B-B14F-4D97-AF65-F5344CB8AC3E}">
-        <p14:creationId xmlns:p14="http://schemas.microsoft.com/office/powerpoint/2010/main" val="1267219906"/>
+        <p14:creationId xmlns:p14="http://schemas.microsoft.com/office/powerpoint/2010/main" val="652594943"/>
       </p:ext>
     </p:extLst>
   </p:cSld>
@@ -17141,7 +17377,7 @@
           <p:cNvPr id="5" name="">
             <a:extLst xmlns:a="http://schemas.openxmlformats.org/drawingml/2006/main">
               <a:ext uri="{FF2B5EF4-FFF2-40B4-BE49-F238E27FC236}">
-                <a16:creationId xmlns:a16="http://schemas.microsoft.com/office/drawing/2014/main" id="{ABFD1881-AD6C-4D73-B6F4-48F640A06A62}"/>
+                <a16:creationId xmlns:a16="http://schemas.microsoft.com/office/drawing/2014/main" id="{694D974F-F2B5-46C8-9145-1C4B1A06FC27}"/>
               </a:ext>
             </a:extLst>
           </p:cNvPr>
@@ -17313,7 +17549,7 @@
                           <a:ea typeface="Arial"/>
                           <a:cs typeface="Arial"/>
                         </a:rPr>
-                        <a:t>Approve self-care eligibility, care timing and handling of clinically material unknowns.</a:t>
+                        <a:t>Separate next contact, required care setting, clinical deadline and service capability before approving routing.</a:t>
                       </a:r>
                     </a:p>
                   </a:txBody>
@@ -17522,7 +17758,7 @@
           <p:cNvPr id="3" name="">
             <a:extLst xmlns:a="http://schemas.openxmlformats.org/drawingml/2006/main">
               <a:ext uri="{FF2B5EF4-FFF2-40B4-BE49-F238E27FC236}">
-                <a16:creationId xmlns:a16="http://schemas.microsoft.com/office/drawing/2014/main" id="{F32B60F4-5AC2-462B-8D8C-16C5820E6443}"/>
+                <a16:creationId xmlns:a16="http://schemas.microsoft.com/office/drawing/2014/main" id="{EC8002B9-82EF-4EA1-91C6-5BA059D0B0E2}"/>
               </a:ext>
             </a:extLst>
           </p:cNvPr>
@@ -17579,7 +17815,7 @@
           <p:cNvPr id="4" name="">
             <a:extLst xmlns:a="http://schemas.openxmlformats.org/drawingml/2006/main">
               <a:ext uri="{FF2B5EF4-FFF2-40B4-BE49-F238E27FC236}">
-                <a16:creationId xmlns:a16="http://schemas.microsoft.com/office/drawing/2014/main" id="{30AABD4A-3F38-4583-9095-76231BF412D3}"/>
+                <a16:creationId xmlns:a16="http://schemas.microsoft.com/office/drawing/2014/main" id="{9CE53D2F-AE2A-4531-9A33-748EFF1E6F71}"/>
               </a:ext>
             </a:extLst>
           </p:cNvPr>
@@ -17634,7 +17870,7 @@
     </p:spTree>
     <p:extLst>
       <p:ext uri="{BB962C8B-B14F-4D97-AF65-F5344CB8AC3E}">
-        <p14:creationId xmlns:p14="http://schemas.microsoft.com/office/powerpoint/2010/main" val="1452197195"/>
+        <p14:creationId xmlns:p14="http://schemas.microsoft.com/office/powerpoint/2010/main" val="315172709"/>
       </p:ext>
     </p:extLst>
   </p:cSld>
@@ -17665,7 +17901,7 @@
           <p:cNvPr id="5" name="">
             <a:extLst xmlns:a="http://schemas.openxmlformats.org/drawingml/2006/main">
               <a:ext uri="{FF2B5EF4-FFF2-40B4-BE49-F238E27FC236}">
-                <a16:creationId xmlns:a16="http://schemas.microsoft.com/office/drawing/2014/main" id="{82CB2349-799A-4C55-AEE6-A07FA7A5A36C}"/>
+                <a16:creationId xmlns:a16="http://schemas.microsoft.com/office/drawing/2014/main" id="{ACCDD65E-8145-482E-8291-FF1A7EFABF8F}"/>
               </a:ext>
             </a:extLst>
           </p:cNvPr>
@@ -17712,7 +17948,7 @@
                 <a:ea typeface="Arial"/>
                 <a:cs typeface="Arial"/>
               </a:rPr>
-              <a:t>Case text: new urgent-routing misses</a:t>
+              <a:t>Case text: care-setting disagreements</a:t>
             </a:r>
           </a:p>
         </p:txBody>
@@ -17944,7 +18180,7 @@
           <p:cNvPr id="3" name="">
             <a:extLst xmlns:a="http://schemas.openxmlformats.org/drawingml/2006/main">
               <a:ext uri="{FF2B5EF4-FFF2-40B4-BE49-F238E27FC236}">
-                <a16:creationId xmlns:a16="http://schemas.microsoft.com/office/drawing/2014/main" id="{B2620C7B-BC83-4F3D-A2BE-4E58878130B5}"/>
+                <a16:creationId xmlns:a16="http://schemas.microsoft.com/office/drawing/2014/main" id="{F79D714A-8A6D-454B-89D1-065C208504E2}"/>
               </a:ext>
             </a:extLst>
           </p:cNvPr>
@@ -17991,7 +18227,7 @@
                 <a:ea typeface="Arial"/>
                 <a:cs typeface="Arial"/>
               </a:rPr>
-              <a:t>The new prompt assigns ASYNC_PHYSICIAN to all three. Frozen baseline and unchanged physician reference assign URGENT_ESCALATION.</a:t>
+              <a:t>Candidate: ASYNC_PHYSICIAN. Frozen baseline and reference: URGENT_ESCALATION. Clinical timing and completed care were not measured.</a:t>
             </a:r>
           </a:p>
         </p:txBody>
@@ -18001,7 +18237,7 @@
           <p:cNvPr id="4" name="">
             <a:extLst xmlns:a="http://schemas.openxmlformats.org/drawingml/2006/main">
               <a:ext uri="{FF2B5EF4-FFF2-40B4-BE49-F238E27FC236}">
-                <a16:creationId xmlns:a16="http://schemas.microsoft.com/office/drawing/2014/main" id="{C6F97261-6BAF-4486-A0B8-B5B28CDC45AB}"/>
+                <a16:creationId xmlns:a16="http://schemas.microsoft.com/office/drawing/2014/main" id="{4FE14EAC-C28C-43C9-8A66-E8FEAF3F73EF}"/>
               </a:ext>
             </a:extLst>
           </p:cNvPr>
@@ -18056,7 +18292,583 @@
     </p:spTree>
     <p:extLst>
       <p:ext uri="{BB962C8B-B14F-4D97-AF65-F5344CB8AC3E}">
-        <p14:creationId xmlns:p14="http://schemas.microsoft.com/office/powerpoint/2010/main" val="1391466645"/>
+        <p14:creationId xmlns:p14="http://schemas.microsoft.com/office/powerpoint/2010/main" val="469175054"/>
+      </p:ext>
+    </p:extLst>
+  </p:cSld>
+</p:sld>
+</file>
+
+<file path=ppt/slides/slide32.xml><?xml version="1.0" encoding="utf-8"?>
+<p:sld xmlns:p="http://schemas.openxmlformats.org/presentationml/2006/main">
+  <p:cSld>
+    <p:bg>
+      <p:bgPr>
+        <a:solidFill xmlns:a="http://schemas.openxmlformats.org/drawingml/2006/main">
+          <a:srgbClr val="F6F4ED"/>
+        </a:solidFill>
+      </p:bgPr>
+    </p:bg>
+    <p:spTree>
+      <p:nvGrpSpPr>
+        <p:cNvPr id="1" name=""/>
+        <p:cNvGrpSpPr/>
+        <p:nvPr/>
+      </p:nvGrpSpPr>
+      <p:grpSpPr>
+        <a:xfrm xmlns:a="http://schemas.openxmlformats.org/drawingml/2006/main"/>
+      </p:grpSpPr>
+      <p:sp>
+        <p:nvSpPr>
+          <p:cNvPr id="6" name="">
+            <a:extLst xmlns:a="http://schemas.openxmlformats.org/drawingml/2006/main">
+              <a:ext uri="{FF2B5EF4-FFF2-40B4-BE49-F238E27FC236}">
+                <a16:creationId xmlns:a16="http://schemas.microsoft.com/office/drawing/2014/main" id="{78541EFA-D9A0-4D41-A266-8AF0670A74CD}"/>
+              </a:ext>
+            </a:extLst>
+          </p:cNvPr>
+          <p:cNvSpPr>
+            <a:spLocks xmlns:a="http://schemas.openxmlformats.org/drawingml/2006/main" noGrp="1"/>
+          </p:cNvSpPr>
+          <p:nvPr/>
+        </p:nvSpPr>
+        <p:spPr>
+          <a:xfrm xmlns:a="http://schemas.openxmlformats.org/drawingml/2006/main">
+            <a:off x="762000" y="485775"/>
+            <a:ext cx="10668000" cy="586550"/>
+          </a:xfrm>
+          <a:prstGeom xmlns:a="http://schemas.openxmlformats.org/drawingml/2006/main" prst="rect">
+            <a:avLst/>
+          </a:prstGeom>
+          <a:noFill xmlns:a="http://schemas.openxmlformats.org/drawingml/2006/main"/>
+          <a:ln xmlns:a="http://schemas.openxmlformats.org/drawingml/2006/main" w="0">
+            <a:noFill/>
+          </a:ln>
+        </p:spPr>
+        <p:txBody>
+          <a:bodyPr xmlns:a="http://schemas.openxmlformats.org/drawingml/2006/main" wrap="square" lIns="0" tIns="0" rIns="0" bIns="0" anchor="t">
+            <a:noAutofit/>
+          </a:bodyPr>
+          <a:lstStyle xmlns:a="http://schemas.openxmlformats.org/drawingml/2006/main"/>
+          <a:p xmlns:a="http://schemas.openxmlformats.org/drawingml/2006/main">
+            <a:pPr>
+              <a:defRPr sz="3525" b="1">
+                <a:solidFill>
+                  <a:srgbClr val="243866"/>
+                </a:solidFill>
+                <a:latin typeface="Arial"/>
+                <a:ea typeface="Arial"/>
+                <a:cs typeface="Arial"/>
+              </a:defRPr>
+            </a:pPr>
+            <a:r>
+              <a:rPr sz="3525" b="1">
+                <a:solidFill>
+                  <a:srgbClr val="243866"/>
+                </a:solidFill>
+                <a:latin typeface="Arial"/>
+                <a:ea typeface="Arial"/>
+                <a:cs typeface="Arial"/>
+              </a:rPr>
+              <a:t>Async care and required clinical timing</a:t>
+            </a:r>
+          </a:p>
+        </p:txBody>
+      </p:sp>
+      <p:graphicFrame>
+        <p:nvGraphicFramePr>
+          <p:cNvPr id="7" name=""/>
+          <p:cNvGraphicFramePr/>
+          <p:nvPr/>
+        </p:nvGraphicFramePr>
+        <p:xfrm>
+          <a:off xmlns:a="http://schemas.openxmlformats.org/drawingml/2006/main" x="762000" y="1619250"/>
+          <a:ext xmlns:a="http://schemas.openxmlformats.org/drawingml/2006/main" cx="10668000" cy="2730246"/>
+        </p:xfrm>
+        <a:graphic xmlns:a="http://schemas.openxmlformats.org/drawingml/2006/main">
+          <a:graphicData uri="http://schemas.openxmlformats.org/drawingml/2006/table">
+            <a:tbl>
+              <a:tblPr firstRow="1" bandRow="0"/>
+              <a:tblGrid>
+                <a:gridCol w="2133600"/>
+                <a:gridCol w="4267200"/>
+                <a:gridCol w="4267200"/>
+              </a:tblGrid>
+              <a:tr h="471678">
+                <a:tc>
+                  <a:txBody>
+                    <a:bodyPr/>
+                    <a:lstStyle/>
+                    <a:p>
+                      <a:r>
+                        <a:rPr sz="1800" b="1">
+                          <a:solidFill>
+                            <a:srgbClr val="FFFFFF"/>
+                          </a:solidFill>
+                          <a:latin typeface="Arial"/>
+                          <a:ea typeface="Arial"/>
+                          <a:cs typeface="Arial"/>
+                        </a:rPr>
+                        <a:t>Dimension</a:t>
+                      </a:r>
+                    </a:p>
+                  </a:txBody>
+                  <a:tcPr marL="133350" marR="133350" marT="76200" marB="76200" anchor="ctr">
+                    <a:solidFill>
+                      <a:srgbClr val="243866"/>
+                    </a:solidFill>
+                  </a:tcPr>
+                </a:tc>
+                <a:tc>
+                  <a:txBody>
+                    <a:bodyPr/>
+                    <a:lstStyle/>
+                    <a:p>
+                      <a:r>
+                        <a:rPr sz="1800" b="1">
+                          <a:solidFill>
+                            <a:srgbClr val="FFFFFF"/>
+                          </a:solidFill>
+                          <a:latin typeface="Arial"/>
+                          <a:ea typeface="Arial"/>
+                          <a:cs typeface="Arial"/>
+                        </a:rPr>
+                        <a:t>Question to specify</a:t>
+                      </a:r>
+                    </a:p>
+                  </a:txBody>
+                  <a:tcPr marL="133350" marR="133350" marT="76200" marB="76200" anchor="ctr">
+                    <a:solidFill>
+                      <a:srgbClr val="243866"/>
+                    </a:solidFill>
+                  </a:tcPr>
+                </a:tc>
+                <a:tc>
+                  <a:txBody>
+                    <a:bodyPr/>
+                    <a:lstStyle/>
+                    <a:p>
+                      <a:r>
+                        <a:rPr sz="1800" b="1">
+                          <a:solidFill>
+                            <a:srgbClr val="FFFFFF"/>
+                          </a:solidFill>
+                          <a:latin typeface="Arial"/>
+                          <a:ea typeface="Arial"/>
+                          <a:cs typeface="Arial"/>
+                        </a:rPr>
+                        <a:t>Evidence required</a:t>
+                      </a:r>
+                    </a:p>
+                  </a:txBody>
+                  <a:tcPr marL="133350" marR="133350" marT="76200" marB="76200" anchor="ctr">
+                    <a:solidFill>
+                      <a:srgbClr val="243866"/>
+                    </a:solidFill>
+                  </a:tcPr>
+                </a:tc>
+              </a:tr>
+              <a:tr h="752856">
+                <a:tc>
+                  <a:txBody>
+                    <a:bodyPr/>
+                    <a:lstStyle/>
+                    <a:p>
+                      <a:r>
+                        <a:rPr sz="1800" b="0">
+                          <a:solidFill>
+                            <a:srgbClr val="28354A"/>
+                          </a:solidFill>
+                          <a:latin typeface="Arial"/>
+                          <a:ea typeface="Arial"/>
+                          <a:cs typeface="Arial"/>
+                        </a:rPr>
+                        <a:t>Contact channel</a:t>
+                      </a:r>
+                    </a:p>
+                  </a:txBody>
+                  <a:tcPr marL="133350" marR="133350" marT="76200" marB="76200" anchor="ctr">
+                    <a:solidFill>
+                      <a:srgbClr val="F6F4ED"/>
+                    </a:solidFill>
+                  </a:tcPr>
+                </a:tc>
+                <a:tc>
+                  <a:txBody>
+                    <a:bodyPr/>
+                    <a:lstStyle/>
+                    <a:p>
+                      <a:r>
+                        <a:rPr sz="1800" b="0">
+                          <a:solidFill>
+                            <a:srgbClr val="28354A"/>
+                          </a:solidFill>
+                          <a:latin typeface="Arial"/>
+                          <a:ea typeface="Arial"/>
+                          <a:cs typeface="Arial"/>
+                        </a:rPr>
+                        <a:t>How does the patient reach a clinician?</a:t>
+                      </a:r>
+                    </a:p>
+                  </a:txBody>
+                  <a:tcPr marL="133350" marR="133350" marT="76200" marB="76200" anchor="ctr">
+                    <a:solidFill>
+                      <a:srgbClr val="F6F4ED"/>
+                    </a:solidFill>
+                  </a:tcPr>
+                </a:tc>
+                <a:tc>
+                  <a:txBody>
+                    <a:bodyPr/>
+                    <a:lstStyle/>
+                    <a:p>
+                      <a:r>
+                        <a:rPr sz="1800" b="0">
+                          <a:solidFill>
+                            <a:srgbClr val="28354A"/>
+                          </a:solidFill>
+                          <a:latin typeface="Arial"/>
+                          <a:ea typeface="Arial"/>
+                          <a:cs typeface="Arial"/>
+                        </a:rPr>
+                        <a:t>Observed time to an appropriate physician response</a:t>
+                      </a:r>
+                    </a:p>
+                  </a:txBody>
+                  <a:tcPr marL="133350" marR="133350" marT="76200" marB="76200" anchor="ctr">
+                    <a:solidFill>
+                      <a:srgbClr val="F6F4ED"/>
+                    </a:solidFill>
+                  </a:tcPr>
+                </a:tc>
+              </a:tr>
+              <a:tr h="752856">
+                <a:tc>
+                  <a:txBody>
+                    <a:bodyPr/>
+                    <a:lstStyle/>
+                    <a:p>
+                      <a:r>
+                        <a:rPr sz="1800" b="0">
+                          <a:solidFill>
+                            <a:srgbClr val="28354A"/>
+                          </a:solidFill>
+                          <a:latin typeface="Arial"/>
+                          <a:ea typeface="Arial"/>
+                          <a:cs typeface="Arial"/>
+                        </a:rPr>
+                        <a:t>Clinical timing</a:t>
+                      </a:r>
+                    </a:p>
+                  </a:txBody>
+                  <a:tcPr marL="133350" marR="133350" marT="76200" marB="76200" anchor="ctr">
+                    <a:solidFill>
+                      <a:srgbClr val="F6F4ED"/>
+                    </a:solidFill>
+                  </a:tcPr>
+                </a:tc>
+                <a:tc>
+                  <a:txBody>
+                    <a:bodyPr/>
+                    <a:lstStyle/>
+                    <a:p>
+                      <a:r>
+                        <a:rPr sz="1800" b="0">
+                          <a:solidFill>
+                            <a:srgbClr val="28354A"/>
+                          </a:solidFill>
+                          <a:latin typeface="Arial"/>
+                          <a:ea typeface="Arial"/>
+                          <a:cs typeface="Arial"/>
+                        </a:rPr>
+                        <a:t>When must assessment or treatment occur?</a:t>
+                      </a:r>
+                    </a:p>
+                  </a:txBody>
+                  <a:tcPr marL="133350" marR="133350" marT="76200" marB="76200" anchor="ctr">
+                    <a:solidFill>
+                      <a:srgbClr val="F6F4ED"/>
+                    </a:solidFill>
+                  </a:tcPr>
+                </a:tc>
+                <a:tc>
+                  <a:txBody>
+                    <a:bodyPr/>
+                    <a:lstStyle/>
+                    <a:p>
+                      <a:r>
+                        <a:rPr sz="1800" b="0">
+                          <a:solidFill>
+                            <a:srgbClr val="28354A"/>
+                          </a:solidFill>
+                          <a:latin typeface="Arial"/>
+                          <a:ea typeface="Arial"/>
+                          <a:cs typeface="Arial"/>
+                        </a:rPr>
+                        <a:t>A clinically approved deadline for the required action</a:t>
+                      </a:r>
+                    </a:p>
+                  </a:txBody>
+                  <a:tcPr marL="133350" marR="133350" marT="76200" marB="76200" anchor="ctr">
+                    <a:solidFill>
+                      <a:srgbClr val="F6F4ED"/>
+                    </a:solidFill>
+                  </a:tcPr>
+                </a:tc>
+              </a:tr>
+              <a:tr h="752856">
+                <a:tc>
+                  <a:txBody>
+                    <a:bodyPr/>
+                    <a:lstStyle/>
+                    <a:p>
+                      <a:r>
+                        <a:rPr sz="1800" b="0">
+                          <a:solidFill>
+                            <a:srgbClr val="28354A"/>
+                          </a:solidFill>
+                          <a:latin typeface="Arial"/>
+                          <a:ea typeface="Arial"/>
+                          <a:cs typeface="Arial"/>
+                        </a:rPr>
+                        <a:t>Care capability</a:t>
+                      </a:r>
+                    </a:p>
+                  </a:txBody>
+                  <a:tcPr marL="133350" marR="133350" marT="76200" marB="76200" anchor="ctr">
+                    <a:solidFill>
+                      <a:srgbClr val="F6F4ED"/>
+                    </a:solidFill>
+                  </a:tcPr>
+                </a:tc>
+                <a:tc>
+                  <a:txBody>
+                    <a:bodyPr/>
+                    <a:lstStyle/>
+                    <a:p>
+                      <a:r>
+                        <a:rPr sz="1800" b="0">
+                          <a:solidFill>
+                            <a:srgbClr val="28354A"/>
+                          </a:solidFill>
+                          <a:latin typeface="Arial"/>
+                          <a:ea typeface="Arial"/>
+                          <a:cs typeface="Arial"/>
+                        </a:rPr>
+                        <a:t>What can the pathway complete or arrange?</a:t>
+                      </a:r>
+                    </a:p>
+                  </a:txBody>
+                  <a:tcPr marL="133350" marR="133350" marT="76200" marB="76200" anchor="ctr">
+                    <a:solidFill>
+                      <a:srgbClr val="F6F4ED"/>
+                    </a:solidFill>
+                  </a:tcPr>
+                </a:tc>
+                <a:tc>
+                  <a:txBody>
+                    <a:bodyPr/>
+                    <a:lstStyle/>
+                    <a:p>
+                      <a:r>
+                        <a:rPr sz="1800" b="0">
+                          <a:solidFill>
+                            <a:srgbClr val="28354A"/>
+                          </a:solidFill>
+                          <a:latin typeface="Arial"/>
+                          <a:ea typeface="Arial"/>
+                          <a:cs typeface="Arial"/>
+                        </a:rPr>
+                        <a:t>Verified examination, testing or transfer when required</a:t>
+                      </a:r>
+                    </a:p>
+                  </a:txBody>
+                  <a:tcPr marL="133350" marR="133350" marT="76200" marB="76200" anchor="ctr">
+                    <a:solidFill>
+                      <a:srgbClr val="F6F4ED"/>
+                    </a:solidFill>
+                  </a:tcPr>
+                </a:tc>
+              </a:tr>
+            </a:tbl>
+          </a:graphicData>
+        </a:graphic>
+      </p:graphicFrame>
+      <p:sp>
+        <p:nvSpPr>
+          <p:cNvPr id="3" name="">
+            <a:extLst xmlns:a="http://schemas.openxmlformats.org/drawingml/2006/main">
+              <a:ext uri="{FF2B5EF4-FFF2-40B4-BE49-F238E27FC236}">
+                <a16:creationId xmlns:a16="http://schemas.microsoft.com/office/drawing/2014/main" id="{71580236-E76C-42B0-AB72-72FFE0A0F9BD}"/>
+              </a:ext>
+            </a:extLst>
+          </p:cNvPr>
+          <p:cNvSpPr>
+            <a:spLocks xmlns:a="http://schemas.openxmlformats.org/drawingml/2006/main" noGrp="1"/>
+          </p:cNvSpPr>
+          <p:nvPr/>
+        </p:nvSpPr>
+        <p:spPr>
+          <a:xfrm xmlns:a="http://schemas.openxmlformats.org/drawingml/2006/main">
+            <a:off x="762000" y="4539996"/>
+            <a:ext cx="10382250" cy="316992"/>
+          </a:xfrm>
+          <a:prstGeom xmlns:a="http://schemas.openxmlformats.org/drawingml/2006/main" prst="rect">
+            <a:avLst/>
+          </a:prstGeom>
+          <a:noFill xmlns:a="http://schemas.openxmlformats.org/drawingml/2006/main"/>
+          <a:ln xmlns:a="http://schemas.openxmlformats.org/drawingml/2006/main" w="0">
+            <a:noFill/>
+          </a:ln>
+        </p:spPr>
+        <p:txBody>
+          <a:bodyPr xmlns:a="http://schemas.openxmlformats.org/drawingml/2006/main" wrap="square" lIns="0" tIns="0" rIns="0" bIns="0" anchor="t">
+            <a:noAutofit/>
+          </a:bodyPr>
+          <a:lstStyle xmlns:a="http://schemas.openxmlformats.org/drawingml/2006/main"/>
+          <a:p xmlns:a="http://schemas.openxmlformats.org/drawingml/2006/main">
+            <a:pPr>
+              <a:defRPr sz="1800">
+                <a:solidFill>
+                  <a:srgbClr val="28354A"/>
+                </a:solidFill>
+                <a:latin typeface="Arial"/>
+                <a:ea typeface="Arial"/>
+                <a:cs typeface="Arial"/>
+              </a:defRPr>
+            </a:pPr>
+            <a:r>
+              <a:rPr sz="1800">
+                <a:solidFill>
+                  <a:srgbClr val="28354A"/>
+                </a:solidFill>
+                <a:latin typeface="Arial"/>
+                <a:ea typeface="Arial"/>
+                <a:cs typeface="Arial"/>
+              </a:rPr>
+              <a:t>Counsel reports an average 2-minute physician response. This is not a guarantee for a particular case.</a:t>
+            </a:r>
+          </a:p>
+        </p:txBody>
+      </p:sp>
+      <p:sp>
+        <p:nvSpPr>
+          <p:cNvPr id="4" name="">
+            <a:extLst xmlns:a="http://schemas.openxmlformats.org/drawingml/2006/main">
+              <a:ext uri="{FF2B5EF4-FFF2-40B4-BE49-F238E27FC236}">
+                <a16:creationId xmlns:a16="http://schemas.microsoft.com/office/drawing/2014/main" id="{7793C984-323C-4D25-9C46-238325DC4EDE}"/>
+              </a:ext>
+            </a:extLst>
+          </p:cNvPr>
+          <p:cNvSpPr>
+            <a:spLocks xmlns:a="http://schemas.openxmlformats.org/drawingml/2006/main" noGrp="1"/>
+          </p:cNvSpPr>
+          <p:nvPr/>
+        </p:nvSpPr>
+        <p:spPr>
+          <a:xfrm xmlns:a="http://schemas.openxmlformats.org/drawingml/2006/main">
+            <a:off x="762000" y="5886450"/>
+            <a:ext cx="10096500" cy="514350"/>
+          </a:xfrm>
+          <a:prstGeom xmlns:a="http://schemas.openxmlformats.org/drawingml/2006/main" prst="rect">
+            <a:avLst/>
+          </a:prstGeom>
+          <a:noFill xmlns:a="http://schemas.openxmlformats.org/drawingml/2006/main"/>
+          <a:ln xmlns:a="http://schemas.openxmlformats.org/drawingml/2006/main" w="0">
+            <a:noFill/>
+          </a:ln>
+        </p:spPr>
+        <p:txBody>
+          <a:bodyPr xmlns:a="http://schemas.openxmlformats.org/drawingml/2006/main" wrap="square" lIns="0" tIns="0" rIns="0" bIns="0" anchor="t">
+            <a:noAutofit/>
+          </a:bodyPr>
+          <a:lstStyle xmlns:a="http://schemas.openxmlformats.org/drawingml/2006/main"/>
+          <a:p xmlns:a="http://schemas.openxmlformats.org/drawingml/2006/main">
+            <a:pPr>
+              <a:defRPr sz="1350">
+                <a:solidFill>
+                  <a:srgbClr val="667084"/>
+                </a:solidFill>
+                <a:latin typeface="Arial"/>
+                <a:ea typeface="Arial"/>
+                <a:cs typeface="Arial"/>
+              </a:defRPr>
+            </a:pPr>
+            <a:r>
+              <a:rPr sz="1350">
+                <a:solidFill>
+                  <a:srgbClr val="667084"/>
+                </a:solidFill>
+                <a:latin typeface="Arial"/>
+                <a:ea typeface="Arial"/>
+                <a:cs typeface="Arial"/>
+              </a:rPr>
+              <a:t>Physician response time does not measure time to examination, testing or completed care. No such timing was measured here.</a:t>
+            </a:r>
+          </a:p>
+        </p:txBody>
+      </p:sp>
+      <p:sp>
+        <p:nvSpPr>
+          <p:cNvPr id="5" name="">
+            <a:extLst xmlns:a="http://schemas.openxmlformats.org/drawingml/2006/main">
+              <a:ext uri="{FF2B5EF4-FFF2-40B4-BE49-F238E27FC236}">
+                <a16:creationId xmlns:a16="http://schemas.microsoft.com/office/drawing/2014/main" id="{C0FB2947-E4BC-445F-8557-28D9D0A2A7A3}"/>
+              </a:ext>
+            </a:extLst>
+          </p:cNvPr>
+          <p:cNvSpPr>
+            <a:spLocks xmlns:a="http://schemas.openxmlformats.org/drawingml/2006/main" noGrp="1"/>
+          </p:cNvSpPr>
+          <p:nvPr/>
+        </p:nvSpPr>
+        <p:spPr>
+          <a:xfrm xmlns:a="http://schemas.openxmlformats.org/drawingml/2006/main">
+            <a:off x="11296650" y="6400800"/>
+            <a:ext cx="361950" cy="228600"/>
+          </a:xfrm>
+          <a:prstGeom xmlns:a="http://schemas.openxmlformats.org/drawingml/2006/main" prst="rect">
+            <a:avLst/>
+          </a:prstGeom>
+          <a:noFill xmlns:a="http://schemas.openxmlformats.org/drawingml/2006/main"/>
+          <a:ln xmlns:a="http://schemas.openxmlformats.org/drawingml/2006/main" w="0">
+            <a:noFill/>
+          </a:ln>
+        </p:spPr>
+        <p:txBody>
+          <a:bodyPr xmlns:a="http://schemas.openxmlformats.org/drawingml/2006/main" wrap="square" lIns="0" tIns="0" rIns="0" bIns="0" anchor="t">
+            <a:noAutofit/>
+          </a:bodyPr>
+          <a:lstStyle xmlns:a="http://schemas.openxmlformats.org/drawingml/2006/main"/>
+          <a:p xmlns:a="http://schemas.openxmlformats.org/drawingml/2006/main">
+            <a:pPr algn="r">
+              <a:defRPr sz="1275">
+                <a:solidFill>
+                  <a:srgbClr val="667084"/>
+                </a:solidFill>
+                <a:latin typeface="Arial"/>
+                <a:ea typeface="Arial"/>
+                <a:cs typeface="Arial"/>
+              </a:defRPr>
+            </a:pPr>
+            <a:r>
+              <a:rPr sz="1275">
+                <a:solidFill>
+                  <a:srgbClr val="667084"/>
+                </a:solidFill>
+                <a:latin typeface="Arial"/>
+                <a:ea typeface="Arial"/>
+                <a:cs typeface="Arial"/>
+              </a:rPr>
+              <a:t>32</a:t>
+            </a:r>
+          </a:p>
+        </p:txBody>
+      </p:sp>
+    </p:spTree>
+    <p:extLst>
+      <p:ext uri="{BB962C8B-B14F-4D97-AF65-F5344CB8AC3E}">
+        <p14:creationId xmlns:p14="http://schemas.microsoft.com/office/powerpoint/2010/main" val="976821349"/>
       </p:ext>
     </p:extLst>
   </p:cSld>
@@ -18087,7 +18899,7 @@
           <p:cNvPr id="7" name="">
             <a:extLst xmlns:a="http://schemas.openxmlformats.org/drawingml/2006/main">
               <a:ext uri="{FF2B5EF4-FFF2-40B4-BE49-F238E27FC236}">
-                <a16:creationId xmlns:a16="http://schemas.microsoft.com/office/drawing/2014/main" id="{55A09439-ADB4-4D0D-9722-A107596696B4}"/>
+                <a16:creationId xmlns:a16="http://schemas.microsoft.com/office/drawing/2014/main" id="{57FD8AB5-63E8-46EC-B60D-5B6BC47788C9}"/>
               </a:ext>
             </a:extLst>
           </p:cNvPr>
@@ -18148,7 +18960,7 @@
           <p:nvPr/>
         </p:nvPicPr>
         <p:blipFill>
-          <a:blip xmlns:r="http://schemas.openxmlformats.org/officeDocument/2006/relationships" xmlns:a="http://schemas.openxmlformats.org/drawingml/2006/main" r:embed="Rb6957c25684e4695"/>
+          <a:blip xmlns:r="http://schemas.openxmlformats.org/officeDocument/2006/relationships" xmlns:a="http://schemas.openxmlformats.org/drawingml/2006/main" r:embed="R3195ccbc7c1e42e8"/>
           <a:stretch xmlns:a="http://schemas.openxmlformats.org/drawingml/2006/main"/>
         </p:blipFill>
         <p:spPr>
@@ -18166,7 +18978,7 @@
           <p:cNvPr id="3" name="">
             <a:extLst xmlns:a="http://schemas.openxmlformats.org/drawingml/2006/main">
               <a:ext uri="{FF2B5EF4-FFF2-40B4-BE49-F238E27FC236}">
-                <a16:creationId xmlns:a16="http://schemas.microsoft.com/office/drawing/2014/main" id="{A2F48E6A-22DE-4097-9451-1980029FD95D}"/>
+                <a16:creationId xmlns:a16="http://schemas.microsoft.com/office/drawing/2014/main" id="{BA0CCFAF-8B07-4781-AF99-569D920AD856}"/>
               </a:ext>
             </a:extLst>
           </p:cNvPr>
@@ -18223,7 +19035,7 @@
           <p:cNvPr id="4" name="">
             <a:extLst xmlns:a="http://schemas.openxmlformats.org/drawingml/2006/main">
               <a:ext uri="{FF2B5EF4-FFF2-40B4-BE49-F238E27FC236}">
-                <a16:creationId xmlns:a16="http://schemas.microsoft.com/office/drawing/2014/main" id="{72BB7D1A-7876-4B7B-AE8D-E7E06C5A686C}"/>
+                <a16:creationId xmlns:a16="http://schemas.microsoft.com/office/drawing/2014/main" id="{B4791358-D571-460A-B385-B342984D2283}"/>
               </a:ext>
             </a:extLst>
           </p:cNvPr>
@@ -18280,7 +19092,7 @@
           <p:cNvPr id="5" name="">
             <a:extLst xmlns:a="http://schemas.openxmlformats.org/drawingml/2006/main">
               <a:ext uri="{FF2B5EF4-FFF2-40B4-BE49-F238E27FC236}">
-                <a16:creationId xmlns:a16="http://schemas.microsoft.com/office/drawing/2014/main" id="{C5DF6373-AC07-422E-B561-BB724AE4F1E1}"/>
+                <a16:creationId xmlns:a16="http://schemas.microsoft.com/office/drawing/2014/main" id="{11440483-3CBC-4FAA-BD4F-CB9006E22024}"/>
               </a:ext>
             </a:extLst>
           </p:cNvPr>
@@ -18337,7 +19149,7 @@
           <p:cNvPr id="6" name="">
             <a:extLst xmlns:a="http://schemas.openxmlformats.org/drawingml/2006/main">
               <a:ext uri="{FF2B5EF4-FFF2-40B4-BE49-F238E27FC236}">
-                <a16:creationId xmlns:a16="http://schemas.microsoft.com/office/drawing/2014/main" id="{39E97F15-CD12-48A2-BD30-60059C147368}"/>
+                <a16:creationId xmlns:a16="http://schemas.microsoft.com/office/drawing/2014/main" id="{7841FAE7-BD21-4207-A030-4472A1199AA9}"/>
               </a:ext>
             </a:extLst>
           </p:cNvPr>
@@ -18392,7 +19204,7 @@
     </p:spTree>
     <p:extLst>
       <p:ext uri="{BB962C8B-B14F-4D97-AF65-F5344CB8AC3E}">
-        <p14:creationId xmlns:p14="http://schemas.microsoft.com/office/powerpoint/2010/main" val="1014604273"/>
+        <p14:creationId xmlns:p14="http://schemas.microsoft.com/office/powerpoint/2010/main" val="1210388423"/>
       </p:ext>
     </p:extLst>
   </p:cSld>
@@ -18423,7 +19235,7 @@
           <p:cNvPr id="5" name="">
             <a:extLst xmlns:a="http://schemas.openxmlformats.org/drawingml/2006/main">
               <a:ext uri="{FF2B5EF4-FFF2-40B4-BE49-F238E27FC236}">
-                <a16:creationId xmlns:a16="http://schemas.microsoft.com/office/drawing/2014/main" id="{06DD2180-651B-4353-88E3-20265A4837D2}"/>
+                <a16:creationId xmlns:a16="http://schemas.microsoft.com/office/drawing/2014/main" id="{16DBFF1D-F202-4FB5-A4EE-5EBBA550B8AE}"/>
               </a:ext>
             </a:extLst>
           </p:cNvPr>
@@ -18582,7 +19394,7 @@
                           <a:ea typeface="Arial"/>
                           <a:cs typeface="Arial"/>
                         </a:rPr>
-                        <a:t>Choose the next care setting</a:t>
+                        <a:t>Choose a care-route bucket</a:t>
                       </a:r>
                     </a:p>
                   </a:txBody>
@@ -18752,7 +19564,7 @@
           <p:cNvPr id="3" name="">
             <a:extLst xmlns:a="http://schemas.openxmlformats.org/drawingml/2006/main">
               <a:ext uri="{FF2B5EF4-FFF2-40B4-BE49-F238E27FC236}">
-                <a16:creationId xmlns:a16="http://schemas.microsoft.com/office/drawing/2014/main" id="{496F08C5-8791-4D1C-A2EF-C36353984622}"/>
+                <a16:creationId xmlns:a16="http://schemas.microsoft.com/office/drawing/2014/main" id="{5A0233E7-BB1D-434B-A797-2F8479936007}"/>
               </a:ext>
             </a:extLst>
           </p:cNvPr>
@@ -18809,7 +19621,7 @@
           <p:cNvPr id="4" name="">
             <a:extLst xmlns:a="http://schemas.openxmlformats.org/drawingml/2006/main">
               <a:ext uri="{FF2B5EF4-FFF2-40B4-BE49-F238E27FC236}">
-                <a16:creationId xmlns:a16="http://schemas.microsoft.com/office/drawing/2014/main" id="{F1B638A8-FE3C-4EB0-920F-0D1459B6EA4C}"/>
+                <a16:creationId xmlns:a16="http://schemas.microsoft.com/office/drawing/2014/main" id="{EA61A5B7-0CB1-4738-86AB-FF1858060ECB}"/>
               </a:ext>
             </a:extLst>
           </p:cNvPr>
@@ -18864,7 +19676,7 @@
     </p:spTree>
     <p:extLst>
       <p:ext uri="{BB962C8B-B14F-4D97-AF65-F5344CB8AC3E}">
-        <p14:creationId xmlns:p14="http://schemas.microsoft.com/office/powerpoint/2010/main" val="2056065562"/>
+        <p14:creationId xmlns:p14="http://schemas.microsoft.com/office/powerpoint/2010/main" val="1015729828"/>
       </p:ext>
     </p:extLst>
   </p:cSld>
@@ -18895,7 +19707,7 @@
           <p:cNvPr id="7" name="">
             <a:extLst xmlns:a="http://schemas.openxmlformats.org/drawingml/2006/main">
               <a:ext uri="{FF2B5EF4-FFF2-40B4-BE49-F238E27FC236}">
-                <a16:creationId xmlns:a16="http://schemas.microsoft.com/office/drawing/2014/main" id="{A6AD5BF8-1899-494B-8F05-35F05831220A}"/>
+                <a16:creationId xmlns:a16="http://schemas.microsoft.com/office/drawing/2014/main" id="{EA8E61FC-4A2C-4BC8-95F8-2E72D8D0B6FA}"/>
               </a:ext>
             </a:extLst>
           </p:cNvPr>
@@ -19174,7 +19986,7 @@
           <p:cNvPr id="3" name="">
             <a:extLst xmlns:a="http://schemas.openxmlformats.org/drawingml/2006/main">
               <a:ext uri="{FF2B5EF4-FFF2-40B4-BE49-F238E27FC236}">
-                <a16:creationId xmlns:a16="http://schemas.microsoft.com/office/drawing/2014/main" id="{722C9D5B-7592-4D3B-BEFF-197305BFCBA2}"/>
+                <a16:creationId xmlns:a16="http://schemas.microsoft.com/office/drawing/2014/main" id="{A4065233-B176-4F40-859C-6DE07A041FA0}"/>
               </a:ext>
             </a:extLst>
           </p:cNvPr>
@@ -19231,7 +20043,7 @@
           <p:cNvPr id="4" name="">
             <a:extLst xmlns:a="http://schemas.openxmlformats.org/drawingml/2006/main">
               <a:ext uri="{FF2B5EF4-FFF2-40B4-BE49-F238E27FC236}">
-                <a16:creationId xmlns:a16="http://schemas.microsoft.com/office/drawing/2014/main" id="{62EC42B3-E43A-4397-B38B-EE2CFB0CB938}"/>
+                <a16:creationId xmlns:a16="http://schemas.microsoft.com/office/drawing/2014/main" id="{4D4E5242-ED81-4FF1-A582-56EC2406F8A4}"/>
               </a:ext>
             </a:extLst>
           </p:cNvPr>
@@ -19288,7 +20100,7 @@
           <p:cNvPr id="5" name="">
             <a:extLst xmlns:a="http://schemas.openxmlformats.org/drawingml/2006/main">
               <a:ext uri="{FF2B5EF4-FFF2-40B4-BE49-F238E27FC236}">
-                <a16:creationId xmlns:a16="http://schemas.microsoft.com/office/drawing/2014/main" id="{1B5FE35A-1E3D-4D0B-AE16-41FF7ADD2450}"/>
+                <a16:creationId xmlns:a16="http://schemas.microsoft.com/office/drawing/2014/main" id="{9C0B61DB-2CF2-4911-B1B6-2C5F1B45C4F2}"/>
               </a:ext>
             </a:extLst>
           </p:cNvPr>
@@ -19335,7 +20147,7 @@
                 <a:ea typeface="Arial"/>
                 <a:cs typeface="Arial"/>
               </a:rPr>
-              <a:t>URGENT_ESCALATION merges two levels of urgency. Route agreement does not establish safe timing or transport.</a:t>
+              <a:t>Async can provide same-day review. These buckets do not specify response deadlines or confirm completed care.</a:t>
             </a:r>
           </a:p>
         </p:txBody>
@@ -19345,7 +20157,7 @@
           <p:cNvPr id="6" name="">
             <a:extLst xmlns:a="http://schemas.openxmlformats.org/drawingml/2006/main">
               <a:ext uri="{FF2B5EF4-FFF2-40B4-BE49-F238E27FC236}">
-                <a16:creationId xmlns:a16="http://schemas.microsoft.com/office/drawing/2014/main" id="{2FAAC6EC-10D9-457D-B73F-DC57CA38BC7C}"/>
+                <a16:creationId xmlns:a16="http://schemas.microsoft.com/office/drawing/2014/main" id="{FE0381D9-195A-4110-B571-992F336B8F45}"/>
               </a:ext>
             </a:extLst>
           </p:cNvPr>
@@ -19400,7 +20212,7 @@
     </p:spTree>
     <p:extLst>
       <p:ext uri="{BB962C8B-B14F-4D97-AF65-F5344CB8AC3E}">
-        <p14:creationId xmlns:p14="http://schemas.microsoft.com/office/powerpoint/2010/main" val="1228187678"/>
+        <p14:creationId xmlns:p14="http://schemas.microsoft.com/office/powerpoint/2010/main" val="426871259"/>
       </p:ext>
     </p:extLst>
   </p:cSld>
@@ -19431,7 +20243,7 @@
           <p:cNvPr id="9" name="">
             <a:extLst xmlns:a="http://schemas.openxmlformats.org/drawingml/2006/main">
               <a:ext uri="{FF2B5EF4-FFF2-40B4-BE49-F238E27FC236}">
-                <a16:creationId xmlns:a16="http://schemas.microsoft.com/office/drawing/2014/main" id="{6038C41A-C883-492D-9D86-A81D92468DD5}"/>
+                <a16:creationId xmlns:a16="http://schemas.microsoft.com/office/drawing/2014/main" id="{25597DD2-E228-4542-953F-C96F06C770DA}"/>
               </a:ext>
             </a:extLst>
           </p:cNvPr>
@@ -19488,7 +20300,7 @@
           <p:cNvPr id="2" name="">
             <a:extLst xmlns:a="http://schemas.openxmlformats.org/drawingml/2006/main">
               <a:ext uri="{FF2B5EF4-FFF2-40B4-BE49-F238E27FC236}">
-                <a16:creationId xmlns:a16="http://schemas.microsoft.com/office/drawing/2014/main" id="{597193A7-0BE4-4B22-AE72-116563CF446A}"/>
+                <a16:creationId xmlns:a16="http://schemas.microsoft.com/office/drawing/2014/main" id="{5477AD1C-D24F-40C9-9DC9-C6D90D6BA175}"/>
               </a:ext>
             </a:extLst>
           </p:cNvPr>
@@ -19545,7 +20357,7 @@
           <p:cNvPr id="3" name="">
             <a:extLst xmlns:a="http://schemas.openxmlformats.org/drawingml/2006/main">
               <a:ext uri="{FF2B5EF4-FFF2-40B4-BE49-F238E27FC236}">
-                <a16:creationId xmlns:a16="http://schemas.microsoft.com/office/drawing/2014/main" id="{D610E7BF-2848-48CA-BA4C-F3F3CEB427F9}"/>
+                <a16:creationId xmlns:a16="http://schemas.microsoft.com/office/drawing/2014/main" id="{ED3DF6A2-F499-4DC4-A8B5-921E8ECD2FBC}"/>
               </a:ext>
             </a:extLst>
           </p:cNvPr>
@@ -19602,7 +20414,7 @@
           <p:cNvPr id="4" name="">
             <a:extLst xmlns:a="http://schemas.openxmlformats.org/drawingml/2006/main">
               <a:ext uri="{FF2B5EF4-FFF2-40B4-BE49-F238E27FC236}">
-                <a16:creationId xmlns:a16="http://schemas.microsoft.com/office/drawing/2014/main" id="{6434A3BC-00DB-4517-889C-BD3C550D1DB5}"/>
+                <a16:creationId xmlns:a16="http://schemas.microsoft.com/office/drawing/2014/main" id="{91C59989-0440-4498-880C-1CBA9DC6BACF}"/>
               </a:ext>
             </a:extLst>
           </p:cNvPr>
@@ -19659,7 +20471,7 @@
           <p:cNvPr id="5" name="">
             <a:extLst xmlns:a="http://schemas.openxmlformats.org/drawingml/2006/main">
               <a:ext uri="{FF2B5EF4-FFF2-40B4-BE49-F238E27FC236}">
-                <a16:creationId xmlns:a16="http://schemas.microsoft.com/office/drawing/2014/main" id="{16D43A30-D7B3-4B81-B3BC-D2983E8BFDA1}"/>
+                <a16:creationId xmlns:a16="http://schemas.microsoft.com/office/drawing/2014/main" id="{C10413B4-412A-4F13-BA07-0C374D0C4141}"/>
               </a:ext>
             </a:extLst>
           </p:cNvPr>
@@ -19716,7 +20528,7 @@
           <p:cNvPr id="6" name="">
             <a:extLst xmlns:a="http://schemas.openxmlformats.org/drawingml/2006/main">
               <a:ext uri="{FF2B5EF4-FFF2-40B4-BE49-F238E27FC236}">
-                <a16:creationId xmlns:a16="http://schemas.microsoft.com/office/drawing/2014/main" id="{58F9B781-883A-4DC9-AB24-1320272F2DC2}"/>
+                <a16:creationId xmlns:a16="http://schemas.microsoft.com/office/drawing/2014/main" id="{0CBF2E5D-1D4E-4757-8CBE-412557F727A5}"/>
               </a:ext>
             </a:extLst>
           </p:cNvPr>
@@ -19773,7 +20585,7 @@
           <p:cNvPr id="7" name="">
             <a:extLst xmlns:a="http://schemas.openxmlformats.org/drawingml/2006/main">
               <a:ext uri="{FF2B5EF4-FFF2-40B4-BE49-F238E27FC236}">
-                <a16:creationId xmlns:a16="http://schemas.microsoft.com/office/drawing/2014/main" id="{9022BA3A-4DE6-4A8D-BB3F-FB8408F7F530}"/>
+                <a16:creationId xmlns:a16="http://schemas.microsoft.com/office/drawing/2014/main" id="{5B2E8EBE-C1BE-4537-B436-7E1C403A8DA1}"/>
               </a:ext>
             </a:extLst>
           </p:cNvPr>
@@ -19830,7 +20642,7 @@
           <p:cNvPr id="8" name="">
             <a:extLst xmlns:a="http://schemas.openxmlformats.org/drawingml/2006/main">
               <a:ext uri="{FF2B5EF4-FFF2-40B4-BE49-F238E27FC236}">
-                <a16:creationId xmlns:a16="http://schemas.microsoft.com/office/drawing/2014/main" id="{87105B3F-2888-4742-89AB-2B449EB4EE37}"/>
+                <a16:creationId xmlns:a16="http://schemas.microsoft.com/office/drawing/2014/main" id="{7CD5EB01-105C-4798-A607-B24717C656B9}"/>
               </a:ext>
             </a:extLst>
           </p:cNvPr>
@@ -19885,7 +20697,7 @@
     </p:spTree>
     <p:extLst>
       <p:ext uri="{BB962C8B-B14F-4D97-AF65-F5344CB8AC3E}">
-        <p14:creationId xmlns:p14="http://schemas.microsoft.com/office/powerpoint/2010/main" val="215353726"/>
+        <p14:creationId xmlns:p14="http://schemas.microsoft.com/office/powerpoint/2010/main" val="426372728"/>
       </p:ext>
     </p:extLst>
   </p:cSld>
@@ -19916,7 +20728,7 @@
           <p:cNvPr id="15" name="">
             <a:extLst xmlns:a="http://schemas.openxmlformats.org/drawingml/2006/main">
               <a:ext uri="{FF2B5EF4-FFF2-40B4-BE49-F238E27FC236}">
-                <a16:creationId xmlns:a16="http://schemas.microsoft.com/office/drawing/2014/main" id="{2C6C4EEA-CFEB-45C4-A74A-555675604643}"/>
+                <a16:creationId xmlns:a16="http://schemas.microsoft.com/office/drawing/2014/main" id="{6047AE0B-98BD-4C46-9B45-BEE423A7B471}"/>
               </a:ext>
             </a:extLst>
           </p:cNvPr>
@@ -19973,7 +20785,7 @@
           <p:cNvPr id="2" name="">
             <a:extLst xmlns:a="http://schemas.openxmlformats.org/drawingml/2006/main">
               <a:ext uri="{FF2B5EF4-FFF2-40B4-BE49-F238E27FC236}">
-                <a16:creationId xmlns:a16="http://schemas.microsoft.com/office/drawing/2014/main" id="{D49F6FFB-A150-4CBC-874D-49907B2D2A78}"/>
+                <a16:creationId xmlns:a16="http://schemas.microsoft.com/office/drawing/2014/main" id="{A47494FB-2907-4F19-A620-A1FD8CC5F687}"/>
               </a:ext>
             </a:extLst>
           </p:cNvPr>
@@ -20030,7 +20842,7 @@
           <p:cNvPr id="3" name="">
             <a:extLst xmlns:a="http://schemas.openxmlformats.org/drawingml/2006/main">
               <a:ext uri="{FF2B5EF4-FFF2-40B4-BE49-F238E27FC236}">
-                <a16:creationId xmlns:a16="http://schemas.microsoft.com/office/drawing/2014/main" id="{9E8F55FE-53CE-484E-971B-7A795627206E}"/>
+                <a16:creationId xmlns:a16="http://schemas.microsoft.com/office/drawing/2014/main" id="{18ED8953-7CC9-46C0-9741-33E40F2DD786}"/>
               </a:ext>
             </a:extLst>
           </p:cNvPr>
@@ -20087,7 +20899,7 @@
           <p:cNvPr id="4" name="">
             <a:extLst xmlns:a="http://schemas.openxmlformats.org/drawingml/2006/main">
               <a:ext uri="{FF2B5EF4-FFF2-40B4-BE49-F238E27FC236}">
-                <a16:creationId xmlns:a16="http://schemas.microsoft.com/office/drawing/2014/main" id="{A384828C-E6AA-4F14-BB4F-1F8514D107D0}"/>
+                <a16:creationId xmlns:a16="http://schemas.microsoft.com/office/drawing/2014/main" id="{B13F260D-AD76-4EE2-877B-DD6445C2F87C}"/>
               </a:ext>
             </a:extLst>
           </p:cNvPr>
@@ -20144,7 +20956,7 @@
           <p:cNvPr id="5" name="">
             <a:extLst xmlns:a="http://schemas.openxmlformats.org/drawingml/2006/main">
               <a:ext uri="{FF2B5EF4-FFF2-40B4-BE49-F238E27FC236}">
-                <a16:creationId xmlns:a16="http://schemas.microsoft.com/office/drawing/2014/main" id="{D02A4861-6C9A-42E6-8F74-F461AFA54C93}"/>
+                <a16:creationId xmlns:a16="http://schemas.microsoft.com/office/drawing/2014/main" id="{9A61BE79-D093-40FA-BF02-E5E7B2681A0D}"/>
               </a:ext>
             </a:extLst>
           </p:cNvPr>
@@ -20201,7 +21013,7 @@
           <p:cNvPr id="6" name="">
             <a:extLst xmlns:a="http://schemas.openxmlformats.org/drawingml/2006/main">
               <a:ext uri="{FF2B5EF4-FFF2-40B4-BE49-F238E27FC236}">
-                <a16:creationId xmlns:a16="http://schemas.microsoft.com/office/drawing/2014/main" id="{AF92DD21-C041-45D0-A545-126A9D450172}"/>
+                <a16:creationId xmlns:a16="http://schemas.microsoft.com/office/drawing/2014/main" id="{AABC776A-D53A-4966-9B21-03144EB5C41C}"/>
               </a:ext>
             </a:extLst>
           </p:cNvPr>
@@ -20258,7 +21070,7 @@
           <p:cNvPr id="7" name="">
             <a:extLst xmlns:a="http://schemas.openxmlformats.org/drawingml/2006/main">
               <a:ext uri="{FF2B5EF4-FFF2-40B4-BE49-F238E27FC236}">
-                <a16:creationId xmlns:a16="http://schemas.microsoft.com/office/drawing/2014/main" id="{908653EC-F317-40B1-83CD-28A89B461E13}"/>
+                <a16:creationId xmlns:a16="http://schemas.microsoft.com/office/drawing/2014/main" id="{2D81A6D8-A7BE-427A-B6E0-5F666E608AC6}"/>
               </a:ext>
             </a:extLst>
           </p:cNvPr>
@@ -20315,7 +21127,7 @@
           <p:cNvPr id="8" name="">
             <a:extLst xmlns:a="http://schemas.openxmlformats.org/drawingml/2006/main">
               <a:ext uri="{FF2B5EF4-FFF2-40B4-BE49-F238E27FC236}">
-                <a16:creationId xmlns:a16="http://schemas.microsoft.com/office/drawing/2014/main" id="{0214948B-9882-4603-BB3C-A05EC3F619E9}"/>
+                <a16:creationId xmlns:a16="http://schemas.microsoft.com/office/drawing/2014/main" id="{1EA74291-092F-4772-B7A9-A2BB5AC4004E}"/>
               </a:ext>
             </a:extLst>
           </p:cNvPr>
@@ -20372,7 +21184,7 @@
           <p:cNvPr id="9" name="">
             <a:extLst xmlns:a="http://schemas.openxmlformats.org/drawingml/2006/main">
               <a:ext uri="{FF2B5EF4-FFF2-40B4-BE49-F238E27FC236}">
-                <a16:creationId xmlns:a16="http://schemas.microsoft.com/office/drawing/2014/main" id="{4406A7AA-E94E-4E7C-835F-BAE3B45C55AB}"/>
+                <a16:creationId xmlns:a16="http://schemas.microsoft.com/office/drawing/2014/main" id="{19E93D36-00BB-459B-BC7B-EABF7C9649B0}"/>
               </a:ext>
             </a:extLst>
           </p:cNvPr>
@@ -20429,7 +21241,7 @@
           <p:cNvPr id="10" name="">
             <a:extLst xmlns:a="http://schemas.openxmlformats.org/drawingml/2006/main">
               <a:ext uri="{FF2B5EF4-FFF2-40B4-BE49-F238E27FC236}">
-                <a16:creationId xmlns:a16="http://schemas.microsoft.com/office/drawing/2014/main" id="{7F83E4E9-C6FB-444D-8012-1F6225E85219}"/>
+                <a16:creationId xmlns:a16="http://schemas.microsoft.com/office/drawing/2014/main" id="{0DD52983-48E0-4C40-ACFC-E81414CD8B63}"/>
               </a:ext>
             </a:extLst>
           </p:cNvPr>
@@ -20486,7 +21298,7 @@
           <p:cNvPr id="11" name="">
             <a:extLst xmlns:a="http://schemas.openxmlformats.org/drawingml/2006/main">
               <a:ext uri="{FF2B5EF4-FFF2-40B4-BE49-F238E27FC236}">
-                <a16:creationId xmlns:a16="http://schemas.microsoft.com/office/drawing/2014/main" id="{F95FD072-B461-4476-AE52-BCF8D459B82A}"/>
+                <a16:creationId xmlns:a16="http://schemas.microsoft.com/office/drawing/2014/main" id="{DDEE6597-D269-4E0C-BD3C-4F62B9A5756E}"/>
               </a:ext>
             </a:extLst>
           </p:cNvPr>
@@ -20543,7 +21355,7 @@
           <p:cNvPr id="12" name="">
             <a:extLst xmlns:a="http://schemas.openxmlformats.org/drawingml/2006/main">
               <a:ext uri="{FF2B5EF4-FFF2-40B4-BE49-F238E27FC236}">
-                <a16:creationId xmlns:a16="http://schemas.microsoft.com/office/drawing/2014/main" id="{7F106BE8-4AE9-4E17-B17C-ED756DB5982B}"/>
+                <a16:creationId xmlns:a16="http://schemas.microsoft.com/office/drawing/2014/main" id="{4641ED77-468C-44C1-A630-229D38AC2D62}"/>
               </a:ext>
             </a:extLst>
           </p:cNvPr>
@@ -20600,7 +21412,7 @@
           <p:cNvPr id="13" name="">
             <a:extLst xmlns:a="http://schemas.openxmlformats.org/drawingml/2006/main">
               <a:ext uri="{FF2B5EF4-FFF2-40B4-BE49-F238E27FC236}">
-                <a16:creationId xmlns:a16="http://schemas.microsoft.com/office/drawing/2014/main" id="{7A4D1A11-C1C3-4223-B345-6AA5F09A440D}"/>
+                <a16:creationId xmlns:a16="http://schemas.microsoft.com/office/drawing/2014/main" id="{F96F44E2-9E47-48EB-9845-F897CCCCC98A}"/>
               </a:ext>
             </a:extLst>
           </p:cNvPr>
@@ -20657,7 +21469,7 @@
           <p:cNvPr id="14" name="">
             <a:extLst xmlns:a="http://schemas.openxmlformats.org/drawingml/2006/main">
               <a:ext uri="{FF2B5EF4-FFF2-40B4-BE49-F238E27FC236}">
-                <a16:creationId xmlns:a16="http://schemas.microsoft.com/office/drawing/2014/main" id="{E6220D46-205C-4229-A862-A5D59FA19FDB}"/>
+                <a16:creationId xmlns:a16="http://schemas.microsoft.com/office/drawing/2014/main" id="{1B69EA4B-931C-4719-88CC-0C933938E8C7}"/>
               </a:ext>
             </a:extLst>
           </p:cNvPr>
@@ -20712,7 +21524,7 @@
     </p:spTree>
     <p:extLst>
       <p:ext uri="{BB962C8B-B14F-4D97-AF65-F5344CB8AC3E}">
-        <p14:creationId xmlns:p14="http://schemas.microsoft.com/office/powerpoint/2010/main" val="1840600143"/>
+        <p14:creationId xmlns:p14="http://schemas.microsoft.com/office/powerpoint/2010/main" val="588257605"/>
       </p:ext>
     </p:extLst>
   </p:cSld>
@@ -20743,7 +21555,7 @@
           <p:cNvPr id="7" name="">
             <a:extLst xmlns:a="http://schemas.openxmlformats.org/drawingml/2006/main">
               <a:ext uri="{FF2B5EF4-FFF2-40B4-BE49-F238E27FC236}">
-                <a16:creationId xmlns:a16="http://schemas.microsoft.com/office/drawing/2014/main" id="{3D55299D-5739-49E2-A275-4F489354FC5A}"/>
+                <a16:creationId xmlns:a16="http://schemas.microsoft.com/office/drawing/2014/main" id="{AF43F282-9D69-4F59-91E8-F8FCFB221245}"/>
               </a:ext>
             </a:extLst>
           </p:cNvPr>
@@ -21119,7 +21931,7 @@
           <p:cNvPr id="3" name="">
             <a:extLst xmlns:a="http://schemas.openxmlformats.org/drawingml/2006/main">
               <a:ext uri="{FF2B5EF4-FFF2-40B4-BE49-F238E27FC236}">
-                <a16:creationId xmlns:a16="http://schemas.microsoft.com/office/drawing/2014/main" id="{80E5AD51-B7BC-478E-B9CA-DB3E922519D9}"/>
+                <a16:creationId xmlns:a16="http://schemas.microsoft.com/office/drawing/2014/main" id="{4D3272FB-5DD8-47E9-B125-E0CF2199E4C4}"/>
               </a:ext>
             </a:extLst>
           </p:cNvPr>
@@ -21176,7 +21988,7 @@
           <p:cNvPr id="4" name="">
             <a:extLst xmlns:a="http://schemas.openxmlformats.org/drawingml/2006/main">
               <a:ext uri="{FF2B5EF4-FFF2-40B4-BE49-F238E27FC236}">
-                <a16:creationId xmlns:a16="http://schemas.microsoft.com/office/drawing/2014/main" id="{3A541AEA-BD76-44CE-B273-28CB8DCC5E73}"/>
+                <a16:creationId xmlns:a16="http://schemas.microsoft.com/office/drawing/2014/main" id="{8B1F7F74-91DB-4AC3-AAE4-FC45E8F76AF8}"/>
               </a:ext>
             </a:extLst>
           </p:cNvPr>
@@ -21233,7 +22045,7 @@
           <p:cNvPr id="5" name="">
             <a:extLst xmlns:a="http://schemas.openxmlformats.org/drawingml/2006/main">
               <a:ext uri="{FF2B5EF4-FFF2-40B4-BE49-F238E27FC236}">
-                <a16:creationId xmlns:a16="http://schemas.microsoft.com/office/drawing/2014/main" id="{C114959A-E9AC-42C5-89EF-3162E33B1C04}"/>
+                <a16:creationId xmlns:a16="http://schemas.microsoft.com/office/drawing/2014/main" id="{F10A7FCE-85AB-4547-8E60-015F8B210823}"/>
               </a:ext>
             </a:extLst>
           </p:cNvPr>
@@ -21290,7 +22102,7 @@
           <p:cNvPr id="6" name="">
             <a:extLst xmlns:a="http://schemas.openxmlformats.org/drawingml/2006/main">
               <a:ext uri="{FF2B5EF4-FFF2-40B4-BE49-F238E27FC236}">
-                <a16:creationId xmlns:a16="http://schemas.microsoft.com/office/drawing/2014/main" id="{4F402B8C-F96B-4180-AC85-6C57F18EEB4B}"/>
+                <a16:creationId xmlns:a16="http://schemas.microsoft.com/office/drawing/2014/main" id="{F6A40DFE-EC16-4182-893B-EDD30A831085}"/>
               </a:ext>
             </a:extLst>
           </p:cNvPr>
@@ -21345,7 +22157,7 @@
     </p:spTree>
     <p:extLst>
       <p:ext uri="{BB962C8B-B14F-4D97-AF65-F5344CB8AC3E}">
-        <p14:creationId xmlns:p14="http://schemas.microsoft.com/office/powerpoint/2010/main" val="1208925010"/>
+        <p14:creationId xmlns:p14="http://schemas.microsoft.com/office/powerpoint/2010/main" val="1116098289"/>
       </p:ext>
     </p:extLst>
   </p:cSld>

</xml_diff>